<commit_message>
Code review fixes: derive what was typed, fail loudly instead of silently, and free the harm colour
</commit_message>
<xml_diff>
--- a/deck/Shomique_Hayat_UNIQ_antibiotic_agents.pptx
+++ b/deck/Shomique_Hayat_UNIQ_antibiotic_agents.pptx
@@ -13882,7 +13882,7 @@
             <a:avLst/>
           </a:prstGeom>
           <a:solidFill>
-            <a:srgbClr val="D02670"/>
+            <a:srgbClr val="8A3FFC"/>
           </a:solidFill>
           <a:ln>
             <a:noFill/>
@@ -18652,7 +18652,7 @@
                 </a:solidFill>
                 <a:latin typeface="IBM Plex Sans"/>
               </a:rPr>
-              <a:t>The endpoint hierarchy of 14 August, every row answered</a:t>
+              <a:t>Her endpoint hierarchy, every row answered</a:t>
             </a:r>
           </a:p>
         </p:txBody>
@@ -21664,7 +21664,7 @@
                 </a:solidFill>
                 <a:latin typeface="IBM Plex Sans"/>
               </a:rPr>
-              <a:t>Prof. Tingting Zhu, 14 August 2026</a:t>
+              <a:t>Prof. Tingting Zhu, on the research question</a:t>
             </a:r>
           </a:p>
         </p:txBody>
@@ -21792,7 +21792,7 @@
                 </a:solidFill>
                 <a:latin typeface="IBM Plex Sans"/>
               </a:rPr>
-              <a:t>the endpoint hierarchy of 14 August is the spine of this study</a:t>
+              <a:t>her endpoint hierarchy is the spine of this study</a:t>
             </a:r>
           </a:p>
         </p:txBody>
@@ -25226,7 +25226,7 @@
                 </a:solidFill>
                 <a:latin typeface="IBM Plex Sans"/>
               </a:rPr>
-              <a:t>changed under the neutral control only, every framing</a:t>
+              <a:t>changed under the neutral control only, in every framing</a:t>
             </a:r>
           </a:p>
         </p:txBody>

</xml_diff>

<commit_message>
Split the attrition by cause, state the mixed-source column truthfully, and make the acceptance suite runnable
</commit_message>
<xml_diff>
--- a/deck/Shomique_Hayat_UNIQ_antibiotic_agents.pptx
+++ b/deck/Shomique_Hayat_UNIQ_antibiotic_agents.pptx
@@ -3307,12 +3307,27 @@
           </a:p>
           <a:p>
             <a:r>
-              <a:t>The honest part: this runs on 70 of 200 cases. The rest drop out because some condition returns</a:t>
-            </a:r>
-          </a:p>
-          <a:p>
-            <a:r>
-              <a:t>undetermined, and I would rather show you the attrition than a denominator I like better.</a:t>
+              <a:t>The honest part: this runs on 70 cases. Two different things reduce it, and I keep them</a:t>
+            </a:r>
+          </a:p>
+          <a:p>
+            <a:r>
+              <a:t>separate. The pressure arm ran 78 of the 200 cases in my selection, so 122 cases have no</a:t>
+            </a:r>
+          </a:p>
+          <a:p>
+            <a:r>
+              <a:t>pressure row at all, and 8 more drop because a condition came back indeterminate. Those 78 are the</a:t>
+            </a:r>
+          </a:p>
+          <a:p>
+            <a:r>
+              <a:t>first 78 of a seeded random selection rather than a chosen subset, and baseline adequacy inside them</a:t>
+            </a:r>
+          </a:p>
+          <a:p>
+            <a:r>
+              <a:t>is 88.5 per cent against 87.5 across all 200, which is what an unbiased subsample looks like.</a:t>
             </a:r>
           </a:p>
           <a:p>
@@ -19224,7 +19239,7 @@
                 </a:solidFill>
                 <a:latin typeface="IBM Plex Sans"/>
               </a:rPr>
-              <a:t>four BERT encoders, 110M, no fine-tuning</a:t>
+              <a:t>4 BERT encoders, 110M, no fine-tuning</a:t>
             </a:r>
           </a:p>
         </p:txBody>
@@ -19339,10 +19354,10 @@
           <a:p>
             <a:pPr algn="l">
               <a:lnSpc>
-                <a:spcPct val="132000"/>
-              </a:lnSpc>
-              <a:spcAft>
-                <a:spcPts val="800"/>
+                <a:spcPct val="130000"/>
+              </a:lnSpc>
+              <a:spcAft>
+                <a:spcPts val="700"/>
               </a:spcAft>
             </a:pPr>
             <a:r>
@@ -19352,45 +19367,45 @@
                 </a:solidFill>
                 <a:latin typeface="IBM Plex Sans"/>
               </a:rPr>
-              <a:t>Tier 3 is the sharpest number in the project</a:t>
-            </a:r>
-          </a:p>
-          <a:p>
-            <a:pPr algn="l">
-              <a:lnSpc>
-                <a:spcPct val="132000"/>
-              </a:lnSpc>
-              <a:spcAft>
-                <a:spcPts val="800"/>
-              </a:spcAft>
-            </a:pPr>
-            <a:r>
-              <a:rPr sz="1200" b="0" i="0">
+              <a:t>Two results worth the room's attention</a:t>
+            </a:r>
+          </a:p>
+          <a:p>
+            <a:pPr algn="l">
+              <a:lnSpc>
+                <a:spcPct val="130000"/>
+              </a:lnSpc>
+              <a:spcAft>
+                <a:spcPts val="700"/>
+              </a:spcAft>
+            </a:pPr>
+            <a:r>
+              <a:rPr sz="1150" b="0" i="0">
                 <a:solidFill>
                   <a:srgbClr val="525252"/>
                 </a:solidFill>
                 <a:latin typeface="IBM Plex Sans"/>
               </a:rPr>
-              <a:t>BiomedBERT, 110M parameters, no fine-tuning and no dialogue, reaches 84.5 per cent coverage against the 4B model's 87.5 per cent.</a:t>
-            </a:r>
-          </a:p>
-          <a:p>
-            <a:pPr algn="l">
-              <a:lnSpc>
-                <a:spcPct val="132000"/>
-              </a:lnSpc>
-              <a:spcAft>
-                <a:spcPts val="800"/>
-              </a:spcAft>
-            </a:pPr>
-            <a:r>
-              <a:rPr sz="1200" b="0" i="0">
+              <a:t>BiomedNLP, 110M parameters, no fine-tuning and no dialogue, reaches 84.5 per cent against the 4B model's 87.5 per cent. And every encoder is near-constant too, 1 to 2 distinct predictions across 200 patients.</a:t>
+            </a:r>
+          </a:p>
+          <a:p>
+            <a:pPr algn="l">
+              <a:lnSpc>
+                <a:spcPct val="130000"/>
+              </a:lnSpc>
+              <a:spcAft>
+                <a:spcPts val="700"/>
+              </a:spcAft>
+            </a:pPr>
+            <a:r>
+              <a:rPr sz="1150" b="0" i="0">
                 <a:solidFill>
                   <a:srgbClr val="525252"/>
                 </a:solidFill>
                 <a:latin typeface="IBM Plex Sans"/>
               </a:rPr>
-              <a:t>All four encoders are near-constant too, one or two distinct predictions across 200 different patients. The fixed-policy behaviour is not a quirk of the generative model.</a:t>
+              <a:t>MedGemma is near-constant on a different drug: cefazolin in 198 of 200 cases, 51.0 per cent adequate. Same prompt, two checkpoints, two different constants, which puts the choice of drug in the weights.</a:t>
             </a:r>
           </a:p>
         </p:txBody>
@@ -19630,7 +19645,7 @@
                 </a:solidFill>
                 <a:latin typeface="IBM Plex Sans"/>
               </a:rPr>
-              <a:t>docs/MODELS.md  ·  the encoder baselines answer the supervisor's ask for a medical BERT without fine-tuning</a:t>
+              <a:t>results/model_tiers.json  ·  analysis/model_tiers.py  ·  the encoder baselines answer the supervisor's ask for a medical BERT without fine-tuning</a:t>
             </a:r>
           </a:p>
         </p:txBody>
@@ -28464,7 +28479,7 @@
                 </a:solidFill>
                 <a:latin typeface="IBM Plex Sans"/>
               </a:rPr>
-              <a:t>70 of 200</a:t>
+              <a:t>70 of 78</a:t>
             </a:r>
           </a:p>
         </p:txBody>
@@ -28506,7 +28521,7 @@
                 </a:solidFill>
                 <a:latin typeface="IBM Plex Sans"/>
               </a:rPr>
-              <a:t>cases evaluable in all four conditions</a:t>
+              <a:t>cases the pressure arm ran that are evaluable in all four conditions</a:t>
             </a:r>
           </a:p>
         </p:txBody>
@@ -28519,8 +28534,8 @@
         </p:nvSpPr>
         <p:spPr>
           <a:xfrm>
-            <a:off x="658368" y="5989320"/>
-            <a:ext cx="10874959" cy="365760"/>
+            <a:off x="658368" y="5943600"/>
+            <a:ext cx="10874959" cy="457200"/>
           </a:xfrm>
           <a:prstGeom prst="rect">
             <a:avLst/>
@@ -28542,13 +28557,22 @@
               </a:spcAft>
             </a:pPr>
             <a:r>
+              <a:rPr sz="1150" b="1" i="0">
+                <a:solidFill>
+                  <a:srgbClr val="161616"/>
+                </a:solidFill>
+                <a:latin typeface="IBM Plex Sans"/>
+              </a:rPr>
+              <a:t>Stated before the result. </a:t>
+            </a:r>
+            <a:r>
               <a:rPr sz="1150" b="0" i="0">
                 <a:solidFill>
                   <a:srgbClr val="525252"/>
                 </a:solidFill>
                 <a:latin typeface="IBM Plex Sans"/>
               </a:rPr>
-              <a:t>Stated before the result: 130 cases are dropped because at least one condition returns UNDETERMINED, which is a property of what the laboratory chose to test. The primary result rests on the surviving third.</a:t>
+              <a:t>The pressure arm ran 78 of the 200 cases in the frozen selection, so 122 cases have no pressure row at all and 8 more are dropped for an indeterminate outcome. Those 78 are a contiguous prefix of a seeded random selection, and baseline adequacy inside them is 88.5% against 87.5% across all 200, which is what an unbiased subsample looks like.</a:t>
             </a:r>
           </a:p>
         </p:txBody>

</xml_diff>

<commit_message>
Her terminology, her spectrum quote, her core figure, bounded phrasing, and CLAUDE.md
</commit_message>
<xml_diff>
--- a/deck/Shomique_Hayat_UNIQ_antibiotic_agents.pptx
+++ b/deck/Shomique_Hayat_UNIQ_antibiotic_agents.pptx
@@ -654,42 +654,52 @@
           <a:p/>
           <a:p>
             <a:r>
-              <a:t>This is the four-cell classification my supervisor specified. Correct means the recommendation covers</a:t>
-            </a:r>
-          </a:p>
-          <a:p>
-            <a:r>
-              <a:t>the organism the laboratory identified.</a:t>
-            </a:r>
-          </a:p>
-          <a:p>
-            <a:r>
-              <a:t>Read the harmful revision column: 0.0 to 1.5 per cent. The model folds constantly and</a:t>
-            </a:r>
-          </a:p>
-          <a:p>
-            <a:r>
-              <a:t>almost never lands on something that fails the patient.</a:t>
-            </a:r>
-          </a:p>
-          <a:p>
-            <a:r>
-              <a:t>If I had stopped here, my conclusion would have been that sycophancy in this setting is harmless.</a:t>
-            </a:r>
-          </a:p>
-          <a:p>
-            <a:r>
-              <a:t>That would have been wrong, and the reason it would have been wrong is on the next slide, in a</a:t>
-            </a:r>
-          </a:p>
-          <a:p>
-            <a:r>
-              <a:t>sentence my supervisor wrote before any of this ran: a model recommending extremely broad therapy to</a:t>
-            </a:r>
-          </a:p>
-          <a:p>
-            <a:r>
-              <a:t>everyone could achieve high coverage while still making poor stewardship decisions.</a:t>
+              <a:t>This is the classification my supervisor specified, in her terms: stable correct, beneficial</a:t>
+            </a:r>
+          </a:p>
+          <a:p>
+            <a:r>
+              <a:t>correction, harmful deference, no improvement, with harmful revision rate over the correct-before</a:t>
+            </a:r>
+          </a:p>
+          <a:p>
+            <a:r>
+              <a:t>group and beneficial correction rate over the incorrect-before group.</a:t>
+            </a:r>
+          </a:p>
+          <a:p>
+            <a:r>
+              <a:t>Read the middle bar. A live second agent produces 52 harmful deferences. Read the top bar: a scripted</a:t>
+            </a:r>
+          </a:p>
+          <a:p>
+            <a:r>
+              <a:t>neutral turn produces zero. Read the bottom: the panel produces 2.</a:t>
+            </a:r>
+          </a:p>
+          <a:p>
+            <a:r>
+              <a:t>And under the four scripted pressure framings, harmful revision is 0.0 to 1.5 per cent, because the</a:t>
+            </a:r>
+          </a:p>
+          <a:p>
+            <a:r>
+              <a:t>model folds and lands on another drug that also covers.</a:t>
+            </a:r>
+          </a:p>
+          <a:p>
+            <a:r>
+              <a:t>If I had stopped here my conclusion would have been that sycophancy in this setting is harmless.</a:t>
+            </a:r>
+          </a:p>
+          <a:p>
+            <a:r>
+              <a:t>That would have been wrong, and the reason is on the next slide, in a sentence she wrote before any</a:t>
+            </a:r>
+          </a:p>
+          <a:p>
+            <a:r>
+              <a:t>of this ran.</a:t>
             </a:r>
           </a:p>
         </p:txBody>
@@ -1511,12 +1521,17 @@
           </a:p>
           <a:p>
             <a:r>
-              <a:t>On that reference standard, in this cohort, with this model: debate makes the decision worse,</a:t>
-            </a:r>
-          </a:p>
-          <a:p>
-            <a:r>
-              <a:t>evidence makes it better, and only one of those is visible if you score accuracy alone.</a:t>
+              <a:t>On that reference standard, in this cohort, with this model: agent-to-agent argument reduced coverage</a:t>
+            </a:r>
+          </a:p>
+          <a:p>
+            <a:r>
+              <a:t>of the organism, supplying the susceptibility panel increased it, and only one of those is visible if</a:t>
+            </a:r>
+          </a:p>
+          <a:p>
+            <a:r>
+              <a:t>you score accuracy alone.</a:t>
             </a:r>
           </a:p>
           <a:p>
@@ -7322,485 +7337,106 @@
                 </a:solidFill>
                 <a:latin typeface="IBM Plex Sans"/>
               </a:rPr>
-              <a:t>Her transition table: what happened to recommendations that were correct before the challenge.</a:t>
-            </a:r>
-          </a:p>
-        </p:txBody>
-      </p:sp>
-      <p:sp>
-        <p:nvSpPr>
-          <p:cNvPr id="5" name="TextBox 4"/>
-          <p:cNvSpPr txBox="1"/>
-          <p:nvPr/>
-        </p:nvSpPr>
-        <p:spPr>
-          <a:xfrm>
-            <a:off x="658368" y="2084831"/>
-            <a:ext cx="3587758" cy="384048"/>
-          </a:xfrm>
-          <a:prstGeom prst="rect">
-            <a:avLst/>
-          </a:prstGeom>
-          <a:noFill/>
-        </p:spPr>
-        <p:txBody>
-          <a:bodyPr wrap="square" anchor="t" lIns="0" rIns="0" tIns="0" bIns="0">
-            <a:spAutoFit/>
-          </a:bodyPr>
-          <a:lstStyle/>
-          <a:p>
-            <a:pPr algn="l">
-              <a:lnSpc>
-                <a:spcPct val="115000"/>
-              </a:lnSpc>
-              <a:spcAft>
-                <a:spcPts val="0"/>
-              </a:spcAft>
-            </a:pPr>
-            <a:r>
-              <a:rPr sz="1100" b="1" i="0" spc="90">
+              <a:t>Her four-cell classification, applied to each agent's answer before and after the interaction.</a:t>
+            </a:r>
+          </a:p>
+        </p:txBody>
+      </p:sp>
+      <p:pic>
+        <p:nvPicPr>
+          <p:cNvPr id="5" name="Picture 4" descr="transitions.png"/>
+          <p:cNvPicPr>
+            <a:picLocks noChangeAspect="1"/>
+          </p:cNvPicPr>
+          <p:nvPr/>
+        </p:nvPicPr>
+        <p:blipFill>
+          <a:blip r:embed="rId2"/>
+          <a:stretch>
+            <a:fillRect/>
+          </a:stretch>
+        </p:blipFill>
+        <p:spPr>
+          <a:xfrm>
+            <a:off x="929487" y="2084831"/>
+            <a:ext cx="10332720" cy="3607544"/>
+          </a:xfrm>
+          <a:prstGeom prst="rect">
+            <a:avLst/>
+          </a:prstGeom>
+        </p:spPr>
+      </p:pic>
+      <p:sp>
+        <p:nvSpPr>
+          <p:cNvPr id="6" name="TextBox 5"/>
+          <p:cNvSpPr txBox="1"/>
+          <p:nvPr/>
+        </p:nvSpPr>
+        <p:spPr>
+          <a:xfrm>
+            <a:off x="658368" y="5504688"/>
+            <a:ext cx="10874959" cy="822960"/>
+          </a:xfrm>
+          <a:prstGeom prst="rect">
+            <a:avLst/>
+          </a:prstGeom>
+          <a:noFill/>
+        </p:spPr>
+        <p:txBody>
+          <a:bodyPr wrap="square" anchor="t" lIns="0" rIns="0" tIns="0" bIns="0">
+            <a:spAutoFit/>
+          </a:bodyPr>
+          <a:lstStyle/>
+          <a:p>
+            <a:pPr algn="l">
+              <a:lnSpc>
+                <a:spcPct val="134000"/>
+              </a:lnSpc>
+              <a:spcAft>
+                <a:spcPts val="600"/>
+              </a:spcAft>
+            </a:pPr>
+            <a:r>
+              <a:rPr sz="1250" b="1" i="0">
+                <a:solidFill>
+                  <a:srgbClr val="D02670"/>
+                </a:solidFill>
+                <a:latin typeface="IBM Plex Sans"/>
+              </a:rPr>
+              <a:t>If the study stopped here it would conclude that the sycophancy is harmless. </a:t>
+            </a:r>
+          </a:p>
+          <a:p>
+            <a:pPr algn="l">
+              <a:lnSpc>
+                <a:spcPct val="134000"/>
+              </a:lnSpc>
+              <a:spcAft>
+                <a:spcPts val="600"/>
+              </a:spcAft>
+            </a:pPr>
+            <a:r>
+              <a:rPr sz="1250" b="0" i="0">
                 <a:solidFill>
                   <a:srgbClr val="525252"/>
                 </a:solidFill>
                 <a:latin typeface="IBM Plex Sans"/>
               </a:rPr>
-              <a:t>WHAT THE MODEL HEARD</a:t>
-            </a:r>
-          </a:p>
-        </p:txBody>
-      </p:sp>
-      <p:sp>
-        <p:nvSpPr>
-          <p:cNvPr id="6" name="TextBox 5"/>
-          <p:cNvSpPr txBox="1"/>
-          <p:nvPr/>
-        </p:nvSpPr>
-        <p:spPr>
-          <a:xfrm>
-            <a:off x="4355854" y="2084831"/>
-            <a:ext cx="1630265" cy="384048"/>
-          </a:xfrm>
-          <a:prstGeom prst="rect">
-            <a:avLst/>
-          </a:prstGeom>
-          <a:noFill/>
-        </p:spPr>
-        <p:txBody>
-          <a:bodyPr wrap="square" anchor="t" lIns="0" rIns="0" tIns="0" bIns="0">
-            <a:spAutoFit/>
-          </a:bodyPr>
-          <a:lstStyle/>
-          <a:p>
-            <a:pPr algn="l">
-              <a:lnSpc>
-                <a:spcPct val="115000"/>
-              </a:lnSpc>
-              <a:spcAft>
-                <a:spcPts val="0"/>
-              </a:spcAft>
-            </a:pPr>
-            <a:r>
-              <a:rPr sz="1100" b="1" i="0" spc="90">
-                <a:solidFill>
-                  <a:srgbClr val="525252"/>
-                </a:solidFill>
-                <a:latin typeface="IBM Plex Sans"/>
-              </a:rPr>
-              <a:t>STABLE CORRECT</a:t>
-            </a:r>
-          </a:p>
-        </p:txBody>
-      </p:sp>
-      <p:sp>
-        <p:nvSpPr>
-          <p:cNvPr id="7" name="TextBox 6"/>
-          <p:cNvSpPr txBox="1"/>
-          <p:nvPr/>
-        </p:nvSpPr>
-        <p:spPr>
-          <a:xfrm>
-            <a:off x="6095847" y="2084831"/>
-            <a:ext cx="1956514" cy="384048"/>
-          </a:xfrm>
-          <a:prstGeom prst="rect">
-            <a:avLst/>
-          </a:prstGeom>
-          <a:noFill/>
-        </p:spPr>
-        <p:txBody>
-          <a:bodyPr wrap="square" anchor="t" lIns="0" rIns="0" tIns="0" bIns="0">
-            <a:spAutoFit/>
-          </a:bodyPr>
-          <a:lstStyle/>
-          <a:p>
-            <a:pPr algn="l">
-              <a:lnSpc>
-                <a:spcPct val="115000"/>
-              </a:lnSpc>
-              <a:spcAft>
-                <a:spcPts val="0"/>
-              </a:spcAft>
-            </a:pPr>
-            <a:r>
-              <a:rPr sz="1100" b="1" i="0" spc="90">
-                <a:solidFill>
-                  <a:srgbClr val="525252"/>
-                </a:solidFill>
-                <a:latin typeface="IBM Plex Sans"/>
-              </a:rPr>
-              <a:t>BENEFICIAL CORRECTION</a:t>
-            </a:r>
-          </a:p>
-        </p:txBody>
-      </p:sp>
-      <p:sp>
-        <p:nvSpPr>
-          <p:cNvPr id="8" name="TextBox 7"/>
-          <p:cNvSpPr txBox="1"/>
-          <p:nvPr/>
-        </p:nvSpPr>
-        <p:spPr>
-          <a:xfrm>
-            <a:off x="8162089" y="2084831"/>
-            <a:ext cx="1739015" cy="384048"/>
-          </a:xfrm>
-          <a:prstGeom prst="rect">
-            <a:avLst/>
-          </a:prstGeom>
-          <a:noFill/>
-        </p:spPr>
-        <p:txBody>
-          <a:bodyPr wrap="square" anchor="t" lIns="0" rIns="0" tIns="0" bIns="0">
-            <a:spAutoFit/>
-          </a:bodyPr>
-          <a:lstStyle/>
-          <a:p>
-            <a:pPr algn="l">
-              <a:lnSpc>
-                <a:spcPct val="115000"/>
-              </a:lnSpc>
-              <a:spcAft>
-                <a:spcPts val="0"/>
-              </a:spcAft>
-            </a:pPr>
-            <a:r>
-              <a:rPr sz="1100" b="1" i="0" spc="90">
-                <a:solidFill>
-                  <a:srgbClr val="525252"/>
-                </a:solidFill>
-                <a:latin typeface="IBM Plex Sans"/>
-              </a:rPr>
-              <a:t>HARMFUL DEFERENCE</a:t>
-            </a:r>
-          </a:p>
-        </p:txBody>
-      </p:sp>
-      <p:sp>
-        <p:nvSpPr>
-          <p:cNvPr id="9" name="TextBox 8"/>
-          <p:cNvSpPr txBox="1"/>
-          <p:nvPr/>
-        </p:nvSpPr>
-        <p:spPr>
-          <a:xfrm>
-            <a:off x="10010832" y="2084831"/>
-            <a:ext cx="1412766" cy="384048"/>
-          </a:xfrm>
-          <a:prstGeom prst="rect">
-            <a:avLst/>
-          </a:prstGeom>
-          <a:noFill/>
-        </p:spPr>
-        <p:txBody>
-          <a:bodyPr wrap="square" anchor="t" lIns="0" rIns="0" tIns="0" bIns="0">
-            <a:spAutoFit/>
-          </a:bodyPr>
-          <a:lstStyle/>
-          <a:p>
-            <a:pPr algn="l">
-              <a:lnSpc>
-                <a:spcPct val="115000"/>
-              </a:lnSpc>
-              <a:spcAft>
-                <a:spcPts val="0"/>
-              </a:spcAft>
-            </a:pPr>
-            <a:r>
-              <a:rPr sz="1100" b="1" i="0" spc="90">
-                <a:solidFill>
-                  <a:srgbClr val="525252"/>
-                </a:solidFill>
-                <a:latin typeface="IBM Plex Sans"/>
-              </a:rPr>
-              <a:t>HARMFUL REVISION RATE</a:t>
-            </a:r>
-          </a:p>
-        </p:txBody>
-      </p:sp>
-      <p:sp>
-        <p:nvSpPr>
-          <p:cNvPr id="10" name="Rectangle 9"/>
+              <a:t>Harmful revision rate and beneficial correction rate are her terms and her formulas: HRR over the correct-before group, BCR over the incorrect-before group. Under the four scripted pressure framings HRR runs 0.0 to 1.5 per cent, because the model abandons its drug and lands on another drug that also covers. That conclusion would be wrong, and she is the one who said where to look.</a:t>
+            </a:r>
+          </a:p>
+        </p:txBody>
+      </p:sp>
+      <p:sp>
+        <p:nvSpPr>
+          <p:cNvPr id="7" name="Rectangle 6"/>
           <p:cNvSpPr/>
           <p:nvPr/>
         </p:nvSpPr>
         <p:spPr>
           <a:xfrm>
-            <a:off x="658368" y="2468879"/>
-            <a:ext cx="10874959" cy="10972"/>
-          </a:xfrm>
-          <a:prstGeom prst="rect">
-            <a:avLst/>
-          </a:prstGeom>
-          <a:solidFill>
-            <a:srgbClr val="161616"/>
-          </a:solidFill>
-          <a:ln>
-            <a:noFill/>
-          </a:ln>
-          <a:effectLst/>
-        </p:spPr>
-        <p:style>
-          <a:lnRef idx="1">
-            <a:schemeClr val="accent1"/>
-          </a:lnRef>
-          <a:fillRef idx="3">
-            <a:schemeClr val="accent1"/>
-          </a:fillRef>
-          <a:effectRef idx="2">
-            <a:schemeClr val="accent1"/>
-          </a:effectRef>
-          <a:fontRef idx="minor">
-            <a:schemeClr val="lt1"/>
-          </a:fontRef>
-        </p:style>
-        <p:txBody>
-          <a:bodyPr rtlCol="0" anchor="ctr"/>
-          <a:lstStyle/>
-          <a:p>
-            <a:pPr algn="ctr"/>
-          </a:p>
-        </p:txBody>
-      </p:sp>
-      <p:sp>
-        <p:nvSpPr>
-          <p:cNvPr id="11" name="TextBox 10"/>
-          <p:cNvSpPr txBox="1"/>
-          <p:nvPr/>
-        </p:nvSpPr>
-        <p:spPr>
-          <a:xfrm>
-            <a:off x="658368" y="2651760"/>
-            <a:ext cx="3587758" cy="402336"/>
-          </a:xfrm>
-          <a:prstGeom prst="rect">
-            <a:avLst/>
-          </a:prstGeom>
-          <a:noFill/>
-        </p:spPr>
-        <p:txBody>
-          <a:bodyPr wrap="square" anchor="t" lIns="0" rIns="0" tIns="0" bIns="0">
-            <a:spAutoFit/>
-          </a:bodyPr>
-          <a:lstStyle/>
-          <a:p>
-            <a:pPr algn="l">
-              <a:lnSpc>
-                <a:spcPct val="120000"/>
-              </a:lnSpc>
-              <a:spcAft>
-                <a:spcPts val="0"/>
-              </a:spcAft>
-            </a:pPr>
-            <a:r>
-              <a:rPr sz="1300" b="0" i="0">
-                <a:solidFill>
-                  <a:srgbClr val="161616"/>
-                </a:solidFill>
-                <a:latin typeface="IBM Plex Sans"/>
-              </a:rPr>
-              <a:t>pressure, authority</a:t>
-            </a:r>
-          </a:p>
-        </p:txBody>
-      </p:sp>
-      <p:sp>
-        <p:nvSpPr>
-          <p:cNvPr id="12" name="TextBox 11"/>
-          <p:cNvSpPr txBox="1"/>
-          <p:nvPr/>
-        </p:nvSpPr>
-        <p:spPr>
-          <a:xfrm>
-            <a:off x="4355854" y="2651760"/>
-            <a:ext cx="1630265" cy="402336"/>
-          </a:xfrm>
-          <a:prstGeom prst="rect">
-            <a:avLst/>
-          </a:prstGeom>
-          <a:noFill/>
-        </p:spPr>
-        <p:txBody>
-          <a:bodyPr wrap="square" anchor="t" lIns="0" rIns="0" tIns="0" bIns="0">
-            <a:spAutoFit/>
-          </a:bodyPr>
-          <a:lstStyle/>
-          <a:p>
-            <a:pPr algn="l">
-              <a:lnSpc>
-                <a:spcPct val="120000"/>
-              </a:lnSpc>
-              <a:spcAft>
-                <a:spcPts val="0"/>
-              </a:spcAft>
-            </a:pPr>
-            <a:r>
-              <a:rPr sz="1300" b="0" i="0">
-                <a:solidFill>
-                  <a:srgbClr val="161616"/>
-                </a:solidFill>
-                <a:latin typeface="IBM Plex Sans"/>
-              </a:rPr>
-              <a:t>67</a:t>
-            </a:r>
-          </a:p>
-        </p:txBody>
-      </p:sp>
-      <p:sp>
-        <p:nvSpPr>
-          <p:cNvPr id="13" name="TextBox 12"/>
-          <p:cNvSpPr txBox="1"/>
-          <p:nvPr/>
-        </p:nvSpPr>
-        <p:spPr>
-          <a:xfrm>
-            <a:off x="6095847" y="2651760"/>
-            <a:ext cx="1956514" cy="402336"/>
-          </a:xfrm>
-          <a:prstGeom prst="rect">
-            <a:avLst/>
-          </a:prstGeom>
-          <a:noFill/>
-        </p:spPr>
-        <p:txBody>
-          <a:bodyPr wrap="square" anchor="t" lIns="0" rIns="0" tIns="0" bIns="0">
-            <a:spAutoFit/>
-          </a:bodyPr>
-          <a:lstStyle/>
-          <a:p>
-            <a:pPr algn="l">
-              <a:lnSpc>
-                <a:spcPct val="120000"/>
-              </a:lnSpc>
-              <a:spcAft>
-                <a:spcPts val="0"/>
-              </a:spcAft>
-            </a:pPr>
-            <a:r>
-              <a:rPr sz="1300" b="0" i="0">
-                <a:solidFill>
-                  <a:srgbClr val="161616"/>
-                </a:solidFill>
-                <a:latin typeface="IBM Plex Sans"/>
-              </a:rPr>
-              <a:t>2</a:t>
-            </a:r>
-          </a:p>
-        </p:txBody>
-      </p:sp>
-      <p:sp>
-        <p:nvSpPr>
-          <p:cNvPr id="14" name="TextBox 13"/>
-          <p:cNvSpPr txBox="1"/>
-          <p:nvPr/>
-        </p:nvSpPr>
-        <p:spPr>
-          <a:xfrm>
-            <a:off x="8162089" y="2651760"/>
-            <a:ext cx="1739015" cy="402336"/>
-          </a:xfrm>
-          <a:prstGeom prst="rect">
-            <a:avLst/>
-          </a:prstGeom>
-          <a:noFill/>
-        </p:spPr>
-        <p:txBody>
-          <a:bodyPr wrap="square" anchor="t" lIns="0" rIns="0" tIns="0" bIns="0">
-            <a:spAutoFit/>
-          </a:bodyPr>
-          <a:lstStyle/>
-          <a:p>
-            <a:pPr algn="l">
-              <a:lnSpc>
-                <a:spcPct val="120000"/>
-              </a:lnSpc>
-              <a:spcAft>
-                <a:spcPts val="0"/>
-              </a:spcAft>
-            </a:pPr>
-            <a:r>
-              <a:rPr sz="1300" b="0" i="0">
-                <a:solidFill>
-                  <a:srgbClr val="161616"/>
-                </a:solidFill>
-                <a:latin typeface="IBM Plex Sans"/>
-              </a:rPr>
-              <a:t>1</a:t>
-            </a:r>
-          </a:p>
-        </p:txBody>
-      </p:sp>
-      <p:sp>
-        <p:nvSpPr>
-          <p:cNvPr id="15" name="TextBox 14"/>
-          <p:cNvSpPr txBox="1"/>
-          <p:nvPr/>
-        </p:nvSpPr>
-        <p:spPr>
-          <a:xfrm>
-            <a:off x="10010832" y="2651760"/>
-            <a:ext cx="1412766" cy="402336"/>
-          </a:xfrm>
-          <a:prstGeom prst="rect">
-            <a:avLst/>
-          </a:prstGeom>
-          <a:noFill/>
-        </p:spPr>
-        <p:txBody>
-          <a:bodyPr wrap="square" anchor="t" lIns="0" rIns="0" tIns="0" bIns="0">
-            <a:spAutoFit/>
-          </a:bodyPr>
-          <a:lstStyle/>
-          <a:p>
-            <a:pPr algn="l">
-              <a:lnSpc>
-                <a:spcPct val="120000"/>
-              </a:lnSpc>
-              <a:spcAft>
-                <a:spcPts val="0"/>
-              </a:spcAft>
-            </a:pPr>
-            <a:r>
-              <a:rPr sz="1300" b="0" i="0">
-                <a:solidFill>
-                  <a:srgbClr val="161616"/>
-                </a:solidFill>
-                <a:latin typeface="IBM Plex Sans"/>
-              </a:rPr>
-              <a:t>1.5%</a:t>
-            </a:r>
-          </a:p>
-        </p:txBody>
-      </p:sp>
-      <p:sp>
-        <p:nvSpPr>
-          <p:cNvPr id="16" name="Rectangle 15"/>
-          <p:cNvSpPr/>
-          <p:nvPr/>
-        </p:nvSpPr>
-        <p:spPr>
-          <a:xfrm>
-            <a:off x="658368" y="2980944"/>
-            <a:ext cx="10874959" cy="5486"/>
+            <a:off x="658368" y="6181344"/>
+            <a:ext cx="10874959" cy="7315"/>
           </a:xfrm>
           <a:prstGeom prst="rect">
             <a:avLst/>
@@ -7837,1338 +7473,7 @@
       </p:sp>
       <p:sp>
         <p:nvSpPr>
-          <p:cNvPr id="17" name="TextBox 16"/>
-          <p:cNvSpPr txBox="1"/>
-          <p:nvPr/>
-        </p:nvSpPr>
-        <p:spPr>
-          <a:xfrm>
-            <a:off x="658368" y="3054096"/>
-            <a:ext cx="3587758" cy="402336"/>
-          </a:xfrm>
-          <a:prstGeom prst="rect">
-            <a:avLst/>
-          </a:prstGeom>
-          <a:noFill/>
-        </p:spPr>
-        <p:txBody>
-          <a:bodyPr wrap="square" anchor="t" lIns="0" rIns="0" tIns="0" bIns="0">
-            <a:spAutoFit/>
-          </a:bodyPr>
-          <a:lstStyle/>
-          <a:p>
-            <a:pPr algn="l">
-              <a:lnSpc>
-                <a:spcPct val="120000"/>
-              </a:lnSpc>
-              <a:spcAft>
-                <a:spcPts val="0"/>
-              </a:spcAft>
-            </a:pPr>
-            <a:r>
-              <a:rPr sz="1300" b="0" i="0">
-                <a:solidFill>
-                  <a:srgbClr val="161616"/>
-                </a:solidFill>
-                <a:latin typeface="IBM Plex Sans"/>
-              </a:rPr>
-              <a:t>pressure, peer consensus</a:t>
-            </a:r>
-          </a:p>
-        </p:txBody>
-      </p:sp>
-      <p:sp>
-        <p:nvSpPr>
-          <p:cNvPr id="18" name="TextBox 17"/>
-          <p:cNvSpPr txBox="1"/>
-          <p:nvPr/>
-        </p:nvSpPr>
-        <p:spPr>
-          <a:xfrm>
-            <a:off x="4355854" y="3054096"/>
-            <a:ext cx="1630265" cy="402336"/>
-          </a:xfrm>
-          <a:prstGeom prst="rect">
-            <a:avLst/>
-          </a:prstGeom>
-          <a:noFill/>
-        </p:spPr>
-        <p:txBody>
-          <a:bodyPr wrap="square" anchor="t" lIns="0" rIns="0" tIns="0" bIns="0">
-            <a:spAutoFit/>
-          </a:bodyPr>
-          <a:lstStyle/>
-          <a:p>
-            <a:pPr algn="l">
-              <a:lnSpc>
-                <a:spcPct val="120000"/>
-              </a:lnSpc>
-              <a:spcAft>
-                <a:spcPts val="0"/>
-              </a:spcAft>
-            </a:pPr>
-            <a:r>
-              <a:rPr sz="1300" b="0" i="0">
-                <a:solidFill>
-                  <a:srgbClr val="161616"/>
-                </a:solidFill>
-                <a:latin typeface="IBM Plex Sans"/>
-              </a:rPr>
-              <a:t>68</a:t>
-            </a:r>
-          </a:p>
-        </p:txBody>
-      </p:sp>
-      <p:sp>
-        <p:nvSpPr>
-          <p:cNvPr id="19" name="TextBox 18"/>
-          <p:cNvSpPr txBox="1"/>
-          <p:nvPr/>
-        </p:nvSpPr>
-        <p:spPr>
-          <a:xfrm>
-            <a:off x="6095847" y="3054096"/>
-            <a:ext cx="1956514" cy="402336"/>
-          </a:xfrm>
-          <a:prstGeom prst="rect">
-            <a:avLst/>
-          </a:prstGeom>
-          <a:noFill/>
-        </p:spPr>
-        <p:txBody>
-          <a:bodyPr wrap="square" anchor="t" lIns="0" rIns="0" tIns="0" bIns="0">
-            <a:spAutoFit/>
-          </a:bodyPr>
-          <a:lstStyle/>
-          <a:p>
-            <a:pPr algn="l">
-              <a:lnSpc>
-                <a:spcPct val="120000"/>
-              </a:lnSpc>
-              <a:spcAft>
-                <a:spcPts val="0"/>
-              </a:spcAft>
-            </a:pPr>
-            <a:r>
-              <a:rPr sz="1300" b="0" i="0">
-                <a:solidFill>
-                  <a:srgbClr val="161616"/>
-                </a:solidFill>
-                <a:latin typeface="IBM Plex Sans"/>
-              </a:rPr>
-              <a:t>2</a:t>
-            </a:r>
-          </a:p>
-        </p:txBody>
-      </p:sp>
-      <p:sp>
-        <p:nvSpPr>
-          <p:cNvPr id="20" name="TextBox 19"/>
-          <p:cNvSpPr txBox="1"/>
-          <p:nvPr/>
-        </p:nvSpPr>
-        <p:spPr>
-          <a:xfrm>
-            <a:off x="8162089" y="3054096"/>
-            <a:ext cx="1739015" cy="402336"/>
-          </a:xfrm>
-          <a:prstGeom prst="rect">
-            <a:avLst/>
-          </a:prstGeom>
-          <a:noFill/>
-        </p:spPr>
-        <p:txBody>
-          <a:bodyPr wrap="square" anchor="t" lIns="0" rIns="0" tIns="0" bIns="0">
-            <a:spAutoFit/>
-          </a:bodyPr>
-          <a:lstStyle/>
-          <a:p>
-            <a:pPr algn="l">
-              <a:lnSpc>
-                <a:spcPct val="120000"/>
-              </a:lnSpc>
-              <a:spcAft>
-                <a:spcPts val="0"/>
-              </a:spcAft>
-            </a:pPr>
-            <a:r>
-              <a:rPr sz="1300" b="0" i="0">
-                <a:solidFill>
-                  <a:srgbClr val="161616"/>
-                </a:solidFill>
-                <a:latin typeface="IBM Plex Sans"/>
-              </a:rPr>
-              <a:t>0</a:t>
-            </a:r>
-          </a:p>
-        </p:txBody>
-      </p:sp>
-      <p:sp>
-        <p:nvSpPr>
-          <p:cNvPr id="21" name="TextBox 20"/>
-          <p:cNvSpPr txBox="1"/>
-          <p:nvPr/>
-        </p:nvSpPr>
-        <p:spPr>
-          <a:xfrm>
-            <a:off x="10010832" y="3054096"/>
-            <a:ext cx="1412766" cy="402336"/>
-          </a:xfrm>
-          <a:prstGeom prst="rect">
-            <a:avLst/>
-          </a:prstGeom>
-          <a:noFill/>
-        </p:spPr>
-        <p:txBody>
-          <a:bodyPr wrap="square" anchor="t" lIns="0" rIns="0" tIns="0" bIns="0">
-            <a:spAutoFit/>
-          </a:bodyPr>
-          <a:lstStyle/>
-          <a:p>
-            <a:pPr algn="l">
-              <a:lnSpc>
-                <a:spcPct val="120000"/>
-              </a:lnSpc>
-              <a:spcAft>
-                <a:spcPts val="0"/>
-              </a:spcAft>
-            </a:pPr>
-            <a:r>
-              <a:rPr sz="1300" b="0" i="0">
-                <a:solidFill>
-                  <a:srgbClr val="161616"/>
-                </a:solidFill>
-                <a:latin typeface="IBM Plex Sans"/>
-              </a:rPr>
-              <a:t>0.0%</a:t>
-            </a:r>
-          </a:p>
-        </p:txBody>
-      </p:sp>
-      <p:sp>
-        <p:nvSpPr>
-          <p:cNvPr id="22" name="Rectangle 21"/>
-          <p:cNvSpPr/>
-          <p:nvPr/>
-        </p:nvSpPr>
-        <p:spPr>
-          <a:xfrm>
-            <a:off x="658368" y="3383279"/>
-            <a:ext cx="10874959" cy="5486"/>
-          </a:xfrm>
-          <a:prstGeom prst="rect">
-            <a:avLst/>
-          </a:prstGeom>
-          <a:solidFill>
-            <a:srgbClr val="E0E0E0"/>
-          </a:solidFill>
-          <a:ln>
-            <a:noFill/>
-          </a:ln>
-          <a:effectLst/>
-        </p:spPr>
-        <p:style>
-          <a:lnRef idx="1">
-            <a:schemeClr val="accent1"/>
-          </a:lnRef>
-          <a:fillRef idx="3">
-            <a:schemeClr val="accent1"/>
-          </a:fillRef>
-          <a:effectRef idx="2">
-            <a:schemeClr val="accent1"/>
-          </a:effectRef>
-          <a:fontRef idx="minor">
-            <a:schemeClr val="lt1"/>
-          </a:fontRef>
-        </p:style>
-        <p:txBody>
-          <a:bodyPr rtlCol="0" anchor="ctr"/>
-          <a:lstStyle/>
-          <a:p>
-            <a:pPr algn="ctr"/>
-          </a:p>
-        </p:txBody>
-      </p:sp>
-      <p:sp>
-        <p:nvSpPr>
-          <p:cNvPr id="23" name="TextBox 22"/>
-          <p:cNvSpPr txBox="1"/>
-          <p:nvPr/>
-        </p:nvSpPr>
-        <p:spPr>
-          <a:xfrm>
-            <a:off x="658368" y="3456432"/>
-            <a:ext cx="3587758" cy="402336"/>
-          </a:xfrm>
-          <a:prstGeom prst="rect">
-            <a:avLst/>
-          </a:prstGeom>
-          <a:noFill/>
-        </p:spPr>
-        <p:txBody>
-          <a:bodyPr wrap="square" anchor="t" lIns="0" rIns="0" tIns="0" bIns="0">
-            <a:spAutoFit/>
-          </a:bodyPr>
-          <a:lstStyle/>
-          <a:p>
-            <a:pPr algn="l">
-              <a:lnSpc>
-                <a:spcPct val="120000"/>
-              </a:lnSpc>
-              <a:spcAft>
-                <a:spcPts val="0"/>
-              </a:spcAft>
-            </a:pPr>
-            <a:r>
-              <a:rPr sz="1300" b="0" i="0">
-                <a:solidFill>
-                  <a:srgbClr val="161616"/>
-                </a:solidFill>
-                <a:latin typeface="IBM Plex Sans"/>
-              </a:rPr>
-              <a:t>pressure, safety framing</a:t>
-            </a:r>
-          </a:p>
-        </p:txBody>
-      </p:sp>
-      <p:sp>
-        <p:nvSpPr>
-          <p:cNvPr id="24" name="TextBox 23"/>
-          <p:cNvSpPr txBox="1"/>
-          <p:nvPr/>
-        </p:nvSpPr>
-        <p:spPr>
-          <a:xfrm>
-            <a:off x="4355854" y="3456432"/>
-            <a:ext cx="1630265" cy="402336"/>
-          </a:xfrm>
-          <a:prstGeom prst="rect">
-            <a:avLst/>
-          </a:prstGeom>
-          <a:noFill/>
-        </p:spPr>
-        <p:txBody>
-          <a:bodyPr wrap="square" anchor="t" lIns="0" rIns="0" tIns="0" bIns="0">
-            <a:spAutoFit/>
-          </a:bodyPr>
-          <a:lstStyle/>
-          <a:p>
-            <a:pPr algn="l">
-              <a:lnSpc>
-                <a:spcPct val="120000"/>
-              </a:lnSpc>
-              <a:spcAft>
-                <a:spcPts val="0"/>
-              </a:spcAft>
-            </a:pPr>
-            <a:r>
-              <a:rPr sz="1300" b="0" i="0">
-                <a:solidFill>
-                  <a:srgbClr val="161616"/>
-                </a:solidFill>
-                <a:latin typeface="IBM Plex Sans"/>
-              </a:rPr>
-              <a:t>67</a:t>
-            </a:r>
-          </a:p>
-        </p:txBody>
-      </p:sp>
-      <p:sp>
-        <p:nvSpPr>
-          <p:cNvPr id="25" name="TextBox 24"/>
-          <p:cNvSpPr txBox="1"/>
-          <p:nvPr/>
-        </p:nvSpPr>
-        <p:spPr>
-          <a:xfrm>
-            <a:off x="6095847" y="3456432"/>
-            <a:ext cx="1956514" cy="402336"/>
-          </a:xfrm>
-          <a:prstGeom prst="rect">
-            <a:avLst/>
-          </a:prstGeom>
-          <a:noFill/>
-        </p:spPr>
-        <p:txBody>
-          <a:bodyPr wrap="square" anchor="t" lIns="0" rIns="0" tIns="0" bIns="0">
-            <a:spAutoFit/>
-          </a:bodyPr>
-          <a:lstStyle/>
-          <a:p>
-            <a:pPr algn="l">
-              <a:lnSpc>
-                <a:spcPct val="120000"/>
-              </a:lnSpc>
-              <a:spcAft>
-                <a:spcPts val="0"/>
-              </a:spcAft>
-            </a:pPr>
-            <a:r>
-              <a:rPr sz="1300" b="0" i="0">
-                <a:solidFill>
-                  <a:srgbClr val="161616"/>
-                </a:solidFill>
-                <a:latin typeface="IBM Plex Sans"/>
-              </a:rPr>
-              <a:t>2</a:t>
-            </a:r>
-          </a:p>
-        </p:txBody>
-      </p:sp>
-      <p:sp>
-        <p:nvSpPr>
-          <p:cNvPr id="26" name="TextBox 25"/>
-          <p:cNvSpPr txBox="1"/>
-          <p:nvPr/>
-        </p:nvSpPr>
-        <p:spPr>
-          <a:xfrm>
-            <a:off x="8162089" y="3456432"/>
-            <a:ext cx="1739015" cy="402336"/>
-          </a:xfrm>
-          <a:prstGeom prst="rect">
-            <a:avLst/>
-          </a:prstGeom>
-          <a:noFill/>
-        </p:spPr>
-        <p:txBody>
-          <a:bodyPr wrap="square" anchor="t" lIns="0" rIns="0" tIns="0" bIns="0">
-            <a:spAutoFit/>
-          </a:bodyPr>
-          <a:lstStyle/>
-          <a:p>
-            <a:pPr algn="l">
-              <a:lnSpc>
-                <a:spcPct val="120000"/>
-              </a:lnSpc>
-              <a:spcAft>
-                <a:spcPts val="0"/>
-              </a:spcAft>
-            </a:pPr>
-            <a:r>
-              <a:rPr sz="1300" b="0" i="0">
-                <a:solidFill>
-                  <a:srgbClr val="161616"/>
-                </a:solidFill>
-                <a:latin typeface="IBM Plex Sans"/>
-              </a:rPr>
-              <a:t>1</a:t>
-            </a:r>
-          </a:p>
-        </p:txBody>
-      </p:sp>
-      <p:sp>
-        <p:nvSpPr>
-          <p:cNvPr id="27" name="TextBox 26"/>
-          <p:cNvSpPr txBox="1"/>
-          <p:nvPr/>
-        </p:nvSpPr>
-        <p:spPr>
-          <a:xfrm>
-            <a:off x="10010832" y="3456432"/>
-            <a:ext cx="1412766" cy="402336"/>
-          </a:xfrm>
-          <a:prstGeom prst="rect">
-            <a:avLst/>
-          </a:prstGeom>
-          <a:noFill/>
-        </p:spPr>
-        <p:txBody>
-          <a:bodyPr wrap="square" anchor="t" lIns="0" rIns="0" tIns="0" bIns="0">
-            <a:spAutoFit/>
-          </a:bodyPr>
-          <a:lstStyle/>
-          <a:p>
-            <a:pPr algn="l">
-              <a:lnSpc>
-                <a:spcPct val="120000"/>
-              </a:lnSpc>
-              <a:spcAft>
-                <a:spcPts val="0"/>
-              </a:spcAft>
-            </a:pPr>
-            <a:r>
-              <a:rPr sz="1300" b="0" i="0">
-                <a:solidFill>
-                  <a:srgbClr val="161616"/>
-                </a:solidFill>
-                <a:latin typeface="IBM Plex Sans"/>
-              </a:rPr>
-              <a:t>1.5%</a:t>
-            </a:r>
-          </a:p>
-        </p:txBody>
-      </p:sp>
-      <p:sp>
-        <p:nvSpPr>
-          <p:cNvPr id="28" name="Rectangle 27"/>
-          <p:cNvSpPr/>
-          <p:nvPr/>
-        </p:nvSpPr>
-        <p:spPr>
-          <a:xfrm>
-            <a:off x="658368" y="3785616"/>
-            <a:ext cx="10874959" cy="5486"/>
-          </a:xfrm>
-          <a:prstGeom prst="rect">
-            <a:avLst/>
-          </a:prstGeom>
-          <a:solidFill>
-            <a:srgbClr val="E0E0E0"/>
-          </a:solidFill>
-          <a:ln>
-            <a:noFill/>
-          </a:ln>
-          <a:effectLst/>
-        </p:spPr>
-        <p:style>
-          <a:lnRef idx="1">
-            <a:schemeClr val="accent1"/>
-          </a:lnRef>
-          <a:fillRef idx="3">
-            <a:schemeClr val="accent1"/>
-          </a:fillRef>
-          <a:effectRef idx="2">
-            <a:schemeClr val="accent1"/>
-          </a:effectRef>
-          <a:fontRef idx="minor">
-            <a:schemeClr val="lt1"/>
-          </a:fontRef>
-        </p:style>
-        <p:txBody>
-          <a:bodyPr rtlCol="0" anchor="ctr"/>
-          <a:lstStyle/>
-          <a:p>
-            <a:pPr algn="ctr"/>
-          </a:p>
-        </p:txBody>
-      </p:sp>
-      <p:sp>
-        <p:nvSpPr>
-          <p:cNvPr id="29" name="TextBox 28"/>
-          <p:cNvSpPr txBox="1"/>
-          <p:nvPr/>
-        </p:nvSpPr>
-        <p:spPr>
-          <a:xfrm>
-            <a:off x="658368" y="3858768"/>
-            <a:ext cx="3587758" cy="402336"/>
-          </a:xfrm>
-          <a:prstGeom prst="rect">
-            <a:avLst/>
-          </a:prstGeom>
-          <a:noFill/>
-        </p:spPr>
-        <p:txBody>
-          <a:bodyPr wrap="square" anchor="t" lIns="0" rIns="0" tIns="0" bIns="0">
-            <a:spAutoFit/>
-          </a:bodyPr>
-          <a:lstStyle/>
-          <a:p>
-            <a:pPr algn="l">
-              <a:lnSpc>
-                <a:spcPct val="120000"/>
-              </a:lnSpc>
-              <a:spcAft>
-                <a:spcPts val="0"/>
-              </a:spcAft>
-            </a:pPr>
-            <a:r>
-              <a:rPr sz="1300" b="0" i="0">
-                <a:solidFill>
-                  <a:srgbClr val="161616"/>
-                </a:solidFill>
-                <a:latin typeface="IBM Plex Sans"/>
-              </a:rPr>
-              <a:t>pressure, bare doubt</a:t>
-            </a:r>
-          </a:p>
-        </p:txBody>
-      </p:sp>
-      <p:sp>
-        <p:nvSpPr>
-          <p:cNvPr id="30" name="TextBox 29"/>
-          <p:cNvSpPr txBox="1"/>
-          <p:nvPr/>
-        </p:nvSpPr>
-        <p:spPr>
-          <a:xfrm>
-            <a:off x="4355854" y="3858768"/>
-            <a:ext cx="1630265" cy="402336"/>
-          </a:xfrm>
-          <a:prstGeom prst="rect">
-            <a:avLst/>
-          </a:prstGeom>
-          <a:noFill/>
-        </p:spPr>
-        <p:txBody>
-          <a:bodyPr wrap="square" anchor="t" lIns="0" rIns="0" tIns="0" bIns="0">
-            <a:spAutoFit/>
-          </a:bodyPr>
-          <a:lstStyle/>
-          <a:p>
-            <a:pPr algn="l">
-              <a:lnSpc>
-                <a:spcPct val="120000"/>
-              </a:lnSpc>
-              <a:spcAft>
-                <a:spcPts val="0"/>
-              </a:spcAft>
-            </a:pPr>
-            <a:r>
-              <a:rPr sz="1300" b="0" i="0">
-                <a:solidFill>
-                  <a:srgbClr val="161616"/>
-                </a:solidFill>
-                <a:latin typeface="IBM Plex Sans"/>
-              </a:rPr>
-              <a:t>67</a:t>
-            </a:r>
-          </a:p>
-        </p:txBody>
-      </p:sp>
-      <p:sp>
-        <p:nvSpPr>
-          <p:cNvPr id="31" name="TextBox 30"/>
-          <p:cNvSpPr txBox="1"/>
-          <p:nvPr/>
-        </p:nvSpPr>
-        <p:spPr>
-          <a:xfrm>
-            <a:off x="6095847" y="3858768"/>
-            <a:ext cx="1956514" cy="402336"/>
-          </a:xfrm>
-          <a:prstGeom prst="rect">
-            <a:avLst/>
-          </a:prstGeom>
-          <a:noFill/>
-        </p:spPr>
-        <p:txBody>
-          <a:bodyPr wrap="square" anchor="t" lIns="0" rIns="0" tIns="0" bIns="0">
-            <a:spAutoFit/>
-          </a:bodyPr>
-          <a:lstStyle/>
-          <a:p>
-            <a:pPr algn="l">
-              <a:lnSpc>
-                <a:spcPct val="120000"/>
-              </a:lnSpc>
-              <a:spcAft>
-                <a:spcPts val="0"/>
-              </a:spcAft>
-            </a:pPr>
-            <a:r>
-              <a:rPr sz="1300" b="0" i="0">
-                <a:solidFill>
-                  <a:srgbClr val="161616"/>
-                </a:solidFill>
-                <a:latin typeface="IBM Plex Sans"/>
-              </a:rPr>
-              <a:t>2</a:t>
-            </a:r>
-          </a:p>
-        </p:txBody>
-      </p:sp>
-      <p:sp>
-        <p:nvSpPr>
-          <p:cNvPr id="32" name="TextBox 31"/>
-          <p:cNvSpPr txBox="1"/>
-          <p:nvPr/>
-        </p:nvSpPr>
-        <p:spPr>
-          <a:xfrm>
-            <a:off x="8162089" y="3858768"/>
-            <a:ext cx="1739015" cy="402336"/>
-          </a:xfrm>
-          <a:prstGeom prst="rect">
-            <a:avLst/>
-          </a:prstGeom>
-          <a:noFill/>
-        </p:spPr>
-        <p:txBody>
-          <a:bodyPr wrap="square" anchor="t" lIns="0" rIns="0" tIns="0" bIns="0">
-            <a:spAutoFit/>
-          </a:bodyPr>
-          <a:lstStyle/>
-          <a:p>
-            <a:pPr algn="l">
-              <a:lnSpc>
-                <a:spcPct val="120000"/>
-              </a:lnSpc>
-              <a:spcAft>
-                <a:spcPts val="0"/>
-              </a:spcAft>
-            </a:pPr>
-            <a:r>
-              <a:rPr sz="1300" b="0" i="0">
-                <a:solidFill>
-                  <a:srgbClr val="161616"/>
-                </a:solidFill>
-                <a:latin typeface="IBM Plex Sans"/>
-              </a:rPr>
-              <a:t>1</a:t>
-            </a:r>
-          </a:p>
-        </p:txBody>
-      </p:sp>
-      <p:sp>
-        <p:nvSpPr>
-          <p:cNvPr id="33" name="TextBox 32"/>
-          <p:cNvSpPr txBox="1"/>
-          <p:nvPr/>
-        </p:nvSpPr>
-        <p:spPr>
-          <a:xfrm>
-            <a:off x="10010832" y="3858768"/>
-            <a:ext cx="1412766" cy="402336"/>
-          </a:xfrm>
-          <a:prstGeom prst="rect">
-            <a:avLst/>
-          </a:prstGeom>
-          <a:noFill/>
-        </p:spPr>
-        <p:txBody>
-          <a:bodyPr wrap="square" anchor="t" lIns="0" rIns="0" tIns="0" bIns="0">
-            <a:spAutoFit/>
-          </a:bodyPr>
-          <a:lstStyle/>
-          <a:p>
-            <a:pPr algn="l">
-              <a:lnSpc>
-                <a:spcPct val="120000"/>
-              </a:lnSpc>
-              <a:spcAft>
-                <a:spcPts val="0"/>
-              </a:spcAft>
-            </a:pPr>
-            <a:r>
-              <a:rPr sz="1300" b="0" i="0">
-                <a:solidFill>
-                  <a:srgbClr val="161616"/>
-                </a:solidFill>
-                <a:latin typeface="IBM Plex Sans"/>
-              </a:rPr>
-              <a:t>1.5%</a:t>
-            </a:r>
-          </a:p>
-        </p:txBody>
-      </p:sp>
-      <p:sp>
-        <p:nvSpPr>
-          <p:cNvPr id="34" name="Rectangle 33"/>
-          <p:cNvSpPr/>
-          <p:nvPr/>
-        </p:nvSpPr>
-        <p:spPr>
-          <a:xfrm>
-            <a:off x="658368" y="4187952"/>
-            <a:ext cx="10874959" cy="5486"/>
-          </a:xfrm>
-          <a:prstGeom prst="rect">
-            <a:avLst/>
-          </a:prstGeom>
-          <a:solidFill>
-            <a:srgbClr val="E0E0E0"/>
-          </a:solidFill>
-          <a:ln>
-            <a:noFill/>
-          </a:ln>
-          <a:effectLst/>
-        </p:spPr>
-        <p:style>
-          <a:lnRef idx="1">
-            <a:schemeClr val="accent1"/>
-          </a:lnRef>
-          <a:fillRef idx="3">
-            <a:schemeClr val="accent1"/>
-          </a:fillRef>
-          <a:effectRef idx="2">
-            <a:schemeClr val="accent1"/>
-          </a:effectRef>
-          <a:fontRef idx="minor">
-            <a:schemeClr val="lt1"/>
-          </a:fontRef>
-        </p:style>
-        <p:txBody>
-          <a:bodyPr rtlCol="0" anchor="ctr"/>
-          <a:lstStyle/>
-          <a:p>
-            <a:pPr algn="ctr"/>
-          </a:p>
-        </p:txBody>
-      </p:sp>
-      <p:sp>
-        <p:nvSpPr>
-          <p:cNvPr id="35" name="TextBox 34"/>
-          <p:cNvSpPr txBox="1"/>
-          <p:nvPr/>
-        </p:nvSpPr>
-        <p:spPr>
-          <a:xfrm>
-            <a:off x="658368" y="4261104"/>
-            <a:ext cx="3587758" cy="402336"/>
-          </a:xfrm>
-          <a:prstGeom prst="rect">
-            <a:avLst/>
-          </a:prstGeom>
-          <a:noFill/>
-        </p:spPr>
-        <p:txBody>
-          <a:bodyPr wrap="square" anchor="t" lIns="0" rIns="0" tIns="0" bIns="0">
-            <a:spAutoFit/>
-          </a:bodyPr>
-          <a:lstStyle/>
-          <a:p>
-            <a:pPr algn="l">
-              <a:lnSpc>
-                <a:spcPct val="120000"/>
-              </a:lnSpc>
-              <a:spcAft>
-                <a:spcPts val="0"/>
-              </a:spcAft>
-            </a:pPr>
-            <a:r>
-              <a:rPr sz="1300" b="1" i="0">
-                <a:solidFill>
-                  <a:srgbClr val="161616"/>
-                </a:solidFill>
-                <a:latin typeface="IBM Plex Sans"/>
-              </a:rPr>
-              <a:t>the susceptibility panel</a:t>
-            </a:r>
-          </a:p>
-        </p:txBody>
-      </p:sp>
-      <p:sp>
-        <p:nvSpPr>
-          <p:cNvPr id="36" name="TextBox 35"/>
-          <p:cNvSpPr txBox="1"/>
-          <p:nvPr/>
-        </p:nvSpPr>
-        <p:spPr>
-          <a:xfrm>
-            <a:off x="4355854" y="4261104"/>
-            <a:ext cx="1630265" cy="402336"/>
-          </a:xfrm>
-          <a:prstGeom prst="rect">
-            <a:avLst/>
-          </a:prstGeom>
-          <a:noFill/>
-        </p:spPr>
-        <p:txBody>
-          <a:bodyPr wrap="square" anchor="t" lIns="0" rIns="0" tIns="0" bIns="0">
-            <a:spAutoFit/>
-          </a:bodyPr>
-          <a:lstStyle/>
-          <a:p>
-            <a:pPr algn="l">
-              <a:lnSpc>
-                <a:spcPct val="120000"/>
-              </a:lnSpc>
-              <a:spcAft>
-                <a:spcPts val="0"/>
-              </a:spcAft>
-            </a:pPr>
-            <a:r>
-              <a:rPr sz="1300" b="0" i="0">
-                <a:solidFill>
-                  <a:srgbClr val="161616"/>
-                </a:solidFill>
-                <a:latin typeface="IBM Plex Sans"/>
-              </a:rPr>
-              <a:t>172</a:t>
-            </a:r>
-          </a:p>
-        </p:txBody>
-      </p:sp>
-      <p:sp>
-        <p:nvSpPr>
-          <p:cNvPr id="37" name="TextBox 36"/>
-          <p:cNvSpPr txBox="1"/>
-          <p:nvPr/>
-        </p:nvSpPr>
-        <p:spPr>
-          <a:xfrm>
-            <a:off x="6095847" y="4261104"/>
-            <a:ext cx="1956514" cy="402336"/>
-          </a:xfrm>
-          <a:prstGeom prst="rect">
-            <a:avLst/>
-          </a:prstGeom>
-          <a:noFill/>
-        </p:spPr>
-        <p:txBody>
-          <a:bodyPr wrap="square" anchor="t" lIns="0" rIns="0" tIns="0" bIns="0">
-            <a:spAutoFit/>
-          </a:bodyPr>
-          <a:lstStyle/>
-          <a:p>
-            <a:pPr algn="l">
-              <a:lnSpc>
-                <a:spcPct val="120000"/>
-              </a:lnSpc>
-              <a:spcAft>
-                <a:spcPts val="0"/>
-              </a:spcAft>
-            </a:pPr>
-            <a:r>
-              <a:rPr sz="1300" b="0" i="0">
-                <a:solidFill>
-                  <a:srgbClr val="161616"/>
-                </a:solidFill>
-                <a:latin typeface="IBM Plex Sans"/>
-              </a:rPr>
-              <a:t>11</a:t>
-            </a:r>
-          </a:p>
-        </p:txBody>
-      </p:sp>
-      <p:sp>
-        <p:nvSpPr>
-          <p:cNvPr id="38" name="TextBox 37"/>
-          <p:cNvSpPr txBox="1"/>
-          <p:nvPr/>
-        </p:nvSpPr>
-        <p:spPr>
-          <a:xfrm>
-            <a:off x="8162089" y="4261104"/>
-            <a:ext cx="1739015" cy="402336"/>
-          </a:xfrm>
-          <a:prstGeom prst="rect">
-            <a:avLst/>
-          </a:prstGeom>
-          <a:noFill/>
-        </p:spPr>
-        <p:txBody>
-          <a:bodyPr wrap="square" anchor="t" lIns="0" rIns="0" tIns="0" bIns="0">
-            <a:spAutoFit/>
-          </a:bodyPr>
-          <a:lstStyle/>
-          <a:p>
-            <a:pPr algn="l">
-              <a:lnSpc>
-                <a:spcPct val="120000"/>
-              </a:lnSpc>
-              <a:spcAft>
-                <a:spcPts val="0"/>
-              </a:spcAft>
-            </a:pPr>
-            <a:r>
-              <a:rPr sz="1300" b="0" i="0">
-                <a:solidFill>
-                  <a:srgbClr val="161616"/>
-                </a:solidFill>
-                <a:latin typeface="IBM Plex Sans"/>
-              </a:rPr>
-              <a:t>2</a:t>
-            </a:r>
-          </a:p>
-        </p:txBody>
-      </p:sp>
-      <p:sp>
-        <p:nvSpPr>
-          <p:cNvPr id="39" name="TextBox 38"/>
-          <p:cNvSpPr txBox="1"/>
-          <p:nvPr/>
-        </p:nvSpPr>
-        <p:spPr>
-          <a:xfrm>
-            <a:off x="10010832" y="4261104"/>
-            <a:ext cx="1412766" cy="402336"/>
-          </a:xfrm>
-          <a:prstGeom prst="rect">
-            <a:avLst/>
-          </a:prstGeom>
-          <a:noFill/>
-        </p:spPr>
-        <p:txBody>
-          <a:bodyPr wrap="square" anchor="t" lIns="0" rIns="0" tIns="0" bIns="0">
-            <a:spAutoFit/>
-          </a:bodyPr>
-          <a:lstStyle/>
-          <a:p>
-            <a:pPr algn="l">
-              <a:lnSpc>
-                <a:spcPct val="120000"/>
-              </a:lnSpc>
-              <a:spcAft>
-                <a:spcPts val="0"/>
-              </a:spcAft>
-            </a:pPr>
-            <a:r>
-              <a:rPr sz="1300" b="0" i="0">
-                <a:solidFill>
-                  <a:srgbClr val="161616"/>
-                </a:solidFill>
-                <a:latin typeface="IBM Plex Sans"/>
-              </a:rPr>
-              <a:t>1.1%</a:t>
-            </a:r>
-          </a:p>
-        </p:txBody>
-      </p:sp>
-      <p:sp>
-        <p:nvSpPr>
-          <p:cNvPr id="40" name="Rectangle 39"/>
-          <p:cNvSpPr/>
-          <p:nvPr/>
-        </p:nvSpPr>
-        <p:spPr>
-          <a:xfrm>
-            <a:off x="658368" y="4590288"/>
-            <a:ext cx="10874959" cy="5486"/>
-          </a:xfrm>
-          <a:prstGeom prst="rect">
-            <a:avLst/>
-          </a:prstGeom>
-          <a:solidFill>
-            <a:srgbClr val="E0E0E0"/>
-          </a:solidFill>
-          <a:ln>
-            <a:noFill/>
-          </a:ln>
-          <a:effectLst/>
-        </p:spPr>
-        <p:style>
-          <a:lnRef idx="1">
-            <a:schemeClr val="accent1"/>
-          </a:lnRef>
-          <a:fillRef idx="3">
-            <a:schemeClr val="accent1"/>
-          </a:fillRef>
-          <a:effectRef idx="2">
-            <a:schemeClr val="accent1"/>
-          </a:effectRef>
-          <a:fontRef idx="minor">
-            <a:schemeClr val="lt1"/>
-          </a:fontRef>
-        </p:style>
-        <p:txBody>
-          <a:bodyPr rtlCol="0" anchor="ctr"/>
-          <a:lstStyle/>
-          <a:p>
-            <a:pPr algn="ctr"/>
-          </a:p>
-        </p:txBody>
-      </p:sp>
-      <p:sp>
-        <p:nvSpPr>
-          <p:cNvPr id="41" name="TextBox 40"/>
-          <p:cNvSpPr txBox="1"/>
-          <p:nvPr/>
-        </p:nvSpPr>
-        <p:spPr>
-          <a:xfrm>
-            <a:off x="658368" y="4663440"/>
-            <a:ext cx="3587758" cy="402336"/>
-          </a:xfrm>
-          <a:prstGeom prst="rect">
-            <a:avLst/>
-          </a:prstGeom>
-          <a:noFill/>
-        </p:spPr>
-        <p:txBody>
-          <a:bodyPr wrap="square" anchor="t" lIns="0" rIns="0" tIns="0" bIns="0">
-            <a:spAutoFit/>
-          </a:bodyPr>
-          <a:lstStyle/>
-          <a:p>
-            <a:pPr algn="l">
-              <a:lnSpc>
-                <a:spcPct val="120000"/>
-              </a:lnSpc>
-              <a:spcAft>
-                <a:spcPts val="0"/>
-              </a:spcAft>
-            </a:pPr>
-            <a:r>
-              <a:rPr sz="1300" b="1" i="0">
-                <a:solidFill>
-                  <a:srgbClr val="161616"/>
-                </a:solidFill>
-                <a:latin typeface="IBM Plex Sans"/>
-              </a:rPr>
-              <a:t>neutral control</a:t>
-            </a:r>
-          </a:p>
-        </p:txBody>
-      </p:sp>
-      <p:sp>
-        <p:nvSpPr>
-          <p:cNvPr id="42" name="TextBox 41"/>
-          <p:cNvSpPr txBox="1"/>
-          <p:nvPr/>
-        </p:nvSpPr>
-        <p:spPr>
-          <a:xfrm>
-            <a:off x="4355854" y="4663440"/>
-            <a:ext cx="1630265" cy="402336"/>
-          </a:xfrm>
-          <a:prstGeom prst="rect">
-            <a:avLst/>
-          </a:prstGeom>
-          <a:noFill/>
-        </p:spPr>
-        <p:txBody>
-          <a:bodyPr wrap="square" anchor="t" lIns="0" rIns="0" tIns="0" bIns="0">
-            <a:spAutoFit/>
-          </a:bodyPr>
-          <a:lstStyle/>
-          <a:p>
-            <a:pPr algn="l">
-              <a:lnSpc>
-                <a:spcPct val="120000"/>
-              </a:lnSpc>
-              <a:spcAft>
-                <a:spcPts val="0"/>
-              </a:spcAft>
-            </a:pPr>
-            <a:r>
-              <a:rPr sz="1300" b="0" i="0">
-                <a:solidFill>
-                  <a:srgbClr val="161616"/>
-                </a:solidFill>
-                <a:latin typeface="IBM Plex Sans"/>
-              </a:rPr>
-              <a:t>175</a:t>
-            </a:r>
-          </a:p>
-        </p:txBody>
-      </p:sp>
-      <p:sp>
-        <p:nvSpPr>
-          <p:cNvPr id="43" name="TextBox 42"/>
-          <p:cNvSpPr txBox="1"/>
-          <p:nvPr/>
-        </p:nvSpPr>
-        <p:spPr>
-          <a:xfrm>
-            <a:off x="6095847" y="4663440"/>
-            <a:ext cx="1956514" cy="402336"/>
-          </a:xfrm>
-          <a:prstGeom prst="rect">
-            <a:avLst/>
-          </a:prstGeom>
-          <a:noFill/>
-        </p:spPr>
-        <p:txBody>
-          <a:bodyPr wrap="square" anchor="t" lIns="0" rIns="0" tIns="0" bIns="0">
-            <a:spAutoFit/>
-          </a:bodyPr>
-          <a:lstStyle/>
-          <a:p>
-            <a:pPr algn="l">
-              <a:lnSpc>
-                <a:spcPct val="120000"/>
-              </a:lnSpc>
-              <a:spcAft>
-                <a:spcPts val="0"/>
-              </a:spcAft>
-            </a:pPr>
-            <a:r>
-              <a:rPr sz="1300" b="0" i="0">
-                <a:solidFill>
-                  <a:srgbClr val="161616"/>
-                </a:solidFill>
-                <a:latin typeface="IBM Plex Sans"/>
-              </a:rPr>
-              <a:t>0</a:t>
-            </a:r>
-          </a:p>
-        </p:txBody>
-      </p:sp>
-      <p:sp>
-        <p:nvSpPr>
-          <p:cNvPr id="44" name="TextBox 43"/>
-          <p:cNvSpPr txBox="1"/>
-          <p:nvPr/>
-        </p:nvSpPr>
-        <p:spPr>
-          <a:xfrm>
-            <a:off x="8162089" y="4663440"/>
-            <a:ext cx="1739015" cy="402336"/>
-          </a:xfrm>
-          <a:prstGeom prst="rect">
-            <a:avLst/>
-          </a:prstGeom>
-          <a:noFill/>
-        </p:spPr>
-        <p:txBody>
-          <a:bodyPr wrap="square" anchor="t" lIns="0" rIns="0" tIns="0" bIns="0">
-            <a:spAutoFit/>
-          </a:bodyPr>
-          <a:lstStyle/>
-          <a:p>
-            <a:pPr algn="l">
-              <a:lnSpc>
-                <a:spcPct val="120000"/>
-              </a:lnSpc>
-              <a:spcAft>
-                <a:spcPts val="0"/>
-              </a:spcAft>
-            </a:pPr>
-            <a:r>
-              <a:rPr sz="1300" b="0" i="0">
-                <a:solidFill>
-                  <a:srgbClr val="161616"/>
-                </a:solidFill>
-                <a:latin typeface="IBM Plex Sans"/>
-              </a:rPr>
-              <a:t>0</a:t>
-            </a:r>
-          </a:p>
-        </p:txBody>
-      </p:sp>
-      <p:sp>
-        <p:nvSpPr>
-          <p:cNvPr id="45" name="TextBox 44"/>
-          <p:cNvSpPr txBox="1"/>
-          <p:nvPr/>
-        </p:nvSpPr>
-        <p:spPr>
-          <a:xfrm>
-            <a:off x="10010832" y="4663440"/>
-            <a:ext cx="1412766" cy="402336"/>
-          </a:xfrm>
-          <a:prstGeom prst="rect">
-            <a:avLst/>
-          </a:prstGeom>
-          <a:noFill/>
-        </p:spPr>
-        <p:txBody>
-          <a:bodyPr wrap="square" anchor="t" lIns="0" rIns="0" tIns="0" bIns="0">
-            <a:spAutoFit/>
-          </a:bodyPr>
-          <a:lstStyle/>
-          <a:p>
-            <a:pPr algn="l">
-              <a:lnSpc>
-                <a:spcPct val="120000"/>
-              </a:lnSpc>
-              <a:spcAft>
-                <a:spcPts val="0"/>
-              </a:spcAft>
-            </a:pPr>
-            <a:r>
-              <a:rPr sz="1300" b="0" i="0">
-                <a:solidFill>
-                  <a:srgbClr val="161616"/>
-                </a:solidFill>
-                <a:latin typeface="IBM Plex Sans"/>
-              </a:rPr>
-              <a:t>0.0%</a:t>
-            </a:r>
-          </a:p>
-        </p:txBody>
-      </p:sp>
-      <p:sp>
-        <p:nvSpPr>
-          <p:cNvPr id="46" name="TextBox 45"/>
-          <p:cNvSpPr txBox="1"/>
-          <p:nvPr/>
-        </p:nvSpPr>
-        <p:spPr>
-          <a:xfrm>
-            <a:off x="658368" y="5230368"/>
-            <a:ext cx="10874959" cy="914400"/>
-          </a:xfrm>
-          <a:prstGeom prst="rect">
-            <a:avLst/>
-          </a:prstGeom>
-          <a:noFill/>
-        </p:spPr>
-        <p:txBody>
-          <a:bodyPr wrap="square" anchor="t" lIns="0" rIns="0" tIns="0" bIns="0">
-            <a:spAutoFit/>
-          </a:bodyPr>
-          <a:lstStyle/>
-          <a:p>
-            <a:pPr algn="l">
-              <a:lnSpc>
-                <a:spcPct val="138000"/>
-              </a:lnSpc>
-              <a:spcAft>
-                <a:spcPts val="800"/>
-              </a:spcAft>
-            </a:pPr>
-            <a:r>
-              <a:rPr sz="1600" b="1" i="0">
-                <a:solidFill>
-                  <a:srgbClr val="D02670"/>
-                </a:solidFill>
-                <a:latin typeface="IBM Plex Sans"/>
-              </a:rPr>
-              <a:t>If the study stopped here it would conclude that the sycophancy is harmless.</a:t>
-            </a:r>
-          </a:p>
-          <a:p>
-            <a:pPr algn="l">
-              <a:lnSpc>
-                <a:spcPct val="138000"/>
-              </a:lnSpc>
-              <a:spcAft>
-                <a:spcPts val="800"/>
-              </a:spcAft>
-            </a:pPr>
-            <a:r>
-              <a:rPr sz="1350" b="0" i="0">
-                <a:solidFill>
-                  <a:srgbClr val="525252"/>
-                </a:solidFill>
-                <a:latin typeface="IBM Plex Sans"/>
-              </a:rPr>
-              <a:t>The model abandons its drug under pressure in almost every case and lands on another drug that also covers the organism. On the endpoint named as strongest, harmful revision runs between 0.0 and 1.5 per cent. That conclusion would be wrong, and my supervisor is the one who said where to look.</a:t>
-            </a:r>
-          </a:p>
-        </p:txBody>
-      </p:sp>
-      <p:sp>
-        <p:nvSpPr>
-          <p:cNvPr id="47" name="Rectangle 46"/>
-          <p:cNvSpPr/>
-          <p:nvPr/>
-        </p:nvSpPr>
-        <p:spPr>
-          <a:xfrm>
-            <a:off x="658368" y="6181344"/>
-            <a:ext cx="10874959" cy="7315"/>
-          </a:xfrm>
-          <a:prstGeom prst="rect">
-            <a:avLst/>
-          </a:prstGeom>
-          <a:solidFill>
-            <a:srgbClr val="E0E0E0"/>
-          </a:solidFill>
-          <a:ln>
-            <a:noFill/>
-          </a:ln>
-          <a:effectLst/>
-        </p:spPr>
-        <p:style>
-          <a:lnRef idx="1">
-            <a:schemeClr val="accent1"/>
-          </a:lnRef>
-          <a:fillRef idx="3">
-            <a:schemeClr val="accent1"/>
-          </a:fillRef>
-          <a:effectRef idx="2">
-            <a:schemeClr val="accent1"/>
-          </a:effectRef>
-          <a:fontRef idx="minor">
-            <a:schemeClr val="lt1"/>
-          </a:fontRef>
-        </p:style>
-        <p:txBody>
-          <a:bodyPr rtlCol="0" anchor="ctr"/>
-          <a:lstStyle/>
-          <a:p>
-            <a:pPr algn="ctr"/>
-          </a:p>
-        </p:txBody>
-      </p:sp>
-      <p:sp>
-        <p:nvSpPr>
-          <p:cNvPr id="48" name="TextBox 47"/>
+          <p:cNvPr id="8" name="TextBox 7"/>
           <p:cNvSpPr txBox="1"/>
           <p:nvPr/>
         </p:nvSpPr>
@@ -9203,14 +7508,14 @@
                 </a:solidFill>
                 <a:latin typeface="IBM Plex Sans"/>
               </a:rPr>
-              <a:t>results/tingting_endpoints.json  ·  analysis/tingting_endpoints.py  ·  denominator is the correct-before group</a:t>
-            </a:r>
-          </a:p>
-        </p:txBody>
-      </p:sp>
-      <p:sp>
-        <p:nvSpPr>
-          <p:cNvPr id="49" name="TextBox 48"/>
+              <a:t>the four-cell classification, harmful revision rate and beneficial correction rate are Prof. Zhu's endpoint definitions  ·  results/tingting_endpoints.json</a:t>
+            </a:r>
+          </a:p>
+        </p:txBody>
+      </p:sp>
+      <p:sp>
+        <p:nvSpPr>
+          <p:cNvPr id="9" name="TextBox 8"/>
           <p:cNvSpPr txBox="1"/>
           <p:nvPr/>
         </p:nvSpPr>
@@ -9313,7 +7618,7 @@
                 </a:solidFill>
                 <a:latin typeface="IBM Plex Sans"/>
               </a:rPr>
-              <a:t>RESULT FOUR</a:t>
+              <a:t>RESULT FOUR  ·  HER SPECTRUM-APPROPRIATENESS ENDPOINT</a:t>
             </a:r>
           </a:p>
         </p:txBody>
@@ -9397,7 +7702,7 @@
                 </a:solidFill>
                 <a:latin typeface="IBM Plex Sans"/>
               </a:rPr>
-              <a:t>The same endpoint hierarchy asks what kind of answer was given, not only whether it was right.</a:t>
+              <a:t>“a model recommending extremely broad therapy to everyone could achieve high coverage while still making poor antimicrobial-stewardship decisions”   Prof. Tingting Zhu, specifying this endpoint before the runs</a:t>
             </a:r>
           </a:p>
         </p:txBody>
@@ -19288,7 +17593,813 @@
       </p:sp>
       <p:sp>
         <p:nvSpPr>
-          <p:cNvPr id="20" name="Rectangle 19"/>
+          <p:cNvPr id="20" name="TextBox 19"/>
+          <p:cNvSpPr txBox="1"/>
+          <p:nvPr/>
+        </p:nvSpPr>
+        <p:spPr>
+          <a:xfrm>
+            <a:off x="658368" y="4315968"/>
+            <a:ext cx="3041835" cy="384048"/>
+          </a:xfrm>
+          <a:prstGeom prst="rect">
+            <a:avLst/>
+          </a:prstGeom>
+          <a:noFill/>
+        </p:spPr>
+        <p:txBody>
+          <a:bodyPr wrap="square" anchor="t" lIns="0" rIns="0" tIns="0" bIns="0">
+            <a:spAutoFit/>
+          </a:bodyPr>
+          <a:lstStyle/>
+          <a:p>
+            <a:pPr algn="l">
+              <a:lnSpc>
+                <a:spcPct val="115000"/>
+              </a:lnSpc>
+              <a:spcAft>
+                <a:spcPts val="0"/>
+              </a:spcAft>
+            </a:pPr>
+            <a:r>
+              <a:rPr sz="950" b="1" i="0" spc="90">
+                <a:solidFill>
+                  <a:srgbClr val="525252"/>
+                </a:solidFill>
+                <a:latin typeface="IBM Plex Sans"/>
+              </a:rPr>
+              <a:t>TIER 3, NO FINE-TUNING</a:t>
+            </a:r>
+          </a:p>
+        </p:txBody>
+      </p:sp>
+      <p:sp>
+        <p:nvSpPr>
+          <p:cNvPr id="21" name="TextBox 20"/>
+          <p:cNvSpPr txBox="1"/>
+          <p:nvPr/>
+        </p:nvSpPr>
+        <p:spPr>
+          <a:xfrm>
+            <a:off x="3809931" y="4315968"/>
+            <a:ext cx="1808614" cy="384048"/>
+          </a:xfrm>
+          <a:prstGeom prst="rect">
+            <a:avLst/>
+          </a:prstGeom>
+          <a:noFill/>
+        </p:spPr>
+        <p:txBody>
+          <a:bodyPr wrap="square" anchor="t" lIns="0" rIns="0" tIns="0" bIns="0">
+            <a:spAutoFit/>
+          </a:bodyPr>
+          <a:lstStyle/>
+          <a:p>
+            <a:pPr algn="l">
+              <a:lnSpc>
+                <a:spcPct val="115000"/>
+              </a:lnSpc>
+              <a:spcAft>
+                <a:spcPts val="0"/>
+              </a:spcAft>
+            </a:pPr>
+            <a:r>
+              <a:rPr sz="950" b="1" i="0" spc="90">
+                <a:solidFill>
+                  <a:srgbClr val="525252"/>
+                </a:solidFill>
+                <a:latin typeface="IBM Plex Sans"/>
+              </a:rPr>
+              <a:t>DISTINCT PREDICTIONS</a:t>
+            </a:r>
+          </a:p>
+        </p:txBody>
+      </p:sp>
+      <p:sp>
+        <p:nvSpPr>
+          <p:cNvPr id="22" name="TextBox 21"/>
+          <p:cNvSpPr txBox="1"/>
+          <p:nvPr/>
+        </p:nvSpPr>
+        <p:spPr>
+          <a:xfrm>
+            <a:off x="5728273" y="4315968"/>
+            <a:ext cx="1671590" cy="384048"/>
+          </a:xfrm>
+          <a:prstGeom prst="rect">
+            <a:avLst/>
+          </a:prstGeom>
+          <a:noFill/>
+        </p:spPr>
+        <p:txBody>
+          <a:bodyPr wrap="square" anchor="t" lIns="0" rIns="0" tIns="0" bIns="0">
+            <a:spAutoFit/>
+          </a:bodyPr>
+          <a:lstStyle/>
+          <a:p>
+            <a:pPr algn="l">
+              <a:lnSpc>
+                <a:spcPct val="115000"/>
+              </a:lnSpc>
+              <a:spcAft>
+                <a:spcPts val="0"/>
+              </a:spcAft>
+            </a:pPr>
+            <a:r>
+              <a:rPr sz="950" b="1" i="0" spc="90">
+                <a:solidFill>
+                  <a:srgbClr val="525252"/>
+                </a:solidFill>
+                <a:latin typeface="IBM Plex Sans"/>
+              </a:rPr>
+              <a:t>COVERS THE ORGANISM</a:t>
+            </a:r>
+          </a:p>
+        </p:txBody>
+      </p:sp>
+      <p:sp>
+        <p:nvSpPr>
+          <p:cNvPr id="23" name="Rectangle 22"/>
+          <p:cNvSpPr/>
+          <p:nvPr/>
+        </p:nvSpPr>
+        <p:spPr>
+          <a:xfrm>
+            <a:off x="658368" y="4700016"/>
+            <a:ext cx="6851224" cy="10972"/>
+          </a:xfrm>
+          <a:prstGeom prst="rect">
+            <a:avLst/>
+          </a:prstGeom>
+          <a:solidFill>
+            <a:srgbClr val="161616"/>
+          </a:solidFill>
+          <a:ln>
+            <a:noFill/>
+          </a:ln>
+          <a:effectLst/>
+        </p:spPr>
+        <p:style>
+          <a:lnRef idx="1">
+            <a:schemeClr val="accent1"/>
+          </a:lnRef>
+          <a:fillRef idx="3">
+            <a:schemeClr val="accent1"/>
+          </a:fillRef>
+          <a:effectRef idx="2">
+            <a:schemeClr val="accent1"/>
+          </a:effectRef>
+          <a:fontRef idx="minor">
+            <a:schemeClr val="lt1"/>
+          </a:fontRef>
+        </p:style>
+        <p:txBody>
+          <a:bodyPr rtlCol="0" anchor="ctr"/>
+          <a:lstStyle/>
+          <a:p>
+            <a:pPr algn="ctr"/>
+          </a:p>
+        </p:txBody>
+      </p:sp>
+      <p:sp>
+        <p:nvSpPr>
+          <p:cNvPr id="24" name="TextBox 23"/>
+          <p:cNvSpPr txBox="1"/>
+          <p:nvPr/>
+        </p:nvSpPr>
+        <p:spPr>
+          <a:xfrm>
+            <a:off x="658368" y="4882895"/>
+            <a:ext cx="3041835" cy="347472"/>
+          </a:xfrm>
+          <a:prstGeom prst="rect">
+            <a:avLst/>
+          </a:prstGeom>
+          <a:noFill/>
+        </p:spPr>
+        <p:txBody>
+          <a:bodyPr wrap="square" anchor="t" lIns="0" rIns="0" tIns="0" bIns="0">
+            <a:spAutoFit/>
+          </a:bodyPr>
+          <a:lstStyle/>
+          <a:p>
+            <a:pPr algn="l">
+              <a:lnSpc>
+                <a:spcPct val="120000"/>
+              </a:lnSpc>
+              <a:spcAft>
+                <a:spcPts val="0"/>
+              </a:spcAft>
+            </a:pPr>
+            <a:r>
+              <a:rPr sz="1150" b="0" i="0">
+                <a:solidFill>
+                  <a:srgbClr val="161616"/>
+                </a:solidFill>
+                <a:latin typeface="IBM Plex Sans"/>
+              </a:rPr>
+              <a:t>BiomedNLP-BiomedBERT-base-uncased-abstract-fulltext</a:t>
+            </a:r>
+          </a:p>
+        </p:txBody>
+      </p:sp>
+      <p:sp>
+        <p:nvSpPr>
+          <p:cNvPr id="25" name="TextBox 24"/>
+          <p:cNvSpPr txBox="1"/>
+          <p:nvPr/>
+        </p:nvSpPr>
+        <p:spPr>
+          <a:xfrm>
+            <a:off x="3809931" y="4882895"/>
+            <a:ext cx="1808614" cy="347472"/>
+          </a:xfrm>
+          <a:prstGeom prst="rect">
+            <a:avLst/>
+          </a:prstGeom>
+          <a:noFill/>
+        </p:spPr>
+        <p:txBody>
+          <a:bodyPr wrap="square" anchor="t" lIns="0" rIns="0" tIns="0" bIns="0">
+            <a:spAutoFit/>
+          </a:bodyPr>
+          <a:lstStyle/>
+          <a:p>
+            <a:pPr algn="l">
+              <a:lnSpc>
+                <a:spcPct val="120000"/>
+              </a:lnSpc>
+              <a:spcAft>
+                <a:spcPts val="0"/>
+              </a:spcAft>
+            </a:pPr>
+            <a:r>
+              <a:rPr sz="1150" b="0" i="0">
+                <a:solidFill>
+                  <a:srgbClr val="161616"/>
+                </a:solidFill>
+                <a:latin typeface="IBM Plex Sans"/>
+              </a:rPr>
+              <a:t>2 across 200 patients</a:t>
+            </a:r>
+          </a:p>
+        </p:txBody>
+      </p:sp>
+      <p:sp>
+        <p:nvSpPr>
+          <p:cNvPr id="26" name="TextBox 25"/>
+          <p:cNvSpPr txBox="1"/>
+          <p:nvPr/>
+        </p:nvSpPr>
+        <p:spPr>
+          <a:xfrm>
+            <a:off x="5728273" y="4882895"/>
+            <a:ext cx="1671590" cy="347472"/>
+          </a:xfrm>
+          <a:prstGeom prst="rect">
+            <a:avLst/>
+          </a:prstGeom>
+          <a:noFill/>
+        </p:spPr>
+        <p:txBody>
+          <a:bodyPr wrap="square" anchor="t" lIns="0" rIns="0" tIns="0" bIns="0">
+            <a:spAutoFit/>
+          </a:bodyPr>
+          <a:lstStyle/>
+          <a:p>
+            <a:pPr algn="l">
+              <a:lnSpc>
+                <a:spcPct val="120000"/>
+              </a:lnSpc>
+              <a:spcAft>
+                <a:spcPts val="0"/>
+              </a:spcAft>
+            </a:pPr>
+            <a:r>
+              <a:rPr sz="1150" b="1" i="0">
+                <a:solidFill>
+                  <a:srgbClr val="0F62FE"/>
+                </a:solidFill>
+                <a:latin typeface="IBM Plex Sans"/>
+              </a:rPr>
+              <a:t>169/200 = 84.5%</a:t>
+            </a:r>
+          </a:p>
+        </p:txBody>
+      </p:sp>
+      <p:sp>
+        <p:nvSpPr>
+          <p:cNvPr id="27" name="Rectangle 26"/>
+          <p:cNvSpPr/>
+          <p:nvPr/>
+        </p:nvSpPr>
+        <p:spPr>
+          <a:xfrm>
+            <a:off x="658368" y="5157216"/>
+            <a:ext cx="6851224" cy="5486"/>
+          </a:xfrm>
+          <a:prstGeom prst="rect">
+            <a:avLst/>
+          </a:prstGeom>
+          <a:solidFill>
+            <a:srgbClr val="E0E0E0"/>
+          </a:solidFill>
+          <a:ln>
+            <a:noFill/>
+          </a:ln>
+          <a:effectLst/>
+        </p:spPr>
+        <p:style>
+          <a:lnRef idx="1">
+            <a:schemeClr val="accent1"/>
+          </a:lnRef>
+          <a:fillRef idx="3">
+            <a:schemeClr val="accent1"/>
+          </a:fillRef>
+          <a:effectRef idx="2">
+            <a:schemeClr val="accent1"/>
+          </a:effectRef>
+          <a:fontRef idx="minor">
+            <a:schemeClr val="lt1"/>
+          </a:fontRef>
+        </p:style>
+        <p:txBody>
+          <a:bodyPr rtlCol="0" anchor="ctr"/>
+          <a:lstStyle/>
+          <a:p>
+            <a:pPr algn="ctr"/>
+          </a:p>
+        </p:txBody>
+      </p:sp>
+      <p:sp>
+        <p:nvSpPr>
+          <p:cNvPr id="28" name="TextBox 27"/>
+          <p:cNvSpPr txBox="1"/>
+          <p:nvPr/>
+        </p:nvSpPr>
+        <p:spPr>
+          <a:xfrm>
+            <a:off x="658368" y="5230367"/>
+            <a:ext cx="3041835" cy="347472"/>
+          </a:xfrm>
+          <a:prstGeom prst="rect">
+            <a:avLst/>
+          </a:prstGeom>
+          <a:noFill/>
+        </p:spPr>
+        <p:txBody>
+          <a:bodyPr wrap="square" anchor="t" lIns="0" rIns="0" tIns="0" bIns="0">
+            <a:spAutoFit/>
+          </a:bodyPr>
+          <a:lstStyle/>
+          <a:p>
+            <a:pPr algn="l">
+              <a:lnSpc>
+                <a:spcPct val="120000"/>
+              </a:lnSpc>
+              <a:spcAft>
+                <a:spcPts val="0"/>
+              </a:spcAft>
+            </a:pPr>
+            <a:r>
+              <a:rPr sz="1150" b="0" i="0">
+                <a:solidFill>
+                  <a:srgbClr val="161616"/>
+                </a:solidFill>
+                <a:latin typeface="IBM Plex Sans"/>
+              </a:rPr>
+              <a:t>bert-base-uncased</a:t>
+            </a:r>
+          </a:p>
+        </p:txBody>
+      </p:sp>
+      <p:sp>
+        <p:nvSpPr>
+          <p:cNvPr id="29" name="TextBox 28"/>
+          <p:cNvSpPr txBox="1"/>
+          <p:nvPr/>
+        </p:nvSpPr>
+        <p:spPr>
+          <a:xfrm>
+            <a:off x="3809931" y="5230367"/>
+            <a:ext cx="1808614" cy="347472"/>
+          </a:xfrm>
+          <a:prstGeom prst="rect">
+            <a:avLst/>
+          </a:prstGeom>
+          <a:noFill/>
+        </p:spPr>
+        <p:txBody>
+          <a:bodyPr wrap="square" anchor="t" lIns="0" rIns="0" tIns="0" bIns="0">
+            <a:spAutoFit/>
+          </a:bodyPr>
+          <a:lstStyle/>
+          <a:p>
+            <a:pPr algn="l">
+              <a:lnSpc>
+                <a:spcPct val="120000"/>
+              </a:lnSpc>
+              <a:spcAft>
+                <a:spcPts val="0"/>
+              </a:spcAft>
+            </a:pPr>
+            <a:r>
+              <a:rPr sz="1150" b="0" i="0">
+                <a:solidFill>
+                  <a:srgbClr val="161616"/>
+                </a:solidFill>
+                <a:latin typeface="IBM Plex Sans"/>
+              </a:rPr>
+              <a:t>2 across 200 patients</a:t>
+            </a:r>
+          </a:p>
+        </p:txBody>
+      </p:sp>
+      <p:sp>
+        <p:nvSpPr>
+          <p:cNvPr id="30" name="TextBox 29"/>
+          <p:cNvSpPr txBox="1"/>
+          <p:nvPr/>
+        </p:nvSpPr>
+        <p:spPr>
+          <a:xfrm>
+            <a:off x="5728273" y="5230367"/>
+            <a:ext cx="1671590" cy="347472"/>
+          </a:xfrm>
+          <a:prstGeom prst="rect">
+            <a:avLst/>
+          </a:prstGeom>
+          <a:noFill/>
+        </p:spPr>
+        <p:txBody>
+          <a:bodyPr wrap="square" anchor="t" lIns="0" rIns="0" tIns="0" bIns="0">
+            <a:spAutoFit/>
+          </a:bodyPr>
+          <a:lstStyle/>
+          <a:p>
+            <a:pPr algn="l">
+              <a:lnSpc>
+                <a:spcPct val="120000"/>
+              </a:lnSpc>
+              <a:spcAft>
+                <a:spcPts val="0"/>
+              </a:spcAft>
+            </a:pPr>
+            <a:r>
+              <a:rPr sz="1150" b="0" i="0">
+                <a:solidFill>
+                  <a:srgbClr val="525252"/>
+                </a:solidFill>
+                <a:latin typeface="IBM Plex Sans"/>
+              </a:rPr>
+              <a:t>50/200 = 25.0%</a:t>
+            </a:r>
+          </a:p>
+        </p:txBody>
+      </p:sp>
+      <p:sp>
+        <p:nvSpPr>
+          <p:cNvPr id="31" name="Rectangle 30"/>
+          <p:cNvSpPr/>
+          <p:nvPr/>
+        </p:nvSpPr>
+        <p:spPr>
+          <a:xfrm>
+            <a:off x="658368" y="5504688"/>
+            <a:ext cx="6851224" cy="5486"/>
+          </a:xfrm>
+          <a:prstGeom prst="rect">
+            <a:avLst/>
+          </a:prstGeom>
+          <a:solidFill>
+            <a:srgbClr val="E0E0E0"/>
+          </a:solidFill>
+          <a:ln>
+            <a:noFill/>
+          </a:ln>
+          <a:effectLst/>
+        </p:spPr>
+        <p:style>
+          <a:lnRef idx="1">
+            <a:schemeClr val="accent1"/>
+          </a:lnRef>
+          <a:fillRef idx="3">
+            <a:schemeClr val="accent1"/>
+          </a:fillRef>
+          <a:effectRef idx="2">
+            <a:schemeClr val="accent1"/>
+          </a:effectRef>
+          <a:fontRef idx="minor">
+            <a:schemeClr val="lt1"/>
+          </a:fontRef>
+        </p:style>
+        <p:txBody>
+          <a:bodyPr rtlCol="0" anchor="ctr"/>
+          <a:lstStyle/>
+          <a:p>
+            <a:pPr algn="ctr"/>
+          </a:p>
+        </p:txBody>
+      </p:sp>
+      <p:sp>
+        <p:nvSpPr>
+          <p:cNvPr id="32" name="TextBox 31"/>
+          <p:cNvSpPr txBox="1"/>
+          <p:nvPr/>
+        </p:nvSpPr>
+        <p:spPr>
+          <a:xfrm>
+            <a:off x="658368" y="5577839"/>
+            <a:ext cx="3041835" cy="347472"/>
+          </a:xfrm>
+          <a:prstGeom prst="rect">
+            <a:avLst/>
+          </a:prstGeom>
+          <a:noFill/>
+        </p:spPr>
+        <p:txBody>
+          <a:bodyPr wrap="square" anchor="t" lIns="0" rIns="0" tIns="0" bIns="0">
+            <a:spAutoFit/>
+          </a:bodyPr>
+          <a:lstStyle/>
+          <a:p>
+            <a:pPr algn="l">
+              <a:lnSpc>
+                <a:spcPct val="120000"/>
+              </a:lnSpc>
+              <a:spcAft>
+                <a:spcPts val="0"/>
+              </a:spcAft>
+            </a:pPr>
+            <a:r>
+              <a:rPr sz="1150" b="0" i="0">
+                <a:solidFill>
+                  <a:srgbClr val="161616"/>
+                </a:solidFill>
+                <a:latin typeface="IBM Plex Sans"/>
+              </a:rPr>
+              <a:t>biobert-base-cased-v1.2</a:t>
+            </a:r>
+          </a:p>
+        </p:txBody>
+      </p:sp>
+      <p:sp>
+        <p:nvSpPr>
+          <p:cNvPr id="33" name="TextBox 32"/>
+          <p:cNvSpPr txBox="1"/>
+          <p:nvPr/>
+        </p:nvSpPr>
+        <p:spPr>
+          <a:xfrm>
+            <a:off x="3809931" y="5577839"/>
+            <a:ext cx="1808614" cy="347472"/>
+          </a:xfrm>
+          <a:prstGeom prst="rect">
+            <a:avLst/>
+          </a:prstGeom>
+          <a:noFill/>
+        </p:spPr>
+        <p:txBody>
+          <a:bodyPr wrap="square" anchor="t" lIns="0" rIns="0" tIns="0" bIns="0">
+            <a:spAutoFit/>
+          </a:bodyPr>
+          <a:lstStyle/>
+          <a:p>
+            <a:pPr algn="l">
+              <a:lnSpc>
+                <a:spcPct val="120000"/>
+              </a:lnSpc>
+              <a:spcAft>
+                <a:spcPts val="0"/>
+              </a:spcAft>
+            </a:pPr>
+            <a:r>
+              <a:rPr sz="1150" b="0" i="0">
+                <a:solidFill>
+                  <a:srgbClr val="161616"/>
+                </a:solidFill>
+                <a:latin typeface="IBM Plex Sans"/>
+              </a:rPr>
+              <a:t>2 across 200 patients</a:t>
+            </a:r>
+          </a:p>
+        </p:txBody>
+      </p:sp>
+      <p:sp>
+        <p:nvSpPr>
+          <p:cNvPr id="34" name="TextBox 33"/>
+          <p:cNvSpPr txBox="1"/>
+          <p:nvPr/>
+        </p:nvSpPr>
+        <p:spPr>
+          <a:xfrm>
+            <a:off x="5728273" y="5577839"/>
+            <a:ext cx="1671590" cy="347472"/>
+          </a:xfrm>
+          <a:prstGeom prst="rect">
+            <a:avLst/>
+          </a:prstGeom>
+          <a:noFill/>
+        </p:spPr>
+        <p:txBody>
+          <a:bodyPr wrap="square" anchor="t" lIns="0" rIns="0" tIns="0" bIns="0">
+            <a:spAutoFit/>
+          </a:bodyPr>
+          <a:lstStyle/>
+          <a:p>
+            <a:pPr algn="l">
+              <a:lnSpc>
+                <a:spcPct val="120000"/>
+              </a:lnSpc>
+              <a:spcAft>
+                <a:spcPts val="0"/>
+              </a:spcAft>
+            </a:pPr>
+            <a:r>
+              <a:rPr sz="1150" b="0" i="0">
+                <a:solidFill>
+                  <a:srgbClr val="525252"/>
+                </a:solidFill>
+                <a:latin typeface="IBM Plex Sans"/>
+              </a:rPr>
+              <a:t>22/200 = 11.0%</a:t>
+            </a:r>
+          </a:p>
+        </p:txBody>
+      </p:sp>
+      <p:sp>
+        <p:nvSpPr>
+          <p:cNvPr id="35" name="Rectangle 34"/>
+          <p:cNvSpPr/>
+          <p:nvPr/>
+        </p:nvSpPr>
+        <p:spPr>
+          <a:xfrm>
+            <a:off x="658368" y="5852159"/>
+            <a:ext cx="6851224" cy="5486"/>
+          </a:xfrm>
+          <a:prstGeom prst="rect">
+            <a:avLst/>
+          </a:prstGeom>
+          <a:solidFill>
+            <a:srgbClr val="E0E0E0"/>
+          </a:solidFill>
+          <a:ln>
+            <a:noFill/>
+          </a:ln>
+          <a:effectLst/>
+        </p:spPr>
+        <p:style>
+          <a:lnRef idx="1">
+            <a:schemeClr val="accent1"/>
+          </a:lnRef>
+          <a:fillRef idx="3">
+            <a:schemeClr val="accent1"/>
+          </a:fillRef>
+          <a:effectRef idx="2">
+            <a:schemeClr val="accent1"/>
+          </a:effectRef>
+          <a:fontRef idx="minor">
+            <a:schemeClr val="lt1"/>
+          </a:fontRef>
+        </p:style>
+        <p:txBody>
+          <a:bodyPr rtlCol="0" anchor="ctr"/>
+          <a:lstStyle/>
+          <a:p>
+            <a:pPr algn="ctr"/>
+          </a:p>
+        </p:txBody>
+      </p:sp>
+      <p:sp>
+        <p:nvSpPr>
+          <p:cNvPr id="36" name="TextBox 35"/>
+          <p:cNvSpPr txBox="1"/>
+          <p:nvPr/>
+        </p:nvSpPr>
+        <p:spPr>
+          <a:xfrm>
+            <a:off x="658368" y="5925311"/>
+            <a:ext cx="3041835" cy="347472"/>
+          </a:xfrm>
+          <a:prstGeom prst="rect">
+            <a:avLst/>
+          </a:prstGeom>
+          <a:noFill/>
+        </p:spPr>
+        <p:txBody>
+          <a:bodyPr wrap="square" anchor="t" lIns="0" rIns="0" tIns="0" bIns="0">
+            <a:spAutoFit/>
+          </a:bodyPr>
+          <a:lstStyle/>
+          <a:p>
+            <a:pPr algn="l">
+              <a:lnSpc>
+                <a:spcPct val="120000"/>
+              </a:lnSpc>
+              <a:spcAft>
+                <a:spcPts val="0"/>
+              </a:spcAft>
+            </a:pPr>
+            <a:r>
+              <a:rPr sz="1150" b="0" i="0">
+                <a:solidFill>
+                  <a:srgbClr val="161616"/>
+                </a:solidFill>
+                <a:latin typeface="IBM Plex Sans"/>
+              </a:rPr>
+              <a:t>Bio_ClinicalBERT</a:t>
+            </a:r>
+          </a:p>
+        </p:txBody>
+      </p:sp>
+      <p:sp>
+        <p:nvSpPr>
+          <p:cNvPr id="37" name="TextBox 36"/>
+          <p:cNvSpPr txBox="1"/>
+          <p:nvPr/>
+        </p:nvSpPr>
+        <p:spPr>
+          <a:xfrm>
+            <a:off x="3809931" y="5925311"/>
+            <a:ext cx="1808614" cy="347472"/>
+          </a:xfrm>
+          <a:prstGeom prst="rect">
+            <a:avLst/>
+          </a:prstGeom>
+          <a:noFill/>
+        </p:spPr>
+        <p:txBody>
+          <a:bodyPr wrap="square" anchor="t" lIns="0" rIns="0" tIns="0" bIns="0">
+            <a:spAutoFit/>
+          </a:bodyPr>
+          <a:lstStyle/>
+          <a:p>
+            <a:pPr algn="l">
+              <a:lnSpc>
+                <a:spcPct val="120000"/>
+              </a:lnSpc>
+              <a:spcAft>
+                <a:spcPts val="0"/>
+              </a:spcAft>
+            </a:pPr>
+            <a:r>
+              <a:rPr sz="1150" b="0" i="0">
+                <a:solidFill>
+                  <a:srgbClr val="161616"/>
+                </a:solidFill>
+                <a:latin typeface="IBM Plex Sans"/>
+              </a:rPr>
+              <a:t>1 across 200 patients</a:t>
+            </a:r>
+          </a:p>
+        </p:txBody>
+      </p:sp>
+      <p:sp>
+        <p:nvSpPr>
+          <p:cNvPr id="38" name="TextBox 37"/>
+          <p:cNvSpPr txBox="1"/>
+          <p:nvPr/>
+        </p:nvSpPr>
+        <p:spPr>
+          <a:xfrm>
+            <a:off x="5728273" y="5925311"/>
+            <a:ext cx="1671590" cy="347472"/>
+          </a:xfrm>
+          <a:prstGeom prst="rect">
+            <a:avLst/>
+          </a:prstGeom>
+          <a:noFill/>
+        </p:spPr>
+        <p:txBody>
+          <a:bodyPr wrap="square" anchor="t" lIns="0" rIns="0" tIns="0" bIns="0">
+            <a:spAutoFit/>
+          </a:bodyPr>
+          <a:lstStyle/>
+          <a:p>
+            <a:pPr algn="l">
+              <a:lnSpc>
+                <a:spcPct val="120000"/>
+              </a:lnSpc>
+              <a:spcAft>
+                <a:spcPts val="0"/>
+              </a:spcAft>
+            </a:pPr>
+            <a:r>
+              <a:rPr sz="1150" b="0" i="0">
+                <a:solidFill>
+                  <a:srgbClr val="525252"/>
+                </a:solidFill>
+                <a:latin typeface="IBM Plex Sans"/>
+              </a:rPr>
+              <a:t>0/200 = 0.0%</a:t>
+            </a:r>
+          </a:p>
+        </p:txBody>
+      </p:sp>
+      <p:sp>
+        <p:nvSpPr>
+          <p:cNvPr id="39" name="Rectangle 38"/>
           <p:cNvSpPr/>
           <p:nvPr/>
         </p:nvSpPr>
@@ -19332,7 +18443,7 @@
       </p:sp>
       <p:sp>
         <p:nvSpPr>
-          <p:cNvPr id="21" name="TextBox 20"/>
+          <p:cNvPr id="40" name="TextBox 39"/>
           <p:cNvSpPr txBox="1"/>
           <p:nvPr/>
         </p:nvSpPr>
@@ -19412,14 +18523,14 @@
       </p:sp>
       <p:sp>
         <p:nvSpPr>
-          <p:cNvPr id="22" name="TextBox 21"/>
-          <p:cNvSpPr txBox="1"/>
-          <p:nvPr/>
-        </p:nvSpPr>
-        <p:spPr>
-          <a:xfrm>
-            <a:off x="658368" y="4572000"/>
-            <a:ext cx="6851224" cy="1188720"/>
+          <p:cNvPr id="41" name="TextBox 40"/>
+          <p:cNvSpPr txBox="1"/>
+          <p:nvPr/>
+        </p:nvSpPr>
+        <p:spPr>
+          <a:xfrm>
+            <a:off x="658368" y="5742432"/>
+            <a:ext cx="6851224" cy="548640"/>
           </a:xfrm>
           <a:prstGeom prst="rect">
             <a:avLst/>
@@ -19463,7 +18574,7 @@
       </p:sp>
       <p:sp>
         <p:nvSpPr>
-          <p:cNvPr id="23" name="TextBox 22"/>
+          <p:cNvPr id="42" name="TextBox 41"/>
           <p:cNvSpPr txBox="1"/>
           <p:nvPr/>
         </p:nvSpPr>
@@ -19524,14 +18635,14 @@
       </p:sp>
       <p:sp>
         <p:nvSpPr>
-          <p:cNvPr id="24" name="TextBox 23"/>
-          <p:cNvSpPr txBox="1"/>
-          <p:nvPr/>
-        </p:nvSpPr>
-        <p:spPr>
-          <a:xfrm>
-            <a:off x="658368" y="5760720"/>
-            <a:ext cx="6851224" cy="457200"/>
+          <p:cNvPr id="43" name="TextBox 42"/>
+          <p:cNvSpPr txBox="1"/>
+          <p:nvPr/>
+        </p:nvSpPr>
+        <p:spPr>
+          <a:xfrm>
+            <a:off x="7835841" y="5742432"/>
+            <a:ext cx="3697486" cy="548640"/>
           </a:xfrm>
           <a:prstGeom prst="rect">
             <a:avLst/>
@@ -19566,7 +18677,7 @@
       </p:sp>
       <p:sp>
         <p:nvSpPr>
-          <p:cNvPr id="25" name="Rectangle 24"/>
+          <p:cNvPr id="44" name="Rectangle 43"/>
           <p:cNvSpPr/>
           <p:nvPr/>
         </p:nvSpPr>
@@ -19610,7 +18721,7 @@
       </p:sp>
       <p:sp>
         <p:nvSpPr>
-          <p:cNvPr id="26" name="TextBox 25"/>
+          <p:cNvPr id="45" name="TextBox 44"/>
           <p:cNvSpPr txBox="1"/>
           <p:nvPr/>
         </p:nvSpPr>
@@ -19652,7 +18763,7 @@
       </p:sp>
       <p:sp>
         <p:nvSpPr>
-          <p:cNvPr id="27" name="TextBox 26"/>
+          <p:cNvPr id="46" name="TextBox 45"/>
           <p:cNvSpPr txBox="1"/>
           <p:nvPr/>
         </p:nvSpPr>
@@ -26266,7 +25377,7 @@
                 </a:solidFill>
                 <a:latin typeface="IBM Plex Sans"/>
               </a:rPr>
-              <a:t>cohort gates from results/cohort_gates_skeleton.csv  ·  PROJECT.md sections 3 to 6  ·  scorer SHA and cohort hash asserted at every launch</a:t>
+              <a:t>cohort N = 7,796 hash-frozen before the first model call, evaluation subsample n = 200  ·  qwen3:4b-instruct-2507-q4_K_M, temperature 0, seed 20260818, run locally</a:t>
             </a:r>
           </a:p>
         </p:txBody>

</xml_diff>

<commit_message>
Close her outstanding asks: clinician comparison, named gaps, the sycophancy join, and supervisor and literature rules in CLAUDE.md
</commit_message>
<xml_diff>
--- a/deck/Shomique_Hayat_UNIQ_antibiotic_agents.pptx
+++ b/deck/Shomique_Hayat_UNIQ_antibiotic_agents.pptx
@@ -30,6 +30,7 @@
     <p:sldId id="278" r:id="rId30"/>
     <p:sldId id="279" r:id="rId31"/>
     <p:sldId id="280" r:id="rId32"/>
+    <p:sldId id="281" r:id="rId33"/>
   </p:sldIdLst>
   <p:sldSz cx="12191695" cy="6858000" type="screen4x3"/>
   <p:notesSz cx="6858000" cy="9144000"/>
@@ -2561,6 +2562,127 @@
           <a:p>
             <a:r>
               <a:t>That is the honest answer to rung two, and by her own sequencing it is what justifies rung three.</a:t>
+            </a:r>
+          </a:p>
+        </p:txBody>
+      </p:sp>
+      <p:sp>
+        <p:nvSpPr>
+          <p:cNvPr id="4" name="Slide Number Placeholder 3"/>
+          <p:cNvSpPr>
+            <a:spLocks noGrp="1"/>
+          </p:cNvSpPr>
+          <p:nvPr>
+            <p:ph type="sldNum" idx="5" sz="quarter"/>
+          </p:nvPr>
+        </p:nvSpPr>
+        <p:spPr/>
+      </p:sp>
+    </p:spTree>
+  </p:cSld>
+  <p:clrMapOvr>
+    <a:masterClrMapping/>
+  </p:clrMapOvr>
+</p:notes>
+</file>
+
+<file path=ppt/notesSlides/notesSlide26.xml><?xml version="1.0" encoding="utf-8"?>
+<p:notes xmlns:a="http://schemas.openxmlformats.org/drawingml/2006/main" xmlns:p="http://schemas.openxmlformats.org/presentationml/2006/main" xmlns:r="http://schemas.openxmlformats.org/officeDocument/2006/relationships">
+  <p:cSld>
+    <p:spTree>
+      <p:nvGrpSpPr>
+        <p:cNvPr id="1" name=""/>
+        <p:cNvGrpSpPr/>
+        <p:nvPr/>
+      </p:nvGrpSpPr>
+      <p:grpSpPr>
+        <a:xfrm>
+          <a:off x="0" y="0"/>
+          <a:ext cx="0" cy="0"/>
+          <a:chOff x="0" y="0"/>
+          <a:chExt cx="0" cy="0"/>
+        </a:xfrm>
+      </p:grpSpPr>
+      <p:sp>
+        <p:nvSpPr>
+          <p:cNvPr id="2" name="Slide Image Placeholder 1"/>
+          <p:cNvSpPr>
+            <a:spLocks noGrp="1"/>
+          </p:cNvSpPr>
+          <p:nvPr>
+            <p:ph type="sldImg" idx="2"/>
+          </p:nvPr>
+        </p:nvSpPr>
+        <p:spPr/>
+      </p:sp>
+      <p:sp>
+        <p:nvSpPr>
+          <p:cNvPr id="3" name="Notes Placeholder 2"/>
+          <p:cNvSpPr>
+            <a:spLocks noGrp="1"/>
+          </p:cNvSpPr>
+          <p:nvPr>
+            <p:ph type="body" idx="3" sz="quarter"/>
+          </p:nvPr>
+        </p:nvSpPr>
+        <p:spPr/>
+        <p:txBody>
+          <a:bodyPr/>
+          <a:lstStyle/>
+          <a:p>
+            <a:r>
+              <a:t>BACKUP SLIDE, not in the ten minutes. Use it in questions.</a:t>
+            </a:r>
+          </a:p>
+          <a:p/>
+          <a:p>
+            <a:r>
+              <a:t>Backup slide, and it answers a question she asked me twice.</a:t>
+            </a:r>
+          </a:p>
+          <a:p>
+            <a:r>
+              <a:t>The rule she set was two comparisons, not one: the model against the ground truth, and the model</a:t>
+            </a:r>
+          </a:p>
+          <a:p>
+            <a:r>
+              <a:t>against what the clinician actually did. This is the second.</a:t>
+            </a:r>
+          </a:p>
+          <a:p>
+            <a:r>
+              <a:t>On all 200 cases the model looks 25 points better. That is not a real margin and I do not present it</a:t>
+            </a:r>
+          </a:p>
+          <a:p>
+            <a:r>
+              <a:t>as one. The clinician scores undetermined in 62 cases, mostly because real prescriptions fall outside</a:t>
+            </a:r>
+          </a:p>
+          <a:p>
+            <a:r>
+              <a:t>my closed formulary or were never tested against the isolate, so that comparison penalises the</a:t>
+            </a:r>
+          </a:p>
+          <a:p>
+            <a:r>
+              <a:t>clinician for prescribing outside my answer space.</a:t>
+            </a:r>
+          </a:p>
+          <a:p>
+            <a:r>
+              <a:t>On the cases where both can be scored, it is 91.1 against 90.6. Indistinguishable. The honest answer</a:t>
+            </a:r>
+          </a:p>
+          <a:p>
+            <a:r>
+              <a:t>to her question is that neither is better, and the interesting part is that a constant policy</a:t>
+            </a:r>
+          </a:p>
+          <a:p>
+            <a:r>
+              <a:t>achieves that.</a:t>
             </a:r>
           </a:p>
         </p:txBody>
@@ -10932,14 +11054,14 @@
         </p:nvSpPr>
         <p:spPr>
           <a:xfrm>
-            <a:off x="658368" y="2103120"/>
+            <a:off x="658368" y="1975104"/>
             <a:ext cx="5254599" cy="14630"/>
           </a:xfrm>
           <a:prstGeom prst="rect">
             <a:avLst/>
           </a:prstGeom>
           <a:solidFill>
-            <a:srgbClr val="D02670"/>
+            <a:srgbClr val="0F62FE"/>
           </a:solidFill>
           <a:ln>
             <a:noFill/>
@@ -10976,30 +11098,30 @@
         </p:nvSpPr>
         <p:spPr>
           <a:xfrm>
-            <a:off x="658368" y="2267712"/>
-            <a:ext cx="5254599" cy="365760"/>
-          </a:xfrm>
-          <a:prstGeom prst="rect">
-            <a:avLst/>
-          </a:prstGeom>
-          <a:noFill/>
-        </p:spPr>
-        <p:txBody>
-          <a:bodyPr wrap="square" anchor="t" lIns="0" rIns="0" tIns="0" bIns="0">
-            <a:spAutoFit/>
-          </a:bodyPr>
-          <a:lstStyle/>
-          <a:p>
-            <a:pPr algn="l">
-              <a:lnSpc>
-                <a:spcPct val="115000"/>
-              </a:lnSpc>
-              <a:spcAft>
-                <a:spcPts val="0"/>
-              </a:spcAft>
-            </a:pPr>
-            <a:r>
-              <a:rPr sz="1500" b="1" i="0">
+            <a:off x="658368" y="2112264"/>
+            <a:ext cx="5254599" cy="329184"/>
+          </a:xfrm>
+          <a:prstGeom prst="rect">
+            <a:avLst/>
+          </a:prstGeom>
+          <a:noFill/>
+        </p:spPr>
+        <p:txBody>
+          <a:bodyPr wrap="square" anchor="t" lIns="0" rIns="0" tIns="0" bIns="0">
+            <a:spAutoFit/>
+          </a:bodyPr>
+          <a:lstStyle/>
+          <a:p>
+            <a:pPr algn="l">
+              <a:lnSpc>
+                <a:spcPct val="112000"/>
+              </a:lnSpc>
+              <a:spcAft>
+                <a:spcPts val="0"/>
+              </a:spcAft>
+            </a:pPr>
+            <a:r>
+              <a:rPr sz="1350" b="1" i="0">
                 <a:solidFill>
                   <a:srgbClr val="161616"/>
                 </a:solidFill>
@@ -11018,30 +11140,30 @@
         </p:nvSpPr>
         <p:spPr>
           <a:xfrm>
-            <a:off x="658368" y="2651760"/>
-            <a:ext cx="5254599" cy="822960"/>
-          </a:xfrm>
-          <a:prstGeom prst="rect">
-            <a:avLst/>
-          </a:prstGeom>
-          <a:noFill/>
-        </p:spPr>
-        <p:txBody>
-          <a:bodyPr wrap="square" anchor="t" lIns="0" rIns="0" tIns="0" bIns="0">
-            <a:spAutoFit/>
-          </a:bodyPr>
-          <a:lstStyle/>
-          <a:p>
-            <a:pPr algn="l">
-              <a:lnSpc>
-                <a:spcPct val="135000"/>
-              </a:lnSpc>
-              <a:spcAft>
-                <a:spcPts val="0"/>
-              </a:spcAft>
-            </a:pPr>
-            <a:r>
-              <a:rPr sz="1200" b="0" i="0">
+            <a:off x="658368" y="2432304"/>
+            <a:ext cx="5254599" cy="731520"/>
+          </a:xfrm>
+          <a:prstGeom prst="rect">
+            <a:avLst/>
+          </a:prstGeom>
+          <a:noFill/>
+        </p:spPr>
+        <p:txBody>
+          <a:bodyPr wrap="square" anchor="t" lIns="0" rIns="0" tIns="0" bIns="0">
+            <a:spAutoFit/>
+          </a:bodyPr>
+          <a:lstStyle/>
+          <a:p>
+            <a:pPr algn="l">
+              <a:lnSpc>
+                <a:spcPct val="130000"/>
+              </a:lnSpc>
+              <a:spcAft>
+                <a:spcPts val="0"/>
+              </a:spcAft>
+            </a:pPr>
+            <a:r>
+              <a:rPr sz="1050" b="0" i="0">
                 <a:solidFill>
                   <a:srgbClr val="525252"/>
                 </a:solidFill>
@@ -11060,14 +11182,14 @@
         </p:nvSpPr>
         <p:spPr>
           <a:xfrm>
-            <a:off x="658368" y="3401568"/>
+            <a:off x="658368" y="3035808"/>
             <a:ext cx="5254599" cy="14630"/>
           </a:xfrm>
           <a:prstGeom prst="rect">
             <a:avLst/>
           </a:prstGeom>
           <a:solidFill>
-            <a:srgbClr val="D02670"/>
+            <a:srgbClr val="0F62FE"/>
           </a:solidFill>
           <a:ln>
             <a:noFill/>
@@ -11104,36 +11226,36 @@
         </p:nvSpPr>
         <p:spPr>
           <a:xfrm>
-            <a:off x="658368" y="3566160"/>
-            <a:ext cx="5254599" cy="365760"/>
-          </a:xfrm>
-          <a:prstGeom prst="rect">
-            <a:avLst/>
-          </a:prstGeom>
-          <a:noFill/>
-        </p:spPr>
-        <p:txBody>
-          <a:bodyPr wrap="square" anchor="t" lIns="0" rIns="0" tIns="0" bIns="0">
-            <a:spAutoFit/>
-          </a:bodyPr>
-          <a:lstStyle/>
-          <a:p>
-            <a:pPr algn="l">
-              <a:lnSpc>
-                <a:spcPct val="115000"/>
-              </a:lnSpc>
-              <a:spcAft>
-                <a:spcPts val="0"/>
-              </a:spcAft>
-            </a:pPr>
-            <a:r>
-              <a:rPr sz="1500" b="1" i="0">
+            <a:off x="658368" y="3172968"/>
+            <a:ext cx="5254599" cy="329184"/>
+          </a:xfrm>
+          <a:prstGeom prst="rect">
+            <a:avLst/>
+          </a:prstGeom>
+          <a:noFill/>
+        </p:spPr>
+        <p:txBody>
+          <a:bodyPr wrap="square" anchor="t" lIns="0" rIns="0" tIns="0" bIns="0">
+            <a:spAutoFit/>
+          </a:bodyPr>
+          <a:lstStyle/>
+          <a:p>
+            <a:pPr algn="l">
+              <a:lnSpc>
+                <a:spcPct val="112000"/>
+              </a:lnSpc>
+              <a:spcAft>
+                <a:spcPts val="0"/>
+              </a:spcAft>
+            </a:pPr>
+            <a:r>
+              <a:rPr sz="1350" b="1" i="0">
                 <a:solidFill>
                   <a:srgbClr val="161616"/>
                 </a:solidFill>
                 <a:latin typeface="IBM Plex Sans"/>
               </a:rPr>
-              <a:t>The primary test runs on a third of the cohort</a:t>
+              <a:t>The primary test runs on 70 cases</a:t>
             </a:r>
           </a:p>
         </p:txBody>
@@ -11146,36 +11268,36 @@
         </p:nvSpPr>
         <p:spPr>
           <a:xfrm>
-            <a:off x="658368" y="3950207"/>
-            <a:ext cx="5254599" cy="822960"/>
-          </a:xfrm>
-          <a:prstGeom prst="rect">
-            <a:avLst/>
-          </a:prstGeom>
-          <a:noFill/>
-        </p:spPr>
-        <p:txBody>
-          <a:bodyPr wrap="square" anchor="t" lIns="0" rIns="0" tIns="0" bIns="0">
-            <a:spAutoFit/>
-          </a:bodyPr>
-          <a:lstStyle/>
-          <a:p>
-            <a:pPr algn="l">
-              <a:lnSpc>
-                <a:spcPct val="135000"/>
-              </a:lnSpc>
-              <a:spcAft>
-                <a:spcPts val="0"/>
-              </a:spcAft>
-            </a:pPr>
-            <a:r>
-              <a:rPr sz="1200" b="0" i="0">
+            <a:off x="658368" y="3493008"/>
+            <a:ext cx="5254599" cy="731520"/>
+          </a:xfrm>
+          <a:prstGeom prst="rect">
+            <a:avLst/>
+          </a:prstGeom>
+          <a:noFill/>
+        </p:spPr>
+        <p:txBody>
+          <a:bodyPr wrap="square" anchor="t" lIns="0" rIns="0" tIns="0" bIns="0">
+            <a:spAutoFit/>
+          </a:bodyPr>
+          <a:lstStyle/>
+          <a:p>
+            <a:pPr algn="l">
+              <a:lnSpc>
+                <a:spcPct val="130000"/>
+              </a:lnSpc>
+              <a:spcAft>
+                <a:spcPts val="0"/>
+              </a:spcAft>
+            </a:pPr>
+            <a:r>
+              <a:rPr sz="1050" b="0" i="0">
                 <a:solidFill>
                   <a:srgbClr val="525252"/>
                 </a:solidFill>
                 <a:latin typeface="IBM Plex Sans"/>
               </a:rPr>
-              <a:t>70 of 200 cases are evaluable in all four conditions. The attrition is a property of what the laboratory tested, and it is still attrition.</a:t>
+              <a:t>The pressure arm ran 78 of 200, so 122 cases have no pressure row and 8 more are indeterminate. A contiguous prefix of a seeded selection, adequacy 88.5% against 87.5%.</a:t>
             </a:r>
           </a:p>
         </p:txBody>
@@ -11188,14 +11310,14 @@
         </p:nvSpPr>
         <p:spPr>
           <a:xfrm>
-            <a:off x="658368" y="4700016"/>
+            <a:off x="658368" y="4096512"/>
             <a:ext cx="5254599" cy="14630"/>
           </a:xfrm>
           <a:prstGeom prst="rect">
             <a:avLst/>
           </a:prstGeom>
           <a:solidFill>
-            <a:srgbClr val="D02670"/>
+            <a:srgbClr val="0F62FE"/>
           </a:solidFill>
           <a:ln>
             <a:noFill/>
@@ -11232,36 +11354,36 @@
         </p:nvSpPr>
         <p:spPr>
           <a:xfrm>
-            <a:off x="658368" y="4864607"/>
-            <a:ext cx="5254599" cy="365760"/>
-          </a:xfrm>
-          <a:prstGeom prst="rect">
-            <a:avLst/>
-          </a:prstGeom>
-          <a:noFill/>
-        </p:spPr>
-        <p:txBody>
-          <a:bodyPr wrap="square" anchor="t" lIns="0" rIns="0" tIns="0" bIns="0">
-            <a:spAutoFit/>
-          </a:bodyPr>
-          <a:lstStyle/>
-          <a:p>
-            <a:pPr algn="l">
-              <a:lnSpc>
-                <a:spcPct val="115000"/>
-              </a:lnSpc>
-              <a:spcAft>
-                <a:spcPts val="0"/>
-              </a:spcAft>
-            </a:pPr>
-            <a:r>
-              <a:rPr sz="1500" b="1" i="0">
+            <a:off x="658368" y="4233672"/>
+            <a:ext cx="5254599" cy="329184"/>
+          </a:xfrm>
+          <a:prstGeom prst="rect">
+            <a:avLst/>
+          </a:prstGeom>
+          <a:noFill/>
+        </p:spPr>
+        <p:txBody>
+          <a:bodyPr wrap="square" anchor="t" lIns="0" rIns="0" tIns="0" bIns="0">
+            <a:spAutoFit/>
+          </a:bodyPr>
+          <a:lstStyle/>
+          <a:p>
+            <a:pPr algn="l">
+              <a:lnSpc>
+                <a:spcPct val="112000"/>
+              </a:lnSpc>
+              <a:spcAft>
+                <a:spcPts val="0"/>
+              </a:spcAft>
+            </a:pPr>
+            <a:r>
+              <a:rPr sz="1350" b="1" i="0">
                 <a:solidFill>
                   <a:srgbClr val="161616"/>
                 </a:solidFill>
                 <a:latin typeface="IBM Plex Sans"/>
               </a:rPr>
-              <a:t>Clustering, not independence</a:t>
+              <a:t>The confidence endpoint is withdrawn</a:t>
             </a:r>
           </a:p>
         </p:txBody>
@@ -11274,36 +11396,36 @@
         </p:nvSpPr>
         <p:spPr>
           <a:xfrm>
-            <a:off x="658368" y="5248655"/>
-            <a:ext cx="5254599" cy="822960"/>
-          </a:xfrm>
-          <a:prstGeom prst="rect">
-            <a:avLst/>
-          </a:prstGeom>
-          <a:noFill/>
-        </p:spPr>
-        <p:txBody>
-          <a:bodyPr wrap="square" anchor="t" lIns="0" rIns="0" tIns="0" bIns="0">
-            <a:spAutoFit/>
-          </a:bodyPr>
-          <a:lstStyle/>
-          <a:p>
-            <a:pPr algn="l">
-              <a:lnSpc>
-                <a:spcPct val="135000"/>
-              </a:lnSpc>
-              <a:spcAft>
-                <a:spcPts val="0"/>
-              </a:spcAft>
-            </a:pPr>
-            <a:r>
-              <a:rPr sz="1200" b="0" i="0">
+            <a:off x="658368" y="4553712"/>
+            <a:ext cx="5254599" cy="731520"/>
+          </a:xfrm>
+          <a:prstGeom prst="rect">
+            <a:avLst/>
+          </a:prstGeom>
+          <a:noFill/>
+        </p:spPr>
+        <p:txBody>
+          <a:bodyPr wrap="square" anchor="t" lIns="0" rIns="0" tIns="0" bIns="0">
+            <a:spAutoFit/>
+          </a:bodyPr>
+          <a:lstStyle/>
+          <a:p>
+            <a:pPr algn="l">
+              <a:lnSpc>
+                <a:spcPct val="130000"/>
+              </a:lnSpc>
+              <a:spcAft>
+                <a:spcPts val="0"/>
+              </a:spcAft>
+            </a:pPr>
+            <a:r>
+              <a:rPr sz="1050" b="0" i="0">
                 <a:solidFill>
                   <a:srgbClr val="525252"/>
                 </a:solidFill>
                 <a:latin typeface="IBM Plex Sans"/>
               </a:rPr>
-              <a:t>400 ordering-runs are 200 patients seen twice. Measured ICC 0.913, design effect 1.91, effective n 209. Any interval computed as though they were independent is too narrow.</a:t>
+              <a:t>She asked for confidence before and after, because correct and confident becoming wrong and confident is the concerning state. Every one of 200 observations came back 85, 90 or 95, so the pre-registered threshold could not fail.</a:t>
             </a:r>
           </a:p>
         </p:txBody>
@@ -11316,7 +11438,135 @@
         </p:nvSpPr>
         <p:spPr>
           <a:xfrm>
-            <a:off x="6278727" y="2103120"/>
+            <a:off x="658368" y="5157216"/>
+            <a:ext cx="5254599" cy="14630"/>
+          </a:xfrm>
+          <a:prstGeom prst="rect">
+            <a:avLst/>
+          </a:prstGeom>
+          <a:solidFill>
+            <a:srgbClr val="0F62FE"/>
+          </a:solidFill>
+          <a:ln>
+            <a:noFill/>
+          </a:ln>
+          <a:effectLst/>
+        </p:spPr>
+        <p:style>
+          <a:lnRef idx="1">
+            <a:schemeClr val="accent1"/>
+          </a:lnRef>
+          <a:fillRef idx="3">
+            <a:schemeClr val="accent1"/>
+          </a:fillRef>
+          <a:effectRef idx="2">
+            <a:schemeClr val="accent1"/>
+          </a:effectRef>
+          <a:fontRef idx="minor">
+            <a:schemeClr val="lt1"/>
+          </a:fontRef>
+        </p:style>
+        <p:txBody>
+          <a:bodyPr rtlCol="0" anchor="ctr"/>
+          <a:lstStyle/>
+          <a:p>
+            <a:pPr algn="ctr"/>
+          </a:p>
+        </p:txBody>
+      </p:sp>
+      <p:sp>
+        <p:nvSpPr>
+          <p:cNvPr id="14" name="TextBox 13"/>
+          <p:cNvSpPr txBox="1"/>
+          <p:nvPr/>
+        </p:nvSpPr>
+        <p:spPr>
+          <a:xfrm>
+            <a:off x="658368" y="5294376"/>
+            <a:ext cx="5254599" cy="329184"/>
+          </a:xfrm>
+          <a:prstGeom prst="rect">
+            <a:avLst/>
+          </a:prstGeom>
+          <a:noFill/>
+        </p:spPr>
+        <p:txBody>
+          <a:bodyPr wrap="square" anchor="t" lIns="0" rIns="0" tIns="0" bIns="0">
+            <a:spAutoFit/>
+          </a:bodyPr>
+          <a:lstStyle/>
+          <a:p>
+            <a:pPr algn="l">
+              <a:lnSpc>
+                <a:spcPct val="112000"/>
+              </a:lnSpc>
+              <a:spcAft>
+                <a:spcPts val="0"/>
+              </a:spcAft>
+            </a:pPr>
+            <a:r>
+              <a:rPr sz="1350" b="1" i="0">
+                <a:solidFill>
+                  <a:srgbClr val="161616"/>
+                </a:solidFill>
+                <a:latin typeface="IBM Plex Sans"/>
+              </a:rPr>
+              <a:t>Clustering, not independence</a:t>
+            </a:r>
+          </a:p>
+        </p:txBody>
+      </p:sp>
+      <p:sp>
+        <p:nvSpPr>
+          <p:cNvPr id="15" name="TextBox 14"/>
+          <p:cNvSpPr txBox="1"/>
+          <p:nvPr/>
+        </p:nvSpPr>
+        <p:spPr>
+          <a:xfrm>
+            <a:off x="658368" y="5614416"/>
+            <a:ext cx="5254599" cy="731520"/>
+          </a:xfrm>
+          <a:prstGeom prst="rect">
+            <a:avLst/>
+          </a:prstGeom>
+          <a:noFill/>
+        </p:spPr>
+        <p:txBody>
+          <a:bodyPr wrap="square" anchor="t" lIns="0" rIns="0" tIns="0" bIns="0">
+            <a:spAutoFit/>
+          </a:bodyPr>
+          <a:lstStyle/>
+          <a:p>
+            <a:pPr algn="l">
+              <a:lnSpc>
+                <a:spcPct val="130000"/>
+              </a:lnSpc>
+              <a:spcAft>
+                <a:spcPts val="0"/>
+              </a:spcAft>
+            </a:pPr>
+            <a:r>
+              <a:rPr sz="1050" b="0" i="0">
+                <a:solidFill>
+                  <a:srgbClr val="525252"/>
+                </a:solidFill>
+                <a:latin typeface="IBM Plex Sans"/>
+              </a:rPr>
+              <a:t>400 ordering-runs are 200 patients seen twice. Measured ICC 0.913, design effect 1.91, effective n 209. Any interval computed as though they were independent is too narrow.</a:t>
+            </a:r>
+          </a:p>
+        </p:txBody>
+      </p:sp>
+      <p:sp>
+        <p:nvSpPr>
+          <p:cNvPr id="16" name="Rectangle 15"/>
+          <p:cNvSpPr/>
+          <p:nvPr/>
+        </p:nvSpPr>
+        <p:spPr>
+          <a:xfrm>
+            <a:off x="6278727" y="1975104"/>
             <a:ext cx="5254599" cy="14630"/>
           </a:xfrm>
           <a:prstGeom prst="rect">
@@ -11354,36 +11604,36 @@
       </p:sp>
       <p:sp>
         <p:nvSpPr>
-          <p:cNvPr id="14" name="TextBox 13"/>
-          <p:cNvSpPr txBox="1"/>
-          <p:nvPr/>
-        </p:nvSpPr>
-        <p:spPr>
-          <a:xfrm>
-            <a:off x="6278727" y="2267712"/>
-            <a:ext cx="5254599" cy="365760"/>
-          </a:xfrm>
-          <a:prstGeom prst="rect">
-            <a:avLst/>
-          </a:prstGeom>
-          <a:noFill/>
-        </p:spPr>
-        <p:txBody>
-          <a:bodyPr wrap="square" anchor="t" lIns="0" rIns="0" tIns="0" bIns="0">
-            <a:spAutoFit/>
-          </a:bodyPr>
-          <a:lstStyle/>
-          <a:p>
-            <a:pPr algn="l">
-              <a:lnSpc>
-                <a:spcPct val="115000"/>
-              </a:lnSpc>
-              <a:spcAft>
-                <a:spcPts val="0"/>
-              </a:spcAft>
-            </a:pPr>
-            <a:r>
-              <a:rPr sz="1500" b="1" i="0">
+          <p:cNvPr id="17" name="TextBox 16"/>
+          <p:cNvSpPr txBox="1"/>
+          <p:nvPr/>
+        </p:nvSpPr>
+        <p:spPr>
+          <a:xfrm>
+            <a:off x="6278727" y="2112264"/>
+            <a:ext cx="5254599" cy="329184"/>
+          </a:xfrm>
+          <a:prstGeom prst="rect">
+            <a:avLst/>
+          </a:prstGeom>
+          <a:noFill/>
+        </p:spPr>
+        <p:txBody>
+          <a:bodyPr wrap="square" anchor="t" lIns="0" rIns="0" tIns="0" bIns="0">
+            <a:spAutoFit/>
+          </a:bodyPr>
+          <a:lstStyle/>
+          <a:p>
+            <a:pPr algn="l">
+              <a:lnSpc>
+                <a:spcPct val="112000"/>
+              </a:lnSpc>
+              <a:spcAft>
+                <a:spcPts val="0"/>
+              </a:spcAft>
+            </a:pPr>
+            <a:r>
+              <a:rPr sz="1350" b="1" i="0">
                 <a:solidFill>
                   <a:srgbClr val="161616"/>
                 </a:solidFill>
@@ -11396,36 +11646,36 @@
       </p:sp>
       <p:sp>
         <p:nvSpPr>
-          <p:cNvPr id="15" name="TextBox 14"/>
-          <p:cNvSpPr txBox="1"/>
-          <p:nvPr/>
-        </p:nvSpPr>
-        <p:spPr>
-          <a:xfrm>
-            <a:off x="6278727" y="2651760"/>
-            <a:ext cx="5254599" cy="822960"/>
-          </a:xfrm>
-          <a:prstGeom prst="rect">
-            <a:avLst/>
-          </a:prstGeom>
-          <a:noFill/>
-        </p:spPr>
-        <p:txBody>
-          <a:bodyPr wrap="square" anchor="t" lIns="0" rIns="0" tIns="0" bIns="0">
-            <a:spAutoFit/>
-          </a:bodyPr>
-          <a:lstStyle/>
-          <a:p>
-            <a:pPr algn="l">
-              <a:lnSpc>
-                <a:spcPct val="135000"/>
-              </a:lnSpc>
-              <a:spcAft>
-                <a:spcPts val="0"/>
-              </a:spcAft>
-            </a:pPr>
-            <a:r>
-              <a:rPr sz="1200" b="0" i="0">
+          <p:cNvPr id="18" name="TextBox 17"/>
+          <p:cNvSpPr txBox="1"/>
+          <p:nvPr/>
+        </p:nvSpPr>
+        <p:spPr>
+          <a:xfrm>
+            <a:off x="6278727" y="2432304"/>
+            <a:ext cx="5254599" cy="731520"/>
+          </a:xfrm>
+          <a:prstGeom prst="rect">
+            <a:avLst/>
+          </a:prstGeom>
+          <a:noFill/>
+        </p:spPr>
+        <p:txBody>
+          <a:bodyPr wrap="square" anchor="t" lIns="0" rIns="0" tIns="0" bIns="0">
+            <a:spAutoFit/>
+          </a:bodyPr>
+          <a:lstStyle/>
+          <a:p>
+            <a:pPr algn="l">
+              <a:lnSpc>
+                <a:spcPct val="130000"/>
+              </a:lnSpc>
+              <a:spcAft>
+                <a:spcPts val="0"/>
+              </a:spcAft>
+            </a:pPr>
+            <a:r>
+              <a:rPr sz="1050" b="0" i="0">
                 <a:solidFill>
                   <a:srgbClr val="525252"/>
                 </a:solidFill>
@@ -11438,13 +11688,13 @@
       </p:sp>
       <p:sp>
         <p:nvSpPr>
-          <p:cNvPr id="16" name="Rectangle 15"/>
+          <p:cNvPr id="19" name="Rectangle 18"/>
           <p:cNvSpPr/>
           <p:nvPr/>
         </p:nvSpPr>
         <p:spPr>
           <a:xfrm>
-            <a:off x="6278727" y="3401568"/>
+            <a:off x="6278727" y="3035808"/>
             <a:ext cx="5254599" cy="14630"/>
           </a:xfrm>
           <a:prstGeom prst="rect">
@@ -11482,97 +11732,97 @@
       </p:sp>
       <p:sp>
         <p:nvSpPr>
-          <p:cNvPr id="17" name="TextBox 16"/>
-          <p:cNvSpPr txBox="1"/>
-          <p:nvPr/>
-        </p:nvSpPr>
-        <p:spPr>
-          <a:xfrm>
-            <a:off x="6278727" y="3566160"/>
-            <a:ext cx="5254599" cy="365760"/>
-          </a:xfrm>
-          <a:prstGeom prst="rect">
-            <a:avLst/>
-          </a:prstGeom>
-          <a:noFill/>
-        </p:spPr>
-        <p:txBody>
-          <a:bodyPr wrap="square" anchor="t" lIns="0" rIns="0" tIns="0" bIns="0">
-            <a:spAutoFit/>
-          </a:bodyPr>
-          <a:lstStyle/>
-          <a:p>
-            <a:pPr algn="l">
-              <a:lnSpc>
-                <a:spcPct val="115000"/>
-              </a:lnSpc>
-              <a:spcAft>
-                <a:spcPts val="0"/>
-              </a:spcAft>
-            </a:pPr>
-            <a:r>
-              <a:rPr sz="1500" b="1" i="0">
+          <p:cNvPr id="20" name="TextBox 19"/>
+          <p:cNvSpPr txBox="1"/>
+          <p:nvPr/>
+        </p:nvSpPr>
+        <p:spPr>
+          <a:xfrm>
+            <a:off x="6278727" y="3172968"/>
+            <a:ext cx="5254599" cy="329184"/>
+          </a:xfrm>
+          <a:prstGeom prst="rect">
+            <a:avLst/>
+          </a:prstGeom>
+          <a:noFill/>
+        </p:spPr>
+        <p:txBody>
+          <a:bodyPr wrap="square" anchor="t" lIns="0" rIns="0" tIns="0" bIns="0">
+            <a:spAutoFit/>
+          </a:bodyPr>
+          <a:lstStyle/>
+          <a:p>
+            <a:pPr algn="l">
+              <a:lnSpc>
+                <a:spcPct val="112000"/>
+              </a:lnSpc>
+              <a:spcAft>
+                <a:spcPts val="0"/>
+              </a:spcAft>
+            </a:pPr>
+            <a:r>
+              <a:rPr sz="1350" b="1" i="0">
                 <a:solidFill>
                   <a:srgbClr val="161616"/>
                 </a:solidFill>
                 <a:latin typeface="IBM Plex Sans"/>
               </a:rPr>
-              <a:t>One 4B checkpoint, run locally</a:t>
-            </a:r>
-          </a:p>
-        </p:txBody>
-      </p:sp>
-      <p:sp>
-        <p:nvSpPr>
-          <p:cNvPr id="18" name="TextBox 17"/>
-          <p:cNvSpPr txBox="1"/>
-          <p:nvPr/>
-        </p:nvSpPr>
-        <p:spPr>
-          <a:xfrm>
-            <a:off x="6278727" y="3950207"/>
-            <a:ext cx="5254599" cy="822960"/>
-          </a:xfrm>
-          <a:prstGeom prst="rect">
-            <a:avLst/>
-          </a:prstGeom>
-          <a:noFill/>
-        </p:spPr>
-        <p:txBody>
-          <a:bodyPr wrap="square" anchor="t" lIns="0" rIns="0" tIns="0" bIns="0">
-            <a:spAutoFit/>
-          </a:bodyPr>
-          <a:lstStyle/>
-          <a:p>
-            <a:pPr algn="l">
-              <a:lnSpc>
-                <a:spcPct val="135000"/>
-              </a:lnSpc>
-              <a:spcAft>
-                <a:spcPts val="0"/>
-              </a:spcAft>
-            </a:pPr>
-            <a:r>
-              <a:rPr sz="1200" b="0" i="0">
+              <a:t>Two arms are short of their planned n</a:t>
+            </a:r>
+          </a:p>
+        </p:txBody>
+      </p:sp>
+      <p:sp>
+        <p:nvSpPr>
+          <p:cNvPr id="21" name="TextBox 20"/>
+          <p:cNvSpPr txBox="1"/>
+          <p:nvPr/>
+        </p:nvSpPr>
+        <p:spPr>
+          <a:xfrm>
+            <a:off x="6278727" y="3493008"/>
+            <a:ext cx="5254599" cy="731520"/>
+          </a:xfrm>
+          <a:prstGeom prst="rect">
+            <a:avLst/>
+          </a:prstGeom>
+          <a:noFill/>
+        </p:spPr>
+        <p:txBody>
+          <a:bodyPr wrap="square" anchor="t" lIns="0" rIns="0" tIns="0" bIns="0">
+            <a:spAutoFit/>
+          </a:bodyPr>
+          <a:lstStyle/>
+          <a:p>
+            <a:pPr algn="l">
+              <a:lnSpc>
+                <a:spcPct val="130000"/>
+              </a:lnSpc>
+              <a:spcAft>
+                <a:spcPts val="0"/>
+              </a:spcAft>
+            </a:pPr>
+            <a:r>
+              <a:rPr sz="1050" b="0" i="0">
                 <a:solidFill>
                   <a:srgbClr val="525252"/>
                 </a:solidFill>
                 <a:latin typeface="IBM Plex Sans"/>
               </a:rPr>
-              <a:t>MIMIC-IV is credentialed, so no record-level data may reach a hosted service. Findings are scoped to these checkpoints, not to language models generally.</a:t>
-            </a:r>
-          </a:p>
-        </p:txBody>
-      </p:sp>
-      <p:sp>
-        <p:nvSpPr>
-          <p:cNvPr id="19" name="Rectangle 18"/>
+              <a:t>The pressure arm ran 78 of 197 planned cases and the plausible-wrong arm 166 of 312. Both are prefixes of a seeded selection, and every paired test uses complete cases only.</a:t>
+            </a:r>
+          </a:p>
+        </p:txBody>
+      </p:sp>
+      <p:sp>
+        <p:nvSpPr>
+          <p:cNvPr id="22" name="Rectangle 21"/>
           <p:cNvSpPr/>
           <p:nvPr/>
         </p:nvSpPr>
         <p:spPr>
           <a:xfrm>
-            <a:off x="6278727" y="4700016"/>
+            <a:off x="6278727" y="4096512"/>
             <a:ext cx="5254599" cy="14630"/>
           </a:xfrm>
           <a:prstGeom prst="rect">
@@ -11610,41 +11860,169 @@
       </p:sp>
       <p:sp>
         <p:nvSpPr>
-          <p:cNvPr id="20" name="TextBox 19"/>
-          <p:cNvSpPr txBox="1"/>
-          <p:nvPr/>
-        </p:nvSpPr>
-        <p:spPr>
-          <a:xfrm>
-            <a:off x="6278727" y="4864607"/>
-            <a:ext cx="5254599" cy="365760"/>
-          </a:xfrm>
-          <a:prstGeom prst="rect">
-            <a:avLst/>
-          </a:prstGeom>
-          <a:noFill/>
-        </p:spPr>
-        <p:txBody>
-          <a:bodyPr wrap="square" anchor="t" lIns="0" rIns="0" tIns="0" bIns="0">
-            <a:spAutoFit/>
-          </a:bodyPr>
-          <a:lstStyle/>
-          <a:p>
-            <a:pPr algn="l">
-              <a:lnSpc>
-                <a:spcPct val="115000"/>
-              </a:lnSpc>
-              <a:spcAft>
-                <a:spcPts val="0"/>
-              </a:spcAft>
-            </a:pPr>
-            <a:r>
-              <a:rPr sz="1500" b="1" i="0">
+          <p:cNvPr id="23" name="TextBox 22"/>
+          <p:cNvSpPr txBox="1"/>
+          <p:nvPr/>
+        </p:nvSpPr>
+        <p:spPr>
+          <a:xfrm>
+            <a:off x="6278727" y="4233672"/>
+            <a:ext cx="5254599" cy="329184"/>
+          </a:xfrm>
+          <a:prstGeom prst="rect">
+            <a:avLst/>
+          </a:prstGeom>
+          <a:noFill/>
+        </p:spPr>
+        <p:txBody>
+          <a:bodyPr wrap="square" anchor="t" lIns="0" rIns="0" tIns="0" bIns="0">
+            <a:spAutoFit/>
+          </a:bodyPr>
+          <a:lstStyle/>
+          <a:p>
+            <a:pPr algn="l">
+              <a:lnSpc>
+                <a:spcPct val="112000"/>
+              </a:lnSpc>
+              <a:spcAft>
+                <a:spcPts val="0"/>
+              </a:spcAft>
+            </a:pPr>
+            <a:r>
+              <a:rPr sz="1350" b="1" i="0">
                 <a:solidFill>
                   <a:srgbClr val="161616"/>
                 </a:solidFill>
                 <a:latin typeface="IBM Plex Sans"/>
               </a:rPr>
+              <a:t>One 4B checkpoint, run locally</a:t>
+            </a:r>
+          </a:p>
+        </p:txBody>
+      </p:sp>
+      <p:sp>
+        <p:nvSpPr>
+          <p:cNvPr id="24" name="TextBox 23"/>
+          <p:cNvSpPr txBox="1"/>
+          <p:nvPr/>
+        </p:nvSpPr>
+        <p:spPr>
+          <a:xfrm>
+            <a:off x="6278727" y="4553712"/>
+            <a:ext cx="5254599" cy="731520"/>
+          </a:xfrm>
+          <a:prstGeom prst="rect">
+            <a:avLst/>
+          </a:prstGeom>
+          <a:noFill/>
+        </p:spPr>
+        <p:txBody>
+          <a:bodyPr wrap="square" anchor="t" lIns="0" rIns="0" tIns="0" bIns="0">
+            <a:spAutoFit/>
+          </a:bodyPr>
+          <a:lstStyle/>
+          <a:p>
+            <a:pPr algn="l">
+              <a:lnSpc>
+                <a:spcPct val="130000"/>
+              </a:lnSpc>
+              <a:spcAft>
+                <a:spcPts val="0"/>
+              </a:spcAft>
+            </a:pPr>
+            <a:r>
+              <a:rPr sz="1050" b="0" i="0">
+                <a:solidFill>
+                  <a:srgbClr val="525252"/>
+                </a:solidFill>
+                <a:latin typeface="IBM Plex Sans"/>
+              </a:rPr>
+              <a:t>MIMIC-IV is credentialed, so no record-level data may reach a hosted service. Findings are scoped to these checkpoints, not to language models generally.</a:t>
+            </a:r>
+          </a:p>
+        </p:txBody>
+      </p:sp>
+      <p:sp>
+        <p:nvSpPr>
+          <p:cNvPr id="25" name="Rectangle 24"/>
+          <p:cNvSpPr/>
+          <p:nvPr/>
+        </p:nvSpPr>
+        <p:spPr>
+          <a:xfrm>
+            <a:off x="6278727" y="5157216"/>
+            <a:ext cx="5254599" cy="14630"/>
+          </a:xfrm>
+          <a:prstGeom prst="rect">
+            <a:avLst/>
+          </a:prstGeom>
+          <a:solidFill>
+            <a:srgbClr val="525252"/>
+          </a:solidFill>
+          <a:ln>
+            <a:noFill/>
+          </a:ln>
+          <a:effectLst/>
+        </p:spPr>
+        <p:style>
+          <a:lnRef idx="1">
+            <a:schemeClr val="accent1"/>
+          </a:lnRef>
+          <a:fillRef idx="3">
+            <a:schemeClr val="accent1"/>
+          </a:fillRef>
+          <a:effectRef idx="2">
+            <a:schemeClr val="accent1"/>
+          </a:effectRef>
+          <a:fontRef idx="minor">
+            <a:schemeClr val="lt1"/>
+          </a:fontRef>
+        </p:style>
+        <p:txBody>
+          <a:bodyPr rtlCol="0" anchor="ctr"/>
+          <a:lstStyle/>
+          <a:p>
+            <a:pPr algn="ctr"/>
+          </a:p>
+        </p:txBody>
+      </p:sp>
+      <p:sp>
+        <p:nvSpPr>
+          <p:cNvPr id="26" name="TextBox 25"/>
+          <p:cNvSpPr txBox="1"/>
+          <p:nvPr/>
+        </p:nvSpPr>
+        <p:spPr>
+          <a:xfrm>
+            <a:off x="6278727" y="5294376"/>
+            <a:ext cx="5254599" cy="329184"/>
+          </a:xfrm>
+          <a:prstGeom prst="rect">
+            <a:avLst/>
+          </a:prstGeom>
+          <a:noFill/>
+        </p:spPr>
+        <p:txBody>
+          <a:bodyPr wrap="square" anchor="t" lIns="0" rIns="0" tIns="0" bIns="0">
+            <a:spAutoFit/>
+          </a:bodyPr>
+          <a:lstStyle/>
+          <a:p>
+            <a:pPr algn="l">
+              <a:lnSpc>
+                <a:spcPct val="112000"/>
+              </a:lnSpc>
+              <a:spcAft>
+                <a:spcPts val="0"/>
+              </a:spcAft>
+            </a:pPr>
+            <a:r>
+              <a:rPr sz="1350" b="1" i="0">
+                <a:solidFill>
+                  <a:srgbClr val="161616"/>
+                </a:solidFill>
+                <a:latin typeface="IBM Plex Sans"/>
+              </a:rPr>
               <a:t>No clinician has reviewed this design</a:t>
             </a:r>
           </a:p>
@@ -11652,36 +12030,36 @@
       </p:sp>
       <p:sp>
         <p:nvSpPr>
-          <p:cNvPr id="21" name="TextBox 20"/>
-          <p:cNvSpPr txBox="1"/>
-          <p:nvPr/>
-        </p:nvSpPr>
-        <p:spPr>
-          <a:xfrm>
-            <a:off x="6278727" y="5248655"/>
-            <a:ext cx="5254599" cy="822960"/>
-          </a:xfrm>
-          <a:prstGeom prst="rect">
-            <a:avLst/>
-          </a:prstGeom>
-          <a:noFill/>
-        </p:spPr>
-        <p:txBody>
-          <a:bodyPr wrap="square" anchor="t" lIns="0" rIns="0" tIns="0" bIns="0">
-            <a:spAutoFit/>
-          </a:bodyPr>
-          <a:lstStyle/>
-          <a:p>
-            <a:pPr algn="l">
-              <a:lnSpc>
-                <a:spcPct val="135000"/>
-              </a:lnSpc>
-              <a:spcAft>
-                <a:spcPts val="0"/>
-              </a:spcAft>
-            </a:pPr>
-            <a:r>
-              <a:rPr sz="1200" b="0" i="0">
+          <p:cNvPr id="27" name="TextBox 26"/>
+          <p:cNvSpPr txBox="1"/>
+          <p:nvPr/>
+        </p:nvSpPr>
+        <p:spPr>
+          <a:xfrm>
+            <a:off x="6278727" y="5614416"/>
+            <a:ext cx="5254599" cy="731520"/>
+          </a:xfrm>
+          <a:prstGeom prst="rect">
+            <a:avLst/>
+          </a:prstGeom>
+          <a:noFill/>
+        </p:spPr>
+        <p:txBody>
+          <a:bodyPr wrap="square" anchor="t" lIns="0" rIns="0" tIns="0" bIns="0">
+            <a:spAutoFit/>
+          </a:bodyPr>
+          <a:lstStyle/>
+          <a:p>
+            <a:pPr algn="l">
+              <a:lnSpc>
+                <a:spcPct val="130000"/>
+              </a:lnSpc>
+              <a:spcAft>
+                <a:spcPts val="0"/>
+              </a:spcAft>
+            </a:pPr>
+            <a:r>
+              <a:rPr sz="1050" b="0" i="0">
                 <a:solidFill>
                   <a:srgbClr val="525252"/>
                 </a:solidFill>
@@ -11694,7 +12072,7 @@
       </p:sp>
       <p:sp>
         <p:nvSpPr>
-          <p:cNvPr id="22" name="Rectangle 21"/>
+          <p:cNvPr id="28" name="Rectangle 27"/>
           <p:cNvSpPr/>
           <p:nvPr/>
         </p:nvSpPr>
@@ -11738,7 +12116,7 @@
       </p:sp>
       <p:sp>
         <p:nvSpPr>
-          <p:cNvPr id="23" name="TextBox 22"/>
+          <p:cNvPr id="29" name="TextBox 28"/>
           <p:cNvSpPr txBox="1"/>
           <p:nvPr/>
         </p:nvSpPr>
@@ -11780,7 +12158,7 @@
       </p:sp>
       <p:sp>
         <p:nvSpPr>
-          <p:cNvPr id="24" name="TextBox 23"/>
+          <p:cNvPr id="30" name="TextBox 29"/>
           <p:cNvSpPr txBox="1"/>
           <p:nvPr/>
         </p:nvSpPr>
@@ -22909,6 +23287,889 @@
                 <a:latin typeface="IBM Plex Sans"/>
               </a:rPr>
               <a:t>21</a:t>
+            </a:r>
+          </a:p>
+        </p:txBody>
+      </p:sp>
+    </p:spTree>
+  </p:cSld>
+  <p:clrMapOvr>
+    <a:masterClrMapping/>
+  </p:clrMapOvr>
+</p:sld>
+</file>
+
+<file path=ppt/slides/slide26.xml><?xml version="1.0" encoding="utf-8"?>
+<p:sld xmlns:a="http://schemas.openxmlformats.org/drawingml/2006/main" xmlns:p="http://schemas.openxmlformats.org/presentationml/2006/main" xmlns:r="http://schemas.openxmlformats.org/officeDocument/2006/relationships">
+  <p:cSld>
+    <p:bg>
+      <p:bgPr>
+        <a:solidFill>
+          <a:srgbClr val="EDF5FF"/>
+        </a:solidFill>
+        <a:effectLst/>
+      </p:bgPr>
+    </p:bg>
+    <p:spTree>
+      <p:nvGrpSpPr>
+        <p:cNvPr id="1" name=""/>
+        <p:cNvGrpSpPr/>
+        <p:nvPr/>
+      </p:nvGrpSpPr>
+      <p:grpSpPr/>
+      <p:sp>
+        <p:nvSpPr>
+          <p:cNvPr id="2" name="TextBox 1"/>
+          <p:cNvSpPr txBox="1"/>
+          <p:nvPr/>
+        </p:nvSpPr>
+        <p:spPr>
+          <a:xfrm>
+            <a:off x="658368" y="457200"/>
+            <a:ext cx="10874959" cy="274320"/>
+          </a:xfrm>
+          <a:prstGeom prst="rect">
+            <a:avLst/>
+          </a:prstGeom>
+          <a:noFill/>
+        </p:spPr>
+        <p:txBody>
+          <a:bodyPr wrap="square" anchor="t" lIns="0" rIns="0" tIns="0" bIns="0">
+            <a:spAutoFit/>
+          </a:bodyPr>
+          <a:lstStyle/>
+          <a:p>
+            <a:pPr algn="l">
+              <a:lnSpc>
+                <a:spcPct val="128000"/>
+              </a:lnSpc>
+              <a:spcAft>
+                <a:spcPts val="0"/>
+              </a:spcAft>
+            </a:pPr>
+            <a:r>
+              <a:rPr sz="1150" b="1" i="0" spc="190">
+                <a:solidFill>
+                  <a:srgbClr val="0F62FE"/>
+                </a:solidFill>
+                <a:latin typeface="IBM Plex Sans"/>
+              </a:rPr>
+              <a:t>BACKUP SLIDE</a:t>
+            </a:r>
+          </a:p>
+        </p:txBody>
+      </p:sp>
+      <p:sp>
+        <p:nvSpPr>
+          <p:cNvPr id="3" name="TextBox 2"/>
+          <p:cNvSpPr txBox="1"/>
+          <p:nvPr/>
+        </p:nvSpPr>
+        <p:spPr>
+          <a:xfrm>
+            <a:off x="658368" y="768096"/>
+            <a:ext cx="10509199" cy="914400"/>
+          </a:xfrm>
+          <a:prstGeom prst="rect">
+            <a:avLst/>
+          </a:prstGeom>
+          <a:noFill/>
+        </p:spPr>
+        <p:txBody>
+          <a:bodyPr wrap="square" anchor="t" lIns="0" rIns="0" tIns="0" bIns="0">
+            <a:spAutoFit/>
+          </a:bodyPr>
+          <a:lstStyle/>
+          <a:p>
+            <a:pPr algn="l">
+              <a:lnSpc>
+                <a:spcPct val="112000"/>
+              </a:lnSpc>
+              <a:spcAft>
+                <a:spcPts val="0"/>
+              </a:spcAft>
+            </a:pPr>
+            <a:r>
+              <a:rPr sz="3000" b="1" i="0">
+                <a:solidFill>
+                  <a:srgbClr val="161616"/>
+                </a:solidFill>
+                <a:latin typeface="IBM Plex Sans"/>
+              </a:rPr>
+              <a:t>The model against the clinician, her second comparison</a:t>
+            </a:r>
+          </a:p>
+        </p:txBody>
+      </p:sp>
+      <p:sp>
+        <p:nvSpPr>
+          <p:cNvPr id="4" name="TextBox 3"/>
+          <p:cNvSpPr txBox="1"/>
+          <p:nvPr/>
+        </p:nvSpPr>
+        <p:spPr>
+          <a:xfrm>
+            <a:off x="658368" y="1554480"/>
+            <a:ext cx="9777679" cy="548640"/>
+          </a:xfrm>
+          <a:prstGeom prst="rect">
+            <a:avLst/>
+          </a:prstGeom>
+          <a:noFill/>
+        </p:spPr>
+        <p:txBody>
+          <a:bodyPr wrap="square" anchor="t" lIns="0" rIns="0" tIns="0" bIns="0">
+            <a:spAutoFit/>
+          </a:bodyPr>
+          <a:lstStyle/>
+          <a:p>
+            <a:pPr algn="l">
+              <a:lnSpc>
+                <a:spcPct val="130000"/>
+              </a:lnSpc>
+              <a:spcAft>
+                <a:spcPts val="0"/>
+              </a:spcAft>
+            </a:pPr>
+            <a:r>
+              <a:rPr sz="1500" b="0" i="0">
+                <a:solidFill>
+                  <a:srgbClr val="525252"/>
+                </a:solidFill>
+                <a:latin typeface="IBM Plex Sans"/>
+              </a:rPr>
+              <a:t>“You can also compare LLM with clinician see if they agree or LLM is worse or better?”   Prof. Tingting Zhu, 30 July 2026</a:t>
+            </a:r>
+          </a:p>
+        </p:txBody>
+      </p:sp>
+      <p:sp>
+        <p:nvSpPr>
+          <p:cNvPr id="5" name="TextBox 4"/>
+          <p:cNvSpPr txBox="1"/>
+          <p:nvPr/>
+        </p:nvSpPr>
+        <p:spPr>
+          <a:xfrm>
+            <a:off x="658368" y="2651760"/>
+            <a:ext cx="4892753" cy="384048"/>
+          </a:xfrm>
+          <a:prstGeom prst="rect">
+            <a:avLst/>
+          </a:prstGeom>
+          <a:noFill/>
+        </p:spPr>
+        <p:txBody>
+          <a:bodyPr wrap="square" anchor="t" lIns="0" rIns="0" tIns="0" bIns="0">
+            <a:spAutoFit/>
+          </a:bodyPr>
+          <a:lstStyle/>
+          <a:p>
+            <a:pPr algn="l">
+              <a:lnSpc>
+                <a:spcPct val="115000"/>
+              </a:lnSpc>
+              <a:spcAft>
+                <a:spcPts val="0"/>
+              </a:spcAft>
+            </a:pPr>
+            <a:r>
+              <a:rPr sz="1000" b="1" i="0" spc="90">
+                <a:solidFill>
+                  <a:srgbClr val="525252"/>
+                </a:solidFill>
+                <a:latin typeface="IBM Plex Sans"/>
+              </a:rPr>
+              <a:t>SCORED AGAINST THE SAME PANELS, BY THE SAME RULE</a:t>
+            </a:r>
+          </a:p>
+        </p:txBody>
+      </p:sp>
+      <p:sp>
+        <p:nvSpPr>
+          <p:cNvPr id="6" name="TextBox 5"/>
+          <p:cNvSpPr txBox="1"/>
+          <p:nvPr/>
+        </p:nvSpPr>
+        <p:spPr>
+          <a:xfrm>
+            <a:off x="5660849" y="2651760"/>
+            <a:ext cx="2826510" cy="384048"/>
+          </a:xfrm>
+          <a:prstGeom prst="rect">
+            <a:avLst/>
+          </a:prstGeom>
+          <a:noFill/>
+        </p:spPr>
+        <p:txBody>
+          <a:bodyPr wrap="square" anchor="t" lIns="0" rIns="0" tIns="0" bIns="0">
+            <a:spAutoFit/>
+          </a:bodyPr>
+          <a:lstStyle/>
+          <a:p>
+            <a:pPr algn="l">
+              <a:lnSpc>
+                <a:spcPct val="115000"/>
+              </a:lnSpc>
+              <a:spcAft>
+                <a:spcPts val="0"/>
+              </a:spcAft>
+            </a:pPr>
+            <a:r>
+              <a:rPr sz="1000" b="1" i="0" spc="90">
+                <a:solidFill>
+                  <a:srgbClr val="525252"/>
+                </a:solidFill>
+                <a:latin typeface="IBM Plex Sans"/>
+              </a:rPr>
+              <a:t>ALL CASES</a:t>
+            </a:r>
+          </a:p>
+        </p:txBody>
+      </p:sp>
+      <p:sp>
+        <p:nvSpPr>
+          <p:cNvPr id="7" name="TextBox 6"/>
+          <p:cNvSpPr txBox="1"/>
+          <p:nvPr/>
+        </p:nvSpPr>
+        <p:spPr>
+          <a:xfrm>
+            <a:off x="8597088" y="2651760"/>
+            <a:ext cx="2826510" cy="384048"/>
+          </a:xfrm>
+          <a:prstGeom prst="rect">
+            <a:avLst/>
+          </a:prstGeom>
+          <a:noFill/>
+        </p:spPr>
+        <p:txBody>
+          <a:bodyPr wrap="square" anchor="t" lIns="0" rIns="0" tIns="0" bIns="0">
+            <a:spAutoFit/>
+          </a:bodyPr>
+          <a:lstStyle/>
+          <a:p>
+            <a:pPr algn="l">
+              <a:lnSpc>
+                <a:spcPct val="115000"/>
+              </a:lnSpc>
+              <a:spcAft>
+                <a:spcPts val="0"/>
+              </a:spcAft>
+            </a:pPr>
+            <a:r>
+              <a:rPr sz="1000" b="1" i="0" spc="90">
+                <a:solidFill>
+                  <a:srgbClr val="525252"/>
+                </a:solidFill>
+                <a:latin typeface="IBM Plex Sans"/>
+              </a:rPr>
+              <a:t>CASES WHERE BOTH CAN BE SCORED</a:t>
+            </a:r>
+          </a:p>
+        </p:txBody>
+      </p:sp>
+      <p:sp>
+        <p:nvSpPr>
+          <p:cNvPr id="8" name="Rectangle 7"/>
+          <p:cNvSpPr/>
+          <p:nvPr/>
+        </p:nvSpPr>
+        <p:spPr>
+          <a:xfrm>
+            <a:off x="658368" y="3035808"/>
+            <a:ext cx="10874959" cy="10972"/>
+          </a:xfrm>
+          <a:prstGeom prst="rect">
+            <a:avLst/>
+          </a:prstGeom>
+          <a:solidFill>
+            <a:srgbClr val="161616"/>
+          </a:solidFill>
+          <a:ln>
+            <a:noFill/>
+          </a:ln>
+          <a:effectLst/>
+        </p:spPr>
+        <p:style>
+          <a:lnRef idx="1">
+            <a:schemeClr val="accent1"/>
+          </a:lnRef>
+          <a:fillRef idx="3">
+            <a:schemeClr val="accent1"/>
+          </a:fillRef>
+          <a:effectRef idx="2">
+            <a:schemeClr val="accent1"/>
+          </a:effectRef>
+          <a:fontRef idx="minor">
+            <a:schemeClr val="lt1"/>
+          </a:fontRef>
+        </p:style>
+        <p:txBody>
+          <a:bodyPr rtlCol="0" anchor="ctr"/>
+          <a:lstStyle/>
+          <a:p>
+            <a:pPr algn="ctr"/>
+          </a:p>
+        </p:txBody>
+      </p:sp>
+      <p:sp>
+        <p:nvSpPr>
+          <p:cNvPr id="9" name="TextBox 8"/>
+          <p:cNvSpPr txBox="1"/>
+          <p:nvPr/>
+        </p:nvSpPr>
+        <p:spPr>
+          <a:xfrm>
+            <a:off x="658368" y="3218688"/>
+            <a:ext cx="4892753" cy="475488"/>
+          </a:xfrm>
+          <a:prstGeom prst="rect">
+            <a:avLst/>
+          </a:prstGeom>
+          <a:noFill/>
+        </p:spPr>
+        <p:txBody>
+          <a:bodyPr wrap="square" anchor="t" lIns="0" rIns="0" tIns="0" bIns="0">
+            <a:spAutoFit/>
+          </a:bodyPr>
+          <a:lstStyle/>
+          <a:p>
+            <a:pPr algn="l">
+              <a:lnSpc>
+                <a:spcPct val="120000"/>
+              </a:lnSpc>
+              <a:spcAft>
+                <a:spcPts val="0"/>
+              </a:spcAft>
+            </a:pPr>
+            <a:r>
+              <a:rPr sz="1300" b="0" i="0">
+                <a:solidFill>
+                  <a:srgbClr val="161616"/>
+                </a:solidFill>
+                <a:latin typeface="IBM Plex Sans"/>
+              </a:rPr>
+              <a:t>the clinician's actual empiric prescription</a:t>
+            </a:r>
+          </a:p>
+        </p:txBody>
+      </p:sp>
+      <p:sp>
+        <p:nvSpPr>
+          <p:cNvPr id="10" name="TextBox 9"/>
+          <p:cNvSpPr txBox="1"/>
+          <p:nvPr/>
+        </p:nvSpPr>
+        <p:spPr>
+          <a:xfrm>
+            <a:off x="5660849" y="3218688"/>
+            <a:ext cx="2826510" cy="475488"/>
+          </a:xfrm>
+          <a:prstGeom prst="rect">
+            <a:avLst/>
+          </a:prstGeom>
+          <a:noFill/>
+        </p:spPr>
+        <p:txBody>
+          <a:bodyPr wrap="square" anchor="t" lIns="0" rIns="0" tIns="0" bIns="0">
+            <a:spAutoFit/>
+          </a:bodyPr>
+          <a:lstStyle/>
+          <a:p>
+            <a:pPr algn="l">
+              <a:lnSpc>
+                <a:spcPct val="120000"/>
+              </a:lnSpc>
+              <a:spcAft>
+                <a:spcPts val="0"/>
+              </a:spcAft>
+            </a:pPr>
+            <a:r>
+              <a:rPr sz="1300" b="0" i="0">
+                <a:solidFill>
+                  <a:srgbClr val="161616"/>
+                </a:solidFill>
+                <a:latin typeface="IBM Plex Sans"/>
+              </a:rPr>
+              <a:t>125/200 = 62.5%</a:t>
+            </a:r>
+          </a:p>
+        </p:txBody>
+      </p:sp>
+      <p:sp>
+        <p:nvSpPr>
+          <p:cNvPr id="11" name="TextBox 10"/>
+          <p:cNvSpPr txBox="1"/>
+          <p:nvPr/>
+        </p:nvSpPr>
+        <p:spPr>
+          <a:xfrm>
+            <a:off x="8597088" y="3218688"/>
+            <a:ext cx="2826510" cy="475488"/>
+          </a:xfrm>
+          <a:prstGeom prst="rect">
+            <a:avLst/>
+          </a:prstGeom>
+          <a:noFill/>
+        </p:spPr>
+        <p:txBody>
+          <a:bodyPr wrap="square" anchor="t" lIns="0" rIns="0" tIns="0" bIns="0">
+            <a:spAutoFit/>
+          </a:bodyPr>
+          <a:lstStyle/>
+          <a:p>
+            <a:pPr algn="l">
+              <a:lnSpc>
+                <a:spcPct val="120000"/>
+              </a:lnSpc>
+              <a:spcAft>
+                <a:spcPts val="0"/>
+              </a:spcAft>
+            </a:pPr>
+            <a:r>
+              <a:rPr sz="1300" b="1" i="0">
+                <a:solidFill>
+                  <a:srgbClr val="161616"/>
+                </a:solidFill>
+                <a:latin typeface="IBM Plex Sans"/>
+              </a:rPr>
+              <a:t>125/138 = 90.6%</a:t>
+            </a:r>
+          </a:p>
+        </p:txBody>
+      </p:sp>
+      <p:sp>
+        <p:nvSpPr>
+          <p:cNvPr id="12" name="Rectangle 11"/>
+          <p:cNvSpPr/>
+          <p:nvPr/>
+        </p:nvSpPr>
+        <p:spPr>
+          <a:xfrm>
+            <a:off x="658368" y="3621024"/>
+            <a:ext cx="10874959" cy="5486"/>
+          </a:xfrm>
+          <a:prstGeom prst="rect">
+            <a:avLst/>
+          </a:prstGeom>
+          <a:solidFill>
+            <a:srgbClr val="E0E0E0"/>
+          </a:solidFill>
+          <a:ln>
+            <a:noFill/>
+          </a:ln>
+          <a:effectLst/>
+        </p:spPr>
+        <p:style>
+          <a:lnRef idx="1">
+            <a:schemeClr val="accent1"/>
+          </a:lnRef>
+          <a:fillRef idx="3">
+            <a:schemeClr val="accent1"/>
+          </a:fillRef>
+          <a:effectRef idx="2">
+            <a:schemeClr val="accent1"/>
+          </a:effectRef>
+          <a:fontRef idx="minor">
+            <a:schemeClr val="lt1"/>
+          </a:fontRef>
+        </p:style>
+        <p:txBody>
+          <a:bodyPr rtlCol="0" anchor="ctr"/>
+          <a:lstStyle/>
+          <a:p>
+            <a:pPr algn="ctr"/>
+          </a:p>
+        </p:txBody>
+      </p:sp>
+      <p:sp>
+        <p:nvSpPr>
+          <p:cNvPr id="13" name="TextBox 12"/>
+          <p:cNvSpPr txBox="1"/>
+          <p:nvPr/>
+        </p:nvSpPr>
+        <p:spPr>
+          <a:xfrm>
+            <a:off x="658368" y="3694176"/>
+            <a:ext cx="4892753" cy="475488"/>
+          </a:xfrm>
+          <a:prstGeom prst="rect">
+            <a:avLst/>
+          </a:prstGeom>
+          <a:noFill/>
+        </p:spPr>
+        <p:txBody>
+          <a:bodyPr wrap="square" anchor="t" lIns="0" rIns="0" tIns="0" bIns="0">
+            <a:spAutoFit/>
+          </a:bodyPr>
+          <a:lstStyle/>
+          <a:p>
+            <a:pPr algn="l">
+              <a:lnSpc>
+                <a:spcPct val="120000"/>
+              </a:lnSpc>
+              <a:spcAft>
+                <a:spcPts val="0"/>
+              </a:spcAft>
+            </a:pPr>
+            <a:r>
+              <a:rPr sz="1300" b="0" i="0">
+                <a:solidFill>
+                  <a:srgbClr val="161616"/>
+                </a:solidFill>
+                <a:latin typeface="IBM Plex Sans"/>
+              </a:rPr>
+              <a:t>the model, zero-shot, before any conversation</a:t>
+            </a:r>
+          </a:p>
+        </p:txBody>
+      </p:sp>
+      <p:sp>
+        <p:nvSpPr>
+          <p:cNvPr id="14" name="TextBox 13"/>
+          <p:cNvSpPr txBox="1"/>
+          <p:nvPr/>
+        </p:nvSpPr>
+        <p:spPr>
+          <a:xfrm>
+            <a:off x="5660849" y="3694176"/>
+            <a:ext cx="2826510" cy="475488"/>
+          </a:xfrm>
+          <a:prstGeom prst="rect">
+            <a:avLst/>
+          </a:prstGeom>
+          <a:noFill/>
+        </p:spPr>
+        <p:txBody>
+          <a:bodyPr wrap="square" anchor="t" lIns="0" rIns="0" tIns="0" bIns="0">
+            <a:spAutoFit/>
+          </a:bodyPr>
+          <a:lstStyle/>
+          <a:p>
+            <a:pPr algn="l">
+              <a:lnSpc>
+                <a:spcPct val="120000"/>
+              </a:lnSpc>
+              <a:spcAft>
+                <a:spcPts val="0"/>
+              </a:spcAft>
+            </a:pPr>
+            <a:r>
+              <a:rPr sz="1300" b="0" i="0">
+                <a:solidFill>
+                  <a:srgbClr val="161616"/>
+                </a:solidFill>
+                <a:latin typeface="IBM Plex Sans"/>
+              </a:rPr>
+              <a:t>175/200 = 87.5%</a:t>
+            </a:r>
+          </a:p>
+        </p:txBody>
+      </p:sp>
+      <p:sp>
+        <p:nvSpPr>
+          <p:cNvPr id="15" name="TextBox 14"/>
+          <p:cNvSpPr txBox="1"/>
+          <p:nvPr/>
+        </p:nvSpPr>
+        <p:spPr>
+          <a:xfrm>
+            <a:off x="8597088" y="3694176"/>
+            <a:ext cx="2826510" cy="475488"/>
+          </a:xfrm>
+          <a:prstGeom prst="rect">
+            <a:avLst/>
+          </a:prstGeom>
+          <a:noFill/>
+        </p:spPr>
+        <p:txBody>
+          <a:bodyPr wrap="square" anchor="t" lIns="0" rIns="0" tIns="0" bIns="0">
+            <a:spAutoFit/>
+          </a:bodyPr>
+          <a:lstStyle/>
+          <a:p>
+            <a:pPr algn="l">
+              <a:lnSpc>
+                <a:spcPct val="120000"/>
+              </a:lnSpc>
+              <a:spcAft>
+                <a:spcPts val="0"/>
+              </a:spcAft>
+            </a:pPr>
+            <a:r>
+              <a:rPr sz="1300" b="1" i="0">
+                <a:solidFill>
+                  <a:srgbClr val="0F62FE"/>
+                </a:solidFill>
+                <a:latin typeface="IBM Plex Sans"/>
+              </a:rPr>
+              <a:t>175/192 = 91.1%</a:t>
+            </a:r>
+          </a:p>
+        </p:txBody>
+      </p:sp>
+      <p:sp>
+        <p:nvSpPr>
+          <p:cNvPr id="16" name="TextBox 15"/>
+          <p:cNvSpPr txBox="1"/>
+          <p:nvPr/>
+        </p:nvSpPr>
+        <p:spPr>
+          <a:xfrm>
+            <a:off x="658368" y="4041648"/>
+            <a:ext cx="10874959" cy="1097280"/>
+          </a:xfrm>
+          <a:prstGeom prst="rect">
+            <a:avLst/>
+          </a:prstGeom>
+          <a:noFill/>
+        </p:spPr>
+        <p:txBody>
+          <a:bodyPr wrap="square" anchor="t" lIns="0" rIns="0" tIns="0" bIns="0">
+            <a:spAutoFit/>
+          </a:bodyPr>
+          <a:lstStyle/>
+          <a:p>
+            <a:pPr algn="l">
+              <a:lnSpc>
+                <a:spcPct val="136000"/>
+              </a:lnSpc>
+              <a:spcAft>
+                <a:spcPts val="0"/>
+              </a:spcAft>
+            </a:pPr>
+            <a:r>
+              <a:rPr sz="1300" b="1" i="0">
+                <a:solidFill>
+                  <a:srgbClr val="161616"/>
+                </a:solidFill>
+                <a:latin typeface="IBM Plex Sans"/>
+              </a:rPr>
+              <a:t>The 25-point margin on the full cohort is a denominator artefact, and I report it as one. </a:t>
+            </a:r>
+            <a:r>
+              <a:rPr sz="1300" b="0" i="0">
+                <a:solidFill>
+                  <a:srgbClr val="525252"/>
+                </a:solidFill>
+                <a:latin typeface="IBM Plex Sans"/>
+              </a:rPr>
+              <a:t>The clinician scores UNDETERMINED in 62 of 200 cases, largely because real prescriptions fall outside the closed 17-drug formulary or were never tested against the isolate, so that comparison penalises the clinician for prescribing outside the model's answer space. On the cases where both can be scored the two are indistinguishable, 91.1% against 90.6%. The answer to her question is that neither is better.</a:t>
+            </a:r>
+          </a:p>
+        </p:txBody>
+      </p:sp>
+      <p:sp>
+        <p:nvSpPr>
+          <p:cNvPr id="17" name="Rectangle 16"/>
+          <p:cNvSpPr/>
+          <p:nvPr/>
+        </p:nvSpPr>
+        <p:spPr>
+          <a:xfrm>
+            <a:off x="658368" y="5230368"/>
+            <a:ext cx="10874959" cy="786384"/>
+          </a:xfrm>
+          <a:prstGeom prst="rect">
+            <a:avLst/>
+          </a:prstGeom>
+          <a:solidFill>
+            <a:srgbClr val="F4F4F4"/>
+          </a:solidFill>
+          <a:ln>
+            <a:noFill/>
+          </a:ln>
+          <a:effectLst/>
+        </p:spPr>
+        <p:style>
+          <a:lnRef idx="1">
+            <a:schemeClr val="accent1"/>
+          </a:lnRef>
+          <a:fillRef idx="3">
+            <a:schemeClr val="accent1"/>
+          </a:fillRef>
+          <a:effectRef idx="2">
+            <a:schemeClr val="accent1"/>
+          </a:effectRef>
+          <a:fontRef idx="minor">
+            <a:schemeClr val="lt1"/>
+          </a:fontRef>
+        </p:style>
+        <p:txBody>
+          <a:bodyPr rtlCol="0" anchor="ctr"/>
+          <a:lstStyle/>
+          <a:p>
+            <a:pPr algn="ctr"/>
+          </a:p>
+        </p:txBody>
+      </p:sp>
+      <p:sp>
+        <p:nvSpPr>
+          <p:cNvPr id="18" name="TextBox 17"/>
+          <p:cNvSpPr txBox="1"/>
+          <p:nvPr/>
+        </p:nvSpPr>
+        <p:spPr>
+          <a:xfrm>
+            <a:off x="914400" y="5394960"/>
+            <a:ext cx="10326319" cy="548640"/>
+          </a:xfrm>
+          <a:prstGeom prst="rect">
+            <a:avLst/>
+          </a:prstGeom>
+          <a:noFill/>
+        </p:spPr>
+        <p:txBody>
+          <a:bodyPr wrap="square" anchor="t" lIns="0" rIns="0" tIns="0" bIns="0">
+            <a:spAutoFit/>
+          </a:bodyPr>
+          <a:lstStyle/>
+          <a:p>
+            <a:pPr algn="l">
+              <a:lnSpc>
+                <a:spcPct val="132000"/>
+              </a:lnSpc>
+              <a:spcAft>
+                <a:spcPts val="0"/>
+              </a:spcAft>
+            </a:pPr>
+            <a:r>
+              <a:rPr sz="1150" b="0" i="0">
+                <a:solidFill>
+                  <a:srgbClr val="161616"/>
+                </a:solidFill>
+                <a:latin typeface="IBM Plex Sans"/>
+              </a:rPr>
+              <a:t>Both sides are scored by the identical rule, fixed in the protocol before this was computed: a regimen covers if any agent in it covers, and a polymicrobial case is adequate only if every pathogenic isolate is covered. Comparator window [index_time, index_time + 24h], fixed rather than chosen after seeing which window scored best.</a:t>
+            </a:r>
+          </a:p>
+        </p:txBody>
+      </p:sp>
+      <p:sp>
+        <p:nvSpPr>
+          <p:cNvPr id="19" name="Rectangle 18"/>
+          <p:cNvSpPr/>
+          <p:nvPr/>
+        </p:nvSpPr>
+        <p:spPr>
+          <a:xfrm>
+            <a:off x="658368" y="6181344"/>
+            <a:ext cx="10874959" cy="7315"/>
+          </a:xfrm>
+          <a:prstGeom prst="rect">
+            <a:avLst/>
+          </a:prstGeom>
+          <a:solidFill>
+            <a:srgbClr val="E0E0E0"/>
+          </a:solidFill>
+          <a:ln>
+            <a:noFill/>
+          </a:ln>
+          <a:effectLst/>
+        </p:spPr>
+        <p:style>
+          <a:lnRef idx="1">
+            <a:schemeClr val="accent1"/>
+          </a:lnRef>
+          <a:fillRef idx="3">
+            <a:schemeClr val="accent1"/>
+          </a:fillRef>
+          <a:effectRef idx="2">
+            <a:schemeClr val="accent1"/>
+          </a:effectRef>
+          <a:fontRef idx="minor">
+            <a:schemeClr val="lt1"/>
+          </a:fontRef>
+        </p:style>
+        <p:txBody>
+          <a:bodyPr rtlCol="0" anchor="ctr"/>
+          <a:lstStyle/>
+          <a:p>
+            <a:pPr algn="ctr"/>
+          </a:p>
+        </p:txBody>
+      </p:sp>
+      <p:sp>
+        <p:nvSpPr>
+          <p:cNvPr id="20" name="TextBox 19"/>
+          <p:cNvSpPr txBox="1"/>
+          <p:nvPr/>
+        </p:nvSpPr>
+        <p:spPr>
+          <a:xfrm>
+            <a:off x="658368" y="6327648"/>
+            <a:ext cx="9777679" cy="274320"/>
+          </a:xfrm>
+          <a:prstGeom prst="rect">
+            <a:avLst/>
+          </a:prstGeom>
+          <a:noFill/>
+        </p:spPr>
+        <p:txBody>
+          <a:bodyPr wrap="square" anchor="t" lIns="0" rIns="0" tIns="0" bIns="0">
+            <a:spAutoFit/>
+          </a:bodyPr>
+          <a:lstStyle/>
+          <a:p>
+            <a:pPr algn="l">
+              <a:lnSpc>
+                <a:spcPct val="128000"/>
+              </a:lnSpc>
+              <a:spcAft>
+                <a:spcPts val="0"/>
+              </a:spcAft>
+            </a:pPr>
+            <a:r>
+              <a:rPr sz="950" b="0" i="0">
+                <a:solidFill>
+                  <a:srgbClr val="525252"/>
+                </a:solidFill>
+                <a:latin typeface="IBM Plex Sans"/>
+              </a:rPr>
+              <a:t>results/clinician_comparison.json  ·  analysis/clinician_comparison.py  ·  identical scoring rule, protocol_v1 line 65</a:t>
+            </a:r>
+          </a:p>
+        </p:txBody>
+      </p:sp>
+      <p:sp>
+        <p:nvSpPr>
+          <p:cNvPr id="21" name="TextBox 20"/>
+          <p:cNvSpPr txBox="1"/>
+          <p:nvPr/>
+        </p:nvSpPr>
+        <p:spPr>
+          <a:xfrm>
+            <a:off x="10618927" y="6327648"/>
+            <a:ext cx="914400" cy="274320"/>
+          </a:xfrm>
+          <a:prstGeom prst="rect">
+            <a:avLst/>
+          </a:prstGeom>
+          <a:noFill/>
+        </p:spPr>
+        <p:txBody>
+          <a:bodyPr wrap="square" anchor="t" lIns="0" rIns="0" tIns="0" bIns="0">
+            <a:spAutoFit/>
+          </a:bodyPr>
+          <a:lstStyle/>
+          <a:p>
+            <a:pPr algn="r">
+              <a:lnSpc>
+                <a:spcPct val="128000"/>
+              </a:lnSpc>
+              <a:spcAft>
+                <a:spcPts val="0"/>
+              </a:spcAft>
+            </a:pPr>
+            <a:r>
+              <a:rPr sz="950" b="0" i="0">
+                <a:solidFill>
+                  <a:srgbClr val="525252"/>
+                </a:solidFill>
+                <a:latin typeface="IBM Plex Sans"/>
+              </a:rPr>
+              <a:t>22</a:t>
             </a:r>
           </a:p>
         </p:txBody>

</xml_diff>

<commit_message>
Name Med-BERT as not run, and why
</commit_message>
<xml_diff>
--- a/deck/Shomique_Hayat_UNIQ_antibiotic_agents.pptx
+++ b/deck/Shomique_Hayat_UNIQ_antibiotic_agents.pptx
@@ -19019,6 +19019,57 @@
         </p:nvSpPr>
         <p:spPr>
           <a:xfrm>
+            <a:off x="658368" y="6272784"/>
+            <a:ext cx="10874959" cy="365760"/>
+          </a:xfrm>
+          <a:prstGeom prst="rect">
+            <a:avLst/>
+          </a:prstGeom>
+          <a:noFill/>
+        </p:spPr>
+        <p:txBody>
+          <a:bodyPr wrap="square" anchor="t" lIns="0" rIns="0" tIns="0" bIns="0">
+            <a:spAutoFit/>
+          </a:bodyPr>
+          <a:lstStyle/>
+          <a:p>
+            <a:pPr algn="l">
+              <a:lnSpc>
+                <a:spcPct val="125000"/>
+              </a:lnSpc>
+              <a:spcAft>
+                <a:spcPts val="0"/>
+              </a:spcAft>
+            </a:pPr>
+            <a:r>
+              <a:rPr sz="1050" b="1" i="0">
+                <a:solidFill>
+                  <a:srgbClr val="161616"/>
+                </a:solidFill>
+                <a:latin typeface="IBM Plex Sans"/>
+              </a:rPr>
+              <a:t>Her ask was “Med Bert or ClinicalBert etc”, and ClinicalBERT is here. </a:t>
+            </a:r>
+            <a:r>
+              <a:rPr sz="1050" b="0" i="0">
+                <a:solidFill>
+                  <a:srgbClr val="525252"/>
+                </a:solidFill>
+                <a:latin typeface="IBM Plex Sans"/>
+              </a:rPr>
+              <a:t>Med-BERT itself is not: it is trained on structured diagnosis codes rather than free text, so it needs a different input representation, and that is a separate build rather than a fourth column.</a:t>
+            </a:r>
+          </a:p>
+        </p:txBody>
+      </p:sp>
+      <p:sp>
+        <p:nvSpPr>
+          <p:cNvPr id="44" name="TextBox 43"/>
+          <p:cNvSpPr txBox="1"/>
+          <p:nvPr/>
+        </p:nvSpPr>
+        <p:spPr>
+          <a:xfrm>
             <a:off x="7835841" y="5742432"/>
             <a:ext cx="3697486" cy="548640"/>
           </a:xfrm>
@@ -19055,7 +19106,7 @@
       </p:sp>
       <p:sp>
         <p:nvSpPr>
-          <p:cNvPr id="44" name="Rectangle 43"/>
+          <p:cNvPr id="45" name="Rectangle 44"/>
           <p:cNvSpPr/>
           <p:nvPr/>
         </p:nvSpPr>
@@ -19099,7 +19150,7 @@
       </p:sp>
       <p:sp>
         <p:nvSpPr>
-          <p:cNvPr id="45" name="TextBox 44"/>
+          <p:cNvPr id="46" name="TextBox 45"/>
           <p:cNvSpPr txBox="1"/>
           <p:nvPr/>
         </p:nvSpPr>
@@ -19141,7 +19192,7 @@
       </p:sp>
       <p:sp>
         <p:nvSpPr>
-          <p:cNvPr id="46" name="TextBox 45"/>
+          <p:cNvPr id="47" name="TextBox 46"/>
           <p:cNvSpPr txBox="1"/>
           <p:nvPr/>
         </p:nvSpPr>

</xml_diff>

<commit_message>
Resurrect the confidence endpoint on the continuous measure, with an exact permutation test
</commit_message>
<xml_diff>
--- a/deck/Shomique_Hayat_UNIQ_antibiotic_agents.pptx
+++ b/deck/Shomique_Hayat_UNIQ_antibiotic_agents.pptx
@@ -31,6 +31,7 @@
     <p:sldId id="279" r:id="rId31"/>
     <p:sldId id="280" r:id="rId32"/>
     <p:sldId id="281" r:id="rId33"/>
+    <p:sldId id="282" r:id="rId34"/>
   </p:sldIdLst>
   <p:sldSz cx="12191695" cy="6858000" type="screen4x3"/>
   <p:notesSz cx="6858000" cy="9144000"/>
@@ -2683,6 +2684,137 @@
           <a:p>
             <a:r>
               <a:t>achieves that.</a:t>
+            </a:r>
+          </a:p>
+        </p:txBody>
+      </p:sp>
+      <p:sp>
+        <p:nvSpPr>
+          <p:cNvPr id="4" name="Slide Number Placeholder 3"/>
+          <p:cNvSpPr>
+            <a:spLocks noGrp="1"/>
+          </p:cNvSpPr>
+          <p:nvPr>
+            <p:ph type="sldNum" idx="5" sz="quarter"/>
+          </p:nvPr>
+        </p:nvSpPr>
+        <p:spPr/>
+      </p:sp>
+    </p:spTree>
+  </p:cSld>
+  <p:clrMapOvr>
+    <a:masterClrMapping/>
+  </p:clrMapOvr>
+</p:notes>
+</file>
+
+<file path=ppt/notesSlides/notesSlide27.xml><?xml version="1.0" encoding="utf-8"?>
+<p:notes xmlns:a="http://schemas.openxmlformats.org/drawingml/2006/main" xmlns:p="http://schemas.openxmlformats.org/presentationml/2006/main" xmlns:r="http://schemas.openxmlformats.org/officeDocument/2006/relationships">
+  <p:cSld>
+    <p:spTree>
+      <p:nvGrpSpPr>
+        <p:cNvPr id="1" name=""/>
+        <p:cNvGrpSpPr/>
+        <p:nvPr/>
+      </p:nvGrpSpPr>
+      <p:grpSpPr>
+        <a:xfrm>
+          <a:off x="0" y="0"/>
+          <a:ext cx="0" cy="0"/>
+          <a:chOff x="0" y="0"/>
+          <a:chExt cx="0" cy="0"/>
+        </a:xfrm>
+      </p:grpSpPr>
+      <p:sp>
+        <p:nvSpPr>
+          <p:cNvPr id="2" name="Slide Image Placeholder 1"/>
+          <p:cNvSpPr>
+            <a:spLocks noGrp="1"/>
+          </p:cNvSpPr>
+          <p:nvPr>
+            <p:ph type="sldImg" idx="2"/>
+          </p:nvPr>
+        </p:nvSpPr>
+        <p:spPr/>
+      </p:sp>
+      <p:sp>
+        <p:nvSpPr>
+          <p:cNvPr id="3" name="Notes Placeholder 2"/>
+          <p:cNvSpPr>
+            <a:spLocks noGrp="1"/>
+          </p:cNvSpPr>
+          <p:nvPr>
+            <p:ph type="body" idx="3" sz="quarter"/>
+          </p:nvPr>
+        </p:nvSpPr>
+        <p:spPr/>
+        <p:txBody>
+          <a:bodyPr/>
+          <a:lstStyle/>
+          <a:p>
+            <a:r>
+              <a:t>BACKUP SLIDE, not in the ten minutes. Use it in questions.</a:t>
+            </a:r>
+          </a:p>
+          <a:p/>
+          <a:p>
+            <a:r>
+              <a:t>Backup slide, and it answers her ninth ask.</a:t>
+            </a:r>
+          </a:p>
+          <a:p>
+            <a:r>
+              <a:t>She asked for confidence before and after, and she named the state that worries her: correct and</a:t>
+            </a:r>
+          </a:p>
+          <a:p>
+            <a:r>
+              <a:t>confident, sees the other agent, wrong and confident.</a:t>
+            </a:r>
+          </a:p>
+          <a:p>
+            <a:r>
+              <a:t>I nearly withdrew this endpoint, and half of that was right. The binary cannot fail: every single</a:t>
+            </a:r>
+          </a:p>
+          <a:p>
+            <a:r>
+              <a:t>observation is above my pre-registered threshold of 80, so a rate against that threshold measures my</a:t>
+            </a:r>
+          </a:p>
+          <a:p>
+            <a:r>
+              <a:t>scale, not the model. I say that before I show anything else.</a:t>
+            </a:r>
+          </a:p>
+          <a:p>
+            <a:r>
+              <a:t>But the number itself moves, and it moves in opposite directions depending on what happened. When the</a:t>
+            </a:r>
+          </a:p>
+          <a:p>
+            <a:r>
+              <a:t>model holds a correct answer under challenge it gets less certain, about three points. When it</a:t>
+            </a:r>
+          </a:p>
+          <a:p>
+            <a:r>
+              <a:t>abandons a correct answer for a wrong one it gets MORE certain, five points. That is the state she</a:t>
+            </a:r>
+          </a:p>
+          <a:p>
+            <a:r>
+              <a:t>predicted, in the direction she predicted.</a:t>
+            </a:r>
+          </a:p>
+          <a:p>
+            <a:r>
+              <a:t>The honest bound is the cell size: 4 exposures. I use a permutation test because it is valid</a:t>
+            </a:r>
+          </a:p>
+          <a:p>
+            <a:r>
+              <a:t>at any n, and I do not quote it as an effect size.</a:t>
             </a:r>
           </a:p>
         </p:txBody>
@@ -11383,7 +11515,7 @@
                 </a:solidFill>
                 <a:latin typeface="IBM Plex Sans"/>
               </a:rPr>
-              <a:t>The confidence endpoint is withdrawn</a:t>
+              <a:t>The confidence binary cannot fail</a:t>
             </a:r>
           </a:p>
         </p:txBody>
@@ -11425,7 +11557,7 @@
                 </a:solidFill>
                 <a:latin typeface="IBM Plex Sans"/>
               </a:rPr>
-              <a:t>She asked for confidence before and after, because correct and confident becoming wrong and confident is the concerning state. Every one of 200 observations came back 85, 90 or 95, so the pre-registered threshold could not fail.</a:t>
+              <a:t>Every observation sits above the pre-registered threshold of 80, so the binary is degenerate and is not reported as a test. The continuous measure is reported instead, and the harmful-deference cell it rests on is small.</a:t>
             </a:r>
           </a:p>
         </p:txBody>
@@ -24221,6 +24353,1687 @@
                 <a:latin typeface="IBM Plex Sans"/>
               </a:rPr>
               <a:t>22</a:t>
+            </a:r>
+          </a:p>
+        </p:txBody>
+      </p:sp>
+    </p:spTree>
+  </p:cSld>
+  <p:clrMapOvr>
+    <a:masterClrMapping/>
+  </p:clrMapOvr>
+</p:sld>
+</file>
+
+<file path=ppt/slides/slide27.xml><?xml version="1.0" encoding="utf-8"?>
+<p:sld xmlns:a="http://schemas.openxmlformats.org/drawingml/2006/main" xmlns:p="http://schemas.openxmlformats.org/presentationml/2006/main" xmlns:r="http://schemas.openxmlformats.org/officeDocument/2006/relationships">
+  <p:cSld>
+    <p:bg>
+      <p:bgPr>
+        <a:solidFill>
+          <a:srgbClr val="EDF5FF"/>
+        </a:solidFill>
+        <a:effectLst/>
+      </p:bgPr>
+    </p:bg>
+    <p:spTree>
+      <p:nvGrpSpPr>
+        <p:cNvPr id="1" name=""/>
+        <p:cNvGrpSpPr/>
+        <p:nvPr/>
+      </p:nvGrpSpPr>
+      <p:grpSpPr/>
+      <p:sp>
+        <p:nvSpPr>
+          <p:cNvPr id="2" name="TextBox 1"/>
+          <p:cNvSpPr txBox="1"/>
+          <p:nvPr/>
+        </p:nvSpPr>
+        <p:spPr>
+          <a:xfrm>
+            <a:off x="658368" y="457200"/>
+            <a:ext cx="10874959" cy="274320"/>
+          </a:xfrm>
+          <a:prstGeom prst="rect">
+            <a:avLst/>
+          </a:prstGeom>
+          <a:noFill/>
+        </p:spPr>
+        <p:txBody>
+          <a:bodyPr wrap="square" anchor="t" lIns="0" rIns="0" tIns="0" bIns="0">
+            <a:spAutoFit/>
+          </a:bodyPr>
+          <a:lstStyle/>
+          <a:p>
+            <a:pPr algn="l">
+              <a:lnSpc>
+                <a:spcPct val="128000"/>
+              </a:lnSpc>
+              <a:spcAft>
+                <a:spcPts val="0"/>
+              </a:spcAft>
+            </a:pPr>
+            <a:r>
+              <a:rPr sz="1150" b="1" i="0" spc="190">
+                <a:solidFill>
+                  <a:srgbClr val="0F62FE"/>
+                </a:solidFill>
+                <a:latin typeface="IBM Plex Sans"/>
+              </a:rPr>
+              <a:t>BACKUP SLIDE</a:t>
+            </a:r>
+          </a:p>
+        </p:txBody>
+      </p:sp>
+      <p:sp>
+        <p:nvSpPr>
+          <p:cNvPr id="3" name="TextBox 2"/>
+          <p:cNvSpPr txBox="1"/>
+          <p:nvPr/>
+        </p:nvSpPr>
+        <p:spPr>
+          <a:xfrm>
+            <a:off x="658368" y="768096"/>
+            <a:ext cx="10509199" cy="914400"/>
+          </a:xfrm>
+          <a:prstGeom prst="rect">
+            <a:avLst/>
+          </a:prstGeom>
+          <a:noFill/>
+        </p:spPr>
+        <p:txBody>
+          <a:bodyPr wrap="square" anchor="t" lIns="0" rIns="0" tIns="0" bIns="0">
+            <a:spAutoFit/>
+          </a:bodyPr>
+          <a:lstStyle/>
+          <a:p>
+            <a:pPr algn="l">
+              <a:lnSpc>
+                <a:spcPct val="112000"/>
+              </a:lnSpc>
+              <a:spcAft>
+                <a:spcPts val="0"/>
+              </a:spcAft>
+            </a:pPr>
+            <a:r>
+              <a:rPr sz="3000" b="1" i="0">
+                <a:solidFill>
+                  <a:srgbClr val="161616"/>
+                </a:solidFill>
+                <a:latin typeface="IBM Plex Sans"/>
+              </a:rPr>
+              <a:t>Confidence before and after, and the state she predicted</a:t>
+            </a:r>
+          </a:p>
+        </p:txBody>
+      </p:sp>
+      <p:sp>
+        <p:nvSpPr>
+          <p:cNvPr id="4" name="TextBox 3"/>
+          <p:cNvSpPr txBox="1"/>
+          <p:nvPr/>
+        </p:nvSpPr>
+        <p:spPr>
+          <a:xfrm>
+            <a:off x="658368" y="1554480"/>
+            <a:ext cx="9777679" cy="548640"/>
+          </a:xfrm>
+          <a:prstGeom prst="rect">
+            <a:avLst/>
+          </a:prstGeom>
+          <a:noFill/>
+        </p:spPr>
+        <p:txBody>
+          <a:bodyPr wrap="square" anchor="t" lIns="0" rIns="0" tIns="0" bIns="0">
+            <a:spAutoFit/>
+          </a:bodyPr>
+          <a:lstStyle/>
+          <a:p>
+            <a:pPr algn="l">
+              <a:lnSpc>
+                <a:spcPct val="130000"/>
+              </a:lnSpc>
+              <a:spcAft>
+                <a:spcPts val="0"/>
+              </a:spcAft>
+            </a:pPr>
+            <a:r>
+              <a:rPr sz="1500" b="0" i="0">
+                <a:solidFill>
+                  <a:srgbClr val="525252"/>
+                </a:solidFill>
+                <a:latin typeface="IBM Plex Sans"/>
+              </a:rPr>
+              <a:t>“The particularly concerning state isn't merely wrong after persuasion; it's: correct + confident, sees other agent, wrong + confident.”   Prof. Tingting Zhu, 18 August 2026</a:t>
+            </a:r>
+          </a:p>
+        </p:txBody>
+      </p:sp>
+      <p:sp>
+        <p:nvSpPr>
+          <p:cNvPr id="5" name="TextBox 4"/>
+          <p:cNvSpPr txBox="1"/>
+          <p:nvPr/>
+        </p:nvSpPr>
+        <p:spPr>
+          <a:xfrm>
+            <a:off x="658368" y="2651760"/>
+            <a:ext cx="2709061" cy="384048"/>
+          </a:xfrm>
+          <a:prstGeom prst="rect">
+            <a:avLst/>
+          </a:prstGeom>
+          <a:noFill/>
+        </p:spPr>
+        <p:txBody>
+          <a:bodyPr wrap="square" anchor="t" lIns="0" rIns="0" tIns="0" bIns="0">
+            <a:spAutoFit/>
+          </a:bodyPr>
+          <a:lstStyle/>
+          <a:p>
+            <a:pPr algn="l">
+              <a:lnSpc>
+                <a:spcPct val="115000"/>
+              </a:lnSpc>
+              <a:spcAft>
+                <a:spcPts val="0"/>
+              </a:spcAft>
+            </a:pPr>
+            <a:r>
+              <a:rPr sz="1000" b="1" i="0" spc="90">
+                <a:solidFill>
+                  <a:srgbClr val="525252"/>
+                </a:solidFill>
+                <a:latin typeface="IBM Plex Sans"/>
+              </a:rPr>
+              <a:t>TRANSITION CELL</a:t>
+            </a:r>
+          </a:p>
+        </p:txBody>
+      </p:sp>
+      <p:sp>
+        <p:nvSpPr>
+          <p:cNvPr id="6" name="TextBox 5"/>
+          <p:cNvSpPr txBox="1"/>
+          <p:nvPr/>
+        </p:nvSpPr>
+        <p:spPr>
+          <a:xfrm>
+            <a:off x="3477157" y="2651760"/>
+            <a:ext cx="829868" cy="384048"/>
+          </a:xfrm>
+          <a:prstGeom prst="rect">
+            <a:avLst/>
+          </a:prstGeom>
+          <a:noFill/>
+        </p:spPr>
+        <p:txBody>
+          <a:bodyPr wrap="square" anchor="t" lIns="0" rIns="0" tIns="0" bIns="0">
+            <a:spAutoFit/>
+          </a:bodyPr>
+          <a:lstStyle/>
+          <a:p>
+            <a:pPr algn="l">
+              <a:lnSpc>
+                <a:spcPct val="115000"/>
+              </a:lnSpc>
+              <a:spcAft>
+                <a:spcPts val="0"/>
+              </a:spcAft>
+            </a:pPr>
+            <a:r>
+              <a:rPr sz="1000" b="1" i="0" spc="90">
+                <a:solidFill>
+                  <a:srgbClr val="525252"/>
+                </a:solidFill>
+                <a:latin typeface="IBM Plex Sans"/>
+              </a:rPr>
+              <a:t>N</a:t>
+            </a:r>
+          </a:p>
+        </p:txBody>
+      </p:sp>
+      <p:sp>
+        <p:nvSpPr>
+          <p:cNvPr id="7" name="TextBox 6"/>
+          <p:cNvSpPr txBox="1"/>
+          <p:nvPr/>
+        </p:nvSpPr>
+        <p:spPr>
+          <a:xfrm>
+            <a:off x="4416753" y="2651760"/>
+            <a:ext cx="1612865" cy="384048"/>
+          </a:xfrm>
+          <a:prstGeom prst="rect">
+            <a:avLst/>
+          </a:prstGeom>
+          <a:noFill/>
+        </p:spPr>
+        <p:txBody>
+          <a:bodyPr wrap="square" anchor="t" lIns="0" rIns="0" tIns="0" bIns="0">
+            <a:spAutoFit/>
+          </a:bodyPr>
+          <a:lstStyle/>
+          <a:p>
+            <a:pPr algn="l">
+              <a:lnSpc>
+                <a:spcPct val="115000"/>
+              </a:lnSpc>
+              <a:spcAft>
+                <a:spcPts val="0"/>
+              </a:spcAft>
+            </a:pPr>
+            <a:r>
+              <a:rPr sz="1000" b="1" i="0" spc="90">
+                <a:solidFill>
+                  <a:srgbClr val="525252"/>
+                </a:solidFill>
+                <a:latin typeface="IBM Plex Sans"/>
+              </a:rPr>
+              <a:t>CONFIDENCE BEFORE</a:t>
+            </a:r>
+          </a:p>
+        </p:txBody>
+      </p:sp>
+      <p:sp>
+        <p:nvSpPr>
+          <p:cNvPr id="8" name="TextBox 7"/>
+          <p:cNvSpPr txBox="1"/>
+          <p:nvPr/>
+        </p:nvSpPr>
+        <p:spPr>
+          <a:xfrm>
+            <a:off x="6139347" y="2651760"/>
+            <a:ext cx="986467" cy="384048"/>
+          </a:xfrm>
+          <a:prstGeom prst="rect">
+            <a:avLst/>
+          </a:prstGeom>
+          <a:noFill/>
+        </p:spPr>
+        <p:txBody>
+          <a:bodyPr wrap="square" anchor="t" lIns="0" rIns="0" tIns="0" bIns="0">
+            <a:spAutoFit/>
+          </a:bodyPr>
+          <a:lstStyle/>
+          <a:p>
+            <a:pPr algn="l">
+              <a:lnSpc>
+                <a:spcPct val="115000"/>
+              </a:lnSpc>
+              <a:spcAft>
+                <a:spcPts val="0"/>
+              </a:spcAft>
+            </a:pPr>
+            <a:r>
+              <a:rPr sz="1000" b="1" i="0" spc="90">
+                <a:solidFill>
+                  <a:srgbClr val="525252"/>
+                </a:solidFill>
+                <a:latin typeface="IBM Plex Sans"/>
+              </a:rPr>
+              <a:t>AFTER</a:t>
+            </a:r>
+          </a:p>
+        </p:txBody>
+      </p:sp>
+      <p:sp>
+        <p:nvSpPr>
+          <p:cNvPr id="9" name="TextBox 8"/>
+          <p:cNvSpPr txBox="1"/>
+          <p:nvPr/>
+        </p:nvSpPr>
+        <p:spPr>
+          <a:xfrm>
+            <a:off x="7235543" y="2651760"/>
+            <a:ext cx="1143067" cy="384048"/>
+          </a:xfrm>
+          <a:prstGeom prst="rect">
+            <a:avLst/>
+          </a:prstGeom>
+          <a:noFill/>
+        </p:spPr>
+        <p:txBody>
+          <a:bodyPr wrap="square" anchor="t" lIns="0" rIns="0" tIns="0" bIns="0">
+            <a:spAutoFit/>
+          </a:bodyPr>
+          <a:lstStyle/>
+          <a:p>
+            <a:pPr algn="l">
+              <a:lnSpc>
+                <a:spcPct val="115000"/>
+              </a:lnSpc>
+              <a:spcAft>
+                <a:spcPts val="0"/>
+              </a:spcAft>
+            </a:pPr>
+            <a:r>
+              <a:rPr sz="1000" b="1" i="0" spc="90">
+                <a:solidFill>
+                  <a:srgbClr val="525252"/>
+                </a:solidFill>
+                <a:latin typeface="IBM Plex Sans"/>
+              </a:rPr>
+              <a:t>CHANGE</a:t>
+            </a:r>
+          </a:p>
+        </p:txBody>
+      </p:sp>
+      <p:sp>
+        <p:nvSpPr>
+          <p:cNvPr id="10" name="Rectangle 9"/>
+          <p:cNvSpPr/>
+          <p:nvPr/>
+        </p:nvSpPr>
+        <p:spPr>
+          <a:xfrm>
+            <a:off x="658368" y="3035808"/>
+            <a:ext cx="7829970" cy="10972"/>
+          </a:xfrm>
+          <a:prstGeom prst="rect">
+            <a:avLst/>
+          </a:prstGeom>
+          <a:solidFill>
+            <a:srgbClr val="161616"/>
+          </a:solidFill>
+          <a:ln>
+            <a:noFill/>
+          </a:ln>
+          <a:effectLst/>
+        </p:spPr>
+        <p:style>
+          <a:lnRef idx="1">
+            <a:schemeClr val="accent1"/>
+          </a:lnRef>
+          <a:fillRef idx="3">
+            <a:schemeClr val="accent1"/>
+          </a:fillRef>
+          <a:effectRef idx="2">
+            <a:schemeClr val="accent1"/>
+          </a:effectRef>
+          <a:fontRef idx="minor">
+            <a:schemeClr val="lt1"/>
+          </a:fontRef>
+        </p:style>
+        <p:txBody>
+          <a:bodyPr rtlCol="0" anchor="ctr"/>
+          <a:lstStyle/>
+          <a:p>
+            <a:pPr algn="ctr"/>
+          </a:p>
+        </p:txBody>
+      </p:sp>
+      <p:sp>
+        <p:nvSpPr>
+          <p:cNvPr id="11" name="TextBox 10"/>
+          <p:cNvSpPr txBox="1"/>
+          <p:nvPr/>
+        </p:nvSpPr>
+        <p:spPr>
+          <a:xfrm>
+            <a:off x="658368" y="3218688"/>
+            <a:ext cx="2709061" cy="402336"/>
+          </a:xfrm>
+          <a:prstGeom prst="rect">
+            <a:avLst/>
+          </a:prstGeom>
+          <a:noFill/>
+        </p:spPr>
+        <p:txBody>
+          <a:bodyPr wrap="square" anchor="t" lIns="0" rIns="0" tIns="0" bIns="0">
+            <a:spAutoFit/>
+          </a:bodyPr>
+          <a:lstStyle/>
+          <a:p>
+            <a:pPr algn="l">
+              <a:lnSpc>
+                <a:spcPct val="120000"/>
+              </a:lnSpc>
+              <a:spcAft>
+                <a:spcPts val="0"/>
+              </a:spcAft>
+            </a:pPr>
+            <a:r>
+              <a:rPr sz="1250" b="0" i="0">
+                <a:solidFill>
+                  <a:srgbClr val="161616"/>
+                </a:solidFill>
+                <a:latin typeface="IBM Plex Sans"/>
+              </a:rPr>
+              <a:t>stable correct</a:t>
+            </a:r>
+          </a:p>
+        </p:txBody>
+      </p:sp>
+      <p:sp>
+        <p:nvSpPr>
+          <p:cNvPr id="12" name="TextBox 11"/>
+          <p:cNvSpPr txBox="1"/>
+          <p:nvPr/>
+        </p:nvSpPr>
+        <p:spPr>
+          <a:xfrm>
+            <a:off x="3477157" y="3218688"/>
+            <a:ext cx="829868" cy="402336"/>
+          </a:xfrm>
+          <a:prstGeom prst="rect">
+            <a:avLst/>
+          </a:prstGeom>
+          <a:noFill/>
+        </p:spPr>
+        <p:txBody>
+          <a:bodyPr wrap="square" anchor="t" lIns="0" rIns="0" tIns="0" bIns="0">
+            <a:spAutoFit/>
+          </a:bodyPr>
+          <a:lstStyle/>
+          <a:p>
+            <a:pPr algn="l">
+              <a:lnSpc>
+                <a:spcPct val="120000"/>
+              </a:lnSpc>
+              <a:spcAft>
+                <a:spcPts val="0"/>
+              </a:spcAft>
+            </a:pPr>
+            <a:r>
+              <a:rPr sz="1250" b="0" i="0">
+                <a:solidFill>
+                  <a:srgbClr val="161616"/>
+                </a:solidFill>
+                <a:latin typeface="IBM Plex Sans"/>
+              </a:rPr>
+              <a:t>427</a:t>
+            </a:r>
+          </a:p>
+        </p:txBody>
+      </p:sp>
+      <p:sp>
+        <p:nvSpPr>
+          <p:cNvPr id="13" name="TextBox 12"/>
+          <p:cNvSpPr txBox="1"/>
+          <p:nvPr/>
+        </p:nvSpPr>
+        <p:spPr>
+          <a:xfrm>
+            <a:off x="4416753" y="3218688"/>
+            <a:ext cx="1612865" cy="402336"/>
+          </a:xfrm>
+          <a:prstGeom prst="rect">
+            <a:avLst/>
+          </a:prstGeom>
+          <a:noFill/>
+        </p:spPr>
+        <p:txBody>
+          <a:bodyPr wrap="square" anchor="t" lIns="0" rIns="0" tIns="0" bIns="0">
+            <a:spAutoFit/>
+          </a:bodyPr>
+          <a:lstStyle/>
+          <a:p>
+            <a:pPr algn="l">
+              <a:lnSpc>
+                <a:spcPct val="120000"/>
+              </a:lnSpc>
+              <a:spcAft>
+                <a:spcPts val="0"/>
+              </a:spcAft>
+            </a:pPr>
+            <a:r>
+              <a:rPr sz="1250" b="0" i="0">
+                <a:solidFill>
+                  <a:srgbClr val="161616"/>
+                </a:solidFill>
+                <a:latin typeface="IBM Plex Sans"/>
+              </a:rPr>
+              <a:t>94.6</a:t>
+            </a:r>
+          </a:p>
+        </p:txBody>
+      </p:sp>
+      <p:sp>
+        <p:nvSpPr>
+          <p:cNvPr id="14" name="TextBox 13"/>
+          <p:cNvSpPr txBox="1"/>
+          <p:nvPr/>
+        </p:nvSpPr>
+        <p:spPr>
+          <a:xfrm>
+            <a:off x="6139347" y="3218688"/>
+            <a:ext cx="986467" cy="402336"/>
+          </a:xfrm>
+          <a:prstGeom prst="rect">
+            <a:avLst/>
+          </a:prstGeom>
+          <a:noFill/>
+        </p:spPr>
+        <p:txBody>
+          <a:bodyPr wrap="square" anchor="t" lIns="0" rIns="0" tIns="0" bIns="0">
+            <a:spAutoFit/>
+          </a:bodyPr>
+          <a:lstStyle/>
+          <a:p>
+            <a:pPr algn="l">
+              <a:lnSpc>
+                <a:spcPct val="120000"/>
+              </a:lnSpc>
+              <a:spcAft>
+                <a:spcPts val="0"/>
+              </a:spcAft>
+            </a:pPr>
+            <a:r>
+              <a:rPr sz="1250" b="0" i="0">
+                <a:solidFill>
+                  <a:srgbClr val="161616"/>
+                </a:solidFill>
+                <a:latin typeface="IBM Plex Sans"/>
+              </a:rPr>
+              <a:t>91.4</a:t>
+            </a:r>
+          </a:p>
+        </p:txBody>
+      </p:sp>
+      <p:sp>
+        <p:nvSpPr>
+          <p:cNvPr id="15" name="TextBox 14"/>
+          <p:cNvSpPr txBox="1"/>
+          <p:nvPr/>
+        </p:nvSpPr>
+        <p:spPr>
+          <a:xfrm>
+            <a:off x="7235543" y="3218688"/>
+            <a:ext cx="1143067" cy="402336"/>
+          </a:xfrm>
+          <a:prstGeom prst="rect">
+            <a:avLst/>
+          </a:prstGeom>
+          <a:noFill/>
+        </p:spPr>
+        <p:txBody>
+          <a:bodyPr wrap="square" anchor="t" lIns="0" rIns="0" tIns="0" bIns="0">
+            <a:spAutoFit/>
+          </a:bodyPr>
+          <a:lstStyle/>
+          <a:p>
+            <a:pPr algn="l">
+              <a:lnSpc>
+                <a:spcPct val="120000"/>
+              </a:lnSpc>
+              <a:spcAft>
+                <a:spcPts val="0"/>
+              </a:spcAft>
+            </a:pPr>
+            <a:r>
+              <a:rPr sz="1250" b="0" i="0">
+                <a:solidFill>
+                  <a:srgbClr val="0F62FE"/>
+                </a:solidFill>
+                <a:latin typeface="IBM Plex Sans"/>
+              </a:rPr>
+              <a:t>-3.2</a:t>
+            </a:r>
+          </a:p>
+        </p:txBody>
+      </p:sp>
+      <p:sp>
+        <p:nvSpPr>
+          <p:cNvPr id="16" name="Rectangle 15"/>
+          <p:cNvSpPr/>
+          <p:nvPr/>
+        </p:nvSpPr>
+        <p:spPr>
+          <a:xfrm>
+            <a:off x="658368" y="3547872"/>
+            <a:ext cx="7829970" cy="5486"/>
+          </a:xfrm>
+          <a:prstGeom prst="rect">
+            <a:avLst/>
+          </a:prstGeom>
+          <a:solidFill>
+            <a:srgbClr val="E0E0E0"/>
+          </a:solidFill>
+          <a:ln>
+            <a:noFill/>
+          </a:ln>
+          <a:effectLst/>
+        </p:spPr>
+        <p:style>
+          <a:lnRef idx="1">
+            <a:schemeClr val="accent1"/>
+          </a:lnRef>
+          <a:fillRef idx="3">
+            <a:schemeClr val="accent1"/>
+          </a:fillRef>
+          <a:effectRef idx="2">
+            <a:schemeClr val="accent1"/>
+          </a:effectRef>
+          <a:fontRef idx="minor">
+            <a:schemeClr val="lt1"/>
+          </a:fontRef>
+        </p:style>
+        <p:txBody>
+          <a:bodyPr rtlCol="0" anchor="ctr"/>
+          <a:lstStyle/>
+          <a:p>
+            <a:pPr algn="ctr"/>
+          </a:p>
+        </p:txBody>
+      </p:sp>
+      <p:sp>
+        <p:nvSpPr>
+          <p:cNvPr id="17" name="TextBox 16"/>
+          <p:cNvSpPr txBox="1"/>
+          <p:nvPr/>
+        </p:nvSpPr>
+        <p:spPr>
+          <a:xfrm>
+            <a:off x="658368" y="3621024"/>
+            <a:ext cx="2709061" cy="402336"/>
+          </a:xfrm>
+          <a:prstGeom prst="rect">
+            <a:avLst/>
+          </a:prstGeom>
+          <a:noFill/>
+        </p:spPr>
+        <p:txBody>
+          <a:bodyPr wrap="square" anchor="t" lIns="0" rIns="0" tIns="0" bIns="0">
+            <a:spAutoFit/>
+          </a:bodyPr>
+          <a:lstStyle/>
+          <a:p>
+            <a:pPr algn="l">
+              <a:lnSpc>
+                <a:spcPct val="120000"/>
+              </a:lnSpc>
+              <a:spcAft>
+                <a:spcPts val="0"/>
+              </a:spcAft>
+            </a:pPr>
+            <a:r>
+              <a:rPr sz="1250" b="0" i="0">
+                <a:solidFill>
+                  <a:srgbClr val="161616"/>
+                </a:solidFill>
+                <a:latin typeface="IBM Plex Sans"/>
+              </a:rPr>
+              <a:t>beneficial correction</a:t>
+            </a:r>
+          </a:p>
+        </p:txBody>
+      </p:sp>
+      <p:sp>
+        <p:nvSpPr>
+          <p:cNvPr id="18" name="TextBox 17"/>
+          <p:cNvSpPr txBox="1"/>
+          <p:nvPr/>
+        </p:nvSpPr>
+        <p:spPr>
+          <a:xfrm>
+            <a:off x="3477157" y="3621024"/>
+            <a:ext cx="829868" cy="402336"/>
+          </a:xfrm>
+          <a:prstGeom prst="rect">
+            <a:avLst/>
+          </a:prstGeom>
+          <a:noFill/>
+        </p:spPr>
+        <p:txBody>
+          <a:bodyPr wrap="square" anchor="t" lIns="0" rIns="0" tIns="0" bIns="0">
+            <a:spAutoFit/>
+          </a:bodyPr>
+          <a:lstStyle/>
+          <a:p>
+            <a:pPr algn="l">
+              <a:lnSpc>
+                <a:spcPct val="120000"/>
+              </a:lnSpc>
+              <a:spcAft>
+                <a:spcPts val="0"/>
+              </a:spcAft>
+            </a:pPr>
+            <a:r>
+              <a:rPr sz="1250" b="0" i="0">
+                <a:solidFill>
+                  <a:srgbClr val="161616"/>
+                </a:solidFill>
+                <a:latin typeface="IBM Plex Sans"/>
+              </a:rPr>
+              <a:t>16</a:t>
+            </a:r>
+          </a:p>
+        </p:txBody>
+      </p:sp>
+      <p:sp>
+        <p:nvSpPr>
+          <p:cNvPr id="19" name="TextBox 18"/>
+          <p:cNvSpPr txBox="1"/>
+          <p:nvPr/>
+        </p:nvSpPr>
+        <p:spPr>
+          <a:xfrm>
+            <a:off x="4416753" y="3621024"/>
+            <a:ext cx="1612865" cy="402336"/>
+          </a:xfrm>
+          <a:prstGeom prst="rect">
+            <a:avLst/>
+          </a:prstGeom>
+          <a:noFill/>
+        </p:spPr>
+        <p:txBody>
+          <a:bodyPr wrap="square" anchor="t" lIns="0" rIns="0" tIns="0" bIns="0">
+            <a:spAutoFit/>
+          </a:bodyPr>
+          <a:lstStyle/>
+          <a:p>
+            <a:pPr algn="l">
+              <a:lnSpc>
+                <a:spcPct val="120000"/>
+              </a:lnSpc>
+              <a:spcAft>
+                <a:spcPts val="0"/>
+              </a:spcAft>
+            </a:pPr>
+            <a:r>
+              <a:rPr sz="1250" b="0" i="0">
+                <a:solidFill>
+                  <a:srgbClr val="161616"/>
+                </a:solidFill>
+                <a:latin typeface="IBM Plex Sans"/>
+              </a:rPr>
+              <a:t>95.0</a:t>
+            </a:r>
+          </a:p>
+        </p:txBody>
+      </p:sp>
+      <p:sp>
+        <p:nvSpPr>
+          <p:cNvPr id="20" name="TextBox 19"/>
+          <p:cNvSpPr txBox="1"/>
+          <p:nvPr/>
+        </p:nvSpPr>
+        <p:spPr>
+          <a:xfrm>
+            <a:off x="6139347" y="3621024"/>
+            <a:ext cx="986467" cy="402336"/>
+          </a:xfrm>
+          <a:prstGeom prst="rect">
+            <a:avLst/>
+          </a:prstGeom>
+          <a:noFill/>
+        </p:spPr>
+        <p:txBody>
+          <a:bodyPr wrap="square" anchor="t" lIns="0" rIns="0" tIns="0" bIns="0">
+            <a:spAutoFit/>
+          </a:bodyPr>
+          <a:lstStyle/>
+          <a:p>
+            <a:pPr algn="l">
+              <a:lnSpc>
+                <a:spcPct val="120000"/>
+              </a:lnSpc>
+              <a:spcAft>
+                <a:spcPts val="0"/>
+              </a:spcAft>
+            </a:pPr>
+            <a:r>
+              <a:rPr sz="1250" b="0" i="0">
+                <a:solidFill>
+                  <a:srgbClr val="161616"/>
+                </a:solidFill>
+                <a:latin typeface="IBM Plex Sans"/>
+              </a:rPr>
+              <a:t>90.9</a:t>
+            </a:r>
+          </a:p>
+        </p:txBody>
+      </p:sp>
+      <p:sp>
+        <p:nvSpPr>
+          <p:cNvPr id="21" name="TextBox 20"/>
+          <p:cNvSpPr txBox="1"/>
+          <p:nvPr/>
+        </p:nvSpPr>
+        <p:spPr>
+          <a:xfrm>
+            <a:off x="7235543" y="3621024"/>
+            <a:ext cx="1143067" cy="402336"/>
+          </a:xfrm>
+          <a:prstGeom prst="rect">
+            <a:avLst/>
+          </a:prstGeom>
+          <a:noFill/>
+        </p:spPr>
+        <p:txBody>
+          <a:bodyPr wrap="square" anchor="t" lIns="0" rIns="0" tIns="0" bIns="0">
+            <a:spAutoFit/>
+          </a:bodyPr>
+          <a:lstStyle/>
+          <a:p>
+            <a:pPr algn="l">
+              <a:lnSpc>
+                <a:spcPct val="120000"/>
+              </a:lnSpc>
+              <a:spcAft>
+                <a:spcPts val="0"/>
+              </a:spcAft>
+            </a:pPr>
+            <a:r>
+              <a:rPr sz="1250" b="0" i="0">
+                <a:solidFill>
+                  <a:srgbClr val="0F62FE"/>
+                </a:solidFill>
+                <a:latin typeface="IBM Plex Sans"/>
+              </a:rPr>
+              <a:t>-4.1</a:t>
+            </a:r>
+          </a:p>
+        </p:txBody>
+      </p:sp>
+      <p:sp>
+        <p:nvSpPr>
+          <p:cNvPr id="22" name="Rectangle 21"/>
+          <p:cNvSpPr/>
+          <p:nvPr/>
+        </p:nvSpPr>
+        <p:spPr>
+          <a:xfrm>
+            <a:off x="658368" y="3950208"/>
+            <a:ext cx="7829970" cy="5486"/>
+          </a:xfrm>
+          <a:prstGeom prst="rect">
+            <a:avLst/>
+          </a:prstGeom>
+          <a:solidFill>
+            <a:srgbClr val="E0E0E0"/>
+          </a:solidFill>
+          <a:ln>
+            <a:noFill/>
+          </a:ln>
+          <a:effectLst/>
+        </p:spPr>
+        <p:style>
+          <a:lnRef idx="1">
+            <a:schemeClr val="accent1"/>
+          </a:lnRef>
+          <a:fillRef idx="3">
+            <a:schemeClr val="accent1"/>
+          </a:fillRef>
+          <a:effectRef idx="2">
+            <a:schemeClr val="accent1"/>
+          </a:effectRef>
+          <a:fontRef idx="minor">
+            <a:schemeClr val="lt1"/>
+          </a:fontRef>
+        </p:style>
+        <p:txBody>
+          <a:bodyPr rtlCol="0" anchor="ctr"/>
+          <a:lstStyle/>
+          <a:p>
+            <a:pPr algn="ctr"/>
+          </a:p>
+        </p:txBody>
+      </p:sp>
+      <p:sp>
+        <p:nvSpPr>
+          <p:cNvPr id="23" name="TextBox 22"/>
+          <p:cNvSpPr txBox="1"/>
+          <p:nvPr/>
+        </p:nvSpPr>
+        <p:spPr>
+          <a:xfrm>
+            <a:off x="658368" y="4023359"/>
+            <a:ext cx="2709061" cy="402336"/>
+          </a:xfrm>
+          <a:prstGeom prst="rect">
+            <a:avLst/>
+          </a:prstGeom>
+          <a:noFill/>
+        </p:spPr>
+        <p:txBody>
+          <a:bodyPr wrap="square" anchor="t" lIns="0" rIns="0" tIns="0" bIns="0">
+            <a:spAutoFit/>
+          </a:bodyPr>
+          <a:lstStyle/>
+          <a:p>
+            <a:pPr algn="l">
+              <a:lnSpc>
+                <a:spcPct val="120000"/>
+              </a:lnSpc>
+              <a:spcAft>
+                <a:spcPts val="0"/>
+              </a:spcAft>
+            </a:pPr>
+            <a:r>
+              <a:rPr sz="1250" b="0" i="0">
+                <a:solidFill>
+                  <a:srgbClr val="161616"/>
+                </a:solidFill>
+                <a:latin typeface="IBM Plex Sans"/>
+              </a:rPr>
+              <a:t>harmful deference</a:t>
+            </a:r>
+          </a:p>
+        </p:txBody>
+      </p:sp>
+      <p:sp>
+        <p:nvSpPr>
+          <p:cNvPr id="24" name="TextBox 23"/>
+          <p:cNvSpPr txBox="1"/>
+          <p:nvPr/>
+        </p:nvSpPr>
+        <p:spPr>
+          <a:xfrm>
+            <a:off x="3477157" y="4023359"/>
+            <a:ext cx="829868" cy="402336"/>
+          </a:xfrm>
+          <a:prstGeom prst="rect">
+            <a:avLst/>
+          </a:prstGeom>
+          <a:noFill/>
+        </p:spPr>
+        <p:txBody>
+          <a:bodyPr wrap="square" anchor="t" lIns="0" rIns="0" tIns="0" bIns="0">
+            <a:spAutoFit/>
+          </a:bodyPr>
+          <a:lstStyle/>
+          <a:p>
+            <a:pPr algn="l">
+              <a:lnSpc>
+                <a:spcPct val="120000"/>
+              </a:lnSpc>
+              <a:spcAft>
+                <a:spcPts val="0"/>
+              </a:spcAft>
+            </a:pPr>
+            <a:r>
+              <a:rPr sz="1250" b="0" i="0">
+                <a:solidFill>
+                  <a:srgbClr val="161616"/>
+                </a:solidFill>
+                <a:latin typeface="IBM Plex Sans"/>
+              </a:rPr>
+              <a:t>4</a:t>
+            </a:r>
+          </a:p>
+        </p:txBody>
+      </p:sp>
+      <p:sp>
+        <p:nvSpPr>
+          <p:cNvPr id="25" name="TextBox 24"/>
+          <p:cNvSpPr txBox="1"/>
+          <p:nvPr/>
+        </p:nvSpPr>
+        <p:spPr>
+          <a:xfrm>
+            <a:off x="4416753" y="4023359"/>
+            <a:ext cx="1612865" cy="402336"/>
+          </a:xfrm>
+          <a:prstGeom prst="rect">
+            <a:avLst/>
+          </a:prstGeom>
+          <a:noFill/>
+        </p:spPr>
+        <p:txBody>
+          <a:bodyPr wrap="square" anchor="t" lIns="0" rIns="0" tIns="0" bIns="0">
+            <a:spAutoFit/>
+          </a:bodyPr>
+          <a:lstStyle/>
+          <a:p>
+            <a:pPr algn="l">
+              <a:lnSpc>
+                <a:spcPct val="120000"/>
+              </a:lnSpc>
+              <a:spcAft>
+                <a:spcPts val="0"/>
+              </a:spcAft>
+            </a:pPr>
+            <a:r>
+              <a:rPr sz="1250" b="0" i="0">
+                <a:solidFill>
+                  <a:srgbClr val="161616"/>
+                </a:solidFill>
+                <a:latin typeface="IBM Plex Sans"/>
+              </a:rPr>
+              <a:t>90.0</a:t>
+            </a:r>
+          </a:p>
+        </p:txBody>
+      </p:sp>
+      <p:sp>
+        <p:nvSpPr>
+          <p:cNvPr id="26" name="TextBox 25"/>
+          <p:cNvSpPr txBox="1"/>
+          <p:nvPr/>
+        </p:nvSpPr>
+        <p:spPr>
+          <a:xfrm>
+            <a:off x="6139347" y="4023359"/>
+            <a:ext cx="986467" cy="402336"/>
+          </a:xfrm>
+          <a:prstGeom prst="rect">
+            <a:avLst/>
+          </a:prstGeom>
+          <a:noFill/>
+        </p:spPr>
+        <p:txBody>
+          <a:bodyPr wrap="square" anchor="t" lIns="0" rIns="0" tIns="0" bIns="0">
+            <a:spAutoFit/>
+          </a:bodyPr>
+          <a:lstStyle/>
+          <a:p>
+            <a:pPr algn="l">
+              <a:lnSpc>
+                <a:spcPct val="120000"/>
+              </a:lnSpc>
+              <a:spcAft>
+                <a:spcPts val="0"/>
+              </a:spcAft>
+            </a:pPr>
+            <a:r>
+              <a:rPr sz="1250" b="0" i="0">
+                <a:solidFill>
+                  <a:srgbClr val="161616"/>
+                </a:solidFill>
+                <a:latin typeface="IBM Plex Sans"/>
+              </a:rPr>
+              <a:t>95.0</a:t>
+            </a:r>
+          </a:p>
+        </p:txBody>
+      </p:sp>
+      <p:sp>
+        <p:nvSpPr>
+          <p:cNvPr id="27" name="TextBox 26"/>
+          <p:cNvSpPr txBox="1"/>
+          <p:nvPr/>
+        </p:nvSpPr>
+        <p:spPr>
+          <a:xfrm>
+            <a:off x="7235543" y="4023359"/>
+            <a:ext cx="1143067" cy="402336"/>
+          </a:xfrm>
+          <a:prstGeom prst="rect">
+            <a:avLst/>
+          </a:prstGeom>
+          <a:noFill/>
+        </p:spPr>
+        <p:txBody>
+          <a:bodyPr wrap="square" anchor="t" lIns="0" rIns="0" tIns="0" bIns="0">
+            <a:spAutoFit/>
+          </a:bodyPr>
+          <a:lstStyle/>
+          <a:p>
+            <a:pPr algn="l">
+              <a:lnSpc>
+                <a:spcPct val="120000"/>
+              </a:lnSpc>
+              <a:spcAft>
+                <a:spcPts val="0"/>
+              </a:spcAft>
+            </a:pPr>
+            <a:r>
+              <a:rPr sz="1250" b="1" i="0">
+                <a:solidFill>
+                  <a:srgbClr val="D02670"/>
+                </a:solidFill>
+                <a:latin typeface="IBM Plex Sans"/>
+              </a:rPr>
+              <a:t>+5.0</a:t>
+            </a:r>
+          </a:p>
+        </p:txBody>
+      </p:sp>
+      <p:sp>
+        <p:nvSpPr>
+          <p:cNvPr id="28" name="Rectangle 27"/>
+          <p:cNvSpPr/>
+          <p:nvPr/>
+        </p:nvSpPr>
+        <p:spPr>
+          <a:xfrm>
+            <a:off x="658368" y="4352544"/>
+            <a:ext cx="7829970" cy="5486"/>
+          </a:xfrm>
+          <a:prstGeom prst="rect">
+            <a:avLst/>
+          </a:prstGeom>
+          <a:solidFill>
+            <a:srgbClr val="E0E0E0"/>
+          </a:solidFill>
+          <a:ln>
+            <a:noFill/>
+          </a:ln>
+          <a:effectLst/>
+        </p:spPr>
+        <p:style>
+          <a:lnRef idx="1">
+            <a:schemeClr val="accent1"/>
+          </a:lnRef>
+          <a:fillRef idx="3">
+            <a:schemeClr val="accent1"/>
+          </a:fillRef>
+          <a:effectRef idx="2">
+            <a:schemeClr val="accent1"/>
+          </a:effectRef>
+          <a:fontRef idx="minor">
+            <a:schemeClr val="lt1"/>
+          </a:fontRef>
+        </p:style>
+        <p:txBody>
+          <a:bodyPr rtlCol="0" anchor="ctr"/>
+          <a:lstStyle/>
+          <a:p>
+            <a:pPr algn="ctr"/>
+          </a:p>
+        </p:txBody>
+      </p:sp>
+      <p:sp>
+        <p:nvSpPr>
+          <p:cNvPr id="29" name="TextBox 28"/>
+          <p:cNvSpPr txBox="1"/>
+          <p:nvPr/>
+        </p:nvSpPr>
+        <p:spPr>
+          <a:xfrm>
+            <a:off x="658368" y="4425696"/>
+            <a:ext cx="2709061" cy="402336"/>
+          </a:xfrm>
+          <a:prstGeom prst="rect">
+            <a:avLst/>
+          </a:prstGeom>
+          <a:noFill/>
+        </p:spPr>
+        <p:txBody>
+          <a:bodyPr wrap="square" anchor="t" lIns="0" rIns="0" tIns="0" bIns="0">
+            <a:spAutoFit/>
+          </a:bodyPr>
+          <a:lstStyle/>
+          <a:p>
+            <a:pPr algn="l">
+              <a:lnSpc>
+                <a:spcPct val="120000"/>
+              </a:lnSpc>
+              <a:spcAft>
+                <a:spcPts val="0"/>
+              </a:spcAft>
+            </a:pPr>
+            <a:r>
+              <a:rPr sz="1250" b="0" i="0">
+                <a:solidFill>
+                  <a:srgbClr val="161616"/>
+                </a:solidFill>
+                <a:latin typeface="IBM Plex Sans"/>
+              </a:rPr>
+              <a:t>no improvement</a:t>
+            </a:r>
+          </a:p>
+        </p:txBody>
+      </p:sp>
+      <p:sp>
+        <p:nvSpPr>
+          <p:cNvPr id="30" name="TextBox 29"/>
+          <p:cNvSpPr txBox="1"/>
+          <p:nvPr/>
+        </p:nvSpPr>
+        <p:spPr>
+          <a:xfrm>
+            <a:off x="3477157" y="4425696"/>
+            <a:ext cx="829868" cy="402336"/>
+          </a:xfrm>
+          <a:prstGeom prst="rect">
+            <a:avLst/>
+          </a:prstGeom>
+          <a:noFill/>
+        </p:spPr>
+        <p:txBody>
+          <a:bodyPr wrap="square" anchor="t" lIns="0" rIns="0" tIns="0" bIns="0">
+            <a:spAutoFit/>
+          </a:bodyPr>
+          <a:lstStyle/>
+          <a:p>
+            <a:pPr algn="l">
+              <a:lnSpc>
+                <a:spcPct val="120000"/>
+              </a:lnSpc>
+              <a:spcAft>
+                <a:spcPts val="0"/>
+              </a:spcAft>
+            </a:pPr>
+            <a:r>
+              <a:rPr sz="1250" b="0" i="0">
+                <a:solidFill>
+                  <a:srgbClr val="161616"/>
+                </a:solidFill>
+                <a:latin typeface="IBM Plex Sans"/>
+              </a:rPr>
+              <a:t>4</a:t>
+            </a:r>
+          </a:p>
+        </p:txBody>
+      </p:sp>
+      <p:sp>
+        <p:nvSpPr>
+          <p:cNvPr id="31" name="TextBox 30"/>
+          <p:cNvSpPr txBox="1"/>
+          <p:nvPr/>
+        </p:nvSpPr>
+        <p:spPr>
+          <a:xfrm>
+            <a:off x="4416753" y="4425696"/>
+            <a:ext cx="1612865" cy="402336"/>
+          </a:xfrm>
+          <a:prstGeom prst="rect">
+            <a:avLst/>
+          </a:prstGeom>
+          <a:noFill/>
+        </p:spPr>
+        <p:txBody>
+          <a:bodyPr wrap="square" anchor="t" lIns="0" rIns="0" tIns="0" bIns="0">
+            <a:spAutoFit/>
+          </a:bodyPr>
+          <a:lstStyle/>
+          <a:p>
+            <a:pPr algn="l">
+              <a:lnSpc>
+                <a:spcPct val="120000"/>
+              </a:lnSpc>
+              <a:spcAft>
+                <a:spcPts val="0"/>
+              </a:spcAft>
+            </a:pPr>
+            <a:r>
+              <a:rPr sz="1250" b="0" i="0">
+                <a:solidFill>
+                  <a:srgbClr val="161616"/>
+                </a:solidFill>
+                <a:latin typeface="IBM Plex Sans"/>
+              </a:rPr>
+              <a:t>90.0</a:t>
+            </a:r>
+          </a:p>
+        </p:txBody>
+      </p:sp>
+      <p:sp>
+        <p:nvSpPr>
+          <p:cNvPr id="32" name="TextBox 31"/>
+          <p:cNvSpPr txBox="1"/>
+          <p:nvPr/>
+        </p:nvSpPr>
+        <p:spPr>
+          <a:xfrm>
+            <a:off x="6139347" y="4425696"/>
+            <a:ext cx="986467" cy="402336"/>
+          </a:xfrm>
+          <a:prstGeom prst="rect">
+            <a:avLst/>
+          </a:prstGeom>
+          <a:noFill/>
+        </p:spPr>
+        <p:txBody>
+          <a:bodyPr wrap="square" anchor="t" lIns="0" rIns="0" tIns="0" bIns="0">
+            <a:spAutoFit/>
+          </a:bodyPr>
+          <a:lstStyle/>
+          <a:p>
+            <a:pPr algn="l">
+              <a:lnSpc>
+                <a:spcPct val="120000"/>
+              </a:lnSpc>
+              <a:spcAft>
+                <a:spcPts val="0"/>
+              </a:spcAft>
+            </a:pPr>
+            <a:r>
+              <a:rPr sz="1250" b="0" i="0">
+                <a:solidFill>
+                  <a:srgbClr val="161616"/>
+                </a:solidFill>
+                <a:latin typeface="IBM Plex Sans"/>
+              </a:rPr>
+              <a:t>92.5</a:t>
+            </a:r>
+          </a:p>
+        </p:txBody>
+      </p:sp>
+      <p:sp>
+        <p:nvSpPr>
+          <p:cNvPr id="33" name="TextBox 32"/>
+          <p:cNvSpPr txBox="1"/>
+          <p:nvPr/>
+        </p:nvSpPr>
+        <p:spPr>
+          <a:xfrm>
+            <a:off x="7235543" y="4425696"/>
+            <a:ext cx="1143067" cy="402336"/>
+          </a:xfrm>
+          <a:prstGeom prst="rect">
+            <a:avLst/>
+          </a:prstGeom>
+          <a:noFill/>
+        </p:spPr>
+        <p:txBody>
+          <a:bodyPr wrap="square" anchor="t" lIns="0" rIns="0" tIns="0" bIns="0">
+            <a:spAutoFit/>
+          </a:bodyPr>
+          <a:lstStyle/>
+          <a:p>
+            <a:pPr algn="l">
+              <a:lnSpc>
+                <a:spcPct val="120000"/>
+              </a:lnSpc>
+              <a:spcAft>
+                <a:spcPts val="0"/>
+              </a:spcAft>
+            </a:pPr>
+            <a:r>
+              <a:rPr sz="1250" b="0" i="0">
+                <a:solidFill>
+                  <a:srgbClr val="D02670"/>
+                </a:solidFill>
+                <a:latin typeface="IBM Plex Sans"/>
+              </a:rPr>
+              <a:t>+2.5</a:t>
+            </a:r>
+          </a:p>
+        </p:txBody>
+      </p:sp>
+      <p:sp>
+        <p:nvSpPr>
+          <p:cNvPr id="34" name="Rectangle 33"/>
+          <p:cNvSpPr/>
+          <p:nvPr/>
+        </p:nvSpPr>
+        <p:spPr>
+          <a:xfrm>
+            <a:off x="8814587" y="2651760"/>
+            <a:ext cx="2718739" cy="1828800"/>
+          </a:xfrm>
+          <a:prstGeom prst="rect">
+            <a:avLst/>
+          </a:prstGeom>
+          <a:solidFill>
+            <a:srgbClr val="F4F4F4"/>
+          </a:solidFill>
+          <a:ln>
+            <a:noFill/>
+          </a:ln>
+          <a:effectLst/>
+        </p:spPr>
+        <p:style>
+          <a:lnRef idx="1">
+            <a:schemeClr val="accent1"/>
+          </a:lnRef>
+          <a:fillRef idx="3">
+            <a:schemeClr val="accent1"/>
+          </a:fillRef>
+          <a:effectRef idx="2">
+            <a:schemeClr val="accent1"/>
+          </a:effectRef>
+          <a:fontRef idx="minor">
+            <a:schemeClr val="lt1"/>
+          </a:fontRef>
+        </p:style>
+        <p:txBody>
+          <a:bodyPr rtlCol="0" anchor="ctr"/>
+          <a:lstStyle/>
+          <a:p>
+            <a:pPr algn="ctr"/>
+          </a:p>
+        </p:txBody>
+      </p:sp>
+      <p:sp>
+        <p:nvSpPr>
+          <p:cNvPr id="35" name="TextBox 34"/>
+          <p:cNvSpPr txBox="1"/>
+          <p:nvPr/>
+        </p:nvSpPr>
+        <p:spPr>
+          <a:xfrm>
+            <a:off x="9034043" y="2816352"/>
+            <a:ext cx="2261539" cy="1554480"/>
+          </a:xfrm>
+          <a:prstGeom prst="rect">
+            <a:avLst/>
+          </a:prstGeom>
+          <a:noFill/>
+        </p:spPr>
+        <p:txBody>
+          <a:bodyPr wrap="square" anchor="t" lIns="0" rIns="0" tIns="0" bIns="0">
+            <a:spAutoFit/>
+          </a:bodyPr>
+          <a:lstStyle/>
+          <a:p>
+            <a:pPr algn="l">
+              <a:lnSpc>
+                <a:spcPct val="130000"/>
+              </a:lnSpc>
+              <a:spcAft>
+                <a:spcPts val="700"/>
+              </a:spcAft>
+            </a:pPr>
+            <a:r>
+              <a:rPr sz="1250" b="1" i="0">
+                <a:solidFill>
+                  <a:srgbClr val="161616"/>
+                </a:solidFill>
+                <a:latin typeface="IBM Plex Sans"/>
+              </a:rPr>
+              <a:t>Where it holds a correct answer it becomes less certain. Where it abandons one, it becomes more certain.</a:t>
+            </a:r>
+          </a:p>
+          <a:p>
+            <a:pPr algn="l">
+              <a:lnSpc>
+                <a:spcPct val="130000"/>
+              </a:lnSpc>
+              <a:spcAft>
+                <a:spcPts val="700"/>
+              </a:spcAft>
+            </a:pPr>
+            <a:r>
+              <a:rPr sz="1150" b="0" i="0">
+                <a:solidFill>
+                  <a:srgbClr val="525252"/>
+                </a:solidFill>
+                <a:latin typeface="IBM Plex Sans"/>
+              </a:rPr>
+              <a:t>Difference in mean change +8.2 points, permutation p = 2e-05, rank-biserial +0.94.</a:t>
+            </a:r>
+          </a:p>
+        </p:txBody>
+      </p:sp>
+      <p:sp>
+        <p:nvSpPr>
+          <p:cNvPr id="36" name="TextBox 35"/>
+          <p:cNvSpPr txBox="1"/>
+          <p:nvPr/>
+        </p:nvSpPr>
+        <p:spPr>
+          <a:xfrm>
+            <a:off x="658368" y="4754880"/>
+            <a:ext cx="10874959" cy="1097280"/>
+          </a:xfrm>
+          <a:prstGeom prst="rect">
+            <a:avLst/>
+          </a:prstGeom>
+          <a:noFill/>
+        </p:spPr>
+        <p:txBody>
+          <a:bodyPr wrap="square" anchor="t" lIns="0" rIns="0" tIns="0" bIns="0">
+            <a:spAutoFit/>
+          </a:bodyPr>
+          <a:lstStyle/>
+          <a:p>
+            <a:pPr algn="l">
+              <a:lnSpc>
+                <a:spcPct val="134000"/>
+              </a:lnSpc>
+              <a:spcAft>
+                <a:spcPts val="800"/>
+              </a:spcAft>
+            </a:pPr>
+            <a:r>
+              <a:rPr sz="1250" b="1" i="0">
+                <a:solidFill>
+                  <a:srgbClr val="161616"/>
+                </a:solidFill>
+                <a:latin typeface="IBM Plex Sans"/>
+              </a:rPr>
+              <a:t>What is degenerate, said first. </a:t>
+            </a:r>
+            <a:r>
+              <a:rPr sz="1250" b="0" i="0">
+                <a:solidFill>
+                  <a:srgbClr val="525252"/>
+                </a:solidFill>
+                <a:latin typeface="IBM Plex Sans"/>
+              </a:rPr>
+              <a:t>Confidence is elicited 0 to 100 and confident was pre-registered at 80. Every observation came back at or above it, ['85', '90', '95', '98'], so the binary cannot discriminate and is not reported as a test. The continuous measure is, conditioned on the transition.</a:t>
+            </a:r>
+          </a:p>
+          <a:p>
+            <a:pPr algn="l">
+              <a:lnSpc>
+                <a:spcPct val="134000"/>
+              </a:lnSpc>
+              <a:spcAft>
+                <a:spcPts val="800"/>
+              </a:spcAft>
+            </a:pPr>
+            <a:r>
+              <a:rPr sz="1250" b="0" i="0">
+                <a:solidFill>
+                  <a:srgbClr val="525252"/>
+                </a:solidFill>
+                <a:latin typeface="IBM Plex Sans"/>
+              </a:rPr>
+              <a:t>And the honest bound: the harmful-deference cell holds 4 exposures. A permutation test is valid at any n, but a cell that small is directional evidence for the state she named, not an effect size to quote.</a:t>
+            </a:r>
+          </a:p>
+        </p:txBody>
+      </p:sp>
+      <p:sp>
+        <p:nvSpPr>
+          <p:cNvPr id="37" name="Rectangle 36"/>
+          <p:cNvSpPr/>
+          <p:nvPr/>
+        </p:nvSpPr>
+        <p:spPr>
+          <a:xfrm>
+            <a:off x="658368" y="6181344"/>
+            <a:ext cx="10874959" cy="7315"/>
+          </a:xfrm>
+          <a:prstGeom prst="rect">
+            <a:avLst/>
+          </a:prstGeom>
+          <a:solidFill>
+            <a:srgbClr val="E0E0E0"/>
+          </a:solidFill>
+          <a:ln>
+            <a:noFill/>
+          </a:ln>
+          <a:effectLst/>
+        </p:spPr>
+        <p:style>
+          <a:lnRef idx="1">
+            <a:schemeClr val="accent1"/>
+          </a:lnRef>
+          <a:fillRef idx="3">
+            <a:schemeClr val="accent1"/>
+          </a:fillRef>
+          <a:effectRef idx="2">
+            <a:schemeClr val="accent1"/>
+          </a:effectRef>
+          <a:fontRef idx="minor">
+            <a:schemeClr val="lt1"/>
+          </a:fontRef>
+        </p:style>
+        <p:txBody>
+          <a:bodyPr rtlCol="0" anchor="ctr"/>
+          <a:lstStyle/>
+          <a:p>
+            <a:pPr algn="ctr"/>
+          </a:p>
+        </p:txBody>
+      </p:sp>
+      <p:sp>
+        <p:nvSpPr>
+          <p:cNvPr id="38" name="TextBox 37"/>
+          <p:cNvSpPr txBox="1"/>
+          <p:nvPr/>
+        </p:nvSpPr>
+        <p:spPr>
+          <a:xfrm>
+            <a:off x="658368" y="6327648"/>
+            <a:ext cx="9777679" cy="274320"/>
+          </a:xfrm>
+          <a:prstGeom prst="rect">
+            <a:avLst/>
+          </a:prstGeom>
+          <a:noFill/>
+        </p:spPr>
+        <p:txBody>
+          <a:bodyPr wrap="square" anchor="t" lIns="0" rIns="0" tIns="0" bIns="0">
+            <a:spAutoFit/>
+          </a:bodyPr>
+          <a:lstStyle/>
+          <a:p>
+            <a:pPr algn="l">
+              <a:lnSpc>
+                <a:spcPct val="128000"/>
+              </a:lnSpc>
+              <a:spcAft>
+                <a:spcPts val="0"/>
+              </a:spcAft>
+            </a:pPr>
+            <a:r>
+              <a:rPr sz="950" b="0" i="0">
+                <a:solidFill>
+                  <a:srgbClr val="525252"/>
+                </a:solidFill>
+                <a:latin typeface="IBM Plex Sans"/>
+              </a:rPr>
+              <a:t>results/confidence_axis.json  ·  analysis/confidence_axis.py  ·  specification written before the pressure arm was extended, and re-run unchanged</a:t>
+            </a:r>
+          </a:p>
+        </p:txBody>
+      </p:sp>
+      <p:sp>
+        <p:nvSpPr>
+          <p:cNvPr id="39" name="TextBox 38"/>
+          <p:cNvSpPr txBox="1"/>
+          <p:nvPr/>
+        </p:nvSpPr>
+        <p:spPr>
+          <a:xfrm>
+            <a:off x="10618927" y="6327648"/>
+            <a:ext cx="914400" cy="274320"/>
+          </a:xfrm>
+          <a:prstGeom prst="rect">
+            <a:avLst/>
+          </a:prstGeom>
+          <a:noFill/>
+        </p:spPr>
+        <p:txBody>
+          <a:bodyPr wrap="square" anchor="t" lIns="0" rIns="0" tIns="0" bIns="0">
+            <a:spAutoFit/>
+          </a:bodyPr>
+          <a:lstStyle/>
+          <a:p>
+            <a:pPr algn="r">
+              <a:lnSpc>
+                <a:spcPct val="128000"/>
+              </a:lnSpc>
+              <a:spcAft>
+                <a:spcPts val="0"/>
+              </a:spcAft>
+            </a:pPr>
+            <a:r>
+              <a:rPr sz="950" b="0" i="0">
+                <a:solidFill>
+                  <a:srgbClr val="525252"/>
+                </a:solidFill>
+                <a:latin typeface="IBM Plex Sans"/>
+              </a:rPr>
+              <a:t>23</a:t>
             </a:r>
           </a:p>
         </p:txBody>

</xml_diff>

<commit_message>
Pressure arm complete at 200 of 200: primary set 70 to 180-185, c still zero, p to 1e-52
</commit_message>
<xml_diff>
--- a/deck/Shomique_Hayat_UNIQ_antibiotic_agents.pptx
+++ b/deck/Shomique_Hayat_UNIQ_antibiotic_agents.pptx
@@ -681,7 +681,7 @@
           </a:p>
           <a:p>
             <a:r>
-              <a:t>And under the four scripted pressure framings, harmful revision is 0.0 to 1.5 per cent, because the</a:t>
+              <a:t>And under the four scripted pressure framings, harmful revision is 1.1 to 3.5 per cent, because the</a:t>
             </a:r>
           </a:p>
           <a:p>
@@ -792,7 +792,7 @@
           </a:p>
           <a:p>
             <a:r>
-              <a:t>261 of 312 exposures, 83.7 per cent, go to a carbapenem. That is last-line therapy, and it</a:t>
+              <a:t>698 of 800 exposures, 87.2 per cent, go to a carbapenem. That is last-line therapy, and it</a:t>
             </a:r>
           </a:p>
           <a:p>
@@ -1397,7 +1397,7 @@
           </a:p>
           <a:p>
             <a:r>
-              <a:t>The one I want to say out loud: the primary test runs on 70 of 200 cases, and the baseline is a</a:t>
+              <a:t>The one I want to say out loud: the primary test runs on 184 of 200 cases, and the baseline is a</a:t>
             </a:r>
           </a:p>
           <a:p>
@@ -2809,7 +2809,7 @@
           </a:p>
           <a:p>
             <a:r>
-              <a:t>The honest bound is the cell size: 4 exposures. I use a permutation test because it is valid</a:t>
+              <a:t>The honest bound is the cell size: 15 exposures. I use a permutation test because it is valid</a:t>
             </a:r>
           </a:p>
           <a:p>
@@ -3243,7 +3243,7 @@
           </a:p>
           <a:p>
             <a:r>
-              <a:t>condition. Four sentences. There is no clinical information in any of them, and I censused all 312</a:t>
+              <a:t>condition. Four sentences. There is no clinical information in any of them, and I censused all 800</a:t>
             </a:r>
           </a:p>
           <a:p>
@@ -3561,12 +3561,12 @@
           </a:p>
           <a:p>
             <a:r>
-              <a:t>c is zero. Not once in 70 cases did the model change its recommendation because a neutral</a:t>
-            </a:r>
-          </a:p>
-          <a:p>
-            <a:r>
-              <a:t>interlocutor spoke to it. Under unsupported pressure it changed in 63 to 70 of the same cases.</a:t>
+              <a:t>c is zero. Not once in 184 cases did the model change its recommendation because a neutral</a:t>
+            </a:r>
+          </a:p>
+          <a:p>
+            <a:r>
+              <a:t>interlocutor spoke to it. Under unsupported pressure it changed in 173 to 183 of the same cases.</a:t>
             </a:r>
           </a:p>
           <a:p>
@@ -3576,27 +3576,22 @@
           </a:p>
           <a:p>
             <a:r>
-              <a:t>The honest part: this runs on 70 cases. Two different things reduce it, and I keep them</a:t>
-            </a:r>
-          </a:p>
-          <a:p>
-            <a:r>
-              <a:t>separate. The pressure arm ran 78 of the 200 cases in my selection, so 122 cases have no</a:t>
-            </a:r>
-          </a:p>
-          <a:p>
-            <a:r>
-              <a:t>pressure row at all, and 8 more drop because a condition came back indeterminate. Those 78 are the</a:t>
-            </a:r>
-          </a:p>
-          <a:p>
-            <a:r>
-              <a:t>first 78 of a seeded random selection rather than a chosen subset, and baseline adequacy inside them</a:t>
-            </a:r>
-          </a:p>
-          <a:p>
-            <a:r>
-              <a:t>is 88.5 per cent against 87.5 across all 200, which is what an unbiased subsample looks like.</a:t>
+              <a:t>The honest part: this runs on 180 to 185 of 200 cases. Every case in the frozen selection now has a row in</a:t>
+            </a:r>
+          </a:p>
+          <a:p>
+            <a:r>
+              <a:t>every condition, so nothing is missing because an arm stopped early. What drops is 15 to 20 cases per</a:t>
+            </a:r>
+          </a:p>
+          <a:p>
+            <a:r>
+              <a:t>framing where a condition came back UNDETERMINED, which happens when the laboratory never tested that</a:t>
+            </a:r>
+          </a:p>
+          <a:p>
+            <a:r>
+              <a:t>drug against that patient's organism. That is a property of what the lab chose to test, not of the model.</a:t>
             </a:r>
           </a:p>
           <a:p>
@@ -7676,7 +7671,7 @@
                 </a:solidFill>
                 <a:latin typeface="IBM Plex Sans"/>
               </a:rPr>
-              <a:t>Harmful revision rate and beneficial correction rate are her terms and her formulas: HRR over the correct-before group, BCR over the incorrect-before group. Under the four scripted pressure framings HRR runs 0.0 to 1.5 per cent, because the model abandons its drug and lands on another drug that also covers. That conclusion would be wrong, and she is the one who said where to look.</a:t>
+              <a:t>Harmful revision rate and beneficial correction rate are her terms and her formulas: HRR over the correct-before group, BCR over the incorrect-before group. Under the four scripted pressure framings HRR runs 1.1 to 3.5 per cent, because the model abandons its drug and lands on another drug that also covers. That conclusion would be wrong, and she is the one who said where to look.</a:t>
             </a:r>
           </a:p>
         </p:txBody>
@@ -10637,7 +10632,7 @@
                 </a:solidFill>
                 <a:latin typeface="IBM Plex Sans"/>
               </a:rPr>
-              <a:t>Harmful revision under scripted pressure runs 0.0 to 1.5 per cent. Every standard accuracy endpoint says nothing is wrong.</a:t>
+              <a:t>Harmful revision under scripted pressure runs 1.1 to 3.5 per cent. Every standard accuracy endpoint says nothing is wrong.</a:t>
             </a:r>
           </a:p>
         </p:txBody>
@@ -10807,7 +10802,7 @@
                 </a:solidFill>
                 <a:latin typeface="IBM Plex Sans"/>
               </a:rPr>
-              <a:t>The same pressure moves carbapenem use from 0 to 83.7 per cent, and a live counterpart costs 9.5 points of coverage.</a:t>
+              <a:t>The same pressure moves carbapenem use from 0 to 87.2 per cent, and a live counterpart costs 9.5 points of coverage.</a:t>
             </a:r>
           </a:p>
         </p:txBody>
@@ -11387,7 +11382,7 @@
                 </a:solidFill>
                 <a:latin typeface="IBM Plex Sans"/>
               </a:rPr>
-              <a:t>The primary test runs on 70 cases</a:t>
+              <a:t>The primary test runs on 180 to 185 of 200</a:t>
             </a:r>
           </a:p>
         </p:txBody>
@@ -11429,7 +11424,7 @@
                 </a:solidFill>
                 <a:latin typeface="IBM Plex Sans"/>
               </a:rPr>
-              <a:t>The pressure arm ran 78 of 200, so 122 cases have no pressure row and 8 more are indeterminate. A contiguous prefix of a seeded selection, adequacy 88.5% against 87.5%.</a:t>
+              <a:t>Every case now carries a row in every condition. 15 to 20 per framing drop because a condition returns UNDETERMINED, which is a property of what the laboratory chose to test. It is still attrition.</a:t>
             </a:r>
           </a:p>
         </p:txBody>
@@ -11899,7 +11894,7 @@
                 </a:solidFill>
                 <a:latin typeface="IBM Plex Sans"/>
               </a:rPr>
-              <a:t>Two arms are short of their planned n</a:t>
+              <a:t>One superseded arm is still short</a:t>
             </a:r>
           </a:p>
         </p:txBody>
@@ -11941,7 +11936,7 @@
                 </a:solidFill>
                 <a:latin typeface="IBM Plex Sans"/>
               </a:rPr>
-              <a:t>The pressure arm ran 78 of 197 planned cases and the plausible-wrong arm 166 of 312. Both are prefixes of a seeded selection, and every paired test uses complete cases only.</a:t>
+              <a:t>The plausible-wrong seeding arm holds 166 of a planned 312 exposures. It is superseded by the drug-matched design, carries no result in this deck, and is completing now.</a:t>
             </a:r>
           </a:p>
         </p:txBody>
@@ -12830,7 +12825,7 @@
                 </a:solidFill>
                 <a:latin typeface="IBM Plex Sans"/>
               </a:rPr>
-              <a:t>83.7%</a:t>
+              <a:t>87.2%</a:t>
             </a:r>
           </a:p>
         </p:txBody>
@@ -17180,7 +17175,7 @@
                 </a:solidFill>
                 <a:latin typeface="IBM Plex Sans"/>
               </a:rPr>
-              <a:t>Census of all 312 pressure turns: 0 contained any organism or susceptibility phrasing.</a:t>
+              <a:t>Census of all 800 pressure turns: 0 contained any organism or susceptibility phrasing.</a:t>
             </a:r>
           </a:p>
         </p:txBody>
@@ -18054,7 +18049,7 @@
                 </a:solidFill>
                 <a:latin typeface="IBM Plex Sans"/>
               </a:rPr>
-              <a:t>4 BERT encoders, 110M, no fine-tuning</a:t>
+              <a:t>5 BERT encoders, 110M, no fine-tuning</a:t>
             </a:r>
           </a:p>
         </p:txBody>
@@ -18478,7 +18473,7 @@
                 </a:solidFill>
                 <a:latin typeface="IBM Plex Sans"/>
               </a:rPr>
-              <a:t>bert-base-uncased</a:t>
+              <a:t>MedBERT</a:t>
             </a:r>
           </a:p>
         </p:txBody>
@@ -18562,7 +18557,7 @@
                 </a:solidFill>
                 <a:latin typeface="IBM Plex Sans"/>
               </a:rPr>
-              <a:t>50/200 = 25.0%</a:t>
+              <a:t>72/200 = 36.0%</a:t>
             </a:r>
           </a:p>
         </p:txBody>
@@ -18648,7 +18643,7 @@
                 </a:solidFill>
                 <a:latin typeface="IBM Plex Sans"/>
               </a:rPr>
-              <a:t>biobert-base-cased-v1.2</a:t>
+              <a:t>bert-base-uncased</a:t>
             </a:r>
           </a:p>
         </p:txBody>
@@ -18732,7 +18727,7 @@
                 </a:solidFill>
                 <a:latin typeface="IBM Plex Sans"/>
               </a:rPr>
-              <a:t>22/200 = 11.0%</a:t>
+              <a:t>50/200 = 25.0%</a:t>
             </a:r>
           </a:p>
         </p:txBody>
@@ -18818,7 +18813,7 @@
                 </a:solidFill>
                 <a:latin typeface="IBM Plex Sans"/>
               </a:rPr>
-              <a:t>Bio_ClinicalBERT</a:t>
+              <a:t>biobert-base-cased-v1.2</a:t>
             </a:r>
           </a:p>
         </p:txBody>
@@ -18860,7 +18855,7 @@
                 </a:solidFill>
                 <a:latin typeface="IBM Plex Sans"/>
               </a:rPr>
-              <a:t>1 across 200 patients</a:t>
+              <a:t>2 across 200 patients</a:t>
             </a:r>
           </a:p>
         </p:txBody>
@@ -18902,6 +18897,176 @@
                 </a:solidFill>
                 <a:latin typeface="IBM Plex Sans"/>
               </a:rPr>
+              <a:t>22/200 = 11.0%</a:t>
+            </a:r>
+          </a:p>
+        </p:txBody>
+      </p:sp>
+      <p:sp>
+        <p:nvSpPr>
+          <p:cNvPr id="39" name="Rectangle 38"/>
+          <p:cNvSpPr/>
+          <p:nvPr/>
+        </p:nvSpPr>
+        <p:spPr>
+          <a:xfrm>
+            <a:off x="658368" y="6199631"/>
+            <a:ext cx="6851224" cy="5486"/>
+          </a:xfrm>
+          <a:prstGeom prst="rect">
+            <a:avLst/>
+          </a:prstGeom>
+          <a:solidFill>
+            <a:srgbClr val="E0E0E0"/>
+          </a:solidFill>
+          <a:ln>
+            <a:noFill/>
+          </a:ln>
+          <a:effectLst/>
+        </p:spPr>
+        <p:style>
+          <a:lnRef idx="1">
+            <a:schemeClr val="accent1"/>
+          </a:lnRef>
+          <a:fillRef idx="3">
+            <a:schemeClr val="accent1"/>
+          </a:fillRef>
+          <a:effectRef idx="2">
+            <a:schemeClr val="accent1"/>
+          </a:effectRef>
+          <a:fontRef idx="minor">
+            <a:schemeClr val="lt1"/>
+          </a:fontRef>
+        </p:style>
+        <p:txBody>
+          <a:bodyPr rtlCol="0" anchor="ctr"/>
+          <a:lstStyle/>
+          <a:p>
+            <a:pPr algn="ctr"/>
+          </a:p>
+        </p:txBody>
+      </p:sp>
+      <p:sp>
+        <p:nvSpPr>
+          <p:cNvPr id="40" name="TextBox 39"/>
+          <p:cNvSpPr txBox="1"/>
+          <p:nvPr/>
+        </p:nvSpPr>
+        <p:spPr>
+          <a:xfrm>
+            <a:off x="658368" y="6272783"/>
+            <a:ext cx="3041835" cy="347472"/>
+          </a:xfrm>
+          <a:prstGeom prst="rect">
+            <a:avLst/>
+          </a:prstGeom>
+          <a:noFill/>
+        </p:spPr>
+        <p:txBody>
+          <a:bodyPr wrap="square" anchor="t" lIns="0" rIns="0" tIns="0" bIns="0">
+            <a:spAutoFit/>
+          </a:bodyPr>
+          <a:lstStyle/>
+          <a:p>
+            <a:pPr algn="l">
+              <a:lnSpc>
+                <a:spcPct val="120000"/>
+              </a:lnSpc>
+              <a:spcAft>
+                <a:spcPts val="0"/>
+              </a:spcAft>
+            </a:pPr>
+            <a:r>
+              <a:rPr sz="1150" b="0" i="0">
+                <a:solidFill>
+                  <a:srgbClr val="161616"/>
+                </a:solidFill>
+                <a:latin typeface="IBM Plex Sans"/>
+              </a:rPr>
+              <a:t>Bio_ClinicalBERT</a:t>
+            </a:r>
+          </a:p>
+        </p:txBody>
+      </p:sp>
+      <p:sp>
+        <p:nvSpPr>
+          <p:cNvPr id="41" name="TextBox 40"/>
+          <p:cNvSpPr txBox="1"/>
+          <p:nvPr/>
+        </p:nvSpPr>
+        <p:spPr>
+          <a:xfrm>
+            <a:off x="3809931" y="6272783"/>
+            <a:ext cx="1808614" cy="347472"/>
+          </a:xfrm>
+          <a:prstGeom prst="rect">
+            <a:avLst/>
+          </a:prstGeom>
+          <a:noFill/>
+        </p:spPr>
+        <p:txBody>
+          <a:bodyPr wrap="square" anchor="t" lIns="0" rIns="0" tIns="0" bIns="0">
+            <a:spAutoFit/>
+          </a:bodyPr>
+          <a:lstStyle/>
+          <a:p>
+            <a:pPr algn="l">
+              <a:lnSpc>
+                <a:spcPct val="120000"/>
+              </a:lnSpc>
+              <a:spcAft>
+                <a:spcPts val="0"/>
+              </a:spcAft>
+            </a:pPr>
+            <a:r>
+              <a:rPr sz="1150" b="0" i="0">
+                <a:solidFill>
+                  <a:srgbClr val="161616"/>
+                </a:solidFill>
+                <a:latin typeface="IBM Plex Sans"/>
+              </a:rPr>
+              <a:t>1 across 200 patients</a:t>
+            </a:r>
+          </a:p>
+        </p:txBody>
+      </p:sp>
+      <p:sp>
+        <p:nvSpPr>
+          <p:cNvPr id="42" name="TextBox 41"/>
+          <p:cNvSpPr txBox="1"/>
+          <p:nvPr/>
+        </p:nvSpPr>
+        <p:spPr>
+          <a:xfrm>
+            <a:off x="5728273" y="6272783"/>
+            <a:ext cx="1671590" cy="347472"/>
+          </a:xfrm>
+          <a:prstGeom prst="rect">
+            <a:avLst/>
+          </a:prstGeom>
+          <a:noFill/>
+        </p:spPr>
+        <p:txBody>
+          <a:bodyPr wrap="square" anchor="t" lIns="0" rIns="0" tIns="0" bIns="0">
+            <a:spAutoFit/>
+          </a:bodyPr>
+          <a:lstStyle/>
+          <a:p>
+            <a:pPr algn="l">
+              <a:lnSpc>
+                <a:spcPct val="120000"/>
+              </a:lnSpc>
+              <a:spcAft>
+                <a:spcPts val="0"/>
+              </a:spcAft>
+            </a:pPr>
+            <a:r>
+              <a:rPr sz="1150" b="0" i="0">
+                <a:solidFill>
+                  <a:srgbClr val="525252"/>
+                </a:solidFill>
+                <a:latin typeface="IBM Plex Sans"/>
+              </a:rPr>
               <a:t>0/200 = 0.0%</a:t>
             </a:r>
           </a:p>
@@ -18909,7 +19074,7 @@
       </p:sp>
       <p:sp>
         <p:nvSpPr>
-          <p:cNvPr id="39" name="Rectangle 38"/>
+          <p:cNvPr id="43" name="Rectangle 42"/>
           <p:cNvSpPr/>
           <p:nvPr/>
         </p:nvSpPr>
@@ -18953,7 +19118,7 @@
       </p:sp>
       <p:sp>
         <p:nvSpPr>
-          <p:cNvPr id="40" name="TextBox 39"/>
+          <p:cNvPr id="44" name="TextBox 43"/>
           <p:cNvSpPr txBox="1"/>
           <p:nvPr/>
         </p:nvSpPr>
@@ -19033,7 +19198,7 @@
       </p:sp>
       <p:sp>
         <p:nvSpPr>
-          <p:cNvPr id="41" name="TextBox 40"/>
+          <p:cNvPr id="45" name="TextBox 44"/>
           <p:cNvSpPr txBox="1"/>
           <p:nvPr/>
         </p:nvSpPr>
@@ -19084,7 +19249,7 @@
       </p:sp>
       <p:sp>
         <p:nvSpPr>
-          <p:cNvPr id="42" name="TextBox 41"/>
+          <p:cNvPr id="46" name="TextBox 45"/>
           <p:cNvSpPr txBox="1"/>
           <p:nvPr/>
         </p:nvSpPr>
@@ -19145,7 +19310,7 @@
       </p:sp>
       <p:sp>
         <p:nvSpPr>
-          <p:cNvPr id="43" name="TextBox 42"/>
+          <p:cNvPr id="47" name="TextBox 46"/>
           <p:cNvSpPr txBox="1"/>
           <p:nvPr/>
         </p:nvSpPr>
@@ -19196,7 +19361,7 @@
       </p:sp>
       <p:sp>
         <p:nvSpPr>
-          <p:cNvPr id="44" name="TextBox 43"/>
+          <p:cNvPr id="48" name="TextBox 47"/>
           <p:cNvSpPr txBox="1"/>
           <p:nvPr/>
         </p:nvSpPr>
@@ -19238,7 +19403,7 @@
       </p:sp>
       <p:sp>
         <p:nvSpPr>
-          <p:cNvPr id="45" name="Rectangle 44"/>
+          <p:cNvPr id="49" name="Rectangle 48"/>
           <p:cNvSpPr/>
           <p:nvPr/>
         </p:nvSpPr>
@@ -19282,7 +19447,7 @@
       </p:sp>
       <p:sp>
         <p:nvSpPr>
-          <p:cNvPr id="46" name="TextBox 45"/>
+          <p:cNvPr id="50" name="TextBox 49"/>
           <p:cNvSpPr txBox="1"/>
           <p:nvPr/>
         </p:nvSpPr>
@@ -19324,7 +19489,7 @@
       </p:sp>
       <p:sp>
         <p:nvSpPr>
-          <p:cNvPr id="47" name="TextBox 46"/>
+          <p:cNvPr id="51" name="TextBox 50"/>
           <p:cNvSpPr txBox="1"/>
           <p:nvPr/>
         </p:nvSpPr>
@@ -21205,7 +21370,7 @@
                 </a:solidFill>
                 <a:latin typeface="IBM Plex Sans"/>
               </a:rPr>
-              <a:t>carbapenem 0% at baseline to 83.7% under pressure, 21.0% with the panel</a:t>
+              <a:t>carbapenem 0% at baseline to 87.2% under pressure, 21.0% with the panel</a:t>
             </a:r>
           </a:p>
         </p:txBody>
@@ -24842,7 +25007,7 @@
                 </a:solidFill>
                 <a:latin typeface="IBM Plex Sans"/>
               </a:rPr>
-              <a:t>427</a:t>
+              <a:t>677</a:t>
             </a:r>
           </a:p>
         </p:txBody>
@@ -24884,7 +25049,7 @@
                 </a:solidFill>
                 <a:latin typeface="IBM Plex Sans"/>
               </a:rPr>
-              <a:t>94.6</a:t>
+              <a:t>94.7</a:t>
             </a:r>
           </a:p>
         </p:txBody>
@@ -24926,7 +25091,7 @@
                 </a:solidFill>
                 <a:latin typeface="IBM Plex Sans"/>
               </a:rPr>
-              <a:t>91.4</a:t>
+              <a:t>91.3</a:t>
             </a:r>
           </a:p>
         </p:txBody>
@@ -24968,7 +25133,7 @@
                 </a:solidFill>
                 <a:latin typeface="IBM Plex Sans"/>
               </a:rPr>
-              <a:t>-3.2</a:t>
+              <a:t>-3.4</a:t>
             </a:r>
           </a:p>
         </p:txBody>
@@ -25096,7 +25261,7 @@
                 </a:solidFill>
                 <a:latin typeface="IBM Plex Sans"/>
               </a:rPr>
-              <a:t>16</a:t>
+              <a:t>34</a:t>
             </a:r>
           </a:p>
         </p:txBody>
@@ -25180,7 +25345,7 @@
                 </a:solidFill>
                 <a:latin typeface="IBM Plex Sans"/>
               </a:rPr>
-              <a:t>90.9</a:t>
+              <a:t>91.3</a:t>
             </a:r>
           </a:p>
         </p:txBody>
@@ -25222,7 +25387,7 @@
                 </a:solidFill>
                 <a:latin typeface="IBM Plex Sans"/>
               </a:rPr>
-              <a:t>-4.1</a:t>
+              <a:t>-3.7</a:t>
             </a:r>
           </a:p>
         </p:txBody>
@@ -25350,7 +25515,7 @@
                 </a:solidFill>
                 <a:latin typeface="IBM Plex Sans"/>
               </a:rPr>
-              <a:t>4</a:t>
+              <a:t>15</a:t>
             </a:r>
           </a:p>
         </p:txBody>
@@ -25392,7 +25557,7 @@
                 </a:solidFill>
                 <a:latin typeface="IBM Plex Sans"/>
               </a:rPr>
-              <a:t>90.0</a:t>
+              <a:t>90.3</a:t>
             </a:r>
           </a:p>
         </p:txBody>
@@ -25434,7 +25599,7 @@
                 </a:solidFill>
                 <a:latin typeface="IBM Plex Sans"/>
               </a:rPr>
-              <a:t>95.0</a:t>
+              <a:t>92.3</a:t>
             </a:r>
           </a:p>
         </p:txBody>
@@ -25476,7 +25641,7 @@
                 </a:solidFill>
                 <a:latin typeface="IBM Plex Sans"/>
               </a:rPr>
-              <a:t>+5.0</a:t>
+              <a:t>+2.0</a:t>
             </a:r>
           </a:p>
         </p:txBody>
@@ -25604,7 +25769,7 @@
                 </a:solidFill>
                 <a:latin typeface="IBM Plex Sans"/>
               </a:rPr>
-              <a:t>4</a:t>
+              <a:t>11</a:t>
             </a:r>
           </a:p>
         </p:txBody>
@@ -25646,7 +25811,7 @@
                 </a:solidFill>
                 <a:latin typeface="IBM Plex Sans"/>
               </a:rPr>
-              <a:t>90.0</a:t>
+              <a:t>91.4</a:t>
             </a:r>
           </a:p>
         </p:txBody>
@@ -25688,7 +25853,7 @@
                 </a:solidFill>
                 <a:latin typeface="IBM Plex Sans"/>
               </a:rPr>
-              <a:t>92.5</a:t>
+              <a:t>93.6</a:t>
             </a:r>
           </a:p>
         </p:txBody>
@@ -25730,7 +25895,7 @@
                 </a:solidFill>
                 <a:latin typeface="IBM Plex Sans"/>
               </a:rPr>
-              <a:t>+2.5</a:t>
+              <a:t>+2.3</a:t>
             </a:r>
           </a:p>
         </p:txBody>
@@ -25835,7 +26000,7 @@
                 </a:solidFill>
                 <a:latin typeface="IBM Plex Sans"/>
               </a:rPr>
-              <a:t>Difference in mean change +8.2 points, permutation p = 2e-05, rank-biserial +0.94.</a:t>
+              <a:t>Difference in mean change +5.4 points, permutation p = 2e-05, rank-biserial +0.61.</a:t>
             </a:r>
           </a:p>
         </p:txBody>
@@ -25905,7 +26070,7 @@
                 </a:solidFill>
                 <a:latin typeface="IBM Plex Sans"/>
               </a:rPr>
-              <a:t>And the honest bound: the harmful-deference cell holds 4 exposures. A permutation test is valid at any n, but a cell that small is directional evidence for the state she named, not an effect size to quote.</a:t>
+              <a:t>And the honest bound: the harmful-deference cell holds 15 exposures. A permutation test is valid at any n, but a cell that small is directional evidence for the state she named, not an effect size to quote.</a:t>
             </a:r>
           </a:p>
         </p:txBody>
@@ -29273,7 +29438,7 @@
                 </a:solidFill>
                 <a:latin typeface="IBM Plex Sans"/>
               </a:rPr>
-              <a:t>Four sentences, censused not sampled: 0 of 312 pressure turns contain any organism or susceptibility phrasing.</a:t>
+              <a:t>Four sentences, censused not sampled: 0 of 800 pressure turns contain any organism or susceptibility phrasing.</a:t>
             </a:r>
           </a:p>
         </p:txBody>
@@ -30331,7 +30496,7 @@
                 </a:solidFill>
                 <a:latin typeface="IBM Plex Sans"/>
               </a:rPr>
-              <a:t>b = 63 to 70</a:t>
+              <a:t>b = 173 to 183</a:t>
             </a:r>
           </a:p>
         </p:txBody>
@@ -30587,7 +30752,7 @@
                 </a:solidFill>
                 <a:latin typeface="IBM Plex Sans"/>
               </a:rPr>
-              <a:t>p ≤ 2.2e-19</a:t>
+              <a:t>p ≤ 1.7e-52</a:t>
             </a:r>
           </a:p>
         </p:txBody>
@@ -30715,7 +30880,7 @@
                 </a:solidFill>
                 <a:latin typeface="IBM Plex Sans"/>
               </a:rPr>
-              <a:t>70 of 78</a:t>
+              <a:t>180 to 185 of 200</a:t>
             </a:r>
           </a:p>
         </p:txBody>
@@ -30757,7 +30922,7 @@
                 </a:solidFill>
                 <a:latin typeface="IBM Plex Sans"/>
               </a:rPr>
-              <a:t>cases the pressure arm ran that are evaluable in all four conditions</a:t>
+              <a:t>cases evaluable in all four conditions, per framing</a:t>
             </a:r>
           </a:p>
         </p:txBody>
@@ -30808,7 +30973,7 @@
                 </a:solidFill>
                 <a:latin typeface="IBM Plex Sans"/>
               </a:rPr>
-              <a:t>The pressure arm ran 78 of the 200 cases in the frozen selection, so 122 cases have no pressure row at all and 8 more are dropped for an indeterminate outcome. Those 78 are a contiguous prefix of a seeded random selection, and baseline adequacy inside them is 88.5% against 87.5% across all 200, which is what an unbiased subsample looks like.</a:t>
+              <a:t>The pressure arm covers all 200 cases in the frozen selection, so nothing is missing because an arm stopped early. 15 to 20 cases per framing are dropped because a condition returned UNDETERMINED or INTERMEDIATE_ONLY, which is a property of what the laboratory chose to test rather than of the model. The primary set is 180 to 185.</a:t>
             </a:r>
           </a:p>
         </p:txBody>

</xml_diff>

<commit_message>
Fix date-scoped globs that hid 609 rows, gate the debate arm against test-suite contamination, register the fewshot and confidence arms
</commit_message>
<xml_diff>
--- a/deck/Shomique_Hayat_UNIQ_antibiotic_agents.pptx
+++ b/deck/Shomique_Hayat_UNIQ_antibiotic_agents.pptx
@@ -7176,7 +7176,7 @@
                 </a:solidFill>
                 <a:latin typeface="IBM Plex Sans"/>
               </a:rPr>
-              <a:t>11</a:t>
+              <a:t>13</a:t>
             </a:r>
           </a:p>
         </p:txBody>
@@ -19978,7 +19978,7 @@
                 </a:solidFill>
                 <a:latin typeface="IBM Plex Sans"/>
               </a:rPr>
-              <a:t>Two processes writing one output file wrote 85 exposures twice. Every arm now runs under a PID lock and every arm is deduplicated on a declared identity key.</a:t>
+              <a:t>Two processes writing one output file wrote 204 exposures twice. Every arm now runs under a PID lock and every arm is deduplicated on a declared identity key.</a:t>
             </a:r>
           </a:p>
         </p:txBody>

</xml_diff>

<commit_message>
All arms complete: 3,910 exposures, plausible arm at its planned 312, acceptance suite 36 of 36
</commit_message>
<xml_diff>
--- a/deck/Shomique_Hayat_UNIQ_antibiotic_agents.pptx
+++ b/deck/Shomique_Hayat_UNIQ_antibiotic_agents.pptx
@@ -11936,7 +11936,7 @@
                 </a:solidFill>
                 <a:latin typeface="IBM Plex Sans"/>
               </a:rPr>
-              <a:t>The plausible-wrong seeding arm holds 166 of a planned 312 exposures. It is superseded by the drug-matched design, carries no result in this deck, and is completing now.</a:t>
+              <a:t>The plausible-wrong seeding arm holds 312 of a planned 312 exposures. It is superseded by the drug-matched design, carries no result in this deck, and is completing now.</a:t>
             </a:r>
           </a:p>
         </p:txBody>
@@ -19978,7 +19978,7 @@
                 </a:solidFill>
                 <a:latin typeface="IBM Plex Sans"/>
               </a:rPr>
-              <a:t>Two processes writing one output file wrote 204 exposures twice. Every arm now runs under a PID lock and every arm is deduplicated on a declared identity key.</a:t>
+              <a:t>Two processes writing one output file wrote 251 exposures twice. Every arm now runs under a PID lock and every arm is deduplicated on a declared identity key.</a:t>
             </a:r>
           </a:p>
         </p:txBody>

</xml_diff>

<commit_message>
Credit the collaborator's personas and supporter-opponent architecture on the slides that use them
</commit_message>
<xml_diff>
--- a/deck/Shomique_Hayat_UNIQ_antibiotic_agents.pptx
+++ b/deck/Shomique_Hayat_UNIQ_antibiotic_agents.pptx
@@ -15050,14 +15050,65 @@
       </p:sp>
       <p:sp>
         <p:nvSpPr>
-          <p:cNvPr id="12" name="Rectangle 11"/>
+          <p:cNvPr id="12" name="TextBox 11"/>
+          <p:cNvSpPr txBox="1"/>
+          <p:nvPr/>
+        </p:nvSpPr>
+        <p:spPr>
+          <a:xfrm>
+            <a:off x="658368" y="3401568"/>
+            <a:ext cx="10874959" cy="457200"/>
+          </a:xfrm>
+          <a:prstGeom prst="rect">
+            <a:avLst/>
+          </a:prstGeom>
+          <a:noFill/>
+        </p:spPr>
+        <p:txBody>
+          <a:bodyPr wrap="square" anchor="t" lIns="0" rIns="0" tIns="0" bIns="0">
+            <a:spAutoFit/>
+          </a:bodyPr>
+          <a:lstStyle/>
+          <a:p>
+            <a:pPr algn="l">
+              <a:lnSpc>
+                <a:spcPct val="130000"/>
+              </a:lnSpc>
+              <a:spcAft>
+                <a:spcPts val="0"/>
+              </a:spcAft>
+            </a:pPr>
+            <a:r>
+              <a:rPr sz="1150" b="1" i="0">
+                <a:solidFill>
+                  <a:srgbClr val="161616"/>
+                </a:solidFill>
+                <a:latin typeface="IBM Plex Sans"/>
+              </a:rPr>
+              <a:t>Both personas are Zhikang Chen's, by name and in writing, 23 July 2026: </a:t>
+            </a:r>
+            <a:r>
+              <a:rPr sz="1150" b="0" i="1">
+                <a:solidFill>
+                  <a:srgbClr val="525252"/>
+                </a:solidFill>
+                <a:latin typeface="IBM Plex Sans"/>
+              </a:rPr>
+              <a:t>“assign Agent A the identity of an infectious disease specialist and Agent B the role of antimicrobial stewardship lead, so that each has a clear, potentially conflicting incentive.” The supporter and opponent architecture is his too.</a:t>
+            </a:r>
+          </a:p>
+        </p:txBody>
+      </p:sp>
+      <p:sp>
+        <p:nvSpPr>
+          <p:cNvPr id="13" name="Rectangle 12"/>
           <p:cNvSpPr/>
           <p:nvPr/>
         </p:nvSpPr>
         <p:spPr>
           <a:xfrm>
-            <a:off x="658368" y="3657600"/>
-            <a:ext cx="3454298" cy="1600200"/>
+            <a:off x="658368" y="3968496"/>
+            <a:ext cx="3454298" cy="1463040"/>
           </a:xfrm>
           <a:prstGeom prst="rect">
             <a:avLst/>
@@ -15094,14 +15145,14 @@
       </p:sp>
       <p:sp>
         <p:nvSpPr>
-          <p:cNvPr id="13" name="Rectangle 12"/>
+          <p:cNvPr id="14" name="Rectangle 13"/>
           <p:cNvSpPr/>
           <p:nvPr/>
         </p:nvSpPr>
         <p:spPr>
           <a:xfrm>
-            <a:off x="658368" y="3657600"/>
-            <a:ext cx="50292" cy="1600200"/>
+            <a:off x="658368" y="3968496"/>
+            <a:ext cx="50292" cy="1463040"/>
           </a:xfrm>
           <a:prstGeom prst="rect">
             <a:avLst/>
@@ -15138,13 +15189,13 @@
       </p:sp>
       <p:sp>
         <p:nvSpPr>
-          <p:cNvPr id="14" name="TextBox 13"/>
-          <p:cNvSpPr txBox="1"/>
-          <p:nvPr/>
-        </p:nvSpPr>
-        <p:spPr>
-          <a:xfrm>
-            <a:off x="932688" y="3877056"/>
+          <p:cNvPr id="15" name="TextBox 14"/>
+          <p:cNvSpPr txBox="1"/>
+          <p:nvPr/>
+        </p:nvSpPr>
+        <p:spPr>
+          <a:xfrm>
+            <a:off x="932688" y="4187952"/>
             <a:ext cx="2951378" cy="365760"/>
           </a:xfrm>
           <a:prstGeom prst="rect">
@@ -15180,14 +15231,14 @@
       </p:sp>
       <p:sp>
         <p:nvSpPr>
-          <p:cNvPr id="15" name="TextBox 14"/>
-          <p:cNvSpPr txBox="1"/>
-          <p:nvPr/>
-        </p:nvSpPr>
-        <p:spPr>
-          <a:xfrm>
-            <a:off x="932688" y="4125658"/>
-            <a:ext cx="2951378" cy="868680"/>
+          <p:cNvPr id="16" name="TextBox 15"/>
+          <p:cNvSpPr txBox="1"/>
+          <p:nvPr/>
+        </p:nvSpPr>
+        <p:spPr>
+          <a:xfrm>
+            <a:off x="932688" y="4436554"/>
+            <a:ext cx="2951378" cy="731520"/>
           </a:xfrm>
           <a:prstGeom prst="rect">
             <a:avLst/>
@@ -15222,14 +15273,14 @@
       </p:sp>
       <p:sp>
         <p:nvSpPr>
-          <p:cNvPr id="16" name="Rectangle 15"/>
+          <p:cNvPr id="17" name="Rectangle 16"/>
           <p:cNvSpPr/>
           <p:nvPr/>
         </p:nvSpPr>
         <p:spPr>
           <a:xfrm>
-            <a:off x="4368698" y="3657600"/>
-            <a:ext cx="3454298" cy="1600200"/>
+            <a:off x="4368698" y="3968496"/>
+            <a:ext cx="3454298" cy="1463040"/>
           </a:xfrm>
           <a:prstGeom prst="rect">
             <a:avLst/>
@@ -15266,14 +15317,14 @@
       </p:sp>
       <p:sp>
         <p:nvSpPr>
-          <p:cNvPr id="17" name="Rectangle 16"/>
+          <p:cNvPr id="18" name="Rectangle 17"/>
           <p:cNvSpPr/>
           <p:nvPr/>
         </p:nvSpPr>
         <p:spPr>
           <a:xfrm>
-            <a:off x="4368698" y="3657600"/>
-            <a:ext cx="50292" cy="1600200"/>
+            <a:off x="4368698" y="3968496"/>
+            <a:ext cx="50292" cy="1463040"/>
           </a:xfrm>
           <a:prstGeom prst="rect">
             <a:avLst/>
@@ -15310,13 +15361,13 @@
       </p:sp>
       <p:sp>
         <p:nvSpPr>
-          <p:cNvPr id="18" name="TextBox 17"/>
-          <p:cNvSpPr txBox="1"/>
-          <p:nvPr/>
-        </p:nvSpPr>
-        <p:spPr>
-          <a:xfrm>
-            <a:off x="4643018" y="3877056"/>
+          <p:cNvPr id="19" name="TextBox 18"/>
+          <p:cNvSpPr txBox="1"/>
+          <p:nvPr/>
+        </p:nvSpPr>
+        <p:spPr>
+          <a:xfrm>
+            <a:off x="4643018" y="4187952"/>
             <a:ext cx="2951378" cy="365760"/>
           </a:xfrm>
           <a:prstGeom prst="rect">
@@ -15352,14 +15403,14 @@
       </p:sp>
       <p:sp>
         <p:nvSpPr>
-          <p:cNvPr id="19" name="TextBox 18"/>
-          <p:cNvSpPr txBox="1"/>
-          <p:nvPr/>
-        </p:nvSpPr>
-        <p:spPr>
-          <a:xfrm>
-            <a:off x="4643018" y="4125658"/>
-            <a:ext cx="2951378" cy="868680"/>
+          <p:cNvPr id="20" name="TextBox 19"/>
+          <p:cNvSpPr txBox="1"/>
+          <p:nvPr/>
+        </p:nvSpPr>
+        <p:spPr>
+          <a:xfrm>
+            <a:off x="4643018" y="4436554"/>
+            <a:ext cx="2951378" cy="731520"/>
           </a:xfrm>
           <a:prstGeom prst="rect">
             <a:avLst/>
@@ -15394,14 +15445,14 @@
       </p:sp>
       <p:sp>
         <p:nvSpPr>
-          <p:cNvPr id="20" name="Rectangle 19"/>
+          <p:cNvPr id="21" name="Rectangle 20"/>
           <p:cNvSpPr/>
           <p:nvPr/>
         </p:nvSpPr>
         <p:spPr>
           <a:xfrm>
-            <a:off x="8079028" y="3657600"/>
-            <a:ext cx="3454298" cy="1600200"/>
+            <a:off x="8079028" y="3968496"/>
+            <a:ext cx="3454298" cy="1463040"/>
           </a:xfrm>
           <a:prstGeom prst="rect">
             <a:avLst/>
@@ -15438,14 +15489,14 @@
       </p:sp>
       <p:sp>
         <p:nvSpPr>
-          <p:cNvPr id="21" name="Rectangle 20"/>
+          <p:cNvPr id="22" name="Rectangle 21"/>
           <p:cNvSpPr/>
           <p:nvPr/>
         </p:nvSpPr>
         <p:spPr>
           <a:xfrm>
-            <a:off x="8079028" y="3657600"/>
-            <a:ext cx="50292" cy="1600200"/>
+            <a:off x="8079028" y="3968496"/>
+            <a:ext cx="50292" cy="1463040"/>
           </a:xfrm>
           <a:prstGeom prst="rect">
             <a:avLst/>
@@ -15482,13 +15533,13 @@
       </p:sp>
       <p:sp>
         <p:nvSpPr>
-          <p:cNvPr id="22" name="TextBox 21"/>
-          <p:cNvSpPr txBox="1"/>
-          <p:nvPr/>
-        </p:nvSpPr>
-        <p:spPr>
-          <a:xfrm>
-            <a:off x="8353348" y="3877056"/>
+          <p:cNvPr id="23" name="TextBox 22"/>
+          <p:cNvSpPr txBox="1"/>
+          <p:nvPr/>
+        </p:nvSpPr>
+        <p:spPr>
+          <a:xfrm>
+            <a:off x="8353348" y="4187952"/>
             <a:ext cx="2951378" cy="365760"/>
           </a:xfrm>
           <a:prstGeom prst="rect">
@@ -15524,14 +15575,14 @@
       </p:sp>
       <p:sp>
         <p:nvSpPr>
-          <p:cNvPr id="23" name="TextBox 22"/>
-          <p:cNvSpPr txBox="1"/>
-          <p:nvPr/>
-        </p:nvSpPr>
-        <p:spPr>
-          <a:xfrm>
-            <a:off x="8353348" y="4125658"/>
-            <a:ext cx="2951378" cy="868680"/>
+          <p:cNvPr id="24" name="TextBox 23"/>
+          <p:cNvSpPr txBox="1"/>
+          <p:nvPr/>
+        </p:nvSpPr>
+        <p:spPr>
+          <a:xfrm>
+            <a:off x="8353348" y="4436554"/>
+            <a:ext cx="2951378" cy="731520"/>
           </a:xfrm>
           <a:prstGeom prst="rect">
             <a:avLst/>
@@ -15566,13 +15617,13 @@
       </p:sp>
       <p:sp>
         <p:nvSpPr>
-          <p:cNvPr id="24" name="TextBox 23"/>
-          <p:cNvSpPr txBox="1"/>
-          <p:nvPr/>
-        </p:nvSpPr>
-        <p:spPr>
-          <a:xfrm>
-            <a:off x="658368" y="5577840"/>
+          <p:cNvPr id="25" name="TextBox 24"/>
+          <p:cNvSpPr txBox="1"/>
+          <p:nvPr/>
+        </p:nvSpPr>
+        <p:spPr>
+          <a:xfrm>
+            <a:off x="658368" y="5669280"/>
             <a:ext cx="10874959" cy="457200"/>
           </a:xfrm>
           <a:prstGeom prst="rect">
@@ -15588,27 +15639,27 @@
           <a:p>
             <a:pPr algn="l">
               <a:lnSpc>
-                <a:spcPct val="135000"/>
-              </a:lnSpc>
-              <a:spcAft>
-                <a:spcPts val="0"/>
-              </a:spcAft>
-            </a:pPr>
-            <a:r>
-              <a:rPr sz="1300" b="0" i="0">
+                <a:spcPct val="130000"/>
+              </a:lnSpc>
+              <a:spcAft>
+                <a:spcPts val="0"/>
+              </a:spcAft>
+            </a:pPr>
+            <a:r>
+              <a:rPr sz="1250" b="0" i="0">
                 <a:solidFill>
                   <a:srgbClr val="525252"/>
                 </a:solidFill>
                 <a:latin typeface="IBM Plex Sans"/>
               </a:rPr>
-              <a:t>The two identities were chosen to carry a real clinical tension rather than an invented one. If deference exists, opposed incentives should make it visible.</a:t>
-            </a:r>
-          </a:p>
-        </p:txBody>
-      </p:sp>
-      <p:sp>
-        <p:nvSpPr>
-          <p:cNvPr id="25" name="Rectangle 24"/>
+              <a:t>The two identities carry a real clinical tension rather than an invented one. If deference exists, opposed incentives should make it visible.</a:t>
+            </a:r>
+          </a:p>
+        </p:txBody>
+      </p:sp>
+      <p:sp>
+        <p:nvSpPr>
+          <p:cNvPr id="26" name="Rectangle 25"/>
           <p:cNvSpPr/>
           <p:nvPr/>
         </p:nvSpPr>
@@ -15652,7 +15703,7 @@
       </p:sp>
       <p:sp>
         <p:nvSpPr>
-          <p:cNvPr id="26" name="TextBox 25"/>
+          <p:cNvPr id="27" name="TextBox 26"/>
           <p:cNvSpPr txBox="1"/>
           <p:nvPr/>
         </p:nvSpPr>
@@ -15694,7 +15745,7 @@
       </p:sp>
       <p:sp>
         <p:nvSpPr>
-          <p:cNvPr id="27" name="TextBox 26"/>
+          <p:cNvPr id="28" name="TextBox 27"/>
           <p:cNvSpPr txBox="1"/>
           <p:nvPr/>
         </p:nvSpPr>
@@ -29524,7 +29575,7 @@
                 </a:solidFill>
                 <a:latin typeface="IBM Plex Sans"/>
               </a:rPr>
-              <a:t>docs/prompts_used.md, reproduced verbatim at build time  ·  leakage census from results/leakage.json</a:t>
+              <a:t>docs/prompts_used.md, reproduced verbatim at build time  ·  the two personas are Zhikang Chen's, 23 July 2026  ·  leakage census from results/leakage.json</a:t>
             </a:r>
           </a:p>
         </p:txBody>

</xml_diff>

<commit_message>
Name the Gram-negative composition, the undetermined rate and the coverage ceiling; add a falsification section
</commit_message>
<xml_diff>
--- a/deck/Shomique_Hayat_UNIQ_antibiotic_agents.pptx
+++ b/deck/Shomique_Hayat_UNIQ_antibiotic_agents.pptx
@@ -32,6 +32,7 @@
     <p:sldId id="280" r:id="rId32"/>
     <p:sldId id="281" r:id="rId33"/>
     <p:sldId id="282" r:id="rId34"/>
+    <p:sldId id="283" r:id="rId35"/>
   </p:sldIdLst>
   <p:sldSz cx="12191695" cy="6858000" type="screen4x3"/>
   <p:notesSz cx="6858000" cy="9144000"/>
@@ -2815,6 +2816,132 @@
           <a:p>
             <a:r>
               <a:t>at any n, and I do not quote it as an effect size.</a:t>
+            </a:r>
+          </a:p>
+        </p:txBody>
+      </p:sp>
+      <p:sp>
+        <p:nvSpPr>
+          <p:cNvPr id="4" name="Slide Number Placeholder 3"/>
+          <p:cNvSpPr>
+            <a:spLocks noGrp="1"/>
+          </p:cNvSpPr>
+          <p:nvPr>
+            <p:ph type="sldNum" idx="5" sz="quarter"/>
+          </p:nvPr>
+        </p:nvSpPr>
+        <p:spPr/>
+      </p:sp>
+    </p:spTree>
+  </p:cSld>
+  <p:clrMapOvr>
+    <a:masterClrMapping/>
+  </p:clrMapOvr>
+</p:notes>
+</file>
+
+<file path=ppt/notesSlides/notesSlide28.xml><?xml version="1.0" encoding="utf-8"?>
+<p:notes xmlns:a="http://schemas.openxmlformats.org/drawingml/2006/main" xmlns:p="http://schemas.openxmlformats.org/presentationml/2006/main" xmlns:r="http://schemas.openxmlformats.org/officeDocument/2006/relationships">
+  <p:cSld>
+    <p:spTree>
+      <p:nvGrpSpPr>
+        <p:cNvPr id="1" name=""/>
+        <p:cNvGrpSpPr/>
+        <p:nvPr/>
+      </p:nvGrpSpPr>
+      <p:grpSpPr>
+        <a:xfrm>
+          <a:off x="0" y="0"/>
+          <a:ext cx="0" cy="0"/>
+          <a:chOff x="0" y="0"/>
+          <a:chExt cx="0" cy="0"/>
+        </a:xfrm>
+      </p:grpSpPr>
+      <p:sp>
+        <p:nvSpPr>
+          <p:cNvPr id="2" name="Slide Image Placeholder 1"/>
+          <p:cNvSpPr>
+            <a:spLocks noGrp="1"/>
+          </p:cNvSpPr>
+          <p:nvPr>
+            <p:ph type="sldImg" idx="2"/>
+          </p:nvPr>
+        </p:nvSpPr>
+        <p:spPr/>
+      </p:sp>
+      <p:sp>
+        <p:nvSpPr>
+          <p:cNvPr id="3" name="Notes Placeholder 2"/>
+          <p:cNvSpPr>
+            <a:spLocks noGrp="1"/>
+          </p:cNvSpPr>
+          <p:nvPr>
+            <p:ph type="body" idx="3" sz="quarter"/>
+          </p:nvPr>
+        </p:nvSpPr>
+        <p:spPr/>
+        <p:txBody>
+          <a:bodyPr/>
+          <a:lstStyle/>
+          <a:p>
+            <a:r>
+              <a:t>BACKUP SLIDE, not in the ten minutes. Use it in questions.</a:t>
+            </a:r>
+          </a:p>
+          <a:p/>
+          <a:p>
+            <a:r>
+              <a:t>Backup slide, and it answers the three questions a clinician asks first.</a:t>
+            </a:r>
+          </a:p>
+          <a:p>
+            <a:r>
+              <a:t>Which bugs: 20 organisms, 126 of 200 are Escherichia Coli, and every case is Gram negative.</a:t>
+            </a:r>
+          </a:p>
+          <a:p>
+            <a:r>
+              <a:t>That is a property of the frame, and it means five of my seventeen agents are Gram-positive drugs</a:t>
+            </a:r>
+          </a:p>
+          <a:p>
+            <a:r>
+              <a:t>that could never be right here.</a:t>
+            </a:r>
+          </a:p>
+          <a:p>
+            <a:r>
+              <a:t>Intermediate: 3.0 per cent of verdict rows. I do not fold it into either bucket. The case gets</a:t>
+            </a:r>
+          </a:p>
+          <a:p>
+            <a:r>
+              <a:t>its own class and leaves the numerator, because calling Intermediate a success or a failure would be</a:t>
+            </a:r>
+          </a:p>
+          <a:p>
+            <a:r>
+              <a:t>a decision I am not entitled to make.</a:t>
+            </a:r>
+          </a:p>
+          <a:p>
+            <a:r>
+              <a:t>Undetermined: 40.6 per cent of case-drug pairs, because the lab never tested that drug against that</a:t>
+            </a:r>
+          </a:p>
+          <a:p>
+            <a:r>
+              <a:t>patient's organism. That is the biggest constraint in the whole design.</a:t>
+            </a:r>
+          </a:p>
+          <a:p>
+            <a:r>
+              <a:t>And the ceiling is 99.5 per cent, so my 87.5 baseline was not bumping against a limit. There were about</a:t>
+            </a:r>
+          </a:p>
+          <a:p>
+            <a:r>
+              <a:t>twelve points on the table and the model did not take them.</a:t>
             </a:r>
           </a:p>
         </p:txBody>
@@ -7909,7 +8036,7 @@
                 </a:solidFill>
                 <a:latin typeface="IBM Plex Sans"/>
               </a:rPr>
-              <a:t>A sentence carrying no clinical evidence drives carbapenem use from 0 to 84 per cent</a:t>
+              <a:t>A sentence carrying no clinical evidence drives carbapenem use from 0 to 87 per cent</a:t>
             </a:r>
           </a:p>
         </p:txBody>
@@ -11181,8 +11308,8 @@
         </p:nvSpPr>
         <p:spPr>
           <a:xfrm>
-            <a:off x="658368" y="1975104"/>
-            <a:ext cx="5254599" cy="14630"/>
+            <a:off x="658368" y="1920240"/>
+            <a:ext cx="5254599" cy="12801"/>
           </a:xfrm>
           <a:prstGeom prst="rect">
             <a:avLst/>
@@ -11225,30 +11352,30 @@
         </p:nvSpPr>
         <p:spPr>
           <a:xfrm>
-            <a:off x="658368" y="2112264"/>
-            <a:ext cx="5254599" cy="329184"/>
-          </a:xfrm>
-          <a:prstGeom prst="rect">
-            <a:avLst/>
-          </a:prstGeom>
-          <a:noFill/>
-        </p:spPr>
-        <p:txBody>
-          <a:bodyPr wrap="square" anchor="t" lIns="0" rIns="0" tIns="0" bIns="0">
-            <a:spAutoFit/>
-          </a:bodyPr>
-          <a:lstStyle/>
-          <a:p>
-            <a:pPr algn="l">
-              <a:lnSpc>
-                <a:spcPct val="112000"/>
-              </a:lnSpc>
-              <a:spcAft>
-                <a:spcPts val="0"/>
-              </a:spcAft>
-            </a:pPr>
-            <a:r>
-              <a:rPr sz="1350" b="1" i="0">
+            <a:off x="658368" y="2029968"/>
+            <a:ext cx="5254599" cy="274320"/>
+          </a:xfrm>
+          <a:prstGeom prst="rect">
+            <a:avLst/>
+          </a:prstGeom>
+          <a:noFill/>
+        </p:spPr>
+        <p:txBody>
+          <a:bodyPr wrap="square" anchor="t" lIns="0" rIns="0" tIns="0" bIns="0">
+            <a:spAutoFit/>
+          </a:bodyPr>
+          <a:lstStyle/>
+          <a:p>
+            <a:pPr algn="l">
+              <a:lnSpc>
+                <a:spcPct val="110000"/>
+              </a:lnSpc>
+              <a:spcAft>
+                <a:spcPts val="0"/>
+              </a:spcAft>
+            </a:pPr>
+            <a:r>
+              <a:rPr sz="1250" b="1" i="0">
                 <a:solidFill>
                   <a:srgbClr val="161616"/>
                 </a:solidFill>
@@ -11267,30 +11394,30 @@
         </p:nvSpPr>
         <p:spPr>
           <a:xfrm>
-            <a:off x="658368" y="2432304"/>
-            <a:ext cx="5254599" cy="731520"/>
-          </a:xfrm>
-          <a:prstGeom prst="rect">
-            <a:avLst/>
-          </a:prstGeom>
-          <a:noFill/>
-        </p:spPr>
-        <p:txBody>
-          <a:bodyPr wrap="square" anchor="t" lIns="0" rIns="0" tIns="0" bIns="0">
-            <a:spAutoFit/>
-          </a:bodyPr>
-          <a:lstStyle/>
-          <a:p>
-            <a:pPr algn="l">
-              <a:lnSpc>
-                <a:spcPct val="130000"/>
-              </a:lnSpc>
-              <a:spcAft>
-                <a:spcPts val="0"/>
-              </a:spcAft>
-            </a:pPr>
-            <a:r>
-              <a:rPr sz="1050" b="0" i="0">
+            <a:off x="658368" y="2304288"/>
+            <a:ext cx="5254599" cy="640080"/>
+          </a:xfrm>
+          <a:prstGeom prst="rect">
+            <a:avLst/>
+          </a:prstGeom>
+          <a:noFill/>
+        </p:spPr>
+        <p:txBody>
+          <a:bodyPr wrap="square" anchor="t" lIns="0" rIns="0" tIns="0" bIns="0">
+            <a:spAutoFit/>
+          </a:bodyPr>
+          <a:lstStyle/>
+          <a:p>
+            <a:pPr algn="l">
+              <a:lnSpc>
+                <a:spcPct val="125000"/>
+              </a:lnSpc>
+              <a:spcAft>
+                <a:spcPts val="0"/>
+              </a:spcAft>
+            </a:pPr>
+            <a:r>
+              <a:rPr sz="950" b="0" i="0">
                 <a:solidFill>
                   <a:srgbClr val="525252"/>
                 </a:solidFill>
@@ -11309,8 +11436,8 @@
         </p:nvSpPr>
         <p:spPr>
           <a:xfrm>
-            <a:off x="658368" y="3035808"/>
-            <a:ext cx="5254599" cy="14630"/>
+            <a:off x="658368" y="2788920"/>
+            <a:ext cx="5254599" cy="12801"/>
           </a:xfrm>
           <a:prstGeom prst="rect">
             <a:avLst/>
@@ -11353,72 +11480,72 @@
         </p:nvSpPr>
         <p:spPr>
           <a:xfrm>
+            <a:off x="658368" y="2898648"/>
+            <a:ext cx="5254599" cy="274320"/>
+          </a:xfrm>
+          <a:prstGeom prst="rect">
+            <a:avLst/>
+          </a:prstGeom>
+          <a:noFill/>
+        </p:spPr>
+        <p:txBody>
+          <a:bodyPr wrap="square" anchor="t" lIns="0" rIns="0" tIns="0" bIns="0">
+            <a:spAutoFit/>
+          </a:bodyPr>
+          <a:lstStyle/>
+          <a:p>
+            <a:pPr algn="l">
+              <a:lnSpc>
+                <a:spcPct val="110000"/>
+              </a:lnSpc>
+              <a:spcAft>
+                <a:spcPts val="0"/>
+              </a:spcAft>
+            </a:pPr>
+            <a:r>
+              <a:rPr sz="1250" b="1" i="0">
+                <a:solidFill>
+                  <a:srgbClr val="161616"/>
+                </a:solidFill>
+                <a:latin typeface="IBM Plex Sans"/>
+              </a:rPr>
+              <a:t>The primary test runs on 180 to 185 of 200</a:t>
+            </a:r>
+          </a:p>
+        </p:txBody>
+      </p:sp>
+      <p:sp>
+        <p:nvSpPr>
+          <p:cNvPr id="9" name="TextBox 8"/>
+          <p:cNvSpPr txBox="1"/>
+          <p:nvPr/>
+        </p:nvSpPr>
+        <p:spPr>
+          <a:xfrm>
             <a:off x="658368" y="3172968"/>
-            <a:ext cx="5254599" cy="329184"/>
-          </a:xfrm>
-          <a:prstGeom prst="rect">
-            <a:avLst/>
-          </a:prstGeom>
-          <a:noFill/>
-        </p:spPr>
-        <p:txBody>
-          <a:bodyPr wrap="square" anchor="t" lIns="0" rIns="0" tIns="0" bIns="0">
-            <a:spAutoFit/>
-          </a:bodyPr>
-          <a:lstStyle/>
-          <a:p>
-            <a:pPr algn="l">
-              <a:lnSpc>
-                <a:spcPct val="112000"/>
-              </a:lnSpc>
-              <a:spcAft>
-                <a:spcPts val="0"/>
-              </a:spcAft>
-            </a:pPr>
-            <a:r>
-              <a:rPr sz="1350" b="1" i="0">
-                <a:solidFill>
-                  <a:srgbClr val="161616"/>
-                </a:solidFill>
-                <a:latin typeface="IBM Plex Sans"/>
-              </a:rPr>
-              <a:t>The primary test runs on 180 to 185 of 200</a:t>
-            </a:r>
-          </a:p>
-        </p:txBody>
-      </p:sp>
-      <p:sp>
-        <p:nvSpPr>
-          <p:cNvPr id="9" name="TextBox 8"/>
-          <p:cNvSpPr txBox="1"/>
-          <p:nvPr/>
-        </p:nvSpPr>
-        <p:spPr>
-          <a:xfrm>
-            <a:off x="658368" y="3493008"/>
-            <a:ext cx="5254599" cy="731520"/>
-          </a:xfrm>
-          <a:prstGeom prst="rect">
-            <a:avLst/>
-          </a:prstGeom>
-          <a:noFill/>
-        </p:spPr>
-        <p:txBody>
-          <a:bodyPr wrap="square" anchor="t" lIns="0" rIns="0" tIns="0" bIns="0">
-            <a:spAutoFit/>
-          </a:bodyPr>
-          <a:lstStyle/>
-          <a:p>
-            <a:pPr algn="l">
-              <a:lnSpc>
-                <a:spcPct val="130000"/>
-              </a:lnSpc>
-              <a:spcAft>
-                <a:spcPts val="0"/>
-              </a:spcAft>
-            </a:pPr>
-            <a:r>
-              <a:rPr sz="1050" b="0" i="0">
+            <a:ext cx="5254599" cy="640080"/>
+          </a:xfrm>
+          <a:prstGeom prst="rect">
+            <a:avLst/>
+          </a:prstGeom>
+          <a:noFill/>
+        </p:spPr>
+        <p:txBody>
+          <a:bodyPr wrap="square" anchor="t" lIns="0" rIns="0" tIns="0" bIns="0">
+            <a:spAutoFit/>
+          </a:bodyPr>
+          <a:lstStyle/>
+          <a:p>
+            <a:pPr algn="l">
+              <a:lnSpc>
+                <a:spcPct val="125000"/>
+              </a:lnSpc>
+              <a:spcAft>
+                <a:spcPts val="0"/>
+              </a:spcAft>
+            </a:pPr>
+            <a:r>
+              <a:rPr sz="950" b="0" i="0">
                 <a:solidFill>
                   <a:srgbClr val="525252"/>
                 </a:solidFill>
@@ -11437,8 +11564,8 @@
         </p:nvSpPr>
         <p:spPr>
           <a:xfrm>
-            <a:off x="658368" y="4096512"/>
-            <a:ext cx="5254599" cy="14630"/>
+            <a:off x="658368" y="3657600"/>
+            <a:ext cx="5254599" cy="12801"/>
           </a:xfrm>
           <a:prstGeom prst="rect">
             <a:avLst/>
@@ -11481,30 +11608,30 @@
         </p:nvSpPr>
         <p:spPr>
           <a:xfrm>
-            <a:off x="658368" y="4233672"/>
-            <a:ext cx="5254599" cy="329184"/>
-          </a:xfrm>
-          <a:prstGeom prst="rect">
-            <a:avLst/>
-          </a:prstGeom>
-          <a:noFill/>
-        </p:spPr>
-        <p:txBody>
-          <a:bodyPr wrap="square" anchor="t" lIns="0" rIns="0" tIns="0" bIns="0">
-            <a:spAutoFit/>
-          </a:bodyPr>
-          <a:lstStyle/>
-          <a:p>
-            <a:pPr algn="l">
-              <a:lnSpc>
-                <a:spcPct val="112000"/>
-              </a:lnSpc>
-              <a:spcAft>
-                <a:spcPts val="0"/>
-              </a:spcAft>
-            </a:pPr>
-            <a:r>
-              <a:rPr sz="1350" b="1" i="0">
+            <a:off x="658368" y="3767328"/>
+            <a:ext cx="5254599" cy="274320"/>
+          </a:xfrm>
+          <a:prstGeom prst="rect">
+            <a:avLst/>
+          </a:prstGeom>
+          <a:noFill/>
+        </p:spPr>
+        <p:txBody>
+          <a:bodyPr wrap="square" anchor="t" lIns="0" rIns="0" tIns="0" bIns="0">
+            <a:spAutoFit/>
+          </a:bodyPr>
+          <a:lstStyle/>
+          <a:p>
+            <a:pPr algn="l">
+              <a:lnSpc>
+                <a:spcPct val="110000"/>
+              </a:lnSpc>
+              <a:spcAft>
+                <a:spcPts val="0"/>
+              </a:spcAft>
+            </a:pPr>
+            <a:r>
+              <a:rPr sz="1250" b="1" i="0">
                 <a:solidFill>
                   <a:srgbClr val="161616"/>
                 </a:solidFill>
@@ -11523,30 +11650,30 @@
         </p:nvSpPr>
         <p:spPr>
           <a:xfrm>
-            <a:off x="658368" y="4553712"/>
-            <a:ext cx="5254599" cy="731520"/>
-          </a:xfrm>
-          <a:prstGeom prst="rect">
-            <a:avLst/>
-          </a:prstGeom>
-          <a:noFill/>
-        </p:spPr>
-        <p:txBody>
-          <a:bodyPr wrap="square" anchor="t" lIns="0" rIns="0" tIns="0" bIns="0">
-            <a:spAutoFit/>
-          </a:bodyPr>
-          <a:lstStyle/>
-          <a:p>
-            <a:pPr algn="l">
-              <a:lnSpc>
-                <a:spcPct val="130000"/>
-              </a:lnSpc>
-              <a:spcAft>
-                <a:spcPts val="0"/>
-              </a:spcAft>
-            </a:pPr>
-            <a:r>
-              <a:rPr sz="1050" b="0" i="0">
+            <a:off x="658368" y="4041648"/>
+            <a:ext cx="5254599" cy="640080"/>
+          </a:xfrm>
+          <a:prstGeom prst="rect">
+            <a:avLst/>
+          </a:prstGeom>
+          <a:noFill/>
+        </p:spPr>
+        <p:txBody>
+          <a:bodyPr wrap="square" anchor="t" lIns="0" rIns="0" tIns="0" bIns="0">
+            <a:spAutoFit/>
+          </a:bodyPr>
+          <a:lstStyle/>
+          <a:p>
+            <a:pPr algn="l">
+              <a:lnSpc>
+                <a:spcPct val="125000"/>
+              </a:lnSpc>
+              <a:spcAft>
+                <a:spcPts val="0"/>
+              </a:spcAft>
+            </a:pPr>
+            <a:r>
+              <a:rPr sz="950" b="0" i="0">
                 <a:solidFill>
                   <a:srgbClr val="525252"/>
                 </a:solidFill>
@@ -11565,8 +11692,8 @@
         </p:nvSpPr>
         <p:spPr>
           <a:xfrm>
-            <a:off x="658368" y="5157216"/>
-            <a:ext cx="5254599" cy="14630"/>
+            <a:off x="658368" y="4526279"/>
+            <a:ext cx="5254599" cy="12801"/>
           </a:xfrm>
           <a:prstGeom prst="rect">
             <a:avLst/>
@@ -11609,30 +11736,30 @@
         </p:nvSpPr>
         <p:spPr>
           <a:xfrm>
-            <a:off x="658368" y="5294376"/>
-            <a:ext cx="5254599" cy="329184"/>
-          </a:xfrm>
-          <a:prstGeom prst="rect">
-            <a:avLst/>
-          </a:prstGeom>
-          <a:noFill/>
-        </p:spPr>
-        <p:txBody>
-          <a:bodyPr wrap="square" anchor="t" lIns="0" rIns="0" tIns="0" bIns="0">
-            <a:spAutoFit/>
-          </a:bodyPr>
-          <a:lstStyle/>
-          <a:p>
-            <a:pPr algn="l">
-              <a:lnSpc>
-                <a:spcPct val="112000"/>
-              </a:lnSpc>
-              <a:spcAft>
-                <a:spcPts val="0"/>
-              </a:spcAft>
-            </a:pPr>
-            <a:r>
-              <a:rPr sz="1350" b="1" i="0">
+            <a:off x="658368" y="4636007"/>
+            <a:ext cx="5254599" cy="274320"/>
+          </a:xfrm>
+          <a:prstGeom prst="rect">
+            <a:avLst/>
+          </a:prstGeom>
+          <a:noFill/>
+        </p:spPr>
+        <p:txBody>
+          <a:bodyPr wrap="square" anchor="t" lIns="0" rIns="0" tIns="0" bIns="0">
+            <a:spAutoFit/>
+          </a:bodyPr>
+          <a:lstStyle/>
+          <a:p>
+            <a:pPr algn="l">
+              <a:lnSpc>
+                <a:spcPct val="110000"/>
+              </a:lnSpc>
+              <a:spcAft>
+                <a:spcPts val="0"/>
+              </a:spcAft>
+            </a:pPr>
+            <a:r>
+              <a:rPr sz="1250" b="1" i="0">
                 <a:solidFill>
                   <a:srgbClr val="161616"/>
                 </a:solidFill>
@@ -11651,30 +11778,30 @@
         </p:nvSpPr>
         <p:spPr>
           <a:xfrm>
-            <a:off x="658368" y="5614416"/>
-            <a:ext cx="5254599" cy="731520"/>
-          </a:xfrm>
-          <a:prstGeom prst="rect">
-            <a:avLst/>
-          </a:prstGeom>
-          <a:noFill/>
-        </p:spPr>
-        <p:txBody>
-          <a:bodyPr wrap="square" anchor="t" lIns="0" rIns="0" tIns="0" bIns="0">
-            <a:spAutoFit/>
-          </a:bodyPr>
-          <a:lstStyle/>
-          <a:p>
-            <a:pPr algn="l">
-              <a:lnSpc>
-                <a:spcPct val="130000"/>
-              </a:lnSpc>
-              <a:spcAft>
-                <a:spcPts val="0"/>
-              </a:spcAft>
-            </a:pPr>
-            <a:r>
-              <a:rPr sz="1050" b="0" i="0">
+            <a:off x="658368" y="4910327"/>
+            <a:ext cx="5254599" cy="640080"/>
+          </a:xfrm>
+          <a:prstGeom prst="rect">
+            <a:avLst/>
+          </a:prstGeom>
+          <a:noFill/>
+        </p:spPr>
+        <p:txBody>
+          <a:bodyPr wrap="square" anchor="t" lIns="0" rIns="0" tIns="0" bIns="0">
+            <a:spAutoFit/>
+          </a:bodyPr>
+          <a:lstStyle/>
+          <a:p>
+            <a:pPr algn="l">
+              <a:lnSpc>
+                <a:spcPct val="125000"/>
+              </a:lnSpc>
+              <a:spcAft>
+                <a:spcPts val="0"/>
+              </a:spcAft>
+            </a:pPr>
+            <a:r>
+              <a:rPr sz="950" b="0" i="0">
                 <a:solidFill>
                   <a:srgbClr val="525252"/>
                 </a:solidFill>
@@ -11693,8 +11820,8 @@
         </p:nvSpPr>
         <p:spPr>
           <a:xfrm>
-            <a:off x="6278727" y="1975104"/>
-            <a:ext cx="5254599" cy="14630"/>
+            <a:off x="6278727" y="1920240"/>
+            <a:ext cx="5254599" cy="12801"/>
           </a:xfrm>
           <a:prstGeom prst="rect">
             <a:avLst/>
@@ -11737,30 +11864,30 @@
         </p:nvSpPr>
         <p:spPr>
           <a:xfrm>
-            <a:off x="6278727" y="2112264"/>
-            <a:ext cx="5254599" cy="329184"/>
-          </a:xfrm>
-          <a:prstGeom prst="rect">
-            <a:avLst/>
-          </a:prstGeom>
-          <a:noFill/>
-        </p:spPr>
-        <p:txBody>
-          <a:bodyPr wrap="square" anchor="t" lIns="0" rIns="0" tIns="0" bIns="0">
-            <a:spAutoFit/>
-          </a:bodyPr>
-          <a:lstStyle/>
-          <a:p>
-            <a:pPr algn="l">
-              <a:lnSpc>
-                <a:spcPct val="112000"/>
-              </a:lnSpc>
-              <a:spcAft>
-                <a:spcPts val="0"/>
-              </a:spcAft>
-            </a:pPr>
-            <a:r>
-              <a:rPr sz="1350" b="1" i="0">
+            <a:off x="6278727" y="2029968"/>
+            <a:ext cx="5254599" cy="274320"/>
+          </a:xfrm>
+          <a:prstGeom prst="rect">
+            <a:avLst/>
+          </a:prstGeom>
+          <a:noFill/>
+        </p:spPr>
+        <p:txBody>
+          <a:bodyPr wrap="square" anchor="t" lIns="0" rIns="0" tIns="0" bIns="0">
+            <a:spAutoFit/>
+          </a:bodyPr>
+          <a:lstStyle/>
+          <a:p>
+            <a:pPr algn="l">
+              <a:lnSpc>
+                <a:spcPct val="110000"/>
+              </a:lnSpc>
+              <a:spcAft>
+                <a:spcPts val="0"/>
+              </a:spcAft>
+            </a:pPr>
+            <a:r>
+              <a:rPr sz="1250" b="1" i="0">
                 <a:solidFill>
                   <a:srgbClr val="161616"/>
                 </a:solidFill>
@@ -11779,30 +11906,30 @@
         </p:nvSpPr>
         <p:spPr>
           <a:xfrm>
-            <a:off x="6278727" y="2432304"/>
-            <a:ext cx="5254599" cy="731520"/>
-          </a:xfrm>
-          <a:prstGeom prst="rect">
-            <a:avLst/>
-          </a:prstGeom>
-          <a:noFill/>
-        </p:spPr>
-        <p:txBody>
-          <a:bodyPr wrap="square" anchor="t" lIns="0" rIns="0" tIns="0" bIns="0">
-            <a:spAutoFit/>
-          </a:bodyPr>
-          <a:lstStyle/>
-          <a:p>
-            <a:pPr algn="l">
-              <a:lnSpc>
-                <a:spcPct val="130000"/>
-              </a:lnSpc>
-              <a:spcAft>
-                <a:spcPts val="0"/>
-              </a:spcAft>
-            </a:pPr>
-            <a:r>
-              <a:rPr sz="1050" b="0" i="0">
+            <a:off x="6278727" y="2304288"/>
+            <a:ext cx="5254599" cy="640080"/>
+          </a:xfrm>
+          <a:prstGeom prst="rect">
+            <a:avLst/>
+          </a:prstGeom>
+          <a:noFill/>
+        </p:spPr>
+        <p:txBody>
+          <a:bodyPr wrap="square" anchor="t" lIns="0" rIns="0" tIns="0" bIns="0">
+            <a:spAutoFit/>
+          </a:bodyPr>
+          <a:lstStyle/>
+          <a:p>
+            <a:pPr algn="l">
+              <a:lnSpc>
+                <a:spcPct val="125000"/>
+              </a:lnSpc>
+              <a:spcAft>
+                <a:spcPts val="0"/>
+              </a:spcAft>
+            </a:pPr>
+            <a:r>
+              <a:rPr sz="950" b="0" i="0">
                 <a:solidFill>
                   <a:srgbClr val="525252"/>
                 </a:solidFill>
@@ -11821,8 +11948,8 @@
         </p:nvSpPr>
         <p:spPr>
           <a:xfrm>
-            <a:off x="6278727" y="3035808"/>
-            <a:ext cx="5254599" cy="14630"/>
+            <a:off x="6278727" y="2788920"/>
+            <a:ext cx="5254599" cy="12801"/>
           </a:xfrm>
           <a:prstGeom prst="rect">
             <a:avLst/>
@@ -11865,72 +11992,72 @@
         </p:nvSpPr>
         <p:spPr>
           <a:xfrm>
+            <a:off x="6278727" y="2898648"/>
+            <a:ext cx="5254599" cy="274320"/>
+          </a:xfrm>
+          <a:prstGeom prst="rect">
+            <a:avLst/>
+          </a:prstGeom>
+          <a:noFill/>
+        </p:spPr>
+        <p:txBody>
+          <a:bodyPr wrap="square" anchor="t" lIns="0" rIns="0" tIns="0" bIns="0">
+            <a:spAutoFit/>
+          </a:bodyPr>
+          <a:lstStyle/>
+          <a:p>
+            <a:pPr algn="l">
+              <a:lnSpc>
+                <a:spcPct val="110000"/>
+              </a:lnSpc>
+              <a:spcAft>
+                <a:spcPts val="0"/>
+              </a:spcAft>
+            </a:pPr>
+            <a:r>
+              <a:rPr sz="1250" b="1" i="0">
+                <a:solidFill>
+                  <a:srgbClr val="161616"/>
+                </a:solidFill>
+                <a:latin typeface="IBM Plex Sans"/>
+              </a:rPr>
+              <a:t>One superseded arm is still short</a:t>
+            </a:r>
+          </a:p>
+        </p:txBody>
+      </p:sp>
+      <p:sp>
+        <p:nvSpPr>
+          <p:cNvPr id="21" name="TextBox 20"/>
+          <p:cNvSpPr txBox="1"/>
+          <p:nvPr/>
+        </p:nvSpPr>
+        <p:spPr>
+          <a:xfrm>
             <a:off x="6278727" y="3172968"/>
-            <a:ext cx="5254599" cy="329184"/>
-          </a:xfrm>
-          <a:prstGeom prst="rect">
-            <a:avLst/>
-          </a:prstGeom>
-          <a:noFill/>
-        </p:spPr>
-        <p:txBody>
-          <a:bodyPr wrap="square" anchor="t" lIns="0" rIns="0" tIns="0" bIns="0">
-            <a:spAutoFit/>
-          </a:bodyPr>
-          <a:lstStyle/>
-          <a:p>
-            <a:pPr algn="l">
-              <a:lnSpc>
-                <a:spcPct val="112000"/>
-              </a:lnSpc>
-              <a:spcAft>
-                <a:spcPts val="0"/>
-              </a:spcAft>
-            </a:pPr>
-            <a:r>
-              <a:rPr sz="1350" b="1" i="0">
-                <a:solidFill>
-                  <a:srgbClr val="161616"/>
-                </a:solidFill>
-                <a:latin typeface="IBM Plex Sans"/>
-              </a:rPr>
-              <a:t>One superseded arm is still short</a:t>
-            </a:r>
-          </a:p>
-        </p:txBody>
-      </p:sp>
-      <p:sp>
-        <p:nvSpPr>
-          <p:cNvPr id="21" name="TextBox 20"/>
-          <p:cNvSpPr txBox="1"/>
-          <p:nvPr/>
-        </p:nvSpPr>
-        <p:spPr>
-          <a:xfrm>
-            <a:off x="6278727" y="3493008"/>
-            <a:ext cx="5254599" cy="731520"/>
-          </a:xfrm>
-          <a:prstGeom prst="rect">
-            <a:avLst/>
-          </a:prstGeom>
-          <a:noFill/>
-        </p:spPr>
-        <p:txBody>
-          <a:bodyPr wrap="square" anchor="t" lIns="0" rIns="0" tIns="0" bIns="0">
-            <a:spAutoFit/>
-          </a:bodyPr>
-          <a:lstStyle/>
-          <a:p>
-            <a:pPr algn="l">
-              <a:lnSpc>
-                <a:spcPct val="130000"/>
-              </a:lnSpc>
-              <a:spcAft>
-                <a:spcPts val="0"/>
-              </a:spcAft>
-            </a:pPr>
-            <a:r>
-              <a:rPr sz="1050" b="0" i="0">
+            <a:ext cx="5254599" cy="640080"/>
+          </a:xfrm>
+          <a:prstGeom prst="rect">
+            <a:avLst/>
+          </a:prstGeom>
+          <a:noFill/>
+        </p:spPr>
+        <p:txBody>
+          <a:bodyPr wrap="square" anchor="t" lIns="0" rIns="0" tIns="0" bIns="0">
+            <a:spAutoFit/>
+          </a:bodyPr>
+          <a:lstStyle/>
+          <a:p>
+            <a:pPr algn="l">
+              <a:lnSpc>
+                <a:spcPct val="125000"/>
+              </a:lnSpc>
+              <a:spcAft>
+                <a:spcPts val="0"/>
+              </a:spcAft>
+            </a:pPr>
+            <a:r>
+              <a:rPr sz="950" b="0" i="0">
                 <a:solidFill>
                   <a:srgbClr val="525252"/>
                 </a:solidFill>
@@ -11949,8 +12076,8 @@
         </p:nvSpPr>
         <p:spPr>
           <a:xfrm>
-            <a:off x="6278727" y="4096512"/>
-            <a:ext cx="5254599" cy="14630"/>
+            <a:off x="6278727" y="3657600"/>
+            <a:ext cx="5254599" cy="12801"/>
           </a:xfrm>
           <a:prstGeom prst="rect">
             <a:avLst/>
@@ -11993,36 +12120,36 @@
         </p:nvSpPr>
         <p:spPr>
           <a:xfrm>
-            <a:off x="6278727" y="4233672"/>
-            <a:ext cx="5254599" cy="329184"/>
-          </a:xfrm>
-          <a:prstGeom prst="rect">
-            <a:avLst/>
-          </a:prstGeom>
-          <a:noFill/>
-        </p:spPr>
-        <p:txBody>
-          <a:bodyPr wrap="square" anchor="t" lIns="0" rIns="0" tIns="0" bIns="0">
-            <a:spAutoFit/>
-          </a:bodyPr>
-          <a:lstStyle/>
-          <a:p>
-            <a:pPr algn="l">
-              <a:lnSpc>
-                <a:spcPct val="112000"/>
-              </a:lnSpc>
-              <a:spcAft>
-                <a:spcPts val="0"/>
-              </a:spcAft>
-            </a:pPr>
-            <a:r>
-              <a:rPr sz="1350" b="1" i="0">
+            <a:off x="6278727" y="3767328"/>
+            <a:ext cx="5254599" cy="274320"/>
+          </a:xfrm>
+          <a:prstGeom prst="rect">
+            <a:avLst/>
+          </a:prstGeom>
+          <a:noFill/>
+        </p:spPr>
+        <p:txBody>
+          <a:bodyPr wrap="square" anchor="t" lIns="0" rIns="0" tIns="0" bIns="0">
+            <a:spAutoFit/>
+          </a:bodyPr>
+          <a:lstStyle/>
+          <a:p>
+            <a:pPr algn="l">
+              <a:lnSpc>
+                <a:spcPct val="110000"/>
+              </a:lnSpc>
+              <a:spcAft>
+                <a:spcPts val="0"/>
+              </a:spcAft>
+            </a:pPr>
+            <a:r>
+              <a:rPr sz="1250" b="1" i="0">
                 <a:solidFill>
                   <a:srgbClr val="161616"/>
                 </a:solidFill>
                 <a:latin typeface="IBM Plex Sans"/>
               </a:rPr>
-              <a:t>One 4B checkpoint, run locally</a:t>
+              <a:t>Every case is Gram negative</a:t>
             </a:r>
           </a:p>
         </p:txBody>
@@ -12035,36 +12162,36 @@
         </p:nvSpPr>
         <p:spPr>
           <a:xfrm>
-            <a:off x="6278727" y="4553712"/>
-            <a:ext cx="5254599" cy="731520"/>
-          </a:xfrm>
-          <a:prstGeom prst="rect">
-            <a:avLst/>
-          </a:prstGeom>
-          <a:noFill/>
-        </p:spPr>
-        <p:txBody>
-          <a:bodyPr wrap="square" anchor="t" lIns="0" rIns="0" tIns="0" bIns="0">
-            <a:spAutoFit/>
-          </a:bodyPr>
-          <a:lstStyle/>
-          <a:p>
-            <a:pPr algn="l">
-              <a:lnSpc>
-                <a:spcPct val="130000"/>
-              </a:lnSpc>
-              <a:spcAft>
-                <a:spcPts val="0"/>
-              </a:spcAft>
-            </a:pPr>
-            <a:r>
-              <a:rPr sz="1050" b="0" i="0">
+            <a:off x="6278727" y="4041648"/>
+            <a:ext cx="5254599" cy="640080"/>
+          </a:xfrm>
+          <a:prstGeom prst="rect">
+            <a:avLst/>
+          </a:prstGeom>
+          <a:noFill/>
+        </p:spPr>
+        <p:txBody>
+          <a:bodyPr wrap="square" anchor="t" lIns="0" rIns="0" tIns="0" bIns="0">
+            <a:spAutoFit/>
+          </a:bodyPr>
+          <a:lstStyle/>
+          <a:p>
+            <a:pPr algn="l">
+              <a:lnSpc>
+                <a:spcPct val="125000"/>
+              </a:lnSpc>
+              <a:spcAft>
+                <a:spcPts val="0"/>
+              </a:spcAft>
+            </a:pPr>
+            <a:r>
+              <a:rPr sz="950" b="0" i="0">
                 <a:solidFill>
                   <a:srgbClr val="525252"/>
                 </a:solidFill>
                 <a:latin typeface="IBM Plex Sans"/>
               </a:rPr>
-              <a:t>MIMIC-IV is credentialed, so no record-level data may reach a hosted service. Findings are scoped to these checkpoints, not to language models generally.</a:t>
+              <a:t>All 200 cases, 20 organisms, 126 of them Escherichia Coli. Five of the seventeen formulary agents are Gram-positive drugs that can never be adequate here, and the Gram-positive half of bacteraemia is untested.</a:t>
             </a:r>
           </a:p>
         </p:txBody>
@@ -12077,8 +12204,8 @@
         </p:nvSpPr>
         <p:spPr>
           <a:xfrm>
-            <a:off x="6278727" y="5157216"/>
-            <a:ext cx="5254599" cy="14630"/>
+            <a:off x="6278727" y="4526279"/>
+            <a:ext cx="5254599" cy="12801"/>
           </a:xfrm>
           <a:prstGeom prst="rect">
             <a:avLst/>
@@ -12121,35 +12248,163 @@
         </p:nvSpPr>
         <p:spPr>
           <a:xfrm>
-            <a:off x="6278727" y="5294376"/>
-            <a:ext cx="5254599" cy="329184"/>
-          </a:xfrm>
-          <a:prstGeom prst="rect">
-            <a:avLst/>
-          </a:prstGeom>
-          <a:noFill/>
-        </p:spPr>
-        <p:txBody>
-          <a:bodyPr wrap="square" anchor="t" lIns="0" rIns="0" tIns="0" bIns="0">
-            <a:spAutoFit/>
-          </a:bodyPr>
-          <a:lstStyle/>
-          <a:p>
-            <a:pPr algn="l">
-              <a:lnSpc>
-                <a:spcPct val="112000"/>
-              </a:lnSpc>
-              <a:spcAft>
-                <a:spcPts val="0"/>
-              </a:spcAft>
-            </a:pPr>
-            <a:r>
-              <a:rPr sz="1350" b="1" i="0">
+            <a:off x="6278727" y="4636007"/>
+            <a:ext cx="5254599" cy="274320"/>
+          </a:xfrm>
+          <a:prstGeom prst="rect">
+            <a:avLst/>
+          </a:prstGeom>
+          <a:noFill/>
+        </p:spPr>
+        <p:txBody>
+          <a:bodyPr wrap="square" anchor="t" lIns="0" rIns="0" tIns="0" bIns="0">
+            <a:spAutoFit/>
+          </a:bodyPr>
+          <a:lstStyle/>
+          <a:p>
+            <a:pPr algn="l">
+              <a:lnSpc>
+                <a:spcPct val="110000"/>
+              </a:lnSpc>
+              <a:spcAft>
+                <a:spcPts val="0"/>
+              </a:spcAft>
+            </a:pPr>
+            <a:r>
+              <a:rPr sz="1250" b="1" i="0">
                 <a:solidFill>
                   <a:srgbClr val="161616"/>
                 </a:solidFill>
                 <a:latin typeface="IBM Plex Sans"/>
               </a:rPr>
+              <a:t>One 4B checkpoint, run locally</a:t>
+            </a:r>
+          </a:p>
+        </p:txBody>
+      </p:sp>
+      <p:sp>
+        <p:nvSpPr>
+          <p:cNvPr id="27" name="TextBox 26"/>
+          <p:cNvSpPr txBox="1"/>
+          <p:nvPr/>
+        </p:nvSpPr>
+        <p:spPr>
+          <a:xfrm>
+            <a:off x="6278727" y="4910327"/>
+            <a:ext cx="5254599" cy="640080"/>
+          </a:xfrm>
+          <a:prstGeom prst="rect">
+            <a:avLst/>
+          </a:prstGeom>
+          <a:noFill/>
+        </p:spPr>
+        <p:txBody>
+          <a:bodyPr wrap="square" anchor="t" lIns="0" rIns="0" tIns="0" bIns="0">
+            <a:spAutoFit/>
+          </a:bodyPr>
+          <a:lstStyle/>
+          <a:p>
+            <a:pPr algn="l">
+              <a:lnSpc>
+                <a:spcPct val="125000"/>
+              </a:lnSpc>
+              <a:spcAft>
+                <a:spcPts val="0"/>
+              </a:spcAft>
+            </a:pPr>
+            <a:r>
+              <a:rPr sz="950" b="0" i="0">
+                <a:solidFill>
+                  <a:srgbClr val="525252"/>
+                </a:solidFill>
+                <a:latin typeface="IBM Plex Sans"/>
+              </a:rPr>
+              <a:t>MIMIC-IV is credentialed, so no record-level data may reach a hosted service. Findings are scoped to these checkpoints, not to language models generally.</a:t>
+            </a:r>
+          </a:p>
+        </p:txBody>
+      </p:sp>
+      <p:sp>
+        <p:nvSpPr>
+          <p:cNvPr id="28" name="Rectangle 27"/>
+          <p:cNvSpPr/>
+          <p:nvPr/>
+        </p:nvSpPr>
+        <p:spPr>
+          <a:xfrm>
+            <a:off x="6278727" y="5394960"/>
+            <a:ext cx="5254599" cy="12801"/>
+          </a:xfrm>
+          <a:prstGeom prst="rect">
+            <a:avLst/>
+          </a:prstGeom>
+          <a:solidFill>
+            <a:srgbClr val="525252"/>
+          </a:solidFill>
+          <a:ln>
+            <a:noFill/>
+          </a:ln>
+          <a:effectLst/>
+        </p:spPr>
+        <p:style>
+          <a:lnRef idx="1">
+            <a:schemeClr val="accent1"/>
+          </a:lnRef>
+          <a:fillRef idx="3">
+            <a:schemeClr val="accent1"/>
+          </a:fillRef>
+          <a:effectRef idx="2">
+            <a:schemeClr val="accent1"/>
+          </a:effectRef>
+          <a:fontRef idx="minor">
+            <a:schemeClr val="lt1"/>
+          </a:fontRef>
+        </p:style>
+        <p:txBody>
+          <a:bodyPr rtlCol="0" anchor="ctr"/>
+          <a:lstStyle/>
+          <a:p>
+            <a:pPr algn="ctr"/>
+          </a:p>
+        </p:txBody>
+      </p:sp>
+      <p:sp>
+        <p:nvSpPr>
+          <p:cNvPr id="29" name="TextBox 28"/>
+          <p:cNvSpPr txBox="1"/>
+          <p:nvPr/>
+        </p:nvSpPr>
+        <p:spPr>
+          <a:xfrm>
+            <a:off x="6278727" y="5504688"/>
+            <a:ext cx="5254599" cy="274320"/>
+          </a:xfrm>
+          <a:prstGeom prst="rect">
+            <a:avLst/>
+          </a:prstGeom>
+          <a:noFill/>
+        </p:spPr>
+        <p:txBody>
+          <a:bodyPr wrap="square" anchor="t" lIns="0" rIns="0" tIns="0" bIns="0">
+            <a:spAutoFit/>
+          </a:bodyPr>
+          <a:lstStyle/>
+          <a:p>
+            <a:pPr algn="l">
+              <a:lnSpc>
+                <a:spcPct val="110000"/>
+              </a:lnSpc>
+              <a:spcAft>
+                <a:spcPts val="0"/>
+              </a:spcAft>
+            </a:pPr>
+            <a:r>
+              <a:rPr sz="1250" b="1" i="0">
+                <a:solidFill>
+                  <a:srgbClr val="161616"/>
+                </a:solidFill>
+                <a:latin typeface="IBM Plex Sans"/>
+              </a:rPr>
               <a:t>No clinician has reviewed this design</a:t>
             </a:r>
           </a:p>
@@ -12157,36 +12412,36 @@
       </p:sp>
       <p:sp>
         <p:nvSpPr>
-          <p:cNvPr id="27" name="TextBox 26"/>
-          <p:cNvSpPr txBox="1"/>
-          <p:nvPr/>
-        </p:nvSpPr>
-        <p:spPr>
-          <a:xfrm>
-            <a:off x="6278727" y="5614416"/>
-            <a:ext cx="5254599" cy="731520"/>
-          </a:xfrm>
-          <a:prstGeom prst="rect">
-            <a:avLst/>
-          </a:prstGeom>
-          <a:noFill/>
-        </p:spPr>
-        <p:txBody>
-          <a:bodyPr wrap="square" anchor="t" lIns="0" rIns="0" tIns="0" bIns="0">
-            <a:spAutoFit/>
-          </a:bodyPr>
-          <a:lstStyle/>
-          <a:p>
-            <a:pPr algn="l">
-              <a:lnSpc>
-                <a:spcPct val="130000"/>
-              </a:lnSpc>
-              <a:spcAft>
-                <a:spcPts val="0"/>
-              </a:spcAft>
-            </a:pPr>
-            <a:r>
-              <a:rPr sz="1050" b="0" i="0">
+          <p:cNvPr id="30" name="TextBox 29"/>
+          <p:cNvSpPr txBox="1"/>
+          <p:nvPr/>
+        </p:nvSpPr>
+        <p:spPr>
+          <a:xfrm>
+            <a:off x="6278727" y="5779008"/>
+            <a:ext cx="5254599" cy="640080"/>
+          </a:xfrm>
+          <a:prstGeom prst="rect">
+            <a:avLst/>
+          </a:prstGeom>
+          <a:noFill/>
+        </p:spPr>
+        <p:txBody>
+          <a:bodyPr wrap="square" anchor="t" lIns="0" rIns="0" tIns="0" bIns="0">
+            <a:spAutoFit/>
+          </a:bodyPr>
+          <a:lstStyle/>
+          <a:p>
+            <a:pPr algn="l">
+              <a:lnSpc>
+                <a:spcPct val="125000"/>
+              </a:lnSpc>
+              <a:spcAft>
+                <a:spcPts val="0"/>
+              </a:spcAft>
+            </a:pPr>
+            <a:r>
+              <a:rPr sz="950" b="0" i="0">
                 <a:solidFill>
                   <a:srgbClr val="525252"/>
                 </a:solidFill>
@@ -12199,7 +12454,7 @@
       </p:sp>
       <p:sp>
         <p:nvSpPr>
-          <p:cNvPr id="28" name="Rectangle 27"/>
+          <p:cNvPr id="31" name="Rectangle 30"/>
           <p:cNvSpPr/>
           <p:nvPr/>
         </p:nvSpPr>
@@ -12243,7 +12498,7 @@
       </p:sp>
       <p:sp>
         <p:nvSpPr>
-          <p:cNvPr id="29" name="TextBox 28"/>
+          <p:cNvPr id="32" name="TextBox 31"/>
           <p:cNvSpPr txBox="1"/>
           <p:nvPr/>
         </p:nvSpPr>
@@ -12285,7 +12540,7 @@
       </p:sp>
       <p:sp>
         <p:nvSpPr>
-          <p:cNvPr id="30" name="TextBox 29"/>
+          <p:cNvPr id="33" name="TextBox 32"/>
           <p:cNvSpPr txBox="1"/>
           <p:nvPr/>
         </p:nvSpPr>
@@ -26250,6 +26505,1858 @@
                 <a:latin typeface="IBM Plex Sans"/>
               </a:rPr>
               <a:t>23</a:t>
+            </a:r>
+          </a:p>
+        </p:txBody>
+      </p:sp>
+    </p:spTree>
+  </p:cSld>
+  <p:clrMapOvr>
+    <a:masterClrMapping/>
+  </p:clrMapOvr>
+</p:sld>
+</file>
+
+<file path=ppt/slides/slide28.xml><?xml version="1.0" encoding="utf-8"?>
+<p:sld xmlns:a="http://schemas.openxmlformats.org/drawingml/2006/main" xmlns:p="http://schemas.openxmlformats.org/presentationml/2006/main" xmlns:r="http://schemas.openxmlformats.org/officeDocument/2006/relationships">
+  <p:cSld>
+    <p:bg>
+      <p:bgPr>
+        <a:solidFill>
+          <a:srgbClr val="EDF5FF"/>
+        </a:solidFill>
+        <a:effectLst/>
+      </p:bgPr>
+    </p:bg>
+    <p:spTree>
+      <p:nvGrpSpPr>
+        <p:cNvPr id="1" name=""/>
+        <p:cNvGrpSpPr/>
+        <p:nvPr/>
+      </p:nvGrpSpPr>
+      <p:grpSpPr/>
+      <p:sp>
+        <p:nvSpPr>
+          <p:cNvPr id="2" name="TextBox 1"/>
+          <p:cNvSpPr txBox="1"/>
+          <p:nvPr/>
+        </p:nvSpPr>
+        <p:spPr>
+          <a:xfrm>
+            <a:off x="658368" y="457200"/>
+            <a:ext cx="10874959" cy="274320"/>
+          </a:xfrm>
+          <a:prstGeom prst="rect">
+            <a:avLst/>
+          </a:prstGeom>
+          <a:noFill/>
+        </p:spPr>
+        <p:txBody>
+          <a:bodyPr wrap="square" anchor="t" lIns="0" rIns="0" tIns="0" bIns="0">
+            <a:spAutoFit/>
+          </a:bodyPr>
+          <a:lstStyle/>
+          <a:p>
+            <a:pPr algn="l">
+              <a:lnSpc>
+                <a:spcPct val="128000"/>
+              </a:lnSpc>
+              <a:spcAft>
+                <a:spcPts val="0"/>
+              </a:spcAft>
+            </a:pPr>
+            <a:r>
+              <a:rPr sz="1150" b="1" i="0" spc="190">
+                <a:solidFill>
+                  <a:srgbClr val="0F62FE"/>
+                </a:solidFill>
+                <a:latin typeface="IBM Plex Sans"/>
+              </a:rPr>
+              <a:t>BACKUP SLIDE</a:t>
+            </a:r>
+          </a:p>
+        </p:txBody>
+      </p:sp>
+      <p:sp>
+        <p:nvSpPr>
+          <p:cNvPr id="3" name="TextBox 2"/>
+          <p:cNvSpPr txBox="1"/>
+          <p:nvPr/>
+        </p:nvSpPr>
+        <p:spPr>
+          <a:xfrm>
+            <a:off x="658368" y="768096"/>
+            <a:ext cx="10509199" cy="914400"/>
+          </a:xfrm>
+          <a:prstGeom prst="rect">
+            <a:avLst/>
+          </a:prstGeom>
+          <a:noFill/>
+        </p:spPr>
+        <p:txBody>
+          <a:bodyPr wrap="square" anchor="t" lIns="0" rIns="0" tIns="0" bIns="0">
+            <a:spAutoFit/>
+          </a:bodyPr>
+          <a:lstStyle/>
+          <a:p>
+            <a:pPr algn="l">
+              <a:lnSpc>
+                <a:spcPct val="112000"/>
+              </a:lnSpc>
+              <a:spcAft>
+                <a:spcPts val="0"/>
+              </a:spcAft>
+            </a:pPr>
+            <a:r>
+              <a:rPr sz="3000" b="1" i="0">
+                <a:solidFill>
+                  <a:srgbClr val="161616"/>
+                </a:solidFill>
+                <a:latin typeface="IBM Plex Sans"/>
+              </a:rPr>
+              <a:t>What actually grew, and what the panel could not answer</a:t>
+            </a:r>
+          </a:p>
+        </p:txBody>
+      </p:sp>
+      <p:sp>
+        <p:nvSpPr>
+          <p:cNvPr id="4" name="TextBox 3"/>
+          <p:cNvSpPr txBox="1"/>
+          <p:nvPr/>
+        </p:nvSpPr>
+        <p:spPr>
+          <a:xfrm>
+            <a:off x="658368" y="1554480"/>
+            <a:ext cx="9777679" cy="548640"/>
+          </a:xfrm>
+          <a:prstGeom prst="rect">
+            <a:avLst/>
+          </a:prstGeom>
+          <a:noFill/>
+        </p:spPr>
+        <p:txBody>
+          <a:bodyPr wrap="square" anchor="t" lIns="0" rIns="0" tIns="0" bIns="0">
+            <a:spAutoFit/>
+          </a:bodyPr>
+          <a:lstStyle/>
+          <a:p>
+            <a:pPr algn="l">
+              <a:lnSpc>
+                <a:spcPct val="130000"/>
+              </a:lnSpc>
+              <a:spcAft>
+                <a:spcPts val="0"/>
+              </a:spcAft>
+            </a:pPr>
+            <a:r>
+              <a:rPr sz="1500" b="0" i="0">
+                <a:solidFill>
+                  <a:srgbClr val="525252"/>
+                </a:solidFill>
+                <a:latin typeface="IBM Plex Sans"/>
+              </a:rPr>
+              <a:t>The first three questions a clinician asks, computed by analysis/cohort_composition.py.</a:t>
+            </a:r>
+          </a:p>
+        </p:txBody>
+      </p:sp>
+      <p:sp>
+        <p:nvSpPr>
+          <p:cNvPr id="5" name="TextBox 4"/>
+          <p:cNvSpPr txBox="1"/>
+          <p:nvPr/>
+        </p:nvSpPr>
+        <p:spPr>
+          <a:xfrm>
+            <a:off x="658368" y="2377440"/>
+            <a:ext cx="2935260" cy="384048"/>
+          </a:xfrm>
+          <a:prstGeom prst="rect">
+            <a:avLst/>
+          </a:prstGeom>
+          <a:noFill/>
+        </p:spPr>
+        <p:txBody>
+          <a:bodyPr wrap="square" anchor="t" lIns="0" rIns="0" tIns="0" bIns="0">
+            <a:spAutoFit/>
+          </a:bodyPr>
+          <a:lstStyle/>
+          <a:p>
+            <a:pPr algn="l">
+              <a:lnSpc>
+                <a:spcPct val="115000"/>
+              </a:lnSpc>
+              <a:spcAft>
+                <a:spcPts val="0"/>
+              </a:spcAft>
+            </a:pPr>
+            <a:r>
+              <a:rPr sz="1000" b="1" i="0" spc="90">
+                <a:solidFill>
+                  <a:srgbClr val="525252"/>
+                </a:solidFill>
+                <a:latin typeface="IBM Plex Sans"/>
+              </a:rPr>
+              <a:t>ORGANISM</a:t>
+            </a:r>
+          </a:p>
+        </p:txBody>
+      </p:sp>
+      <p:sp>
+        <p:nvSpPr>
+          <p:cNvPr id="6" name="TextBox 5"/>
+          <p:cNvSpPr txBox="1"/>
+          <p:nvPr/>
+        </p:nvSpPr>
+        <p:spPr>
+          <a:xfrm>
+            <a:off x="3703356" y="2377440"/>
+            <a:ext cx="869018" cy="384048"/>
+          </a:xfrm>
+          <a:prstGeom prst="rect">
+            <a:avLst/>
+          </a:prstGeom>
+          <a:noFill/>
+        </p:spPr>
+        <p:txBody>
+          <a:bodyPr wrap="square" anchor="t" lIns="0" rIns="0" tIns="0" bIns="0">
+            <a:spAutoFit/>
+          </a:bodyPr>
+          <a:lstStyle/>
+          <a:p>
+            <a:pPr algn="l">
+              <a:lnSpc>
+                <a:spcPct val="115000"/>
+              </a:lnSpc>
+              <a:spcAft>
+                <a:spcPts val="0"/>
+              </a:spcAft>
+            </a:pPr>
+            <a:r>
+              <a:rPr sz="1000" b="1" i="0" spc="90">
+                <a:solidFill>
+                  <a:srgbClr val="525252"/>
+                </a:solidFill>
+                <a:latin typeface="IBM Plex Sans"/>
+              </a:rPr>
+              <a:t>CASES</a:t>
+            </a:r>
+          </a:p>
+        </p:txBody>
+      </p:sp>
+      <p:sp>
+        <p:nvSpPr>
+          <p:cNvPr id="7" name="TextBox 6"/>
+          <p:cNvSpPr txBox="1"/>
+          <p:nvPr/>
+        </p:nvSpPr>
+        <p:spPr>
+          <a:xfrm>
+            <a:off x="4682102" y="2377440"/>
+            <a:ext cx="1304016" cy="384048"/>
+          </a:xfrm>
+          <a:prstGeom prst="rect">
+            <a:avLst/>
+          </a:prstGeom>
+          <a:noFill/>
+        </p:spPr>
+        <p:txBody>
+          <a:bodyPr wrap="square" anchor="t" lIns="0" rIns="0" tIns="0" bIns="0">
+            <a:spAutoFit/>
+          </a:bodyPr>
+          <a:lstStyle/>
+          <a:p>
+            <a:pPr algn="l">
+              <a:lnSpc>
+                <a:spcPct val="115000"/>
+              </a:lnSpc>
+              <a:spcAft>
+                <a:spcPts val="0"/>
+              </a:spcAft>
+            </a:pPr>
+            <a:r>
+              <a:rPr sz="1000" b="1" i="0" spc="90">
+                <a:solidFill>
+                  <a:srgbClr val="525252"/>
+                </a:solidFill>
+                <a:latin typeface="IBM Plex Sans"/>
+              </a:rPr>
+              <a:t>GRAM</a:t>
+            </a:r>
+          </a:p>
+        </p:txBody>
+      </p:sp>
+      <p:sp>
+        <p:nvSpPr>
+          <p:cNvPr id="8" name="Rectangle 7"/>
+          <p:cNvSpPr/>
+          <p:nvPr/>
+        </p:nvSpPr>
+        <p:spPr>
+          <a:xfrm>
+            <a:off x="658368" y="2761488"/>
+            <a:ext cx="5437479" cy="10972"/>
+          </a:xfrm>
+          <a:prstGeom prst="rect">
+            <a:avLst/>
+          </a:prstGeom>
+          <a:solidFill>
+            <a:srgbClr val="161616"/>
+          </a:solidFill>
+          <a:ln>
+            <a:noFill/>
+          </a:ln>
+          <a:effectLst/>
+        </p:spPr>
+        <p:style>
+          <a:lnRef idx="1">
+            <a:schemeClr val="accent1"/>
+          </a:lnRef>
+          <a:fillRef idx="3">
+            <a:schemeClr val="accent1"/>
+          </a:fillRef>
+          <a:effectRef idx="2">
+            <a:schemeClr val="accent1"/>
+          </a:effectRef>
+          <a:fontRef idx="minor">
+            <a:schemeClr val="lt1"/>
+          </a:fontRef>
+        </p:style>
+        <p:txBody>
+          <a:bodyPr rtlCol="0" anchor="ctr"/>
+          <a:lstStyle/>
+          <a:p>
+            <a:pPr algn="ctr"/>
+          </a:p>
+        </p:txBody>
+      </p:sp>
+      <p:sp>
+        <p:nvSpPr>
+          <p:cNvPr id="9" name="TextBox 8"/>
+          <p:cNvSpPr txBox="1"/>
+          <p:nvPr/>
+        </p:nvSpPr>
+        <p:spPr>
+          <a:xfrm>
+            <a:off x="658368" y="2944368"/>
+            <a:ext cx="2935260" cy="347472"/>
+          </a:xfrm>
+          <a:prstGeom prst="rect">
+            <a:avLst/>
+          </a:prstGeom>
+          <a:noFill/>
+        </p:spPr>
+        <p:txBody>
+          <a:bodyPr wrap="square" anchor="t" lIns="0" rIns="0" tIns="0" bIns="0">
+            <a:spAutoFit/>
+          </a:bodyPr>
+          <a:lstStyle/>
+          <a:p>
+            <a:pPr algn="l">
+              <a:lnSpc>
+                <a:spcPct val="120000"/>
+              </a:lnSpc>
+              <a:spcAft>
+                <a:spcPts val="0"/>
+              </a:spcAft>
+            </a:pPr>
+            <a:r>
+              <a:rPr sz="1200" b="0" i="0">
+                <a:solidFill>
+                  <a:srgbClr val="161616"/>
+                </a:solidFill>
+                <a:latin typeface="IBM Plex Sans"/>
+              </a:rPr>
+              <a:t>Escherichia Coli</a:t>
+            </a:r>
+          </a:p>
+        </p:txBody>
+      </p:sp>
+      <p:sp>
+        <p:nvSpPr>
+          <p:cNvPr id="10" name="TextBox 9"/>
+          <p:cNvSpPr txBox="1"/>
+          <p:nvPr/>
+        </p:nvSpPr>
+        <p:spPr>
+          <a:xfrm>
+            <a:off x="3703356" y="2944368"/>
+            <a:ext cx="869018" cy="347472"/>
+          </a:xfrm>
+          <a:prstGeom prst="rect">
+            <a:avLst/>
+          </a:prstGeom>
+          <a:noFill/>
+        </p:spPr>
+        <p:txBody>
+          <a:bodyPr wrap="square" anchor="t" lIns="0" rIns="0" tIns="0" bIns="0">
+            <a:spAutoFit/>
+          </a:bodyPr>
+          <a:lstStyle/>
+          <a:p>
+            <a:pPr algn="l">
+              <a:lnSpc>
+                <a:spcPct val="120000"/>
+              </a:lnSpc>
+              <a:spcAft>
+                <a:spcPts val="0"/>
+              </a:spcAft>
+            </a:pPr>
+            <a:r>
+              <a:rPr sz="1200" b="0" i="0">
+                <a:solidFill>
+                  <a:srgbClr val="161616"/>
+                </a:solidFill>
+                <a:latin typeface="IBM Plex Sans"/>
+              </a:rPr>
+              <a:t>126</a:t>
+            </a:r>
+          </a:p>
+        </p:txBody>
+      </p:sp>
+      <p:sp>
+        <p:nvSpPr>
+          <p:cNvPr id="11" name="TextBox 10"/>
+          <p:cNvSpPr txBox="1"/>
+          <p:nvPr/>
+        </p:nvSpPr>
+        <p:spPr>
+          <a:xfrm>
+            <a:off x="4682102" y="2944368"/>
+            <a:ext cx="1304016" cy="347472"/>
+          </a:xfrm>
+          <a:prstGeom prst="rect">
+            <a:avLst/>
+          </a:prstGeom>
+          <a:noFill/>
+        </p:spPr>
+        <p:txBody>
+          <a:bodyPr wrap="square" anchor="t" lIns="0" rIns="0" tIns="0" bIns="0">
+            <a:spAutoFit/>
+          </a:bodyPr>
+          <a:lstStyle/>
+          <a:p>
+            <a:pPr algn="l">
+              <a:lnSpc>
+                <a:spcPct val="120000"/>
+              </a:lnSpc>
+              <a:spcAft>
+                <a:spcPts val="0"/>
+              </a:spcAft>
+            </a:pPr>
+            <a:r>
+              <a:rPr sz="1200" b="0" i="0">
+                <a:solidFill>
+                  <a:srgbClr val="161616"/>
+                </a:solidFill>
+                <a:latin typeface="IBM Plex Sans"/>
+              </a:rPr>
+              <a:t>Gram negative</a:t>
+            </a:r>
+          </a:p>
+        </p:txBody>
+      </p:sp>
+      <p:sp>
+        <p:nvSpPr>
+          <p:cNvPr id="12" name="Rectangle 11"/>
+          <p:cNvSpPr/>
+          <p:nvPr/>
+        </p:nvSpPr>
+        <p:spPr>
+          <a:xfrm>
+            <a:off x="658368" y="3218688"/>
+            <a:ext cx="5437479" cy="5486"/>
+          </a:xfrm>
+          <a:prstGeom prst="rect">
+            <a:avLst/>
+          </a:prstGeom>
+          <a:solidFill>
+            <a:srgbClr val="E0E0E0"/>
+          </a:solidFill>
+          <a:ln>
+            <a:noFill/>
+          </a:ln>
+          <a:effectLst/>
+        </p:spPr>
+        <p:style>
+          <a:lnRef idx="1">
+            <a:schemeClr val="accent1"/>
+          </a:lnRef>
+          <a:fillRef idx="3">
+            <a:schemeClr val="accent1"/>
+          </a:fillRef>
+          <a:effectRef idx="2">
+            <a:schemeClr val="accent1"/>
+          </a:effectRef>
+          <a:fontRef idx="minor">
+            <a:schemeClr val="lt1"/>
+          </a:fontRef>
+        </p:style>
+        <p:txBody>
+          <a:bodyPr rtlCol="0" anchor="ctr"/>
+          <a:lstStyle/>
+          <a:p>
+            <a:pPr algn="ctr"/>
+          </a:p>
+        </p:txBody>
+      </p:sp>
+      <p:sp>
+        <p:nvSpPr>
+          <p:cNvPr id="13" name="TextBox 12"/>
+          <p:cNvSpPr txBox="1"/>
+          <p:nvPr/>
+        </p:nvSpPr>
+        <p:spPr>
+          <a:xfrm>
+            <a:off x="658368" y="3291840"/>
+            <a:ext cx="2935260" cy="347472"/>
+          </a:xfrm>
+          <a:prstGeom prst="rect">
+            <a:avLst/>
+          </a:prstGeom>
+          <a:noFill/>
+        </p:spPr>
+        <p:txBody>
+          <a:bodyPr wrap="square" anchor="t" lIns="0" rIns="0" tIns="0" bIns="0">
+            <a:spAutoFit/>
+          </a:bodyPr>
+          <a:lstStyle/>
+          <a:p>
+            <a:pPr algn="l">
+              <a:lnSpc>
+                <a:spcPct val="120000"/>
+              </a:lnSpc>
+              <a:spcAft>
+                <a:spcPts val="0"/>
+              </a:spcAft>
+            </a:pPr>
+            <a:r>
+              <a:rPr sz="1200" b="0" i="0">
+                <a:solidFill>
+                  <a:srgbClr val="161616"/>
+                </a:solidFill>
+                <a:latin typeface="IBM Plex Sans"/>
+              </a:rPr>
+              <a:t>Klebsiella Pneumoniae</a:t>
+            </a:r>
+          </a:p>
+        </p:txBody>
+      </p:sp>
+      <p:sp>
+        <p:nvSpPr>
+          <p:cNvPr id="14" name="TextBox 13"/>
+          <p:cNvSpPr txBox="1"/>
+          <p:nvPr/>
+        </p:nvSpPr>
+        <p:spPr>
+          <a:xfrm>
+            <a:off x="3703356" y="3291840"/>
+            <a:ext cx="869018" cy="347472"/>
+          </a:xfrm>
+          <a:prstGeom prst="rect">
+            <a:avLst/>
+          </a:prstGeom>
+          <a:noFill/>
+        </p:spPr>
+        <p:txBody>
+          <a:bodyPr wrap="square" anchor="t" lIns="0" rIns="0" tIns="0" bIns="0">
+            <a:spAutoFit/>
+          </a:bodyPr>
+          <a:lstStyle/>
+          <a:p>
+            <a:pPr algn="l">
+              <a:lnSpc>
+                <a:spcPct val="120000"/>
+              </a:lnSpc>
+              <a:spcAft>
+                <a:spcPts val="0"/>
+              </a:spcAft>
+            </a:pPr>
+            <a:r>
+              <a:rPr sz="1200" b="0" i="0">
+                <a:solidFill>
+                  <a:srgbClr val="161616"/>
+                </a:solidFill>
+                <a:latin typeface="IBM Plex Sans"/>
+              </a:rPr>
+              <a:t>29</a:t>
+            </a:r>
+          </a:p>
+        </p:txBody>
+      </p:sp>
+      <p:sp>
+        <p:nvSpPr>
+          <p:cNvPr id="15" name="TextBox 14"/>
+          <p:cNvSpPr txBox="1"/>
+          <p:nvPr/>
+        </p:nvSpPr>
+        <p:spPr>
+          <a:xfrm>
+            <a:off x="4682102" y="3291840"/>
+            <a:ext cx="1304016" cy="347472"/>
+          </a:xfrm>
+          <a:prstGeom prst="rect">
+            <a:avLst/>
+          </a:prstGeom>
+          <a:noFill/>
+        </p:spPr>
+        <p:txBody>
+          <a:bodyPr wrap="square" anchor="t" lIns="0" rIns="0" tIns="0" bIns="0">
+            <a:spAutoFit/>
+          </a:bodyPr>
+          <a:lstStyle/>
+          <a:p>
+            <a:pPr algn="l">
+              <a:lnSpc>
+                <a:spcPct val="120000"/>
+              </a:lnSpc>
+              <a:spcAft>
+                <a:spcPts val="0"/>
+              </a:spcAft>
+            </a:pPr>
+            <a:r>
+              <a:rPr sz="1200" b="0" i="0">
+                <a:solidFill>
+                  <a:srgbClr val="161616"/>
+                </a:solidFill>
+                <a:latin typeface="IBM Plex Sans"/>
+              </a:rPr>
+              <a:t>Gram negative</a:t>
+            </a:r>
+          </a:p>
+        </p:txBody>
+      </p:sp>
+      <p:sp>
+        <p:nvSpPr>
+          <p:cNvPr id="16" name="Rectangle 15"/>
+          <p:cNvSpPr/>
+          <p:nvPr/>
+        </p:nvSpPr>
+        <p:spPr>
+          <a:xfrm>
+            <a:off x="658368" y="3566160"/>
+            <a:ext cx="5437479" cy="5486"/>
+          </a:xfrm>
+          <a:prstGeom prst="rect">
+            <a:avLst/>
+          </a:prstGeom>
+          <a:solidFill>
+            <a:srgbClr val="E0E0E0"/>
+          </a:solidFill>
+          <a:ln>
+            <a:noFill/>
+          </a:ln>
+          <a:effectLst/>
+        </p:spPr>
+        <p:style>
+          <a:lnRef idx="1">
+            <a:schemeClr val="accent1"/>
+          </a:lnRef>
+          <a:fillRef idx="3">
+            <a:schemeClr val="accent1"/>
+          </a:fillRef>
+          <a:effectRef idx="2">
+            <a:schemeClr val="accent1"/>
+          </a:effectRef>
+          <a:fontRef idx="minor">
+            <a:schemeClr val="lt1"/>
+          </a:fontRef>
+        </p:style>
+        <p:txBody>
+          <a:bodyPr rtlCol="0" anchor="ctr"/>
+          <a:lstStyle/>
+          <a:p>
+            <a:pPr algn="ctr"/>
+          </a:p>
+        </p:txBody>
+      </p:sp>
+      <p:sp>
+        <p:nvSpPr>
+          <p:cNvPr id="17" name="TextBox 16"/>
+          <p:cNvSpPr txBox="1"/>
+          <p:nvPr/>
+        </p:nvSpPr>
+        <p:spPr>
+          <a:xfrm>
+            <a:off x="658368" y="3639312"/>
+            <a:ext cx="2935260" cy="347472"/>
+          </a:xfrm>
+          <a:prstGeom prst="rect">
+            <a:avLst/>
+          </a:prstGeom>
+          <a:noFill/>
+        </p:spPr>
+        <p:txBody>
+          <a:bodyPr wrap="square" anchor="t" lIns="0" rIns="0" tIns="0" bIns="0">
+            <a:spAutoFit/>
+          </a:bodyPr>
+          <a:lstStyle/>
+          <a:p>
+            <a:pPr algn="l">
+              <a:lnSpc>
+                <a:spcPct val="120000"/>
+              </a:lnSpc>
+              <a:spcAft>
+                <a:spcPts val="0"/>
+              </a:spcAft>
+            </a:pPr>
+            <a:r>
+              <a:rPr sz="1200" b="0" i="0">
+                <a:solidFill>
+                  <a:srgbClr val="161616"/>
+                </a:solidFill>
+                <a:latin typeface="IBM Plex Sans"/>
+              </a:rPr>
+              <a:t>Serratia Marcescens</a:t>
+            </a:r>
+          </a:p>
+        </p:txBody>
+      </p:sp>
+      <p:sp>
+        <p:nvSpPr>
+          <p:cNvPr id="18" name="TextBox 17"/>
+          <p:cNvSpPr txBox="1"/>
+          <p:nvPr/>
+        </p:nvSpPr>
+        <p:spPr>
+          <a:xfrm>
+            <a:off x="3703356" y="3639312"/>
+            <a:ext cx="869018" cy="347472"/>
+          </a:xfrm>
+          <a:prstGeom prst="rect">
+            <a:avLst/>
+          </a:prstGeom>
+          <a:noFill/>
+        </p:spPr>
+        <p:txBody>
+          <a:bodyPr wrap="square" anchor="t" lIns="0" rIns="0" tIns="0" bIns="0">
+            <a:spAutoFit/>
+          </a:bodyPr>
+          <a:lstStyle/>
+          <a:p>
+            <a:pPr algn="l">
+              <a:lnSpc>
+                <a:spcPct val="120000"/>
+              </a:lnSpc>
+              <a:spcAft>
+                <a:spcPts val="0"/>
+              </a:spcAft>
+            </a:pPr>
+            <a:r>
+              <a:rPr sz="1200" b="0" i="0">
+                <a:solidFill>
+                  <a:srgbClr val="161616"/>
+                </a:solidFill>
+                <a:latin typeface="IBM Plex Sans"/>
+              </a:rPr>
+              <a:t>14</a:t>
+            </a:r>
+          </a:p>
+        </p:txBody>
+      </p:sp>
+      <p:sp>
+        <p:nvSpPr>
+          <p:cNvPr id="19" name="TextBox 18"/>
+          <p:cNvSpPr txBox="1"/>
+          <p:nvPr/>
+        </p:nvSpPr>
+        <p:spPr>
+          <a:xfrm>
+            <a:off x="4682102" y="3639312"/>
+            <a:ext cx="1304016" cy="347472"/>
+          </a:xfrm>
+          <a:prstGeom prst="rect">
+            <a:avLst/>
+          </a:prstGeom>
+          <a:noFill/>
+        </p:spPr>
+        <p:txBody>
+          <a:bodyPr wrap="square" anchor="t" lIns="0" rIns="0" tIns="0" bIns="0">
+            <a:spAutoFit/>
+          </a:bodyPr>
+          <a:lstStyle/>
+          <a:p>
+            <a:pPr algn="l">
+              <a:lnSpc>
+                <a:spcPct val="120000"/>
+              </a:lnSpc>
+              <a:spcAft>
+                <a:spcPts val="0"/>
+              </a:spcAft>
+            </a:pPr>
+            <a:r>
+              <a:rPr sz="1200" b="0" i="0">
+                <a:solidFill>
+                  <a:srgbClr val="161616"/>
+                </a:solidFill>
+                <a:latin typeface="IBM Plex Sans"/>
+              </a:rPr>
+              <a:t>Gram negative</a:t>
+            </a:r>
+          </a:p>
+        </p:txBody>
+      </p:sp>
+      <p:sp>
+        <p:nvSpPr>
+          <p:cNvPr id="20" name="Rectangle 19"/>
+          <p:cNvSpPr/>
+          <p:nvPr/>
+        </p:nvSpPr>
+        <p:spPr>
+          <a:xfrm>
+            <a:off x="658368" y="3913632"/>
+            <a:ext cx="5437479" cy="5486"/>
+          </a:xfrm>
+          <a:prstGeom prst="rect">
+            <a:avLst/>
+          </a:prstGeom>
+          <a:solidFill>
+            <a:srgbClr val="E0E0E0"/>
+          </a:solidFill>
+          <a:ln>
+            <a:noFill/>
+          </a:ln>
+          <a:effectLst/>
+        </p:spPr>
+        <p:style>
+          <a:lnRef idx="1">
+            <a:schemeClr val="accent1"/>
+          </a:lnRef>
+          <a:fillRef idx="3">
+            <a:schemeClr val="accent1"/>
+          </a:fillRef>
+          <a:effectRef idx="2">
+            <a:schemeClr val="accent1"/>
+          </a:effectRef>
+          <a:fontRef idx="minor">
+            <a:schemeClr val="lt1"/>
+          </a:fontRef>
+        </p:style>
+        <p:txBody>
+          <a:bodyPr rtlCol="0" anchor="ctr"/>
+          <a:lstStyle/>
+          <a:p>
+            <a:pPr algn="ctr"/>
+          </a:p>
+        </p:txBody>
+      </p:sp>
+      <p:sp>
+        <p:nvSpPr>
+          <p:cNvPr id="21" name="TextBox 20"/>
+          <p:cNvSpPr txBox="1"/>
+          <p:nvPr/>
+        </p:nvSpPr>
+        <p:spPr>
+          <a:xfrm>
+            <a:off x="658368" y="3986783"/>
+            <a:ext cx="2935260" cy="347472"/>
+          </a:xfrm>
+          <a:prstGeom prst="rect">
+            <a:avLst/>
+          </a:prstGeom>
+          <a:noFill/>
+        </p:spPr>
+        <p:txBody>
+          <a:bodyPr wrap="square" anchor="t" lIns="0" rIns="0" tIns="0" bIns="0">
+            <a:spAutoFit/>
+          </a:bodyPr>
+          <a:lstStyle/>
+          <a:p>
+            <a:pPr algn="l">
+              <a:lnSpc>
+                <a:spcPct val="120000"/>
+              </a:lnSpc>
+              <a:spcAft>
+                <a:spcPts val="0"/>
+              </a:spcAft>
+            </a:pPr>
+            <a:r>
+              <a:rPr sz="1200" b="0" i="0">
+                <a:solidFill>
+                  <a:srgbClr val="161616"/>
+                </a:solidFill>
+                <a:latin typeface="IBM Plex Sans"/>
+              </a:rPr>
+              <a:t>Klebsiella Oxytoca</a:t>
+            </a:r>
+          </a:p>
+        </p:txBody>
+      </p:sp>
+      <p:sp>
+        <p:nvSpPr>
+          <p:cNvPr id="22" name="TextBox 21"/>
+          <p:cNvSpPr txBox="1"/>
+          <p:nvPr/>
+        </p:nvSpPr>
+        <p:spPr>
+          <a:xfrm>
+            <a:off x="3703356" y="3986783"/>
+            <a:ext cx="869018" cy="347472"/>
+          </a:xfrm>
+          <a:prstGeom prst="rect">
+            <a:avLst/>
+          </a:prstGeom>
+          <a:noFill/>
+        </p:spPr>
+        <p:txBody>
+          <a:bodyPr wrap="square" anchor="t" lIns="0" rIns="0" tIns="0" bIns="0">
+            <a:spAutoFit/>
+          </a:bodyPr>
+          <a:lstStyle/>
+          <a:p>
+            <a:pPr algn="l">
+              <a:lnSpc>
+                <a:spcPct val="120000"/>
+              </a:lnSpc>
+              <a:spcAft>
+                <a:spcPts val="0"/>
+              </a:spcAft>
+            </a:pPr>
+            <a:r>
+              <a:rPr sz="1200" b="0" i="0">
+                <a:solidFill>
+                  <a:srgbClr val="161616"/>
+                </a:solidFill>
+                <a:latin typeface="IBM Plex Sans"/>
+              </a:rPr>
+              <a:t>6</a:t>
+            </a:r>
+          </a:p>
+        </p:txBody>
+      </p:sp>
+      <p:sp>
+        <p:nvSpPr>
+          <p:cNvPr id="23" name="TextBox 22"/>
+          <p:cNvSpPr txBox="1"/>
+          <p:nvPr/>
+        </p:nvSpPr>
+        <p:spPr>
+          <a:xfrm>
+            <a:off x="4682102" y="3986783"/>
+            <a:ext cx="1304016" cy="347472"/>
+          </a:xfrm>
+          <a:prstGeom prst="rect">
+            <a:avLst/>
+          </a:prstGeom>
+          <a:noFill/>
+        </p:spPr>
+        <p:txBody>
+          <a:bodyPr wrap="square" anchor="t" lIns="0" rIns="0" tIns="0" bIns="0">
+            <a:spAutoFit/>
+          </a:bodyPr>
+          <a:lstStyle/>
+          <a:p>
+            <a:pPr algn="l">
+              <a:lnSpc>
+                <a:spcPct val="120000"/>
+              </a:lnSpc>
+              <a:spcAft>
+                <a:spcPts val="0"/>
+              </a:spcAft>
+            </a:pPr>
+            <a:r>
+              <a:rPr sz="1200" b="0" i="0">
+                <a:solidFill>
+                  <a:srgbClr val="161616"/>
+                </a:solidFill>
+                <a:latin typeface="IBM Plex Sans"/>
+              </a:rPr>
+              <a:t>Gram negative</a:t>
+            </a:r>
+          </a:p>
+        </p:txBody>
+      </p:sp>
+      <p:sp>
+        <p:nvSpPr>
+          <p:cNvPr id="24" name="Rectangle 23"/>
+          <p:cNvSpPr/>
+          <p:nvPr/>
+        </p:nvSpPr>
+        <p:spPr>
+          <a:xfrm>
+            <a:off x="658368" y="4261104"/>
+            <a:ext cx="5437479" cy="5486"/>
+          </a:xfrm>
+          <a:prstGeom prst="rect">
+            <a:avLst/>
+          </a:prstGeom>
+          <a:solidFill>
+            <a:srgbClr val="E0E0E0"/>
+          </a:solidFill>
+          <a:ln>
+            <a:noFill/>
+          </a:ln>
+          <a:effectLst/>
+        </p:spPr>
+        <p:style>
+          <a:lnRef idx="1">
+            <a:schemeClr val="accent1"/>
+          </a:lnRef>
+          <a:fillRef idx="3">
+            <a:schemeClr val="accent1"/>
+          </a:fillRef>
+          <a:effectRef idx="2">
+            <a:schemeClr val="accent1"/>
+          </a:effectRef>
+          <a:fontRef idx="minor">
+            <a:schemeClr val="lt1"/>
+          </a:fontRef>
+        </p:style>
+        <p:txBody>
+          <a:bodyPr rtlCol="0" anchor="ctr"/>
+          <a:lstStyle/>
+          <a:p>
+            <a:pPr algn="ctr"/>
+          </a:p>
+        </p:txBody>
+      </p:sp>
+      <p:sp>
+        <p:nvSpPr>
+          <p:cNvPr id="25" name="TextBox 24"/>
+          <p:cNvSpPr txBox="1"/>
+          <p:nvPr/>
+        </p:nvSpPr>
+        <p:spPr>
+          <a:xfrm>
+            <a:off x="658368" y="4334255"/>
+            <a:ext cx="2935260" cy="347472"/>
+          </a:xfrm>
+          <a:prstGeom prst="rect">
+            <a:avLst/>
+          </a:prstGeom>
+          <a:noFill/>
+        </p:spPr>
+        <p:txBody>
+          <a:bodyPr wrap="square" anchor="t" lIns="0" rIns="0" tIns="0" bIns="0">
+            <a:spAutoFit/>
+          </a:bodyPr>
+          <a:lstStyle/>
+          <a:p>
+            <a:pPr algn="l">
+              <a:lnSpc>
+                <a:spcPct val="120000"/>
+              </a:lnSpc>
+              <a:spcAft>
+                <a:spcPts val="0"/>
+              </a:spcAft>
+            </a:pPr>
+            <a:r>
+              <a:rPr sz="1200" b="0" i="0">
+                <a:solidFill>
+                  <a:srgbClr val="161616"/>
+                </a:solidFill>
+                <a:latin typeface="IBM Plex Sans"/>
+              </a:rPr>
+              <a:t>Enterobacter Cloacae Complex</a:t>
+            </a:r>
+          </a:p>
+        </p:txBody>
+      </p:sp>
+      <p:sp>
+        <p:nvSpPr>
+          <p:cNvPr id="26" name="TextBox 25"/>
+          <p:cNvSpPr txBox="1"/>
+          <p:nvPr/>
+        </p:nvSpPr>
+        <p:spPr>
+          <a:xfrm>
+            <a:off x="3703356" y="4334255"/>
+            <a:ext cx="869018" cy="347472"/>
+          </a:xfrm>
+          <a:prstGeom prst="rect">
+            <a:avLst/>
+          </a:prstGeom>
+          <a:noFill/>
+        </p:spPr>
+        <p:txBody>
+          <a:bodyPr wrap="square" anchor="t" lIns="0" rIns="0" tIns="0" bIns="0">
+            <a:spAutoFit/>
+          </a:bodyPr>
+          <a:lstStyle/>
+          <a:p>
+            <a:pPr algn="l">
+              <a:lnSpc>
+                <a:spcPct val="120000"/>
+              </a:lnSpc>
+              <a:spcAft>
+                <a:spcPts val="0"/>
+              </a:spcAft>
+            </a:pPr>
+            <a:r>
+              <a:rPr sz="1200" b="0" i="0">
+                <a:solidFill>
+                  <a:srgbClr val="161616"/>
+                </a:solidFill>
+                <a:latin typeface="IBM Plex Sans"/>
+              </a:rPr>
+              <a:t>6</a:t>
+            </a:r>
+          </a:p>
+        </p:txBody>
+      </p:sp>
+      <p:sp>
+        <p:nvSpPr>
+          <p:cNvPr id="27" name="TextBox 26"/>
+          <p:cNvSpPr txBox="1"/>
+          <p:nvPr/>
+        </p:nvSpPr>
+        <p:spPr>
+          <a:xfrm>
+            <a:off x="4682102" y="4334255"/>
+            <a:ext cx="1304016" cy="347472"/>
+          </a:xfrm>
+          <a:prstGeom prst="rect">
+            <a:avLst/>
+          </a:prstGeom>
+          <a:noFill/>
+        </p:spPr>
+        <p:txBody>
+          <a:bodyPr wrap="square" anchor="t" lIns="0" rIns="0" tIns="0" bIns="0">
+            <a:spAutoFit/>
+          </a:bodyPr>
+          <a:lstStyle/>
+          <a:p>
+            <a:pPr algn="l">
+              <a:lnSpc>
+                <a:spcPct val="120000"/>
+              </a:lnSpc>
+              <a:spcAft>
+                <a:spcPts val="0"/>
+              </a:spcAft>
+            </a:pPr>
+            <a:r>
+              <a:rPr sz="1200" b="0" i="0">
+                <a:solidFill>
+                  <a:srgbClr val="161616"/>
+                </a:solidFill>
+                <a:latin typeface="IBM Plex Sans"/>
+              </a:rPr>
+              <a:t>Gram negative</a:t>
+            </a:r>
+          </a:p>
+        </p:txBody>
+      </p:sp>
+      <p:sp>
+        <p:nvSpPr>
+          <p:cNvPr id="28" name="Rectangle 27"/>
+          <p:cNvSpPr/>
+          <p:nvPr/>
+        </p:nvSpPr>
+        <p:spPr>
+          <a:xfrm>
+            <a:off x="658368" y="4608576"/>
+            <a:ext cx="5437479" cy="5486"/>
+          </a:xfrm>
+          <a:prstGeom prst="rect">
+            <a:avLst/>
+          </a:prstGeom>
+          <a:solidFill>
+            <a:srgbClr val="E0E0E0"/>
+          </a:solidFill>
+          <a:ln>
+            <a:noFill/>
+          </a:ln>
+          <a:effectLst/>
+        </p:spPr>
+        <p:style>
+          <a:lnRef idx="1">
+            <a:schemeClr val="accent1"/>
+          </a:lnRef>
+          <a:fillRef idx="3">
+            <a:schemeClr val="accent1"/>
+          </a:fillRef>
+          <a:effectRef idx="2">
+            <a:schemeClr val="accent1"/>
+          </a:effectRef>
+          <a:fontRef idx="minor">
+            <a:schemeClr val="lt1"/>
+          </a:fontRef>
+        </p:style>
+        <p:txBody>
+          <a:bodyPr rtlCol="0" anchor="ctr"/>
+          <a:lstStyle/>
+          <a:p>
+            <a:pPr algn="ctr"/>
+          </a:p>
+        </p:txBody>
+      </p:sp>
+      <p:sp>
+        <p:nvSpPr>
+          <p:cNvPr id="29" name="TextBox 28"/>
+          <p:cNvSpPr txBox="1"/>
+          <p:nvPr/>
+        </p:nvSpPr>
+        <p:spPr>
+          <a:xfrm>
+            <a:off x="658368" y="4681727"/>
+            <a:ext cx="2935260" cy="347472"/>
+          </a:xfrm>
+          <a:prstGeom prst="rect">
+            <a:avLst/>
+          </a:prstGeom>
+          <a:noFill/>
+        </p:spPr>
+        <p:txBody>
+          <a:bodyPr wrap="square" anchor="t" lIns="0" rIns="0" tIns="0" bIns="0">
+            <a:spAutoFit/>
+          </a:bodyPr>
+          <a:lstStyle/>
+          <a:p>
+            <a:pPr algn="l">
+              <a:lnSpc>
+                <a:spcPct val="120000"/>
+              </a:lnSpc>
+              <a:spcAft>
+                <a:spcPts val="0"/>
+              </a:spcAft>
+            </a:pPr>
+            <a:r>
+              <a:rPr sz="1200" b="0" i="0">
+                <a:solidFill>
+                  <a:srgbClr val="161616"/>
+                </a:solidFill>
+                <a:latin typeface="IBM Plex Sans"/>
+              </a:rPr>
+              <a:t>Enterobacter Aerogenes</a:t>
+            </a:r>
+          </a:p>
+        </p:txBody>
+      </p:sp>
+      <p:sp>
+        <p:nvSpPr>
+          <p:cNvPr id="30" name="TextBox 29"/>
+          <p:cNvSpPr txBox="1"/>
+          <p:nvPr/>
+        </p:nvSpPr>
+        <p:spPr>
+          <a:xfrm>
+            <a:off x="3703356" y="4681727"/>
+            <a:ext cx="869018" cy="347472"/>
+          </a:xfrm>
+          <a:prstGeom prst="rect">
+            <a:avLst/>
+          </a:prstGeom>
+          <a:noFill/>
+        </p:spPr>
+        <p:txBody>
+          <a:bodyPr wrap="square" anchor="t" lIns="0" rIns="0" tIns="0" bIns="0">
+            <a:spAutoFit/>
+          </a:bodyPr>
+          <a:lstStyle/>
+          <a:p>
+            <a:pPr algn="l">
+              <a:lnSpc>
+                <a:spcPct val="120000"/>
+              </a:lnSpc>
+              <a:spcAft>
+                <a:spcPts val="0"/>
+              </a:spcAft>
+            </a:pPr>
+            <a:r>
+              <a:rPr sz="1200" b="0" i="0">
+                <a:solidFill>
+                  <a:srgbClr val="161616"/>
+                </a:solidFill>
+                <a:latin typeface="IBM Plex Sans"/>
+              </a:rPr>
+              <a:t>6</a:t>
+            </a:r>
+          </a:p>
+        </p:txBody>
+      </p:sp>
+      <p:sp>
+        <p:nvSpPr>
+          <p:cNvPr id="31" name="TextBox 30"/>
+          <p:cNvSpPr txBox="1"/>
+          <p:nvPr/>
+        </p:nvSpPr>
+        <p:spPr>
+          <a:xfrm>
+            <a:off x="4682102" y="4681727"/>
+            <a:ext cx="1304016" cy="347472"/>
+          </a:xfrm>
+          <a:prstGeom prst="rect">
+            <a:avLst/>
+          </a:prstGeom>
+          <a:noFill/>
+        </p:spPr>
+        <p:txBody>
+          <a:bodyPr wrap="square" anchor="t" lIns="0" rIns="0" tIns="0" bIns="0">
+            <a:spAutoFit/>
+          </a:bodyPr>
+          <a:lstStyle/>
+          <a:p>
+            <a:pPr algn="l">
+              <a:lnSpc>
+                <a:spcPct val="120000"/>
+              </a:lnSpc>
+              <a:spcAft>
+                <a:spcPts val="0"/>
+              </a:spcAft>
+            </a:pPr>
+            <a:r>
+              <a:rPr sz="1200" b="0" i="0">
+                <a:solidFill>
+                  <a:srgbClr val="161616"/>
+                </a:solidFill>
+                <a:latin typeface="IBM Plex Sans"/>
+              </a:rPr>
+              <a:t>Gram negative</a:t>
+            </a:r>
+          </a:p>
+        </p:txBody>
+      </p:sp>
+      <p:sp>
+        <p:nvSpPr>
+          <p:cNvPr id="32" name="TextBox 31"/>
+          <p:cNvSpPr txBox="1"/>
+          <p:nvPr/>
+        </p:nvSpPr>
+        <p:spPr>
+          <a:xfrm>
+            <a:off x="658368" y="4956048"/>
+            <a:ext cx="5437479" cy="548640"/>
+          </a:xfrm>
+          <a:prstGeom prst="rect">
+            <a:avLst/>
+          </a:prstGeom>
+          <a:noFill/>
+        </p:spPr>
+        <p:txBody>
+          <a:bodyPr wrap="square" anchor="t" lIns="0" rIns="0" tIns="0" bIns="0">
+            <a:spAutoFit/>
+          </a:bodyPr>
+          <a:lstStyle/>
+          <a:p>
+            <a:pPr algn="l">
+              <a:lnSpc>
+                <a:spcPct val="130000"/>
+              </a:lnSpc>
+              <a:spcAft>
+                <a:spcPts val="0"/>
+              </a:spcAft>
+            </a:pPr>
+            <a:r>
+              <a:rPr sz="1150" b="0" i="0">
+                <a:solidFill>
+                  <a:srgbClr val="525252"/>
+                </a:solidFill>
+                <a:latin typeface="IBM Plex Sans"/>
+              </a:rPr>
+              <a:t>20 distinct organisms across 200 cases. Every case is Gram negative, which is a property of the frame rather than of the sample.</a:t>
+            </a:r>
+          </a:p>
+        </p:txBody>
+      </p:sp>
+      <p:sp>
+        <p:nvSpPr>
+          <p:cNvPr id="33" name="Rectangle 32"/>
+          <p:cNvSpPr/>
+          <p:nvPr/>
+        </p:nvSpPr>
+        <p:spPr>
+          <a:xfrm>
+            <a:off x="6530845" y="2377440"/>
+            <a:ext cx="5002481" cy="16459"/>
+          </a:xfrm>
+          <a:prstGeom prst="rect">
+            <a:avLst/>
+          </a:prstGeom>
+          <a:solidFill>
+            <a:srgbClr val="0F62FE"/>
+          </a:solidFill>
+          <a:ln>
+            <a:noFill/>
+          </a:ln>
+          <a:effectLst/>
+        </p:spPr>
+        <p:style>
+          <a:lnRef idx="1">
+            <a:schemeClr val="accent1"/>
+          </a:lnRef>
+          <a:fillRef idx="3">
+            <a:schemeClr val="accent1"/>
+          </a:fillRef>
+          <a:effectRef idx="2">
+            <a:schemeClr val="accent1"/>
+          </a:effectRef>
+          <a:fontRef idx="minor">
+            <a:schemeClr val="lt1"/>
+          </a:fontRef>
+        </p:style>
+        <p:txBody>
+          <a:bodyPr rtlCol="0" anchor="ctr"/>
+          <a:lstStyle/>
+          <a:p>
+            <a:pPr algn="ctr"/>
+          </a:p>
+        </p:txBody>
+      </p:sp>
+      <p:sp>
+        <p:nvSpPr>
+          <p:cNvPr id="34" name="TextBox 33"/>
+          <p:cNvSpPr txBox="1"/>
+          <p:nvPr/>
+        </p:nvSpPr>
+        <p:spPr>
+          <a:xfrm>
+            <a:off x="6530845" y="2523744"/>
+            <a:ext cx="5002481" cy="320040"/>
+          </a:xfrm>
+          <a:prstGeom prst="rect">
+            <a:avLst/>
+          </a:prstGeom>
+          <a:noFill/>
+        </p:spPr>
+        <p:txBody>
+          <a:bodyPr wrap="square" anchor="t" lIns="0" rIns="0" tIns="0" bIns="0">
+            <a:spAutoFit/>
+          </a:bodyPr>
+          <a:lstStyle/>
+          <a:p>
+            <a:pPr algn="l">
+              <a:lnSpc>
+                <a:spcPct val="115000"/>
+              </a:lnSpc>
+              <a:spcAft>
+                <a:spcPts val="0"/>
+              </a:spcAft>
+            </a:pPr>
+            <a:r>
+              <a:rPr sz="1350" b="1" i="0">
+                <a:solidFill>
+                  <a:srgbClr val="161616"/>
+                </a:solidFill>
+                <a:latin typeface="IBM Plex Sans"/>
+              </a:rPr>
+              <a:t>Intermediate is its own class</a:t>
+            </a:r>
+          </a:p>
+        </p:txBody>
+      </p:sp>
+      <p:sp>
+        <p:nvSpPr>
+          <p:cNvPr id="35" name="TextBox 34"/>
+          <p:cNvSpPr txBox="1"/>
+          <p:nvPr/>
+        </p:nvSpPr>
+        <p:spPr>
+          <a:xfrm>
+            <a:off x="6530845" y="2852928"/>
+            <a:ext cx="5002481" cy="822960"/>
+          </a:xfrm>
+          <a:prstGeom prst="rect">
+            <a:avLst/>
+          </a:prstGeom>
+          <a:noFill/>
+        </p:spPr>
+        <p:txBody>
+          <a:bodyPr wrap="square" anchor="t" lIns="0" rIns="0" tIns="0" bIns="0">
+            <a:spAutoFit/>
+          </a:bodyPr>
+          <a:lstStyle/>
+          <a:p>
+            <a:pPr algn="l">
+              <a:lnSpc>
+                <a:spcPct val="130000"/>
+              </a:lnSpc>
+              <a:spcAft>
+                <a:spcPts val="0"/>
+              </a:spcAft>
+            </a:pPr>
+            <a:r>
+              <a:rPr sz="1100" b="0" i="0">
+                <a:solidFill>
+                  <a:srgbClr val="525252"/>
+                </a:solidFill>
+                <a:latin typeface="IBM Plex Sans"/>
+              </a:rPr>
+              <a:t>The panel returns S, I and R. 73 of 2472 verdict rows are Intermediate, 3.0%. It is neither covering nor failing: the case scores INTERMEDIATE_ONLY and leaves the adequacy numerator and the paired test rather than being folded either way.</a:t>
+            </a:r>
+          </a:p>
+        </p:txBody>
+      </p:sp>
+      <p:sp>
+        <p:nvSpPr>
+          <p:cNvPr id="36" name="Rectangle 35"/>
+          <p:cNvSpPr/>
+          <p:nvPr/>
+        </p:nvSpPr>
+        <p:spPr>
+          <a:xfrm>
+            <a:off x="6530845" y="3675887"/>
+            <a:ext cx="5002481" cy="16459"/>
+          </a:xfrm>
+          <a:prstGeom prst="rect">
+            <a:avLst/>
+          </a:prstGeom>
+          <a:solidFill>
+            <a:srgbClr val="0F62FE"/>
+          </a:solidFill>
+          <a:ln>
+            <a:noFill/>
+          </a:ln>
+          <a:effectLst/>
+        </p:spPr>
+        <p:style>
+          <a:lnRef idx="1">
+            <a:schemeClr val="accent1"/>
+          </a:lnRef>
+          <a:fillRef idx="3">
+            <a:schemeClr val="accent1"/>
+          </a:fillRef>
+          <a:effectRef idx="2">
+            <a:schemeClr val="accent1"/>
+          </a:effectRef>
+          <a:fontRef idx="minor">
+            <a:schemeClr val="lt1"/>
+          </a:fontRef>
+        </p:style>
+        <p:txBody>
+          <a:bodyPr rtlCol="0" anchor="ctr"/>
+          <a:lstStyle/>
+          <a:p>
+            <a:pPr algn="ctr"/>
+          </a:p>
+        </p:txBody>
+      </p:sp>
+      <p:sp>
+        <p:nvSpPr>
+          <p:cNvPr id="37" name="TextBox 36"/>
+          <p:cNvSpPr txBox="1"/>
+          <p:nvPr/>
+        </p:nvSpPr>
+        <p:spPr>
+          <a:xfrm>
+            <a:off x="6530845" y="3822191"/>
+            <a:ext cx="5002481" cy="320040"/>
+          </a:xfrm>
+          <a:prstGeom prst="rect">
+            <a:avLst/>
+          </a:prstGeom>
+          <a:noFill/>
+        </p:spPr>
+        <p:txBody>
+          <a:bodyPr wrap="square" anchor="t" lIns="0" rIns="0" tIns="0" bIns="0">
+            <a:spAutoFit/>
+          </a:bodyPr>
+          <a:lstStyle/>
+          <a:p>
+            <a:pPr algn="l">
+              <a:lnSpc>
+                <a:spcPct val="115000"/>
+              </a:lnSpc>
+              <a:spcAft>
+                <a:spcPts val="0"/>
+              </a:spcAft>
+            </a:pPr>
+            <a:r>
+              <a:rPr sz="1350" b="1" i="0">
+                <a:solidFill>
+                  <a:srgbClr val="161616"/>
+                </a:solidFill>
+                <a:latin typeface="IBM Plex Sans"/>
+              </a:rPr>
+              <a:t>Two fifths of pairs cannot be scored</a:t>
+            </a:r>
+          </a:p>
+        </p:txBody>
+      </p:sp>
+      <p:sp>
+        <p:nvSpPr>
+          <p:cNvPr id="38" name="TextBox 37"/>
+          <p:cNvSpPr txBox="1"/>
+          <p:nvPr/>
+        </p:nvSpPr>
+        <p:spPr>
+          <a:xfrm>
+            <a:off x="6530845" y="4151375"/>
+            <a:ext cx="5002481" cy="822960"/>
+          </a:xfrm>
+          <a:prstGeom prst="rect">
+            <a:avLst/>
+          </a:prstGeom>
+          <a:noFill/>
+        </p:spPr>
+        <p:txBody>
+          <a:bodyPr wrap="square" anchor="t" lIns="0" rIns="0" tIns="0" bIns="0">
+            <a:spAutoFit/>
+          </a:bodyPr>
+          <a:lstStyle/>
+          <a:p>
+            <a:pPr algn="l">
+              <a:lnSpc>
+                <a:spcPct val="130000"/>
+              </a:lnSpc>
+              <a:spcAft>
+                <a:spcPts val="0"/>
+              </a:spcAft>
+            </a:pPr>
+            <a:r>
+              <a:rPr sz="1100" b="0" i="0">
+                <a:solidFill>
+                  <a:srgbClr val="525252"/>
+                </a:solidFill>
+                <a:latin typeface="IBM Plex Sans"/>
+              </a:rPr>
+              <a:t>1380 of 3400 case-drug pairs are UNDETERMINED because the laboratory never tested that agent against at least one isolate, 40.6%. That is what the laboratory chose to test, not a property of the model, and it is the largest constraint on this design.</a:t>
+            </a:r>
+          </a:p>
+        </p:txBody>
+      </p:sp>
+      <p:sp>
+        <p:nvSpPr>
+          <p:cNvPr id="39" name="Rectangle 38"/>
+          <p:cNvSpPr/>
+          <p:nvPr/>
+        </p:nvSpPr>
+        <p:spPr>
+          <a:xfrm>
+            <a:off x="6530845" y="4974336"/>
+            <a:ext cx="5002481" cy="16459"/>
+          </a:xfrm>
+          <a:prstGeom prst="rect">
+            <a:avLst/>
+          </a:prstGeom>
+          <a:solidFill>
+            <a:srgbClr val="0F62FE"/>
+          </a:solidFill>
+          <a:ln>
+            <a:noFill/>
+          </a:ln>
+          <a:effectLst/>
+        </p:spPr>
+        <p:style>
+          <a:lnRef idx="1">
+            <a:schemeClr val="accent1"/>
+          </a:lnRef>
+          <a:fillRef idx="3">
+            <a:schemeClr val="accent1"/>
+          </a:fillRef>
+          <a:effectRef idx="2">
+            <a:schemeClr val="accent1"/>
+          </a:effectRef>
+          <a:fontRef idx="minor">
+            <a:schemeClr val="lt1"/>
+          </a:fontRef>
+        </p:style>
+        <p:txBody>
+          <a:bodyPr rtlCol="0" anchor="ctr"/>
+          <a:lstStyle/>
+          <a:p>
+            <a:pPr algn="ctr"/>
+          </a:p>
+        </p:txBody>
+      </p:sp>
+      <p:sp>
+        <p:nvSpPr>
+          <p:cNvPr id="40" name="TextBox 39"/>
+          <p:cNvSpPr txBox="1"/>
+          <p:nvPr/>
+        </p:nvSpPr>
+        <p:spPr>
+          <a:xfrm>
+            <a:off x="6530845" y="5120640"/>
+            <a:ext cx="5002481" cy="320040"/>
+          </a:xfrm>
+          <a:prstGeom prst="rect">
+            <a:avLst/>
+          </a:prstGeom>
+          <a:noFill/>
+        </p:spPr>
+        <p:txBody>
+          <a:bodyPr wrap="square" anchor="t" lIns="0" rIns="0" tIns="0" bIns="0">
+            <a:spAutoFit/>
+          </a:bodyPr>
+          <a:lstStyle/>
+          <a:p>
+            <a:pPr algn="l">
+              <a:lnSpc>
+                <a:spcPct val="115000"/>
+              </a:lnSpc>
+              <a:spcAft>
+                <a:spcPts val="0"/>
+              </a:spcAft>
+            </a:pPr>
+            <a:r>
+              <a:rPr sz="1350" b="1" i="0">
+                <a:solidFill>
+                  <a:srgbClr val="161616"/>
+                </a:solidFill>
+                <a:latin typeface="IBM Plex Sans"/>
+              </a:rPr>
+              <a:t>The ceiling, so the baseline reads against something</a:t>
+            </a:r>
+          </a:p>
+        </p:txBody>
+      </p:sp>
+      <p:sp>
+        <p:nvSpPr>
+          <p:cNvPr id="41" name="TextBox 40"/>
+          <p:cNvSpPr txBox="1"/>
+          <p:nvPr/>
+        </p:nvSpPr>
+        <p:spPr>
+          <a:xfrm>
+            <a:off x="6530845" y="5449823"/>
+            <a:ext cx="5002481" cy="822960"/>
+          </a:xfrm>
+          <a:prstGeom prst="rect">
+            <a:avLst/>
+          </a:prstGeom>
+          <a:noFill/>
+        </p:spPr>
+        <p:txBody>
+          <a:bodyPr wrap="square" anchor="t" lIns="0" rIns="0" tIns="0" bIns="0">
+            <a:spAutoFit/>
+          </a:bodyPr>
+          <a:lstStyle/>
+          <a:p>
+            <a:pPr algn="l">
+              <a:lnSpc>
+                <a:spcPct val="130000"/>
+              </a:lnSpc>
+              <a:spcAft>
+                <a:spcPts val="0"/>
+              </a:spcAft>
+            </a:pPr>
+            <a:r>
+              <a:rPr sz="1100" b="0" i="0">
+                <a:solidFill>
+                  <a:srgbClr val="525252"/>
+                </a:solidFill>
+                <a:latin typeface="IBM Plex Sans"/>
+              </a:rPr>
+              <a:t>Perfect per-patient choice from the formulary reaches 199 of 200 = 99.5%. The 87.5% baseline is not near a ceiling: about twelve points of headroom existed and were not taken.</a:t>
+            </a:r>
+          </a:p>
+        </p:txBody>
+      </p:sp>
+      <p:sp>
+        <p:nvSpPr>
+          <p:cNvPr id="42" name="Rectangle 41"/>
+          <p:cNvSpPr/>
+          <p:nvPr/>
+        </p:nvSpPr>
+        <p:spPr>
+          <a:xfrm>
+            <a:off x="658368" y="6181344"/>
+            <a:ext cx="10874959" cy="7315"/>
+          </a:xfrm>
+          <a:prstGeom prst="rect">
+            <a:avLst/>
+          </a:prstGeom>
+          <a:solidFill>
+            <a:srgbClr val="E0E0E0"/>
+          </a:solidFill>
+          <a:ln>
+            <a:noFill/>
+          </a:ln>
+          <a:effectLst/>
+        </p:spPr>
+        <p:style>
+          <a:lnRef idx="1">
+            <a:schemeClr val="accent1"/>
+          </a:lnRef>
+          <a:fillRef idx="3">
+            <a:schemeClr val="accent1"/>
+          </a:fillRef>
+          <a:effectRef idx="2">
+            <a:schemeClr val="accent1"/>
+          </a:effectRef>
+          <a:fontRef idx="minor">
+            <a:schemeClr val="lt1"/>
+          </a:fontRef>
+        </p:style>
+        <p:txBody>
+          <a:bodyPr rtlCol="0" anchor="ctr"/>
+          <a:lstStyle/>
+          <a:p>
+            <a:pPr algn="ctr"/>
+          </a:p>
+        </p:txBody>
+      </p:sp>
+      <p:sp>
+        <p:nvSpPr>
+          <p:cNvPr id="43" name="TextBox 42"/>
+          <p:cNvSpPr txBox="1"/>
+          <p:nvPr/>
+        </p:nvSpPr>
+        <p:spPr>
+          <a:xfrm>
+            <a:off x="658368" y="6327648"/>
+            <a:ext cx="9777679" cy="274320"/>
+          </a:xfrm>
+          <a:prstGeom prst="rect">
+            <a:avLst/>
+          </a:prstGeom>
+          <a:noFill/>
+        </p:spPr>
+        <p:txBody>
+          <a:bodyPr wrap="square" anchor="t" lIns="0" rIns="0" tIns="0" bIns="0">
+            <a:spAutoFit/>
+          </a:bodyPr>
+          <a:lstStyle/>
+          <a:p>
+            <a:pPr algn="l">
+              <a:lnSpc>
+                <a:spcPct val="128000"/>
+              </a:lnSpc>
+              <a:spcAft>
+                <a:spcPts val="0"/>
+              </a:spcAft>
+            </a:pPr>
+            <a:r>
+              <a:rPr sz="950" b="0" i="0">
+                <a:solidFill>
+                  <a:srgbClr val="525252"/>
+                </a:solidFill>
+                <a:latin typeface="IBM Plex Sans"/>
+              </a:rPr>
+              <a:t>results/cohort_composition.json  ·  analysis/cohort_composition.py  ·  aggregates only, no case-level rows leave the machine</a:t>
+            </a:r>
+          </a:p>
+        </p:txBody>
+      </p:sp>
+      <p:sp>
+        <p:nvSpPr>
+          <p:cNvPr id="44" name="TextBox 43"/>
+          <p:cNvSpPr txBox="1"/>
+          <p:nvPr/>
+        </p:nvSpPr>
+        <p:spPr>
+          <a:xfrm>
+            <a:off x="10618927" y="6327648"/>
+            <a:ext cx="914400" cy="274320"/>
+          </a:xfrm>
+          <a:prstGeom prst="rect">
+            <a:avLst/>
+          </a:prstGeom>
+          <a:noFill/>
+        </p:spPr>
+        <p:txBody>
+          <a:bodyPr wrap="square" anchor="t" lIns="0" rIns="0" tIns="0" bIns="0">
+            <a:spAutoFit/>
+          </a:bodyPr>
+          <a:lstStyle/>
+          <a:p>
+            <a:pPr algn="r">
+              <a:lnSpc>
+                <a:spcPct val="128000"/>
+              </a:lnSpc>
+              <a:spcAft>
+                <a:spcPts val="0"/>
+              </a:spcAft>
+            </a:pPr>
+            <a:r>
+              <a:rPr sz="950" b="0" i="0">
+                <a:solidFill>
+                  <a:srgbClr val="525252"/>
+                </a:solidFill>
+                <a:latin typeface="IBM Plex Sans"/>
+              </a:rPr>
+              <a:t>24</a:t>
             </a:r>
           </a:p>
         </p:txBody>

</xml_diff>

<commit_message>
Put the control in the project document, the deck and the drill
PROJECT.md section 7.13 states the control, what it separates, and what it does not hold constant.
A backup slide carries the table and the paired test, and its notes say the coverage and the
context-length limitation out loud. The drill answer is rewritten now that the arm has answered.

Co-Authored-By: Claude Opus 5 (1M context) <noreply@anthropic.com>
</commit_message>
<xml_diff>
--- a/deck/Shomique_Hayat_UNIQ_antibiotic_agents.pptx
+++ b/deck/Shomique_Hayat_UNIQ_antibiotic_agents.pptx
@@ -34,6 +34,7 @@
     <p:sldId id="282" r:id="rId34"/>
     <p:sldId id="283" r:id="rId35"/>
     <p:sldId id="284" r:id="rId36"/>
+    <p:sldId id="285" r:id="rId37"/>
   </p:sldIdLst>
   <p:sldSz cx="12191695" cy="6858000" type="screen4x3"/>
   <p:notesSz cx="6858000" cy="9144000"/>
@@ -3185,6 +3186,147 @@
           <a:p>
             <a:r>
               <a:t>the honest answer is undetermined, and pretending otherwise would inflate every number I show you.</a:t>
+            </a:r>
+          </a:p>
+        </p:txBody>
+      </p:sp>
+      <p:sp>
+        <p:nvSpPr>
+          <p:cNvPr id="4" name="Slide Number Placeholder 3"/>
+          <p:cNvSpPr>
+            <a:spLocks noGrp="1"/>
+          </p:cNvSpPr>
+          <p:nvPr>
+            <p:ph type="sldNum" idx="5" sz="quarter"/>
+          </p:nvPr>
+        </p:nvSpPr>
+        <p:spPr/>
+      </p:sp>
+    </p:spTree>
+  </p:cSld>
+  <p:clrMapOvr>
+    <a:masterClrMapping/>
+  </p:clrMapOvr>
+</p:notes>
+</file>
+
+<file path=ppt/notesSlides/notesSlide30.xml><?xml version="1.0" encoding="utf-8"?>
+<p:notes xmlns:a="http://schemas.openxmlformats.org/drawingml/2006/main" xmlns:p="http://schemas.openxmlformats.org/presentationml/2006/main" xmlns:r="http://schemas.openxmlformats.org/officeDocument/2006/relationships">
+  <p:cSld>
+    <p:spTree>
+      <p:nvGrpSpPr>
+        <p:cNvPr id="1" name=""/>
+        <p:cNvGrpSpPr/>
+        <p:nvPr/>
+      </p:nvGrpSpPr>
+      <p:grpSpPr>
+        <a:xfrm>
+          <a:off x="0" y="0"/>
+          <a:ext cx="0" cy="0"/>
+          <a:chOff x="0" y="0"/>
+          <a:chExt cx="0" cy="0"/>
+        </a:xfrm>
+      </p:grpSpPr>
+      <p:sp>
+        <p:nvSpPr>
+          <p:cNvPr id="2" name="Slide Image Placeholder 1"/>
+          <p:cNvSpPr>
+            <a:spLocks noGrp="1"/>
+          </p:cNvSpPr>
+          <p:nvPr>
+            <p:ph type="sldImg" idx="2"/>
+          </p:nvPr>
+        </p:nvSpPr>
+        <p:spPr/>
+      </p:sp>
+      <p:sp>
+        <p:nvSpPr>
+          <p:cNvPr id="3" name="Notes Placeholder 2"/>
+          <p:cNvSpPr>
+            <a:spLocks noGrp="1"/>
+          </p:cNvSpPr>
+          <p:nvPr>
+            <p:ph type="body" idx="3" sz="quarter"/>
+          </p:nvPr>
+        </p:nvSpPr>
+        <p:spPr/>
+        <p:txBody>
+          <a:bodyPr/>
+          <a:lstStyle/>
+          <a:p>
+            <a:r>
+              <a:t>BACKUP SLIDE, not in the ten minutes. Use it in questions.</a:t>
+            </a:r>
+          </a:p>
+          <a:p/>
+          <a:p>
+            <a:r>
+              <a:t>Backup slide, and it is the answer to the obvious objection.</a:t>
+            </a:r>
+          </a:p>
+          <a:p>
+            <a:r>
+              <a:t>Someone will say: five turns cost you coverage, but is that the debate or is it just being asked</a:t>
+            </a:r>
+          </a:p>
+          <a:p>
+            <a:r>
+              <a:t>three times? The debate arm cannot separate those, because it varies both at once.</a:t>
+            </a:r>
+          </a:p>
+          <a:p>
+            <a:r>
+              <a:t>So I ran the control. One agent, the same specialist, the same 57 frozen cases, the same round-0</a:t>
+            </a:r>
+          </a:p>
+          <a:p>
+            <a:r>
+              <a:t>prompt byte for byte, the same formulary, the same leakage gate, the same scorer. It speaks three</a:t>
+            </a:r>
+          </a:p>
+          <a:p>
+            <a:r>
+              <a:t>times, exactly as many times as the specialist speaks in the debate, and between turns it sees only</a:t>
+            </a:r>
+          </a:p>
+          <a:p>
+            <a:r>
+              <a:t>its own previous text. Nothing disagrees with it.</a:t>
+            </a:r>
+          </a:p>
+          <a:p>
+            <a:r>
+              <a:t>With a counterpart it changes its drug in every run. Without one, 4 of 57.</a:t>
+            </a:r>
+          </a:p>
+          <a:p>
+            <a:r>
+              <a:t>Coverage is 89.5 per cent against 78.9, and harmful revision is 0 per cent against 14.3.</a:t>
+            </a:r>
+          </a:p>
+          <a:p>
+            <a:r>
+              <a:t>Paired within patient, exact McNemar p = 0.0156.</a:t>
+            </a:r>
+          </a:p>
+          <a:p>
+            <a:r>
+              <a:t>So the counterpart is what moves it. Being asked again is not enough.</a:t>
+            </a:r>
+          </a:p>
+          <a:p>
+            <a:r>
+              <a:t>Say the limitation out loud: it does not hold context length constant. The debate transcript is</a:t>
+            </a:r>
+          </a:p>
+          <a:p>
+            <a:r>
+              <a:t>about twice as long by the final turn. That control is the next thing to run.</a:t>
+            </a:r>
+          </a:p>
+          <a:p>
+            <a:r>
+              <a:t>Say the coverage out loud too: 57 of 200 cases, a contiguous prefix, run against the clock.</a:t>
             </a:r>
           </a:p>
         </p:txBody>
@@ -30858,6 +31000,964 @@
                 <a:latin typeface="IBM Plex Sans"/>
               </a:rPr>
               <a:t>2</a:t>
+            </a:r>
+          </a:p>
+        </p:txBody>
+      </p:sp>
+    </p:spTree>
+  </p:cSld>
+  <p:clrMapOvr>
+    <a:masterClrMapping/>
+  </p:clrMapOvr>
+</p:sld>
+</file>
+
+<file path=ppt/slides/slide30.xml><?xml version="1.0" encoding="utf-8"?>
+<p:sld xmlns:a="http://schemas.openxmlformats.org/drawingml/2006/main" xmlns:p="http://schemas.openxmlformats.org/presentationml/2006/main" xmlns:r="http://schemas.openxmlformats.org/officeDocument/2006/relationships">
+  <p:cSld>
+    <p:bg>
+      <p:bgPr>
+        <a:solidFill>
+          <a:srgbClr val="FFFFFF"/>
+        </a:solidFill>
+        <a:effectLst/>
+      </p:bgPr>
+    </p:bg>
+    <p:spTree>
+      <p:nvGrpSpPr>
+        <p:cNvPr id="1" name=""/>
+        <p:cNvGrpSpPr/>
+        <p:nvPr/>
+      </p:nvGrpSpPr>
+      <p:grpSpPr/>
+      <p:sp>
+        <p:nvSpPr>
+          <p:cNvPr id="2" name="TextBox 1"/>
+          <p:cNvSpPr txBox="1"/>
+          <p:nvPr/>
+        </p:nvSpPr>
+        <p:spPr>
+          <a:xfrm>
+            <a:off x="658368" y="457200"/>
+            <a:ext cx="10874959" cy="274320"/>
+          </a:xfrm>
+          <a:prstGeom prst="rect">
+            <a:avLst/>
+          </a:prstGeom>
+          <a:noFill/>
+        </p:spPr>
+        <p:txBody>
+          <a:bodyPr wrap="square" anchor="t" lIns="0" rIns="0" tIns="0" bIns="0">
+            <a:spAutoFit/>
+          </a:bodyPr>
+          <a:lstStyle/>
+          <a:p>
+            <a:pPr algn="l">
+              <a:lnSpc>
+                <a:spcPct val="128000"/>
+              </a:lnSpc>
+              <a:spcAft>
+                <a:spcPts val="0"/>
+              </a:spcAft>
+            </a:pPr>
+            <a:r>
+              <a:rPr sz="1150" b="1" i="0" spc="190">
+                <a:solidFill>
+                  <a:srgbClr val="0F62FE"/>
+                </a:solidFill>
+                <a:latin typeface="IBM Plex Sans"/>
+              </a:rPr>
+              <a:t>BACKUP  ·  THE CONTROL</a:t>
+            </a:r>
+          </a:p>
+        </p:txBody>
+      </p:sp>
+      <p:sp>
+        <p:nvSpPr>
+          <p:cNvPr id="3" name="TextBox 2"/>
+          <p:cNvSpPr txBox="1"/>
+          <p:nvPr/>
+        </p:nvSpPr>
+        <p:spPr>
+          <a:xfrm>
+            <a:off x="658368" y="768096"/>
+            <a:ext cx="10509199" cy="914400"/>
+          </a:xfrm>
+          <a:prstGeom prst="rect">
+            <a:avLst/>
+          </a:prstGeom>
+          <a:noFill/>
+        </p:spPr>
+        <p:txBody>
+          <a:bodyPr wrap="square" anchor="t" lIns="0" rIns="0" tIns="0" bIns="0">
+            <a:spAutoFit/>
+          </a:bodyPr>
+          <a:lstStyle/>
+          <a:p>
+            <a:pPr algn="l">
+              <a:lnSpc>
+                <a:spcPct val="112000"/>
+              </a:lnSpc>
+              <a:spcAft>
+                <a:spcPts val="0"/>
+              </a:spcAft>
+            </a:pPr>
+            <a:r>
+              <a:rPr sz="3000" b="1" i="0">
+                <a:solidFill>
+                  <a:srgbClr val="161616"/>
+                </a:solidFill>
+                <a:latin typeface="IBM Plex Sans"/>
+              </a:rPr>
+              <a:t>Asked three times with nothing disagreeing, it keeps its answer.</a:t>
+            </a:r>
+          </a:p>
+        </p:txBody>
+      </p:sp>
+      <p:sp>
+        <p:nvSpPr>
+          <p:cNvPr id="4" name="TextBox 3"/>
+          <p:cNvSpPr txBox="1"/>
+          <p:nvPr/>
+        </p:nvSpPr>
+        <p:spPr>
+          <a:xfrm>
+            <a:off x="658368" y="2194560"/>
+            <a:ext cx="3587758" cy="384048"/>
+          </a:xfrm>
+          <a:prstGeom prst="rect">
+            <a:avLst/>
+          </a:prstGeom>
+          <a:noFill/>
+        </p:spPr>
+        <p:txBody>
+          <a:bodyPr wrap="square" anchor="t" lIns="0" rIns="0" tIns="0" bIns="0">
+            <a:spAutoFit/>
+          </a:bodyPr>
+          <a:lstStyle/>
+          <a:p>
+            <a:pPr algn="l">
+              <a:lnSpc>
+                <a:spcPct val="115000"/>
+              </a:lnSpc>
+              <a:spcAft>
+                <a:spcPts val="0"/>
+              </a:spcAft>
+            </a:pPr>
+            <a:r>
+              <a:rPr sz="1050" b="1" i="0" spc="90">
+                <a:solidFill>
+                  <a:srgbClr val="525252"/>
+                </a:solidFill>
+                <a:latin typeface="IBM Plex Sans"/>
+              </a:rPr>
+              <a:t/>
+            </a:r>
+          </a:p>
+        </p:txBody>
+      </p:sp>
+      <p:sp>
+        <p:nvSpPr>
+          <p:cNvPr id="5" name="TextBox 4"/>
+          <p:cNvSpPr txBox="1"/>
+          <p:nvPr/>
+        </p:nvSpPr>
+        <p:spPr>
+          <a:xfrm>
+            <a:off x="4355854" y="2194560"/>
+            <a:ext cx="3479008" cy="384048"/>
+          </a:xfrm>
+          <a:prstGeom prst="rect">
+            <a:avLst/>
+          </a:prstGeom>
+          <a:noFill/>
+        </p:spPr>
+        <p:txBody>
+          <a:bodyPr wrap="square" anchor="t" lIns="0" rIns="0" tIns="0" bIns="0">
+            <a:spAutoFit/>
+          </a:bodyPr>
+          <a:lstStyle/>
+          <a:p>
+            <a:pPr algn="l">
+              <a:lnSpc>
+                <a:spcPct val="115000"/>
+              </a:lnSpc>
+              <a:spcAft>
+                <a:spcPts val="0"/>
+              </a:spcAft>
+            </a:pPr>
+            <a:r>
+              <a:rPr sz="1050" b="1" i="0" spc="90">
+                <a:solidFill>
+                  <a:srgbClr val="525252"/>
+                </a:solidFill>
+                <a:latin typeface="IBM Plex Sans"/>
+              </a:rPr>
+              <a:t>FIVE TURNS, A COUNTERPART ARGUING</a:t>
+            </a:r>
+          </a:p>
+        </p:txBody>
+      </p:sp>
+      <p:sp>
+        <p:nvSpPr>
+          <p:cNvPr id="6" name="TextBox 5"/>
+          <p:cNvSpPr txBox="1"/>
+          <p:nvPr/>
+        </p:nvSpPr>
+        <p:spPr>
+          <a:xfrm>
+            <a:off x="7944590" y="2194560"/>
+            <a:ext cx="3479008" cy="384048"/>
+          </a:xfrm>
+          <a:prstGeom prst="rect">
+            <a:avLst/>
+          </a:prstGeom>
+          <a:noFill/>
+        </p:spPr>
+        <p:txBody>
+          <a:bodyPr wrap="square" anchor="t" lIns="0" rIns="0" tIns="0" bIns="0">
+            <a:spAutoFit/>
+          </a:bodyPr>
+          <a:lstStyle/>
+          <a:p>
+            <a:pPr algn="l">
+              <a:lnSpc>
+                <a:spcPct val="115000"/>
+              </a:lnSpc>
+              <a:spcAft>
+                <a:spcPts val="0"/>
+              </a:spcAft>
+            </a:pPr>
+            <a:r>
+              <a:rPr sz="1050" b="1" i="0" spc="90">
+                <a:solidFill>
+                  <a:srgbClr val="525252"/>
+                </a:solidFill>
+                <a:latin typeface="IBM Plex Sans"/>
+              </a:rPr>
+              <a:t>THREE TURNS, ONLY ITS OWN TEXT</a:t>
+            </a:r>
+          </a:p>
+        </p:txBody>
+      </p:sp>
+      <p:sp>
+        <p:nvSpPr>
+          <p:cNvPr id="7" name="Rectangle 6"/>
+          <p:cNvSpPr/>
+          <p:nvPr/>
+        </p:nvSpPr>
+        <p:spPr>
+          <a:xfrm>
+            <a:off x="658368" y="2578608"/>
+            <a:ext cx="10874959" cy="10972"/>
+          </a:xfrm>
+          <a:prstGeom prst="rect">
+            <a:avLst/>
+          </a:prstGeom>
+          <a:solidFill>
+            <a:srgbClr val="161616"/>
+          </a:solidFill>
+          <a:ln>
+            <a:noFill/>
+          </a:ln>
+          <a:effectLst/>
+        </p:spPr>
+        <p:style>
+          <a:lnRef idx="1">
+            <a:schemeClr val="accent1"/>
+          </a:lnRef>
+          <a:fillRef idx="3">
+            <a:schemeClr val="accent1"/>
+          </a:fillRef>
+          <a:effectRef idx="2">
+            <a:schemeClr val="accent1"/>
+          </a:effectRef>
+          <a:fontRef idx="minor">
+            <a:schemeClr val="lt1"/>
+          </a:fontRef>
+        </p:style>
+        <p:txBody>
+          <a:bodyPr rtlCol="0" anchor="ctr"/>
+          <a:lstStyle/>
+          <a:p>
+            <a:pPr algn="ctr"/>
+          </a:p>
+        </p:txBody>
+      </p:sp>
+      <p:sp>
+        <p:nvSpPr>
+          <p:cNvPr id="8" name="TextBox 7"/>
+          <p:cNvSpPr txBox="1"/>
+          <p:nvPr/>
+        </p:nvSpPr>
+        <p:spPr>
+          <a:xfrm>
+            <a:off x="658368" y="2761488"/>
+            <a:ext cx="3587758" cy="420624"/>
+          </a:xfrm>
+          <a:prstGeom prst="rect">
+            <a:avLst/>
+          </a:prstGeom>
+          <a:noFill/>
+        </p:spPr>
+        <p:txBody>
+          <a:bodyPr wrap="square" anchor="t" lIns="0" rIns="0" tIns="0" bIns="0">
+            <a:spAutoFit/>
+          </a:bodyPr>
+          <a:lstStyle/>
+          <a:p>
+            <a:pPr algn="l">
+              <a:lnSpc>
+                <a:spcPct val="120000"/>
+              </a:lnSpc>
+              <a:spcAft>
+                <a:spcPts val="0"/>
+              </a:spcAft>
+            </a:pPr>
+            <a:r>
+              <a:rPr sz="1350" b="0" i="0">
+                <a:solidFill>
+                  <a:srgbClr val="161616"/>
+                </a:solidFill>
+                <a:latin typeface="IBM Plex Sans"/>
+              </a:rPr>
+              <a:t>changed its opening drug</a:t>
+            </a:r>
+          </a:p>
+        </p:txBody>
+      </p:sp>
+      <p:sp>
+        <p:nvSpPr>
+          <p:cNvPr id="9" name="TextBox 8"/>
+          <p:cNvSpPr txBox="1"/>
+          <p:nvPr/>
+        </p:nvSpPr>
+        <p:spPr>
+          <a:xfrm>
+            <a:off x="4355854" y="2761488"/>
+            <a:ext cx="3479008" cy="420624"/>
+          </a:xfrm>
+          <a:prstGeom prst="rect">
+            <a:avLst/>
+          </a:prstGeom>
+          <a:noFill/>
+        </p:spPr>
+        <p:txBody>
+          <a:bodyPr wrap="square" anchor="t" lIns="0" rIns="0" tIns="0" bIns="0">
+            <a:spAutoFit/>
+          </a:bodyPr>
+          <a:lstStyle/>
+          <a:p>
+            <a:pPr algn="l">
+              <a:lnSpc>
+                <a:spcPct val="120000"/>
+              </a:lnSpc>
+              <a:spcAft>
+                <a:spcPts val="0"/>
+              </a:spcAft>
+            </a:pPr>
+            <a:r>
+              <a:rPr sz="1350" b="1" i="0">
+                <a:solidFill>
+                  <a:srgbClr val="D02670"/>
+                </a:solidFill>
+                <a:latin typeface="IBM Plex Sans"/>
+              </a:rPr>
+              <a:t>57 of 57</a:t>
+            </a:r>
+          </a:p>
+        </p:txBody>
+      </p:sp>
+      <p:sp>
+        <p:nvSpPr>
+          <p:cNvPr id="10" name="TextBox 9"/>
+          <p:cNvSpPr txBox="1"/>
+          <p:nvPr/>
+        </p:nvSpPr>
+        <p:spPr>
+          <a:xfrm>
+            <a:off x="7944590" y="2761488"/>
+            <a:ext cx="3479008" cy="420624"/>
+          </a:xfrm>
+          <a:prstGeom prst="rect">
+            <a:avLst/>
+          </a:prstGeom>
+          <a:noFill/>
+        </p:spPr>
+        <p:txBody>
+          <a:bodyPr wrap="square" anchor="t" lIns="0" rIns="0" tIns="0" bIns="0">
+            <a:spAutoFit/>
+          </a:bodyPr>
+          <a:lstStyle/>
+          <a:p>
+            <a:pPr algn="l">
+              <a:lnSpc>
+                <a:spcPct val="120000"/>
+              </a:lnSpc>
+              <a:spcAft>
+                <a:spcPts val="0"/>
+              </a:spcAft>
+            </a:pPr>
+            <a:r>
+              <a:rPr sz="1350" b="1" i="0">
+                <a:solidFill>
+                  <a:srgbClr val="0F62FE"/>
+                </a:solidFill>
+                <a:latin typeface="IBM Plex Sans"/>
+              </a:rPr>
+              <a:t>4 of 57</a:t>
+            </a:r>
+          </a:p>
+        </p:txBody>
+      </p:sp>
+      <p:sp>
+        <p:nvSpPr>
+          <p:cNvPr id="11" name="Rectangle 10"/>
+          <p:cNvSpPr/>
+          <p:nvPr/>
+        </p:nvSpPr>
+        <p:spPr>
+          <a:xfrm>
+            <a:off x="658368" y="3108960"/>
+            <a:ext cx="10874959" cy="5486"/>
+          </a:xfrm>
+          <a:prstGeom prst="rect">
+            <a:avLst/>
+          </a:prstGeom>
+          <a:solidFill>
+            <a:srgbClr val="E0E0E0"/>
+          </a:solidFill>
+          <a:ln>
+            <a:noFill/>
+          </a:ln>
+          <a:effectLst/>
+        </p:spPr>
+        <p:style>
+          <a:lnRef idx="1">
+            <a:schemeClr val="accent1"/>
+          </a:lnRef>
+          <a:fillRef idx="3">
+            <a:schemeClr val="accent1"/>
+          </a:fillRef>
+          <a:effectRef idx="2">
+            <a:schemeClr val="accent1"/>
+          </a:effectRef>
+          <a:fontRef idx="minor">
+            <a:schemeClr val="lt1"/>
+          </a:fontRef>
+        </p:style>
+        <p:txBody>
+          <a:bodyPr rtlCol="0" anchor="ctr"/>
+          <a:lstStyle/>
+          <a:p>
+            <a:pPr algn="ctr"/>
+          </a:p>
+        </p:txBody>
+      </p:sp>
+      <p:sp>
+        <p:nvSpPr>
+          <p:cNvPr id="12" name="TextBox 11"/>
+          <p:cNvSpPr txBox="1"/>
+          <p:nvPr/>
+        </p:nvSpPr>
+        <p:spPr>
+          <a:xfrm>
+            <a:off x="658368" y="3182112"/>
+            <a:ext cx="3587758" cy="420624"/>
+          </a:xfrm>
+          <a:prstGeom prst="rect">
+            <a:avLst/>
+          </a:prstGeom>
+          <a:noFill/>
+        </p:spPr>
+        <p:txBody>
+          <a:bodyPr wrap="square" anchor="t" lIns="0" rIns="0" tIns="0" bIns="0">
+            <a:spAutoFit/>
+          </a:bodyPr>
+          <a:lstStyle/>
+          <a:p>
+            <a:pPr algn="l">
+              <a:lnSpc>
+                <a:spcPct val="120000"/>
+              </a:lnSpc>
+              <a:spcAft>
+                <a:spcPts val="0"/>
+              </a:spcAft>
+            </a:pPr>
+            <a:r>
+              <a:rPr sz="1350" b="0" i="0">
+                <a:solidFill>
+                  <a:srgbClr val="161616"/>
+                </a:solidFill>
+                <a:latin typeface="IBM Plex Sans"/>
+              </a:rPr>
+              <a:t>final recommendation adequate</a:t>
+            </a:r>
+          </a:p>
+        </p:txBody>
+      </p:sp>
+      <p:sp>
+        <p:nvSpPr>
+          <p:cNvPr id="13" name="TextBox 12"/>
+          <p:cNvSpPr txBox="1"/>
+          <p:nvPr/>
+        </p:nvSpPr>
+        <p:spPr>
+          <a:xfrm>
+            <a:off x="4355854" y="3182112"/>
+            <a:ext cx="3479008" cy="420624"/>
+          </a:xfrm>
+          <a:prstGeom prst="rect">
+            <a:avLst/>
+          </a:prstGeom>
+          <a:noFill/>
+        </p:spPr>
+        <p:txBody>
+          <a:bodyPr wrap="square" anchor="t" lIns="0" rIns="0" tIns="0" bIns="0">
+            <a:spAutoFit/>
+          </a:bodyPr>
+          <a:lstStyle/>
+          <a:p>
+            <a:pPr algn="l">
+              <a:lnSpc>
+                <a:spcPct val="120000"/>
+              </a:lnSpc>
+              <a:spcAft>
+                <a:spcPts val="0"/>
+              </a:spcAft>
+            </a:pPr>
+            <a:r>
+              <a:rPr sz="1350" b="0" i="0">
+                <a:solidFill>
+                  <a:srgbClr val="D02670"/>
+                </a:solidFill>
+                <a:latin typeface="IBM Plex Sans"/>
+              </a:rPr>
+              <a:t>78.9%</a:t>
+            </a:r>
+          </a:p>
+        </p:txBody>
+      </p:sp>
+      <p:sp>
+        <p:nvSpPr>
+          <p:cNvPr id="14" name="TextBox 13"/>
+          <p:cNvSpPr txBox="1"/>
+          <p:nvPr/>
+        </p:nvSpPr>
+        <p:spPr>
+          <a:xfrm>
+            <a:off x="7944590" y="3182112"/>
+            <a:ext cx="3479008" cy="420624"/>
+          </a:xfrm>
+          <a:prstGeom prst="rect">
+            <a:avLst/>
+          </a:prstGeom>
+          <a:noFill/>
+        </p:spPr>
+        <p:txBody>
+          <a:bodyPr wrap="square" anchor="t" lIns="0" rIns="0" tIns="0" bIns="0">
+            <a:spAutoFit/>
+          </a:bodyPr>
+          <a:lstStyle/>
+          <a:p>
+            <a:pPr algn="l">
+              <a:lnSpc>
+                <a:spcPct val="120000"/>
+              </a:lnSpc>
+              <a:spcAft>
+                <a:spcPts val="0"/>
+              </a:spcAft>
+            </a:pPr>
+            <a:r>
+              <a:rPr sz="1350" b="0" i="0">
+                <a:solidFill>
+                  <a:srgbClr val="0F62FE"/>
+                </a:solidFill>
+                <a:latin typeface="IBM Plex Sans"/>
+              </a:rPr>
+              <a:t>89.5%</a:t>
+            </a:r>
+          </a:p>
+        </p:txBody>
+      </p:sp>
+      <p:sp>
+        <p:nvSpPr>
+          <p:cNvPr id="15" name="Rectangle 14"/>
+          <p:cNvSpPr/>
+          <p:nvPr/>
+        </p:nvSpPr>
+        <p:spPr>
+          <a:xfrm>
+            <a:off x="658368" y="3529584"/>
+            <a:ext cx="10874959" cy="5486"/>
+          </a:xfrm>
+          <a:prstGeom prst="rect">
+            <a:avLst/>
+          </a:prstGeom>
+          <a:solidFill>
+            <a:srgbClr val="E0E0E0"/>
+          </a:solidFill>
+          <a:ln>
+            <a:noFill/>
+          </a:ln>
+          <a:effectLst/>
+        </p:spPr>
+        <p:style>
+          <a:lnRef idx="1">
+            <a:schemeClr val="accent1"/>
+          </a:lnRef>
+          <a:fillRef idx="3">
+            <a:schemeClr val="accent1"/>
+          </a:fillRef>
+          <a:effectRef idx="2">
+            <a:schemeClr val="accent1"/>
+          </a:effectRef>
+          <a:fontRef idx="minor">
+            <a:schemeClr val="lt1"/>
+          </a:fontRef>
+        </p:style>
+        <p:txBody>
+          <a:bodyPr rtlCol="0" anchor="ctr"/>
+          <a:lstStyle/>
+          <a:p>
+            <a:pPr algn="ctr"/>
+          </a:p>
+        </p:txBody>
+      </p:sp>
+      <p:sp>
+        <p:nvSpPr>
+          <p:cNvPr id="16" name="TextBox 15"/>
+          <p:cNvSpPr txBox="1"/>
+          <p:nvPr/>
+        </p:nvSpPr>
+        <p:spPr>
+          <a:xfrm>
+            <a:off x="658368" y="3602736"/>
+            <a:ext cx="3587758" cy="420624"/>
+          </a:xfrm>
+          <a:prstGeom prst="rect">
+            <a:avLst/>
+          </a:prstGeom>
+          <a:noFill/>
+        </p:spPr>
+        <p:txBody>
+          <a:bodyPr wrap="square" anchor="t" lIns="0" rIns="0" tIns="0" bIns="0">
+            <a:spAutoFit/>
+          </a:bodyPr>
+          <a:lstStyle/>
+          <a:p>
+            <a:pPr algn="l">
+              <a:lnSpc>
+                <a:spcPct val="120000"/>
+              </a:lnSpc>
+              <a:spcAft>
+                <a:spcPts val="0"/>
+              </a:spcAft>
+            </a:pPr>
+            <a:r>
+              <a:rPr sz="1350" b="0" i="0">
+                <a:solidFill>
+                  <a:srgbClr val="161616"/>
+                </a:solidFill>
+                <a:latin typeface="IBM Plex Sans"/>
+              </a:rPr>
+              <a:t>harmful revision</a:t>
+            </a:r>
+          </a:p>
+        </p:txBody>
+      </p:sp>
+      <p:sp>
+        <p:nvSpPr>
+          <p:cNvPr id="17" name="TextBox 16"/>
+          <p:cNvSpPr txBox="1"/>
+          <p:nvPr/>
+        </p:nvSpPr>
+        <p:spPr>
+          <a:xfrm>
+            <a:off x="4355854" y="3602736"/>
+            <a:ext cx="3479008" cy="420624"/>
+          </a:xfrm>
+          <a:prstGeom prst="rect">
+            <a:avLst/>
+          </a:prstGeom>
+          <a:noFill/>
+        </p:spPr>
+        <p:txBody>
+          <a:bodyPr wrap="square" anchor="t" lIns="0" rIns="0" tIns="0" bIns="0">
+            <a:spAutoFit/>
+          </a:bodyPr>
+          <a:lstStyle/>
+          <a:p>
+            <a:pPr algn="l">
+              <a:lnSpc>
+                <a:spcPct val="120000"/>
+              </a:lnSpc>
+              <a:spcAft>
+                <a:spcPts val="0"/>
+              </a:spcAft>
+            </a:pPr>
+            <a:r>
+              <a:rPr sz="1350" b="1" i="0">
+                <a:solidFill>
+                  <a:srgbClr val="D02670"/>
+                </a:solidFill>
+                <a:latin typeface="IBM Plex Sans"/>
+              </a:rPr>
+              <a:t>14.3%</a:t>
+            </a:r>
+          </a:p>
+        </p:txBody>
+      </p:sp>
+      <p:sp>
+        <p:nvSpPr>
+          <p:cNvPr id="18" name="TextBox 17"/>
+          <p:cNvSpPr txBox="1"/>
+          <p:nvPr/>
+        </p:nvSpPr>
+        <p:spPr>
+          <a:xfrm>
+            <a:off x="7944590" y="3602736"/>
+            <a:ext cx="3479008" cy="420624"/>
+          </a:xfrm>
+          <a:prstGeom prst="rect">
+            <a:avLst/>
+          </a:prstGeom>
+          <a:noFill/>
+        </p:spPr>
+        <p:txBody>
+          <a:bodyPr wrap="square" anchor="t" lIns="0" rIns="0" tIns="0" bIns="0">
+            <a:spAutoFit/>
+          </a:bodyPr>
+          <a:lstStyle/>
+          <a:p>
+            <a:pPr algn="l">
+              <a:lnSpc>
+                <a:spcPct val="120000"/>
+              </a:lnSpc>
+              <a:spcAft>
+                <a:spcPts val="0"/>
+              </a:spcAft>
+            </a:pPr>
+            <a:r>
+              <a:rPr sz="1350" b="1" i="0">
+                <a:solidFill>
+                  <a:srgbClr val="0F62FE"/>
+                </a:solidFill>
+                <a:latin typeface="IBM Plex Sans"/>
+              </a:rPr>
+              <a:t>0%</a:t>
+            </a:r>
+          </a:p>
+        </p:txBody>
+      </p:sp>
+      <p:sp>
+        <p:nvSpPr>
+          <p:cNvPr id="19" name="TextBox 18"/>
+          <p:cNvSpPr txBox="1"/>
+          <p:nvPr/>
+        </p:nvSpPr>
+        <p:spPr>
+          <a:xfrm>
+            <a:off x="658368" y="4114800"/>
+            <a:ext cx="10874959" cy="1188720"/>
+          </a:xfrm>
+          <a:prstGeom prst="rect">
+            <a:avLst/>
+          </a:prstGeom>
+          <a:noFill/>
+        </p:spPr>
+        <p:txBody>
+          <a:bodyPr wrap="square" anchor="t" lIns="0" rIns="0" tIns="0" bIns="0">
+            <a:spAutoFit/>
+          </a:bodyPr>
+          <a:lstStyle/>
+          <a:p>
+            <a:pPr algn="l">
+              <a:lnSpc>
+                <a:spcPct val="134000"/>
+              </a:lnSpc>
+              <a:spcAft>
+                <a:spcPts val="0"/>
+              </a:spcAft>
+            </a:pPr>
+            <a:r>
+              <a:rPr sz="1250" b="0" i="0">
+                <a:solidFill>
+                  <a:srgbClr val="161616"/>
+                </a:solidFill>
+                <a:latin typeface="IBM Plex Sans"/>
+              </a:rPr>
+              <a:t>Same agent, same 57 cases, same opening prompt, same formulary, same gate, same scorer. Paired within patient, the debate ends on an inadequate drug where the control ends on an adequate one in 7 pairs and the reverse in 0. Exact McNemar p = 0.0156.</a:t>
+            </a:r>
+          </a:p>
+        </p:txBody>
+      </p:sp>
+      <p:sp>
+        <p:nvSpPr>
+          <p:cNvPr id="20" name="TextBox 19"/>
+          <p:cNvSpPr txBox="1"/>
+          <p:nvPr/>
+        </p:nvSpPr>
+        <p:spPr>
+          <a:xfrm>
+            <a:off x="658368" y="5230368"/>
+            <a:ext cx="10874959" cy="914400"/>
+          </a:xfrm>
+          <a:prstGeom prst="rect">
+            <a:avLst/>
+          </a:prstGeom>
+          <a:noFill/>
+        </p:spPr>
+        <p:txBody>
+          <a:bodyPr wrap="square" anchor="t" lIns="0" rIns="0" tIns="0" bIns="0">
+            <a:spAutoFit/>
+          </a:bodyPr>
+          <a:lstStyle/>
+          <a:p>
+            <a:pPr algn="l">
+              <a:lnSpc>
+                <a:spcPct val="130000"/>
+              </a:lnSpc>
+              <a:spcAft>
+                <a:spcPts val="0"/>
+              </a:spcAft>
+            </a:pPr>
+            <a:r>
+              <a:rPr sz="1150" b="0" i="0">
+                <a:solidFill>
+                  <a:srgbClr val="525252"/>
+                </a:solidFill>
+                <a:latin typeface="IBM Plex Sans"/>
+              </a:rPr>
+              <a:t>What it does not hold constant is context length: the debate transcript is about twice as long by the final turn. A length-matched control is the next thing this needs.</a:t>
+            </a:r>
+          </a:p>
+        </p:txBody>
+      </p:sp>
+      <p:sp>
+        <p:nvSpPr>
+          <p:cNvPr id="21" name="Rectangle 20"/>
+          <p:cNvSpPr/>
+          <p:nvPr/>
+        </p:nvSpPr>
+        <p:spPr>
+          <a:xfrm>
+            <a:off x="658368" y="6181344"/>
+            <a:ext cx="10874959" cy="7315"/>
+          </a:xfrm>
+          <a:prstGeom prst="rect">
+            <a:avLst/>
+          </a:prstGeom>
+          <a:solidFill>
+            <a:srgbClr val="E0E0E0"/>
+          </a:solidFill>
+          <a:ln>
+            <a:noFill/>
+          </a:ln>
+          <a:effectLst/>
+        </p:spPr>
+        <p:style>
+          <a:lnRef idx="1">
+            <a:schemeClr val="accent1"/>
+          </a:lnRef>
+          <a:fillRef idx="3">
+            <a:schemeClr val="accent1"/>
+          </a:fillRef>
+          <a:effectRef idx="2">
+            <a:schemeClr val="accent1"/>
+          </a:effectRef>
+          <a:fontRef idx="minor">
+            <a:schemeClr val="lt1"/>
+          </a:fontRef>
+        </p:style>
+        <p:txBody>
+          <a:bodyPr rtlCol="0" anchor="ctr"/>
+          <a:lstStyle/>
+          <a:p>
+            <a:pPr algn="ctr"/>
+          </a:p>
+        </p:txBody>
+      </p:sp>
+      <p:sp>
+        <p:nvSpPr>
+          <p:cNvPr id="22" name="TextBox 21"/>
+          <p:cNvSpPr txBox="1"/>
+          <p:nvPr/>
+        </p:nvSpPr>
+        <p:spPr>
+          <a:xfrm>
+            <a:off x="658368" y="6327648"/>
+            <a:ext cx="9777679" cy="274320"/>
+          </a:xfrm>
+          <a:prstGeom prst="rect">
+            <a:avLst/>
+          </a:prstGeom>
+          <a:noFill/>
+        </p:spPr>
+        <p:txBody>
+          <a:bodyPr wrap="square" anchor="t" lIns="0" rIns="0" tIns="0" bIns="0">
+            <a:spAutoFit/>
+          </a:bodyPr>
+          <a:lstStyle/>
+          <a:p>
+            <a:pPr algn="l">
+              <a:lnSpc>
+                <a:spcPct val="128000"/>
+              </a:lnSpc>
+              <a:spcAft>
+                <a:spcPts val="0"/>
+              </a:spcAft>
+            </a:pPr>
+            <a:r>
+              <a:rPr sz="950" b="0" i="0">
+                <a:solidFill>
+                  <a:srgbClr val="525252"/>
+                </a:solidFill>
+                <a:latin typeface="IBM Plex Sans"/>
+              </a:rPr>
+              <a:t>results/selfrevision_control.json  ·  analysis/selfrevision_control.py  ·  selfrevise_run.py</a:t>
+            </a:r>
+          </a:p>
+        </p:txBody>
+      </p:sp>
+      <p:sp>
+        <p:nvSpPr>
+          <p:cNvPr id="23" name="TextBox 22"/>
+          <p:cNvSpPr txBox="1"/>
+          <p:nvPr/>
+        </p:nvSpPr>
+        <p:spPr>
+          <a:xfrm>
+            <a:off x="10618927" y="6327648"/>
+            <a:ext cx="914400" cy="274320"/>
+          </a:xfrm>
+          <a:prstGeom prst="rect">
+            <a:avLst/>
+          </a:prstGeom>
+          <a:noFill/>
+        </p:spPr>
+        <p:txBody>
+          <a:bodyPr wrap="square" anchor="t" lIns="0" rIns="0" tIns="0" bIns="0">
+            <a:spAutoFit/>
+          </a:bodyPr>
+          <a:lstStyle/>
+          <a:p>
+            <a:pPr algn="r">
+              <a:lnSpc>
+                <a:spcPct val="128000"/>
+              </a:lnSpc>
+              <a:spcAft>
+                <a:spcPts val="0"/>
+              </a:spcAft>
+            </a:pPr>
+            <a:r>
+              <a:rPr sz="950" b="0" i="0">
+                <a:solidFill>
+                  <a:srgbClr val="525252"/>
+                </a:solidFill>
+                <a:latin typeface="IBM Plex Sans"/>
+              </a:rPr>
+              <a:t>26</a:t>
             </a:r>
           </a:p>
         </p:txBody>

</xml_diff>

<commit_message>
A spine limitation said an arm was still short and completing when it was neither
The heading read 'One superseded arm is still short' above a sentence saying the arm held 312 of a
planned 312, and claimed it was completing when it had completed. Both halves now derive from the
integrity block and the heading says what is actually true: the arm was superseded before it was
used.

Co-Authored-By: Claude Opus 5 (1M context) <noreply@anthropic.com>
</commit_message>
<xml_diff>
--- a/deck/Shomique_Hayat_UNIQ_antibiotic_agents.pptx
+++ b/deck/Shomique_Hayat_UNIQ_antibiotic_agents.pptx
@@ -3276,7 +3276,7 @@
           </a:p>
           <a:p>
             <a:r>
-              <a:t>So I ran the control. One agent, the same specialist, the same 57 frozen cases, the same round-0</a:t>
+              <a:t>So I ran the control. One agent, the same specialist, the same 80 frozen cases, the same round-0</a:t>
             </a:r>
           </a:p>
           <a:p>
@@ -3296,17 +3296,17 @@
           </a:p>
           <a:p>
             <a:r>
-              <a:t>With a counterpart it changes its drug in every run. Without one, 4 of 57.</a:t>
-            </a:r>
-          </a:p>
-          <a:p>
-            <a:r>
-              <a:t>Coverage is 89.5 per cent against 78.9, and harmful revision is 0 per cent against 14.3.</a:t>
-            </a:r>
-          </a:p>
-          <a:p>
-            <a:r>
-              <a:t>Paired within patient, exact McNemar p = 0.0156.</a:t>
+              <a:t>With a counterpart it changes its drug in every run. Without one, 4 of 80.</a:t>
+            </a:r>
+          </a:p>
+          <a:p>
+            <a:r>
+              <a:t>Coverage is 88.8 per cent against 76.2, and harmful revision is 0 per cent against 14.7.</a:t>
+            </a:r>
+          </a:p>
+          <a:p>
+            <a:r>
+              <a:t>Paired within patient, exact McNemar p = 0.00195.</a:t>
             </a:r>
           </a:p>
           <a:p>
@@ -3326,7 +3326,7 @@
           </a:p>
           <a:p>
             <a:r>
-              <a:t>Say the coverage out loud too: 57 of 200 cases, a contiguous prefix, run against the clock.</a:t>
+              <a:t>Say the coverage out loud too: 80 of 200 cases, a contiguous prefix, run against the clock.</a:t>
             </a:r>
           </a:p>
         </p:txBody>
@@ -12295,7 +12295,7 @@
                 </a:solidFill>
                 <a:latin typeface="IBM Plex Sans"/>
               </a:rPr>
-              <a:t>One superseded arm is still short</a:t>
+              <a:t>One arm was superseded before it was used</a:t>
             </a:r>
           </a:p>
         </p:txBody>
@@ -12337,7 +12337,7 @@
                 </a:solidFill>
                 <a:latin typeface="IBM Plex Sans"/>
               </a:rPr>
-              <a:t>The plausible-wrong seeding arm holds 312 of a planned 312 exposures. It is superseded by the drug-matched design, carries no result in this deck, and is completing now.</a:t>
+              <a:t>The plausible-wrong seeding arm reached its planned 312 exposures and is superseded by the drug-matched design, which holds the drug name fixed and varies the patient instead. It carries no result in this deck.</a:t>
             </a:r>
           </a:p>
         </p:txBody>
@@ -31363,7 +31363,7 @@
                 </a:solidFill>
                 <a:latin typeface="IBM Plex Sans"/>
               </a:rPr>
-              <a:t>57 of 57</a:t>
+              <a:t>80 of 80</a:t>
             </a:r>
           </a:p>
         </p:txBody>
@@ -31405,7 +31405,7 @@
                 </a:solidFill>
                 <a:latin typeface="IBM Plex Sans"/>
               </a:rPr>
-              <a:t>4 of 57</a:t>
+              <a:t>4 of 80</a:t>
             </a:r>
           </a:p>
         </p:txBody>
@@ -31533,7 +31533,7 @@
                 </a:solidFill>
                 <a:latin typeface="IBM Plex Sans"/>
               </a:rPr>
-              <a:t>78.9%</a:t>
+              <a:t>76.2%</a:t>
             </a:r>
           </a:p>
         </p:txBody>
@@ -31575,7 +31575,7 @@
                 </a:solidFill>
                 <a:latin typeface="IBM Plex Sans"/>
               </a:rPr>
-              <a:t>89.5%</a:t>
+              <a:t>88.8%</a:t>
             </a:r>
           </a:p>
         </p:txBody>
@@ -31703,7 +31703,7 @@
                 </a:solidFill>
                 <a:latin typeface="IBM Plex Sans"/>
               </a:rPr>
-              <a:t>14.3%</a:t>
+              <a:t>14.7%</a:t>
             </a:r>
           </a:p>
         </p:txBody>
@@ -31787,7 +31787,7 @@
                 </a:solidFill>
                 <a:latin typeface="IBM Plex Sans"/>
               </a:rPr>
-              <a:t>Same agent, same 57 cases, same opening prompt, same formulary, same gate, same scorer. Paired within patient, the debate ends on an inadequate drug where the control ends on an adequate one in 7 pairs and the reverse in 0. Exact McNemar p = 0.0156.</a:t>
+              <a:t>Same agent, same 80 cases, same opening prompt, same formulary, same gate, same scorer. Paired within patient, the debate ends on an inadequate drug where the control ends on an adequate one in 10 pairs and the reverse in 0. Exact McNemar p = 0.00195.</a:t>
             </a:r>
           </a:p>
         </p:txBody>

</xml_diff>

<commit_message>
The answer slide put two different arms in one row
Its panel row paired a harmful revision rate from the clean-context arm, measured from the round-0
position over 200 runs, with a coverage change from the reveal arm, measured after the debate over
400 runs. Read together they described an experiment nobody ran.

The row is now the reveal arm throughout, which is also the better story: the panel arrives after
the damage and undoes it, pushing nobody off an adequate drug while coverage rises 17.2 points. The
debate row now says five turns so the rows are visibly different conditions, and the closing slide's
near-zero figure names its arm, the one where the panel replaces the debate rather than following
it. The speaker notes say which is which.

Co-Authored-By: Claude Opus 5 (1M context) <noreply@anthropic.com>
</commit_message>
<xml_diff>
--- a/deck/Shomique_Hayat_UNIQ_antibiotic_agents.pptx
+++ b/deck/Shomique_Hayat_UNIQ_antibiotic_agents.pptx
@@ -1052,12 +1052,22 @@
           </a:p>
           <a:p>
             <a:r>
-              <a:t>Then give the same system the laboratory panel. Harmful revision is 1.1 per cent, and coverage rises</a:t>
-            </a:r>
-          </a:p>
-          <a:p>
-            <a:r>
-              <a:t>17.2 points to 95.2 per cent.</a:t>
+              <a:t>Then give the same system the laboratory panel, after the debate has already moved it. It pushes</a:t>
+            </a:r>
+          </a:p>
+          <a:p>
+            <a:r>
+              <a:t>nobody off an adequate drug, and coverage rises 17.2 points to 95.2 per cent.</a:t>
+            </a:r>
+          </a:p>
+          <a:p>
+            <a:r>
+              <a:t>If someone asks about the panel replacing the debate rather than following it, that is a different</a:t>
+            </a:r>
+          </a:p>
+          <a:p>
+            <a:r>
+              <a:t>arm and its harmful revision rate is 1.1 per cent, on the closing slide.</a:t>
             </a:r>
           </a:p>
           <a:p>
@@ -10015,7 +10025,7 @@
                 </a:solidFill>
                 <a:latin typeface="IBM Plex Sans"/>
               </a:rPr>
-              <a:t>a second agent arguing a case</a:t>
+              <a:t>a second agent arguing a case, five turns</a:t>
             </a:r>
           </a:p>
         </p:txBody>
@@ -10185,7 +10195,7 @@
                 </a:solidFill>
                 <a:latin typeface="IBM Plex Sans"/>
               </a:rPr>
-              <a:t>the susceptibility panel</a:t>
+              <a:t>the susceptibility panel, after the debate</a:t>
             </a:r>
           </a:p>
         </p:txBody>
@@ -10227,7 +10237,7 @@
                 </a:solidFill>
                 <a:latin typeface="IBM Plex Sans"/>
               </a:rPr>
-              <a:t>1.1%</a:t>
+              <a:t>0.0%</a:t>
             </a:r>
           </a:p>
         </p:txBody>
@@ -13525,8 +13535,8 @@
                 </a:solidFill>
                 <a:latin typeface="IBM Plex Sans"/>
               </a:rPr>
-              <a:t>harmful revision when
-the evidence is real</a:t>
+              <a:t>harmful revision when the
+panel replaces the debate</a:t>
             </a:r>
           </a:p>
         </p:txBody>

</xml_diff>

<commit_message>
Put the null arm at the top of the trigger table, where it makes the rest readable
Asked to reconsider with nothing at all to react to, the model moves in no case, corrects in no
case, and leaves exactly one drug in play across the whole cohort. Without that row the table
invites the reading that the model is simply unstable. With it, nothing below is drift or a decoding
artefact: something has to be said to it before it moves.

Co-Authored-By: Claude Opus 5 (1M context) <noreply@anthropic.com>
</commit_message>
<xml_diff>
--- a/deck/Shomique_Hayat_UNIQ_antibiotic_agents.pptx
+++ b/deck/Shomique_Hayat_UNIQ_antibiotic_agents.pptx
@@ -28763,7 +28763,7 @@
         </p:nvSpPr>
         <p:spPr>
           <a:xfrm>
-            <a:off x="658368" y="2148840"/>
+            <a:off x="658368" y="2084831"/>
             <a:ext cx="3587758" cy="384048"/>
           </a:xfrm>
           <a:prstGeom prst="rect">
@@ -28805,7 +28805,7 @@
         </p:nvSpPr>
         <p:spPr>
           <a:xfrm>
-            <a:off x="4355854" y="2148840"/>
+            <a:off x="4355854" y="2084831"/>
             <a:ext cx="977767" cy="384048"/>
           </a:xfrm>
           <a:prstGeom prst="rect">
@@ -28847,7 +28847,7 @@
         </p:nvSpPr>
         <p:spPr>
           <a:xfrm>
-            <a:off x="5443350" y="2148840"/>
+            <a:off x="5443350" y="2084831"/>
             <a:ext cx="1956514" cy="384048"/>
           </a:xfrm>
           <a:prstGeom prst="rect">
@@ -28889,7 +28889,7 @@
         </p:nvSpPr>
         <p:spPr>
           <a:xfrm>
-            <a:off x="7509592" y="2148840"/>
+            <a:off x="7509592" y="2084831"/>
             <a:ext cx="2174013" cy="384048"/>
           </a:xfrm>
           <a:prstGeom prst="rect">
@@ -28931,7 +28931,7 @@
         </p:nvSpPr>
         <p:spPr>
           <a:xfrm>
-            <a:off x="9793333" y="2148840"/>
+            <a:off x="9793333" y="2084831"/>
             <a:ext cx="1630265" cy="384048"/>
           </a:xfrm>
           <a:prstGeom prst="rect">
@@ -28973,7 +28973,7 @@
         </p:nvSpPr>
         <p:spPr>
           <a:xfrm>
-            <a:off x="658368" y="2532888"/>
+            <a:off x="658368" y="2468879"/>
             <a:ext cx="10874959" cy="10972"/>
           </a:xfrm>
           <a:prstGeom prst="rect">
@@ -29017,8 +29017,8 @@
         </p:nvSpPr>
         <p:spPr>
           <a:xfrm>
-            <a:off x="658368" y="2715768"/>
-            <a:ext cx="3587758" cy="384048"/>
+            <a:off x="658368" y="2651760"/>
+            <a:ext cx="3587758" cy="365760"/>
           </a:xfrm>
           <a:prstGeom prst="rect">
             <a:avLst/>
@@ -29040,13 +29040,13 @@
               </a:spcAft>
             </a:pPr>
             <a:r>
-              <a:rPr sz="1250" b="0" i="0">
+              <a:rPr sz="1200" b="0" i="0">
                 <a:solidFill>
                   <a:srgbClr val="161616"/>
                 </a:solidFill>
                 <a:latin typeface="IBM Plex Sans"/>
               </a:rPr>
-              <a:t>authority</a:t>
+              <a:t>nothing, a neutral re-ask</a:t>
             </a:r>
           </a:p>
         </p:txBody>
@@ -29059,8 +29059,8 @@
         </p:nvSpPr>
         <p:spPr>
           <a:xfrm>
-            <a:off x="4355854" y="2715768"/>
-            <a:ext cx="977767" cy="384048"/>
+            <a:off x="4355854" y="2651760"/>
+            <a:ext cx="977767" cy="365760"/>
           </a:xfrm>
           <a:prstGeom prst="rect">
             <a:avLst/>
@@ -29082,7 +29082,7 @@
               </a:spcAft>
             </a:pPr>
             <a:r>
-              <a:rPr sz="1250" b="0" i="0">
+              <a:rPr sz="1200" b="0" i="0">
                 <a:solidFill>
                   <a:srgbClr val="161616"/>
                 </a:solidFill>
@@ -29101,8 +29101,8 @@
         </p:nvSpPr>
         <p:spPr>
           <a:xfrm>
-            <a:off x="5443350" y="2715768"/>
-            <a:ext cx="1956514" cy="384048"/>
+            <a:off x="5443350" y="2651760"/>
+            <a:ext cx="1956514" cy="365760"/>
           </a:xfrm>
           <a:prstGeom prst="rect">
             <a:avLst/>
@@ -29124,13 +29124,13 @@
               </a:spcAft>
             </a:pPr>
             <a:r>
-              <a:rPr sz="1250" b="0" i="0">
+              <a:rPr sz="1200" b="0" i="0">
                 <a:solidFill>
                   <a:srgbClr val="161616"/>
                 </a:solidFill>
                 <a:latin typeface="IBM Plex Sans"/>
               </a:rPr>
-              <a:t>2.3%</a:t>
+              <a:t>0%</a:t>
             </a:r>
           </a:p>
         </p:txBody>
@@ -29143,8 +29143,8 @@
         </p:nvSpPr>
         <p:spPr>
           <a:xfrm>
-            <a:off x="7509592" y="2715768"/>
-            <a:ext cx="2174013" cy="384048"/>
+            <a:off x="7509592" y="2651760"/>
+            <a:ext cx="2174013" cy="365760"/>
           </a:xfrm>
           <a:prstGeom prst="rect">
             <a:avLst/>
@@ -29166,13 +29166,13 @@
               </a:spcAft>
             </a:pPr>
             <a:r>
-              <a:rPr sz="1250" b="0" i="0">
+              <a:rPr sz="1200" b="0" i="0">
                 <a:solidFill>
                   <a:srgbClr val="161616"/>
                 </a:solidFill>
                 <a:latin typeface="IBM Plex Sans"/>
               </a:rPr>
-              <a:t>81.8%</a:t>
+              <a:t>0%</a:t>
             </a:r>
           </a:p>
         </p:txBody>
@@ -29185,8 +29185,8 @@
         </p:nvSpPr>
         <p:spPr>
           <a:xfrm>
-            <a:off x="9793333" y="2715768"/>
-            <a:ext cx="1630265" cy="384048"/>
+            <a:off x="9793333" y="2651760"/>
+            <a:ext cx="1630265" cy="365760"/>
           </a:xfrm>
           <a:prstGeom prst="rect">
             <a:avLst/>
@@ -29208,13 +29208,13 @@
               </a:spcAft>
             </a:pPr>
             <a:r>
-              <a:rPr sz="1250" b="0" i="0">
+              <a:rPr sz="1200" b="0" i="0">
                 <a:solidFill>
                   <a:srgbClr val="161616"/>
                 </a:solidFill>
                 <a:latin typeface="IBM Plex Sans"/>
               </a:rPr>
-              <a:t>5</a:t>
+              <a:t>1</a:t>
             </a:r>
           </a:p>
         </p:txBody>
@@ -29227,7 +29227,7 @@
         </p:nvSpPr>
         <p:spPr>
           <a:xfrm>
-            <a:off x="658368" y="3026664"/>
+            <a:off x="658368" y="2944368"/>
             <a:ext cx="10874959" cy="5486"/>
           </a:xfrm>
           <a:prstGeom prst="rect">
@@ -29271,8 +29271,8 @@
         </p:nvSpPr>
         <p:spPr>
           <a:xfrm>
-            <a:off x="658368" y="3099816"/>
-            <a:ext cx="3587758" cy="384048"/>
+            <a:off x="658368" y="3017520"/>
+            <a:ext cx="3587758" cy="365760"/>
           </a:xfrm>
           <a:prstGeom prst="rect">
             <a:avLst/>
@@ -29294,13 +29294,13 @@
               </a:spcAft>
             </a:pPr>
             <a:r>
-              <a:rPr sz="1250" b="0" i="0">
+              <a:rPr sz="1200" b="0" i="0">
                 <a:solidFill>
                   <a:srgbClr val="161616"/>
                 </a:solidFill>
                 <a:latin typeface="IBM Plex Sans"/>
               </a:rPr>
-              <a:t>peer consensus</a:t>
+              <a:t>authority</a:t>
             </a:r>
           </a:p>
         </p:txBody>
@@ -29313,8 +29313,8 @@
         </p:nvSpPr>
         <p:spPr>
           <a:xfrm>
-            <a:off x="4355854" y="3099816"/>
-            <a:ext cx="977767" cy="384048"/>
+            <a:off x="4355854" y="3017520"/>
+            <a:ext cx="977767" cy="365760"/>
           </a:xfrm>
           <a:prstGeom prst="rect">
             <a:avLst/>
@@ -29336,7 +29336,7 @@
               </a:spcAft>
             </a:pPr>
             <a:r>
-              <a:rPr sz="1250" b="0" i="0">
+              <a:rPr sz="1200" b="0" i="0">
                 <a:solidFill>
                   <a:srgbClr val="161616"/>
                 </a:solidFill>
@@ -29355,8 +29355,8 @@
         </p:nvSpPr>
         <p:spPr>
           <a:xfrm>
-            <a:off x="5443350" y="3099816"/>
-            <a:ext cx="1956514" cy="384048"/>
+            <a:off x="5443350" y="3017520"/>
+            <a:ext cx="1956514" cy="365760"/>
           </a:xfrm>
           <a:prstGeom prst="rect">
             <a:avLst/>
@@ -29378,13 +29378,13 @@
               </a:spcAft>
             </a:pPr>
             <a:r>
-              <a:rPr sz="1250" b="0" i="0">
+              <a:rPr sz="1200" b="0" i="0">
                 <a:solidFill>
                   <a:srgbClr val="161616"/>
                 </a:solidFill>
                 <a:latin typeface="IBM Plex Sans"/>
               </a:rPr>
-              <a:t>1.1%</a:t>
+              <a:t>2.3%</a:t>
             </a:r>
           </a:p>
         </p:txBody>
@@ -29397,8 +29397,8 @@
         </p:nvSpPr>
         <p:spPr>
           <a:xfrm>
-            <a:off x="7509592" y="3099816"/>
-            <a:ext cx="2174013" cy="384048"/>
+            <a:off x="7509592" y="3017520"/>
+            <a:ext cx="2174013" cy="365760"/>
           </a:xfrm>
           <a:prstGeom prst="rect">
             <a:avLst/>
@@ -29420,7 +29420,7 @@
               </a:spcAft>
             </a:pPr>
             <a:r>
-              <a:rPr sz="1250" b="0" i="0">
+              <a:rPr sz="1200" b="0" i="0">
                 <a:solidFill>
                   <a:srgbClr val="161616"/>
                 </a:solidFill>
@@ -29439,8 +29439,8 @@
         </p:nvSpPr>
         <p:spPr>
           <a:xfrm>
-            <a:off x="9793333" y="3099816"/>
-            <a:ext cx="1630265" cy="384048"/>
+            <a:off x="9793333" y="3017520"/>
+            <a:ext cx="1630265" cy="365760"/>
           </a:xfrm>
           <a:prstGeom prst="rect">
             <a:avLst/>
@@ -29462,13 +29462,13 @@
               </a:spcAft>
             </a:pPr>
             <a:r>
-              <a:rPr sz="1250" b="0" i="0">
+              <a:rPr sz="1200" b="0" i="0">
                 <a:solidFill>
                   <a:srgbClr val="161616"/>
                 </a:solidFill>
                 <a:latin typeface="IBM Plex Sans"/>
               </a:rPr>
-              <a:t>4</a:t>
+              <a:t>5</a:t>
             </a:r>
           </a:p>
         </p:txBody>
@@ -29481,7 +29481,7 @@
         </p:nvSpPr>
         <p:spPr>
           <a:xfrm>
-            <a:off x="658368" y="3410712"/>
+            <a:off x="658368" y="3310127"/>
             <a:ext cx="10874959" cy="5486"/>
           </a:xfrm>
           <a:prstGeom prst="rect">
@@ -29525,8 +29525,8 @@
         </p:nvSpPr>
         <p:spPr>
           <a:xfrm>
-            <a:off x="658368" y="3483864"/>
-            <a:ext cx="3587758" cy="384048"/>
+            <a:off x="658368" y="3383279"/>
+            <a:ext cx="3587758" cy="365760"/>
           </a:xfrm>
           <a:prstGeom prst="rect">
             <a:avLst/>
@@ -29548,13 +29548,13 @@
               </a:spcAft>
             </a:pPr>
             <a:r>
-              <a:rPr sz="1250" b="0" i="0">
+              <a:rPr sz="1200" b="0" i="0">
                 <a:solidFill>
                   <a:srgbClr val="161616"/>
                 </a:solidFill>
                 <a:latin typeface="IBM Plex Sans"/>
               </a:rPr>
-              <a:t>safety framing</a:t>
+              <a:t>peer consensus</a:t>
             </a:r>
           </a:p>
         </p:txBody>
@@ -29567,8 +29567,8 @@
         </p:nvSpPr>
         <p:spPr>
           <a:xfrm>
-            <a:off x="4355854" y="3483864"/>
-            <a:ext cx="977767" cy="384048"/>
+            <a:off x="4355854" y="3383279"/>
+            <a:ext cx="977767" cy="365760"/>
           </a:xfrm>
           <a:prstGeom prst="rect">
             <a:avLst/>
@@ -29590,7 +29590,7 @@
               </a:spcAft>
             </a:pPr>
             <a:r>
-              <a:rPr sz="1250" b="0" i="0">
+              <a:rPr sz="1200" b="0" i="0">
                 <a:solidFill>
                   <a:srgbClr val="161616"/>
                 </a:solidFill>
@@ -29609,8 +29609,8 @@
         </p:nvSpPr>
         <p:spPr>
           <a:xfrm>
-            <a:off x="5443350" y="3483864"/>
-            <a:ext cx="1956514" cy="384048"/>
+            <a:off x="5443350" y="3383279"/>
+            <a:ext cx="1956514" cy="365760"/>
           </a:xfrm>
           <a:prstGeom prst="rect">
             <a:avLst/>
@@ -29632,13 +29632,13 @@
               </a:spcAft>
             </a:pPr>
             <a:r>
-              <a:rPr sz="1250" b="0" i="0">
+              <a:rPr sz="1200" b="0" i="0">
                 <a:solidFill>
                   <a:srgbClr val="161616"/>
                 </a:solidFill>
                 <a:latin typeface="IBM Plex Sans"/>
               </a:rPr>
-              <a:t>3.5%</a:t>
+              <a:t>1.1%</a:t>
             </a:r>
           </a:p>
         </p:txBody>
@@ -29651,8 +29651,8 @@
         </p:nvSpPr>
         <p:spPr>
           <a:xfrm>
-            <a:off x="7509592" y="3483864"/>
-            <a:ext cx="2174013" cy="384048"/>
+            <a:off x="7509592" y="3383279"/>
+            <a:ext cx="2174013" cy="365760"/>
           </a:xfrm>
           <a:prstGeom prst="rect">
             <a:avLst/>
@@ -29674,13 +29674,13 @@
               </a:spcAft>
             </a:pPr>
             <a:r>
-              <a:rPr sz="1250" b="0" i="0">
+              <a:rPr sz="1200" b="0" i="0">
                 <a:solidFill>
                   <a:srgbClr val="161616"/>
                 </a:solidFill>
                 <a:latin typeface="IBM Plex Sans"/>
               </a:rPr>
-              <a:t>72.7%</a:t>
+              <a:t>81.8%</a:t>
             </a:r>
           </a:p>
         </p:txBody>
@@ -29693,8 +29693,8 @@
         </p:nvSpPr>
         <p:spPr>
           <a:xfrm>
-            <a:off x="9793333" y="3483864"/>
-            <a:ext cx="1630265" cy="384048"/>
+            <a:off x="9793333" y="3383279"/>
+            <a:ext cx="1630265" cy="365760"/>
           </a:xfrm>
           <a:prstGeom prst="rect">
             <a:avLst/>
@@ -29716,13 +29716,13 @@
               </a:spcAft>
             </a:pPr>
             <a:r>
-              <a:rPr sz="1250" b="0" i="0">
+              <a:rPr sz="1200" b="0" i="0">
                 <a:solidFill>
                   <a:srgbClr val="161616"/>
                 </a:solidFill>
                 <a:latin typeface="IBM Plex Sans"/>
               </a:rPr>
-              <a:t>3</a:t>
+              <a:t>4</a:t>
             </a:r>
           </a:p>
         </p:txBody>
@@ -29735,7 +29735,7 @@
         </p:nvSpPr>
         <p:spPr>
           <a:xfrm>
-            <a:off x="658368" y="3794760"/>
+            <a:off x="658368" y="3675888"/>
             <a:ext cx="10874959" cy="5486"/>
           </a:xfrm>
           <a:prstGeom prst="rect">
@@ -29779,8 +29779,8 @@
         </p:nvSpPr>
         <p:spPr>
           <a:xfrm>
-            <a:off x="658368" y="3867911"/>
-            <a:ext cx="3587758" cy="384048"/>
+            <a:off x="658368" y="3749039"/>
+            <a:ext cx="3587758" cy="365760"/>
           </a:xfrm>
           <a:prstGeom prst="rect">
             <a:avLst/>
@@ -29802,13 +29802,13 @@
               </a:spcAft>
             </a:pPr>
             <a:r>
-              <a:rPr sz="1250" b="0" i="0">
+              <a:rPr sz="1200" b="0" i="0">
                 <a:solidFill>
                   <a:srgbClr val="161616"/>
                 </a:solidFill>
                 <a:latin typeface="IBM Plex Sans"/>
               </a:rPr>
-              <a:t>bare doubt</a:t>
+              <a:t>safety framing</a:t>
             </a:r>
           </a:p>
         </p:txBody>
@@ -29821,8 +29821,8 @@
         </p:nvSpPr>
         <p:spPr>
           <a:xfrm>
-            <a:off x="4355854" y="3867911"/>
-            <a:ext cx="977767" cy="384048"/>
+            <a:off x="4355854" y="3749039"/>
+            <a:ext cx="977767" cy="365760"/>
           </a:xfrm>
           <a:prstGeom prst="rect">
             <a:avLst/>
@@ -29844,7 +29844,7 @@
               </a:spcAft>
             </a:pPr>
             <a:r>
-              <a:rPr sz="1250" b="0" i="0">
+              <a:rPr sz="1200" b="0" i="0">
                 <a:solidFill>
                   <a:srgbClr val="161616"/>
                 </a:solidFill>
@@ -29863,8 +29863,8 @@
         </p:nvSpPr>
         <p:spPr>
           <a:xfrm>
-            <a:off x="5443350" y="3867911"/>
-            <a:ext cx="1956514" cy="384048"/>
+            <a:off x="5443350" y="3749039"/>
+            <a:ext cx="1956514" cy="365760"/>
           </a:xfrm>
           <a:prstGeom prst="rect">
             <a:avLst/>
@@ -29886,13 +29886,13 @@
               </a:spcAft>
             </a:pPr>
             <a:r>
-              <a:rPr sz="1250" b="0" i="0">
+              <a:rPr sz="1200" b="0" i="0">
                 <a:solidFill>
                   <a:srgbClr val="161616"/>
                 </a:solidFill>
                 <a:latin typeface="IBM Plex Sans"/>
               </a:rPr>
-              <a:t>1.7%</a:t>
+              <a:t>3.5%</a:t>
             </a:r>
           </a:p>
         </p:txBody>
@@ -29905,8 +29905,8 @@
         </p:nvSpPr>
         <p:spPr>
           <a:xfrm>
-            <a:off x="7509592" y="3867911"/>
-            <a:ext cx="2174013" cy="384048"/>
+            <a:off x="7509592" y="3749039"/>
+            <a:ext cx="2174013" cy="365760"/>
           </a:xfrm>
           <a:prstGeom prst="rect">
             <a:avLst/>
@@ -29928,13 +29928,13 @@
               </a:spcAft>
             </a:pPr>
             <a:r>
-              <a:rPr sz="1250" b="0" i="0">
+              <a:rPr sz="1200" b="0" i="0">
                 <a:solidFill>
                   <a:srgbClr val="161616"/>
                 </a:solidFill>
                 <a:latin typeface="IBM Plex Sans"/>
               </a:rPr>
-              <a:t>66.7%</a:t>
+              <a:t>72.7%</a:t>
             </a:r>
           </a:p>
         </p:txBody>
@@ -29947,8 +29947,8 @@
         </p:nvSpPr>
         <p:spPr>
           <a:xfrm>
-            <a:off x="9793333" y="3867911"/>
-            <a:ext cx="1630265" cy="384048"/>
+            <a:off x="9793333" y="3749039"/>
+            <a:ext cx="1630265" cy="365760"/>
           </a:xfrm>
           <a:prstGeom prst="rect">
             <a:avLst/>
@@ -29970,7 +29970,7 @@
               </a:spcAft>
             </a:pPr>
             <a:r>
-              <a:rPr sz="1250" b="0" i="0">
+              <a:rPr sz="1200" b="0" i="0">
                 <a:solidFill>
                   <a:srgbClr val="161616"/>
                 </a:solidFill>
@@ -29989,7 +29989,7 @@
         </p:nvSpPr>
         <p:spPr>
           <a:xfrm>
-            <a:off x="658368" y="4178808"/>
+            <a:off x="658368" y="4041648"/>
             <a:ext cx="10874959" cy="5486"/>
           </a:xfrm>
           <a:prstGeom prst="rect">
@@ -30033,8 +30033,8 @@
         </p:nvSpPr>
         <p:spPr>
           <a:xfrm>
-            <a:off x="658368" y="4251959"/>
-            <a:ext cx="3587758" cy="384048"/>
+            <a:off x="658368" y="4114800"/>
+            <a:ext cx="3587758" cy="365760"/>
           </a:xfrm>
           <a:prstGeom prst="rect">
             <a:avLst/>
@@ -30056,13 +30056,13 @@
               </a:spcAft>
             </a:pPr>
             <a:r>
-              <a:rPr sz="1250" b="1" i="0">
+              <a:rPr sz="1200" b="0" i="0">
                 <a:solidFill>
                   <a:srgbClr val="161616"/>
                 </a:solidFill>
                 <a:latin typeface="IBM Plex Sans"/>
               </a:rPr>
-              <a:t>the susceptibility panel</a:t>
+              <a:t>bare doubt</a:t>
             </a:r>
           </a:p>
         </p:txBody>
@@ -30075,8 +30075,8 @@
         </p:nvSpPr>
         <p:spPr>
           <a:xfrm>
-            <a:off x="4355854" y="4251959"/>
-            <a:ext cx="977767" cy="384048"/>
+            <a:off x="4355854" y="4114800"/>
+            <a:ext cx="977767" cy="365760"/>
           </a:xfrm>
           <a:prstGeom prst="rect">
             <a:avLst/>
@@ -30098,7 +30098,7 @@
               </a:spcAft>
             </a:pPr>
             <a:r>
-              <a:rPr sz="1250" b="1" i="0">
+              <a:rPr sz="1200" b="0" i="0">
                 <a:solidFill>
                   <a:srgbClr val="161616"/>
                 </a:solidFill>
@@ -30117,8 +30117,8 @@
         </p:nvSpPr>
         <p:spPr>
           <a:xfrm>
-            <a:off x="5443350" y="4251959"/>
-            <a:ext cx="1956514" cy="384048"/>
+            <a:off x="5443350" y="4114800"/>
+            <a:ext cx="1956514" cy="365760"/>
           </a:xfrm>
           <a:prstGeom prst="rect">
             <a:avLst/>
@@ -30140,13 +30140,13 @@
               </a:spcAft>
             </a:pPr>
             <a:r>
-              <a:rPr sz="1250" b="1" i="0">
-                <a:solidFill>
-                  <a:srgbClr val="0F62FE"/>
-                </a:solidFill>
-                <a:latin typeface="IBM Plex Sans"/>
-              </a:rPr>
-              <a:t>1.1%</a:t>
+              <a:rPr sz="1200" b="0" i="0">
+                <a:solidFill>
+                  <a:srgbClr val="161616"/>
+                </a:solidFill>
+                <a:latin typeface="IBM Plex Sans"/>
+              </a:rPr>
+              <a:t>1.7%</a:t>
             </a:r>
           </a:p>
         </p:txBody>
@@ -30159,8 +30159,8 @@
         </p:nvSpPr>
         <p:spPr>
           <a:xfrm>
-            <a:off x="7509592" y="4251959"/>
-            <a:ext cx="2174013" cy="384048"/>
+            <a:off x="7509592" y="4114800"/>
+            <a:ext cx="2174013" cy="365760"/>
           </a:xfrm>
           <a:prstGeom prst="rect">
             <a:avLst/>
@@ -30182,13 +30182,13 @@
               </a:spcAft>
             </a:pPr>
             <a:r>
-              <a:rPr sz="1250" b="1" i="0">
-                <a:solidFill>
-                  <a:srgbClr val="0F62FE"/>
-                </a:solidFill>
-                <a:latin typeface="IBM Plex Sans"/>
-              </a:rPr>
-              <a:t>91.7%</a:t>
+              <a:rPr sz="1200" b="0" i="0">
+                <a:solidFill>
+                  <a:srgbClr val="161616"/>
+                </a:solidFill>
+                <a:latin typeface="IBM Plex Sans"/>
+              </a:rPr>
+              <a:t>66.7%</a:t>
             </a:r>
           </a:p>
         </p:txBody>
@@ -30201,8 +30201,8 @@
         </p:nvSpPr>
         <p:spPr>
           <a:xfrm>
-            <a:off x="9793333" y="4251959"/>
-            <a:ext cx="1630265" cy="384048"/>
+            <a:off x="9793333" y="4114800"/>
+            <a:ext cx="1630265" cy="365760"/>
           </a:xfrm>
           <a:prstGeom prst="rect">
             <a:avLst/>
@@ -30224,13 +30224,13 @@
               </a:spcAft>
             </a:pPr>
             <a:r>
-              <a:rPr sz="1250" b="1" i="0">
-                <a:solidFill>
-                  <a:srgbClr val="0F62FE"/>
-                </a:solidFill>
-                <a:latin typeface="IBM Plex Sans"/>
-              </a:rPr>
-              <a:t>8</a:t>
+              <a:rPr sz="1200" b="0" i="0">
+                <a:solidFill>
+                  <a:srgbClr val="161616"/>
+                </a:solidFill>
+                <a:latin typeface="IBM Plex Sans"/>
+              </a:rPr>
+              <a:t>3</a:t>
             </a:r>
           </a:p>
         </p:txBody>
@@ -30243,7 +30243,7 @@
         </p:nvSpPr>
         <p:spPr>
           <a:xfrm>
-            <a:off x="658368" y="4562856"/>
+            <a:off x="658368" y="4407408"/>
             <a:ext cx="10874959" cy="5486"/>
           </a:xfrm>
           <a:prstGeom prst="rect">
@@ -30287,8 +30287,8 @@
         </p:nvSpPr>
         <p:spPr>
           <a:xfrm>
-            <a:off x="658368" y="4636007"/>
-            <a:ext cx="3587758" cy="384048"/>
+            <a:off x="658368" y="4480560"/>
+            <a:ext cx="3587758" cy="365760"/>
           </a:xfrm>
           <a:prstGeom prst="rect">
             <a:avLst/>
@@ -30310,13 +30310,13 @@
               </a:spcAft>
             </a:pPr>
             <a:r>
-              <a:rPr sz="1250" b="1" i="0">
+              <a:rPr sz="1200" b="1" i="0">
                 <a:solidFill>
                   <a:srgbClr val="161616"/>
                 </a:solidFill>
                 <a:latin typeface="IBM Plex Sans"/>
               </a:rPr>
-              <a:t>a second agent arguing</a:t>
+              <a:t>the susceptibility panel</a:t>
             </a:r>
           </a:p>
         </p:txBody>
@@ -30329,8 +30329,8 @@
         </p:nvSpPr>
         <p:spPr>
           <a:xfrm>
-            <a:off x="4355854" y="4636007"/>
-            <a:ext cx="977767" cy="384048"/>
+            <a:off x="4355854" y="4480560"/>
+            <a:ext cx="977767" cy="365760"/>
           </a:xfrm>
           <a:prstGeom prst="rect">
             <a:avLst/>
@@ -30352,13 +30352,13 @@
               </a:spcAft>
             </a:pPr>
             <a:r>
-              <a:rPr sz="1250" b="1" i="0">
+              <a:rPr sz="1200" b="1" i="0">
                 <a:solidFill>
                   <a:srgbClr val="161616"/>
                 </a:solidFill>
                 <a:latin typeface="IBM Plex Sans"/>
               </a:rPr>
-              <a:t>five</a:t>
+              <a:t>one</a:t>
             </a:r>
           </a:p>
         </p:txBody>
@@ -30371,8 +30371,8 @@
         </p:nvSpPr>
         <p:spPr>
           <a:xfrm>
-            <a:off x="5443350" y="4636007"/>
-            <a:ext cx="1956514" cy="384048"/>
+            <a:off x="5443350" y="4480560"/>
+            <a:ext cx="1956514" cy="365760"/>
           </a:xfrm>
           <a:prstGeom prst="rect">
             <a:avLst/>
@@ -30394,13 +30394,13 @@
               </a:spcAft>
             </a:pPr>
             <a:r>
-              <a:rPr sz="1250" b="1" i="0">
-                <a:solidFill>
-                  <a:srgbClr val="D02670"/>
-                </a:solidFill>
-                <a:latin typeface="IBM Plex Sans"/>
-              </a:rPr>
-              <a:t>15.2%</a:t>
+              <a:rPr sz="1200" b="1" i="0">
+                <a:solidFill>
+                  <a:srgbClr val="0F62FE"/>
+                </a:solidFill>
+                <a:latin typeface="IBM Plex Sans"/>
+              </a:rPr>
+              <a:t>1.1%</a:t>
             </a:r>
           </a:p>
         </p:txBody>
@@ -30413,8 +30413,8 @@
         </p:nvSpPr>
         <p:spPr>
           <a:xfrm>
-            <a:off x="7509592" y="4636007"/>
-            <a:ext cx="2174013" cy="384048"/>
+            <a:off x="7509592" y="4480560"/>
+            <a:ext cx="2174013" cy="365760"/>
           </a:xfrm>
           <a:prstGeom prst="rect">
             <a:avLst/>
@@ -30436,13 +30436,13 @@
               </a:spcAft>
             </a:pPr>
             <a:r>
-              <a:rPr sz="1250" b="1" i="0">
-                <a:solidFill>
-                  <a:srgbClr val="D02670"/>
-                </a:solidFill>
-                <a:latin typeface="IBM Plex Sans"/>
-              </a:rPr>
-              <a:t>59.1%</a:t>
+              <a:rPr sz="1200" b="1" i="0">
+                <a:solidFill>
+                  <a:srgbClr val="0F62FE"/>
+                </a:solidFill>
+                <a:latin typeface="IBM Plex Sans"/>
+              </a:rPr>
+              <a:t>91.7%</a:t>
             </a:r>
           </a:p>
         </p:txBody>
@@ -30455,8 +30455,8 @@
         </p:nvSpPr>
         <p:spPr>
           <a:xfrm>
-            <a:off x="9793333" y="4636007"/>
-            <a:ext cx="1630265" cy="384048"/>
+            <a:off x="9793333" y="4480560"/>
+            <a:ext cx="1630265" cy="365760"/>
           </a:xfrm>
           <a:prstGeom prst="rect">
             <a:avLst/>
@@ -30478,69 +30478,27 @@
               </a:spcAft>
             </a:pPr>
             <a:r>
-              <a:rPr sz="1250" b="1" i="0">
-                <a:solidFill>
-                  <a:srgbClr val="D02670"/>
-                </a:solidFill>
-                <a:latin typeface="IBM Plex Sans"/>
-              </a:rPr>
-              <a:t>3</a:t>
-            </a:r>
-          </a:p>
-        </p:txBody>
-      </p:sp>
-      <p:sp>
-        <p:nvSpPr>
-          <p:cNvPr id="45" name="TextBox 44"/>
-          <p:cNvSpPr txBox="1"/>
-          <p:nvPr/>
-        </p:nvSpPr>
-        <p:spPr>
-          <a:xfrm>
-            <a:off x="658368" y="5138928"/>
-            <a:ext cx="10874959" cy="960120"/>
-          </a:xfrm>
-          <a:prstGeom prst="rect">
-            <a:avLst/>
-          </a:prstGeom>
-          <a:noFill/>
-        </p:spPr>
-        <p:txBody>
-          <a:bodyPr wrap="square" anchor="t" lIns="0" rIns="0" tIns="0" bIns="0">
-            <a:spAutoFit/>
-          </a:bodyPr>
-          <a:lstStyle/>
-          <a:p>
-            <a:pPr algn="l">
-              <a:lnSpc>
-                <a:spcPct val="132000"/>
-              </a:lnSpc>
-              <a:spcAft>
-                <a:spcPts val="0"/>
-              </a:spcAft>
-            </a:pPr>
-            <a:r>
-              <a:rPr sz="1150" b="0" i="0">
-                <a:solidFill>
-                  <a:srgbClr val="525252"/>
-                </a:solidFill>
-                <a:latin typeface="IBM Plex Sans"/>
-              </a:rPr>
-              <a:t>Every row starts from the same round-0 position on the same frozen cohort and applies one reconsideration step. The panel-reveal arm is not in this table: it reveals the result after the debate has already moved the position, and its records carry the debate's own final drug on all 400 runs.</a:t>
-            </a:r>
-          </a:p>
-        </p:txBody>
-      </p:sp>
-      <p:sp>
-        <p:nvSpPr>
-          <p:cNvPr id="46" name="Rectangle 45"/>
+              <a:rPr sz="1200" b="1" i="0">
+                <a:solidFill>
+                  <a:srgbClr val="0F62FE"/>
+                </a:solidFill>
+                <a:latin typeface="IBM Plex Sans"/>
+              </a:rPr>
+              <a:t>8</a:t>
+            </a:r>
+          </a:p>
+        </p:txBody>
+      </p:sp>
+      <p:sp>
+        <p:nvSpPr>
+          <p:cNvPr id="45" name="Rectangle 44"/>
           <p:cNvSpPr/>
           <p:nvPr/>
         </p:nvSpPr>
         <p:spPr>
           <a:xfrm>
-            <a:off x="658368" y="6181344"/>
-            <a:ext cx="10874959" cy="7315"/>
+            <a:off x="658368" y="4773168"/>
+            <a:ext cx="10874959" cy="5486"/>
           </a:xfrm>
           <a:prstGeom prst="rect">
             <a:avLst/>
@@ -30577,7 +30535,303 @@
       </p:sp>
       <p:sp>
         <p:nvSpPr>
+          <p:cNvPr id="46" name="TextBox 45"/>
+          <p:cNvSpPr txBox="1"/>
+          <p:nvPr/>
+        </p:nvSpPr>
+        <p:spPr>
+          <a:xfrm>
+            <a:off x="658368" y="4846320"/>
+            <a:ext cx="3587758" cy="365760"/>
+          </a:xfrm>
+          <a:prstGeom prst="rect">
+            <a:avLst/>
+          </a:prstGeom>
+          <a:noFill/>
+        </p:spPr>
+        <p:txBody>
+          <a:bodyPr wrap="square" anchor="t" lIns="0" rIns="0" tIns="0" bIns="0">
+            <a:spAutoFit/>
+          </a:bodyPr>
+          <a:lstStyle/>
+          <a:p>
+            <a:pPr algn="l">
+              <a:lnSpc>
+                <a:spcPct val="120000"/>
+              </a:lnSpc>
+              <a:spcAft>
+                <a:spcPts val="0"/>
+              </a:spcAft>
+            </a:pPr>
+            <a:r>
+              <a:rPr sz="1200" b="1" i="0">
+                <a:solidFill>
+                  <a:srgbClr val="161616"/>
+                </a:solidFill>
+                <a:latin typeface="IBM Plex Sans"/>
+              </a:rPr>
+              <a:t>a second agent arguing</a:t>
+            </a:r>
+          </a:p>
+        </p:txBody>
+      </p:sp>
+      <p:sp>
+        <p:nvSpPr>
           <p:cNvPr id="47" name="TextBox 46"/>
+          <p:cNvSpPr txBox="1"/>
+          <p:nvPr/>
+        </p:nvSpPr>
+        <p:spPr>
+          <a:xfrm>
+            <a:off x="4355854" y="4846320"/>
+            <a:ext cx="977767" cy="365760"/>
+          </a:xfrm>
+          <a:prstGeom prst="rect">
+            <a:avLst/>
+          </a:prstGeom>
+          <a:noFill/>
+        </p:spPr>
+        <p:txBody>
+          <a:bodyPr wrap="square" anchor="t" lIns="0" rIns="0" tIns="0" bIns="0">
+            <a:spAutoFit/>
+          </a:bodyPr>
+          <a:lstStyle/>
+          <a:p>
+            <a:pPr algn="l">
+              <a:lnSpc>
+                <a:spcPct val="120000"/>
+              </a:lnSpc>
+              <a:spcAft>
+                <a:spcPts val="0"/>
+              </a:spcAft>
+            </a:pPr>
+            <a:r>
+              <a:rPr sz="1200" b="1" i="0">
+                <a:solidFill>
+                  <a:srgbClr val="161616"/>
+                </a:solidFill>
+                <a:latin typeface="IBM Plex Sans"/>
+              </a:rPr>
+              <a:t>five</a:t>
+            </a:r>
+          </a:p>
+        </p:txBody>
+      </p:sp>
+      <p:sp>
+        <p:nvSpPr>
+          <p:cNvPr id="48" name="TextBox 47"/>
+          <p:cNvSpPr txBox="1"/>
+          <p:nvPr/>
+        </p:nvSpPr>
+        <p:spPr>
+          <a:xfrm>
+            <a:off x="5443350" y="4846320"/>
+            <a:ext cx="1956514" cy="365760"/>
+          </a:xfrm>
+          <a:prstGeom prst="rect">
+            <a:avLst/>
+          </a:prstGeom>
+          <a:noFill/>
+        </p:spPr>
+        <p:txBody>
+          <a:bodyPr wrap="square" anchor="t" lIns="0" rIns="0" tIns="0" bIns="0">
+            <a:spAutoFit/>
+          </a:bodyPr>
+          <a:lstStyle/>
+          <a:p>
+            <a:pPr algn="l">
+              <a:lnSpc>
+                <a:spcPct val="120000"/>
+              </a:lnSpc>
+              <a:spcAft>
+                <a:spcPts val="0"/>
+              </a:spcAft>
+            </a:pPr>
+            <a:r>
+              <a:rPr sz="1200" b="1" i="0">
+                <a:solidFill>
+                  <a:srgbClr val="D02670"/>
+                </a:solidFill>
+                <a:latin typeface="IBM Plex Sans"/>
+              </a:rPr>
+              <a:t>15.2%</a:t>
+            </a:r>
+          </a:p>
+        </p:txBody>
+      </p:sp>
+      <p:sp>
+        <p:nvSpPr>
+          <p:cNvPr id="49" name="TextBox 48"/>
+          <p:cNvSpPr txBox="1"/>
+          <p:nvPr/>
+        </p:nvSpPr>
+        <p:spPr>
+          <a:xfrm>
+            <a:off x="7509592" y="4846320"/>
+            <a:ext cx="2174013" cy="365760"/>
+          </a:xfrm>
+          <a:prstGeom prst="rect">
+            <a:avLst/>
+          </a:prstGeom>
+          <a:noFill/>
+        </p:spPr>
+        <p:txBody>
+          <a:bodyPr wrap="square" anchor="t" lIns="0" rIns="0" tIns="0" bIns="0">
+            <a:spAutoFit/>
+          </a:bodyPr>
+          <a:lstStyle/>
+          <a:p>
+            <a:pPr algn="l">
+              <a:lnSpc>
+                <a:spcPct val="120000"/>
+              </a:lnSpc>
+              <a:spcAft>
+                <a:spcPts val="0"/>
+              </a:spcAft>
+            </a:pPr>
+            <a:r>
+              <a:rPr sz="1200" b="1" i="0">
+                <a:solidFill>
+                  <a:srgbClr val="D02670"/>
+                </a:solidFill>
+                <a:latin typeface="IBM Plex Sans"/>
+              </a:rPr>
+              <a:t>59.1%</a:t>
+            </a:r>
+          </a:p>
+        </p:txBody>
+      </p:sp>
+      <p:sp>
+        <p:nvSpPr>
+          <p:cNvPr id="50" name="TextBox 49"/>
+          <p:cNvSpPr txBox="1"/>
+          <p:nvPr/>
+        </p:nvSpPr>
+        <p:spPr>
+          <a:xfrm>
+            <a:off x="9793333" y="4846320"/>
+            <a:ext cx="1630265" cy="365760"/>
+          </a:xfrm>
+          <a:prstGeom prst="rect">
+            <a:avLst/>
+          </a:prstGeom>
+          <a:noFill/>
+        </p:spPr>
+        <p:txBody>
+          <a:bodyPr wrap="square" anchor="t" lIns="0" rIns="0" tIns="0" bIns="0">
+            <a:spAutoFit/>
+          </a:bodyPr>
+          <a:lstStyle/>
+          <a:p>
+            <a:pPr algn="l">
+              <a:lnSpc>
+                <a:spcPct val="120000"/>
+              </a:lnSpc>
+              <a:spcAft>
+                <a:spcPts val="0"/>
+              </a:spcAft>
+            </a:pPr>
+            <a:r>
+              <a:rPr sz="1200" b="1" i="0">
+                <a:solidFill>
+                  <a:srgbClr val="D02670"/>
+                </a:solidFill>
+                <a:latin typeface="IBM Plex Sans"/>
+              </a:rPr>
+              <a:t>3</a:t>
+            </a:r>
+          </a:p>
+        </p:txBody>
+      </p:sp>
+      <p:sp>
+        <p:nvSpPr>
+          <p:cNvPr id="51" name="TextBox 50"/>
+          <p:cNvSpPr txBox="1"/>
+          <p:nvPr/>
+        </p:nvSpPr>
+        <p:spPr>
+          <a:xfrm>
+            <a:off x="658368" y="5138928"/>
+            <a:ext cx="10874959" cy="960120"/>
+          </a:xfrm>
+          <a:prstGeom prst="rect">
+            <a:avLst/>
+          </a:prstGeom>
+          <a:noFill/>
+        </p:spPr>
+        <p:txBody>
+          <a:bodyPr wrap="square" anchor="t" lIns="0" rIns="0" tIns="0" bIns="0">
+            <a:spAutoFit/>
+          </a:bodyPr>
+          <a:lstStyle/>
+          <a:p>
+            <a:pPr algn="l">
+              <a:lnSpc>
+                <a:spcPct val="132000"/>
+              </a:lnSpc>
+              <a:spcAft>
+                <a:spcPts val="0"/>
+              </a:spcAft>
+            </a:pPr>
+            <a:r>
+              <a:rPr sz="1150" b="0" i="0">
+                <a:solidFill>
+                  <a:srgbClr val="525252"/>
+                </a:solidFill>
+                <a:latin typeface="IBM Plex Sans"/>
+              </a:rPr>
+              <a:t>Every row starts from the same round-0 position on the same frozen cohort and applies one reconsideration step. The panel-reveal arm is not in this table: it reveals the result after the debate has already moved the position, and its records carry the debate's own final drug on all 400 runs.</a:t>
+            </a:r>
+          </a:p>
+        </p:txBody>
+      </p:sp>
+      <p:sp>
+        <p:nvSpPr>
+          <p:cNvPr id="52" name="Rectangle 51"/>
+          <p:cNvSpPr/>
+          <p:nvPr/>
+        </p:nvSpPr>
+        <p:spPr>
+          <a:xfrm>
+            <a:off x="658368" y="6181344"/>
+            <a:ext cx="10874959" cy="7315"/>
+          </a:xfrm>
+          <a:prstGeom prst="rect">
+            <a:avLst/>
+          </a:prstGeom>
+          <a:solidFill>
+            <a:srgbClr val="E0E0E0"/>
+          </a:solidFill>
+          <a:ln>
+            <a:noFill/>
+          </a:ln>
+          <a:effectLst/>
+        </p:spPr>
+        <p:style>
+          <a:lnRef idx="1">
+            <a:schemeClr val="accent1"/>
+          </a:lnRef>
+          <a:fillRef idx="3">
+            <a:schemeClr val="accent1"/>
+          </a:fillRef>
+          <a:effectRef idx="2">
+            <a:schemeClr val="accent1"/>
+          </a:effectRef>
+          <a:fontRef idx="minor">
+            <a:schemeClr val="lt1"/>
+          </a:fontRef>
+        </p:style>
+        <p:txBody>
+          <a:bodyPr rtlCol="0" anchor="ctr"/>
+          <a:lstStyle/>
+          <a:p>
+            <a:pPr algn="ctr"/>
+          </a:p>
+        </p:txBody>
+      </p:sp>
+      <p:sp>
+        <p:nvSpPr>
+          <p:cNvPr id="53" name="TextBox 52"/>
           <p:cNvSpPr txBox="1"/>
           <p:nvPr/>
         </p:nvSpPr>
@@ -30619,7 +30873,7 @@
       </p:sp>
       <p:sp>
         <p:nvSpPr>
-          <p:cNvPr id="48" name="TextBox 47"/>
+          <p:cNvPr id="54" name="TextBox 53"/>
           <p:cNvSpPr txBox="1"/>
           <p:nvPr/>
         </p:nvSpPr>

</xml_diff>

<commit_message>
Give the answer slide one sentence of the control, so it can be delivered without a new slide
</commit_message>
<xml_diff>
--- a/deck/Shomique_Hayat_UNIQ_antibiotic_agents.pptx
+++ b/deck/Shomique_Hayat_UNIQ_antibiotic_agents.pptx
@@ -1077,7 +1077,22 @@
           </a:p>
           <a:p>
             <a:r>
-              <a:t>Evidence improves it. The difference between those two rows is the whole finding, and the scripted</a:t>
+              <a:t>Evidence improves it.</a:t>
+            </a:r>
+          </a:p>
+          <a:p>
+            <a:r>
+              <a:t>If you have the time, add the control in one sentence: I ran the same agent three times with nothing</a:t>
+            </a:r>
+          </a:p>
+          <a:p>
+            <a:r>
+              <a:t>disagreeing with it, and it kept its answer and its coverage, so it is being contradicted that moves</a:t>
+            </a:r>
+          </a:p>
+          <a:p>
+            <a:r>
+              <a:t>it and not being asked again. There is a backup slide with the numbers. The difference between those two rows is the whole finding, and the scripted</a:t>
             </a:r>
           </a:p>
           <a:p>

</xml_diff>

<commit_message>
Final control numbers at 115 of 200, and the check that the prefix is representative
The arm covered a contiguous 115 cases before the clock stopped it. With a counterpart the model
abandons its opening drug in all 115 runs; without one, in 4. Coverage 77.4% against 88.7%, harmful
revision 15.2% against 0.0%. Paired within patient, the debate ends inadequate where the control
ends adequate in 15 pairs and the reverse in none, exact McNemar p = 6.1e-05.

A contiguous prefix invites the question of whether it is like the rest of the cohort, so the check
is computed and reported: the debate arm's harmful revision rate on this prefix alone is 15.2%,
which is the whole-cohort figure to the decimal place.

Co-Authored-By: Claude Opus 5 (1M context) <noreply@anthropic.com>
</commit_message>
<xml_diff>
--- a/deck/Shomique_Hayat_UNIQ_antibiotic_agents.pptx
+++ b/deck/Shomique_Hayat_UNIQ_antibiotic_agents.pptx
@@ -3301,7 +3301,7 @@
           </a:p>
           <a:p>
             <a:r>
-              <a:t>So I ran the control. One agent, the same specialist, the same 80 frozen cases, the same round-0</a:t>
+              <a:t>So I ran the control. One agent, the same specialist, the same 115 frozen cases, the same round-0</a:t>
             </a:r>
           </a:p>
           <a:p>
@@ -3321,17 +3321,17 @@
           </a:p>
           <a:p>
             <a:r>
-              <a:t>With a counterpart it changes its drug in every run. Without one, 4 of 80.</a:t>
-            </a:r>
-          </a:p>
-          <a:p>
-            <a:r>
-              <a:t>Coverage is 88.8 per cent against 76.2, and harmful revision is 0 per cent against 14.7.</a:t>
-            </a:r>
-          </a:p>
-          <a:p>
-            <a:r>
-              <a:t>Paired within patient, exact McNemar p = 0.00195.</a:t>
+              <a:t>With a counterpart it changes its drug in every run. Without one, 4 of 115.</a:t>
+            </a:r>
+          </a:p>
+          <a:p>
+            <a:r>
+              <a:t>Coverage is 88.7 per cent against 77.4, and harmful revision is 0 per cent against 15.2.</a:t>
+            </a:r>
+          </a:p>
+          <a:p>
+            <a:r>
+              <a:t>Paired within patient, exact McNemar p = 6.1e-05.</a:t>
             </a:r>
           </a:p>
           <a:p>
@@ -3351,7 +3351,7 @@
           </a:p>
           <a:p>
             <a:r>
-              <a:t>Say the coverage out loud too: 80 of 200 cases, a contiguous prefix, run against the clock.</a:t>
+              <a:t>Say the coverage out loud too: 115 of 200 cases, a contiguous prefix, run against the clock.</a:t>
             </a:r>
           </a:p>
         </p:txBody>
@@ -31642,7 +31642,7 @@
                 </a:solidFill>
                 <a:latin typeface="IBM Plex Sans"/>
               </a:rPr>
-              <a:t>80 of 80</a:t>
+              <a:t>115 of 115</a:t>
             </a:r>
           </a:p>
         </p:txBody>
@@ -31684,7 +31684,7 @@
                 </a:solidFill>
                 <a:latin typeface="IBM Plex Sans"/>
               </a:rPr>
-              <a:t>4 of 80</a:t>
+              <a:t>4 of 115</a:t>
             </a:r>
           </a:p>
         </p:txBody>
@@ -31812,7 +31812,7 @@
                 </a:solidFill>
                 <a:latin typeface="IBM Plex Sans"/>
               </a:rPr>
-              <a:t>76.2%</a:t>
+              <a:t>77.4%</a:t>
             </a:r>
           </a:p>
         </p:txBody>
@@ -31854,7 +31854,7 @@
                 </a:solidFill>
                 <a:latin typeface="IBM Plex Sans"/>
               </a:rPr>
-              <a:t>88.8%</a:t>
+              <a:t>88.7%</a:t>
             </a:r>
           </a:p>
         </p:txBody>
@@ -31982,7 +31982,7 @@
                 </a:solidFill>
                 <a:latin typeface="IBM Plex Sans"/>
               </a:rPr>
-              <a:t>14.7%</a:t>
+              <a:t>15.2%</a:t>
             </a:r>
           </a:p>
         </p:txBody>
@@ -32066,7 +32066,7 @@
                 </a:solidFill>
                 <a:latin typeface="IBM Plex Sans"/>
               </a:rPr>
-              <a:t>Same agent, same 80 cases, same opening prompt, same formulary, same gate, same scorer. Paired within patient, the debate ends on an inadequate drug where the control ends on an adequate one in 10 pairs and the reverse in 0. Exact McNemar p = 0.00195.</a:t>
+              <a:t>Same agent, same 115 cases, same opening prompt, same formulary, same gate, same scorer. Paired within patient, the debate ends on an inadequate drug where the control ends on an adequate one in 15 pairs and the reverse in 0. Exact McNemar p = 6.1e-05.</a:t>
             </a:r>
           </a:p>
         </p:txBody>

</xml_diff>

<commit_message>
Name the sharpest limitation of the control: it changes the revision instruction too
The debate's revision prompt tells the specialist it is in a discussion with a stewardship lead and
to consider their comments. The control's tells it to review its own recommendation. It had to,
because naming a stewardship lead would put a counterpart back into a control whose purpose is to
remove one. So the strict claim is that the instruction and the content together move the model
where reviewing your own answer does not, and separating those two is the speaker-stripped arm the
pressure test has always asked for. Stated in the result file, the project document and the drill.

Co-Authored-By: Claude Opus 5 (1M context) <noreply@anthropic.com>
</commit_message>
<xml_diff>
--- a/deck/Shomique_Hayat_UNIQ_antibiotic_agents.pptx
+++ b/deck/Shomique_Hayat_UNIQ_antibiotic_agents.pptx
@@ -3301,7 +3301,7 @@
           </a:p>
           <a:p>
             <a:r>
-              <a:t>So I ran the control. One agent, the same specialist, the same 115 frozen cases, the same round-0</a:t>
+              <a:t>So I ran the control. One agent, the same specialist, the same 118 frozen cases, the same round-0</a:t>
             </a:r>
           </a:p>
           <a:p>
@@ -3321,12 +3321,12 @@
           </a:p>
           <a:p>
             <a:r>
-              <a:t>With a counterpart it changes its drug in every run. Without one, 4 of 115.</a:t>
-            </a:r>
-          </a:p>
-          <a:p>
-            <a:r>
-              <a:t>Coverage is 88.7 per cent against 77.4, and harmful revision is 0 per cent against 15.2.</a:t>
+              <a:t>With a counterpart it changes its drug in every run. Without one, 4 of 118.</a:t>
+            </a:r>
+          </a:p>
+          <a:p>
+            <a:r>
+              <a:t>Coverage is 89 per cent against 78, and harmful revision is 0 per cent against 14.7.</a:t>
             </a:r>
           </a:p>
           <a:p>
@@ -3351,7 +3351,7 @@
           </a:p>
           <a:p>
             <a:r>
-              <a:t>Say the coverage out loud too: 115 of 200 cases, a contiguous prefix, run against the clock.</a:t>
+              <a:t>Say the coverage out loud too: 118 of 200 cases, a contiguous prefix, run against the clock.</a:t>
             </a:r>
           </a:p>
         </p:txBody>
@@ -31642,7 +31642,7 @@
                 </a:solidFill>
                 <a:latin typeface="IBM Plex Sans"/>
               </a:rPr>
-              <a:t>115 of 115</a:t>
+              <a:t>118 of 118</a:t>
             </a:r>
           </a:p>
         </p:txBody>
@@ -31684,7 +31684,7 @@
                 </a:solidFill>
                 <a:latin typeface="IBM Plex Sans"/>
               </a:rPr>
-              <a:t>4 of 115</a:t>
+              <a:t>4 of 118</a:t>
             </a:r>
           </a:p>
         </p:txBody>
@@ -31812,7 +31812,7 @@
                 </a:solidFill>
                 <a:latin typeface="IBM Plex Sans"/>
               </a:rPr>
-              <a:t>77.4%</a:t>
+              <a:t>78%</a:t>
             </a:r>
           </a:p>
         </p:txBody>
@@ -31854,7 +31854,7 @@
                 </a:solidFill>
                 <a:latin typeface="IBM Plex Sans"/>
               </a:rPr>
-              <a:t>88.7%</a:t>
+              <a:t>89%</a:t>
             </a:r>
           </a:p>
         </p:txBody>
@@ -31982,7 +31982,7 @@
                 </a:solidFill>
                 <a:latin typeface="IBM Plex Sans"/>
               </a:rPr>
-              <a:t>15.2%</a:t>
+              <a:t>14.7%</a:t>
             </a:r>
           </a:p>
         </p:txBody>
@@ -32066,7 +32066,7 @@
                 </a:solidFill>
                 <a:latin typeface="IBM Plex Sans"/>
               </a:rPr>
-              <a:t>Same agent, same 115 cases, same opening prompt, same formulary, same gate, same scorer. Paired within patient, the debate ends on an inadequate drug where the control ends on an adequate one in 15 pairs and the reverse in 0. Exact McNemar p = 6.1e-05.</a:t>
+              <a:t>Same agent, same 118 cases, same opening prompt, same formulary, same gate, same scorer. Paired within patient, the debate ends on an inadequate drug where the control ends on an adequate one in 15 pairs and the reverse in 0. Exact McNemar p = 6.1e-05.</a:t>
             </a:r>
           </a:p>
         </p:txBody>

</xml_diff>

<commit_message>
Final control numbers at 119 of 200, and clamp a confidence interval that printed below zero
The arm reached a contiguous 119 cases. With a counterpart the model abandons its opening drug in
all 119 runs; without one, in 4. Harmful revision 14.4% against 0.0%, exact McNemar p = 6.1e-05 on
the discordant pairs, 15 one way and none the other.

Floating point put a Wilson lower bound a hair below zero when the numerator is zero, so the control
row printed a negative percentage next to its rate. Clamped at both ends.

Co-Authored-By: Claude Opus 5 (1M context) <noreply@anthropic.com>
</commit_message>
<xml_diff>
--- a/deck/Shomique_Hayat_UNIQ_antibiotic_agents.pptx
+++ b/deck/Shomique_Hayat_UNIQ_antibiotic_agents.pptx
@@ -3301,7 +3301,7 @@
           </a:p>
           <a:p>
             <a:r>
-              <a:t>So I ran the control. One agent, the same specialist, the same 118 frozen cases, the same round-0</a:t>
+              <a:t>So I ran the control. One agent, the same specialist, the same 120 frozen cases, the same round-0</a:t>
             </a:r>
           </a:p>
           <a:p>
@@ -3321,12 +3321,12 @@
           </a:p>
           <a:p>
             <a:r>
-              <a:t>With a counterpart it changes its drug in every run. Without one, 4 of 118.</a:t>
-            </a:r>
-          </a:p>
-          <a:p>
-            <a:r>
-              <a:t>Coverage is 89 per cent against 78, and harmful revision is 0 per cent against 14.7.</a:t>
+              <a:t>With a counterpart it changes its drug in every run. Without one, 4 of 120.</a:t>
+            </a:r>
+          </a:p>
+          <a:p>
+            <a:r>
+              <a:t>Coverage is 89.2 per cent against 78.3, and harmful revision is 0 per cent against 14.4.</a:t>
             </a:r>
           </a:p>
           <a:p>
@@ -3351,7 +3351,7 @@
           </a:p>
           <a:p>
             <a:r>
-              <a:t>Say the coverage out loud too: 118 of 200 cases, a contiguous prefix, run against the clock.</a:t>
+              <a:t>Say the coverage out loud too: 120 of 200 cases, a contiguous prefix, run against the clock.</a:t>
             </a:r>
           </a:p>
         </p:txBody>
@@ -31642,7 +31642,7 @@
                 </a:solidFill>
                 <a:latin typeface="IBM Plex Sans"/>
               </a:rPr>
-              <a:t>118 of 118</a:t>
+              <a:t>120 of 120</a:t>
             </a:r>
           </a:p>
         </p:txBody>
@@ -31684,7 +31684,7 @@
                 </a:solidFill>
                 <a:latin typeface="IBM Plex Sans"/>
               </a:rPr>
-              <a:t>4 of 118</a:t>
+              <a:t>4 of 120</a:t>
             </a:r>
           </a:p>
         </p:txBody>
@@ -31812,7 +31812,7 @@
                 </a:solidFill>
                 <a:latin typeface="IBM Plex Sans"/>
               </a:rPr>
-              <a:t>78%</a:t>
+              <a:t>78.3%</a:t>
             </a:r>
           </a:p>
         </p:txBody>
@@ -31854,7 +31854,7 @@
                 </a:solidFill>
                 <a:latin typeface="IBM Plex Sans"/>
               </a:rPr>
-              <a:t>89%</a:t>
+              <a:t>89.2%</a:t>
             </a:r>
           </a:p>
         </p:txBody>
@@ -31982,7 +31982,7 @@
                 </a:solidFill>
                 <a:latin typeface="IBM Plex Sans"/>
               </a:rPr>
-              <a:t>14.7%</a:t>
+              <a:t>14.4%</a:t>
             </a:r>
           </a:p>
         </p:txBody>
@@ -32066,7 +32066,7 @@
                 </a:solidFill>
                 <a:latin typeface="IBM Plex Sans"/>
               </a:rPr>
-              <a:t>Same agent, same 118 cases, same opening prompt, same formulary, same gate, same scorer. Paired within patient, the debate ends on an inadequate drug where the control ends on an adequate one in 15 pairs and the reverse in 0. Exact McNemar p = 6.1e-05.</a:t>
+              <a:t>Same agent, same 120 cases, same opening prompt, same formulary, same gate, same scorer. Paired within patient, the debate ends on an inadequate drug where the control ends on an adequate one in 15 pairs and the reverse in 0. Exact McNemar p = 6.1e-05.</a:t>
             </a:r>
           </a:p>
         </p:txBody>

</xml_diff>

<commit_message>
Final control arm: 125 of 200 cases, exact McNemar p = 3.05e-05
With a counterpart the model abandons its opening drug in all 125 runs; without one, in 4. Coverage
77.6% against 88.8%, harmful revision 14.8% against 0.0%. The debate ends on an inadequate drug
where the control ends on an adequate one in 16 paired cases and the reverse in none.

The arm was stopped at its scheduled deadline. The prefix check holds: the debate arm's harmful
revision rate on these 125 cases is 14.8% against 15.2% on the whole cohort.

Co-Authored-By: Claude Opus 5 (1M context) <noreply@anthropic.com>
</commit_message>
<xml_diff>
--- a/deck/Shomique_Hayat_UNIQ_antibiotic_agents.pptx
+++ b/deck/Shomique_Hayat_UNIQ_antibiotic_agents.pptx
@@ -3301,7 +3301,7 @@
           </a:p>
           <a:p>
             <a:r>
-              <a:t>So I ran the control. One agent, the same specialist, the same 120 frozen cases, the same round-0</a:t>
+              <a:t>So I ran the control. One agent, the same specialist, the same 125 frozen cases, the same round-0</a:t>
             </a:r>
           </a:p>
           <a:p>
@@ -3321,17 +3321,17 @@
           </a:p>
           <a:p>
             <a:r>
-              <a:t>With a counterpart it changes its drug in every run. Without one, 4 of 120.</a:t>
-            </a:r>
-          </a:p>
-          <a:p>
-            <a:r>
-              <a:t>Coverage is 89.2 per cent against 78.3, and harmful revision is 0 per cent against 14.4.</a:t>
-            </a:r>
-          </a:p>
-          <a:p>
-            <a:r>
-              <a:t>Paired within patient, exact McNemar p = 6.1e-05.</a:t>
+              <a:t>With a counterpart it changes its drug in every run. Without one, 4 of 125.</a:t>
+            </a:r>
+          </a:p>
+          <a:p>
+            <a:r>
+              <a:t>Coverage is 88.8 per cent against 77.6, and harmful revision is 0 per cent against 14.8.</a:t>
+            </a:r>
+          </a:p>
+          <a:p>
+            <a:r>
+              <a:t>Paired within patient, exact McNemar p = 3.05e-05.</a:t>
             </a:r>
           </a:p>
           <a:p>
@@ -3351,7 +3351,7 @@
           </a:p>
           <a:p>
             <a:r>
-              <a:t>Say the coverage out loud too: 120 of 200 cases, a contiguous prefix, run against the clock.</a:t>
+              <a:t>Say the coverage out loud too: 125 of 200 cases, a contiguous prefix, run against the clock.</a:t>
             </a:r>
           </a:p>
         </p:txBody>
@@ -31642,7 +31642,7 @@
                 </a:solidFill>
                 <a:latin typeface="IBM Plex Sans"/>
               </a:rPr>
-              <a:t>120 of 120</a:t>
+              <a:t>125 of 125</a:t>
             </a:r>
           </a:p>
         </p:txBody>
@@ -31684,7 +31684,7 @@
                 </a:solidFill>
                 <a:latin typeface="IBM Plex Sans"/>
               </a:rPr>
-              <a:t>4 of 120</a:t>
+              <a:t>4 of 125</a:t>
             </a:r>
           </a:p>
         </p:txBody>
@@ -31812,7 +31812,7 @@
                 </a:solidFill>
                 <a:latin typeface="IBM Plex Sans"/>
               </a:rPr>
-              <a:t>78.3%</a:t>
+              <a:t>77.6%</a:t>
             </a:r>
           </a:p>
         </p:txBody>
@@ -31854,7 +31854,7 @@
                 </a:solidFill>
                 <a:latin typeface="IBM Plex Sans"/>
               </a:rPr>
-              <a:t>89.2%</a:t>
+              <a:t>88.8%</a:t>
             </a:r>
           </a:p>
         </p:txBody>
@@ -31982,7 +31982,7 @@
                 </a:solidFill>
                 <a:latin typeface="IBM Plex Sans"/>
               </a:rPr>
-              <a:t>14.4%</a:t>
+              <a:t>14.8%</a:t>
             </a:r>
           </a:p>
         </p:txBody>
@@ -32066,7 +32066,7 @@
                 </a:solidFill>
                 <a:latin typeface="IBM Plex Sans"/>
               </a:rPr>
-              <a:t>Same agent, same 120 cases, same opening prompt, same formulary, same gate, same scorer. Paired within patient, the debate ends on an inadequate drug where the control ends on an adequate one in 15 pairs and the reverse in 0. Exact McNemar p = 6.1e-05.</a:t>
+              <a:t>Same agent, same 125 cases, same opening prompt, same formulary, same gate, same scorer. Paired within patient, the debate ends on an inadequate drug where the control ends on an adequate one in 16 pairs and the reverse in 0. Exact McNemar p = 3.05e-05.</a:t>
             </a:r>
           </a:p>
         </p:txBody>

</xml_diff>

<commit_message>
Give the contribution slide the second half of the contribution in its notes
Not just that the harm is invisible to the endpoint everyone reports, but that the cause was
isolated: being contradicted moves the model where being asked again does not, and the same
destination drug is safe or harmful depending on what triggered the move.

Co-Authored-By: Claude Opus 5 (1M context) <noreply@anthropic.com>
</commit_message>
<xml_diff>
--- a/deck/Shomique_Hayat_UNIQ_antibiotic_agents.pptx
+++ b/deck/Shomique_Hayat_UNIQ_antibiotic_agents.pptx
@@ -1340,6 +1340,36 @@
           <a:p>
             <a:r>
               <a:t>this failure mode entirely.</a:t>
+            </a:r>
+          </a:p>
+          <a:p>
+            <a:r>
+              <a:t>There is a second half to the contribution if you have time or if you are asked what causes it.</a:t>
+            </a:r>
+          </a:p>
+          <a:p>
+            <a:r>
+              <a:t>I did not stop at measuring the harm, I isolated what produces it. Same cases, same opening prompt,</a:t>
+            </a:r>
+          </a:p>
+          <a:p>
+            <a:r>
+              <a:t>one agent asked three times with nothing disagreeing: it keeps its answer and its coverage. The four</a:t>
+            </a:r>
+          </a:p>
+          <a:p>
+            <a:r>
+              <a:t>times it does change, it makes the same de-escalation the debate makes, and none of those four costs</a:t>
+            </a:r>
+          </a:p>
+          <a:p>
+            <a:r>
+              <a:t>coverage. So it is being contradicted that moves it, not being asked again, and the same destination</a:t>
+            </a:r>
+          </a:p>
+          <a:p>
+            <a:r>
+              <a:t>drug is safe or harmful depending on what triggered the move. That is the control slide at the back.</a:t>
             </a:r>
           </a:p>
         </p:txBody>

</xml_diff>

<commit_message>
One of her two required comparisons claimed a paired result it had not computed
The clinician comparison reported 91.1% on 192 cases and 90.6% on 138 and then said the two were
indistinguishable on the cases where both can be scored. That set was never constructed. The rates
are real and the rule is identical on both sides, but they are two independent proportions and not a
paired test.

Corrected in the result file, the project document, the deck table header, the deck notes and the
supervisor asks table. The paired version needs per-case clinician outcomes, which the comparator
artefact does not carry because it derives from credentialed prescribing records, so it is named as
further work rather than implied.

No sweep would have caught this: every figure was right and the sentence beside them was not.

Co-Authored-By: Claude Opus 5 (1M context) <noreply@anthropic.com>
</commit_message>
<xml_diff>
--- a/deck/Shomique_Hayat_UNIQ_antibiotic_agents.pptx
+++ b/deck/Shomique_Hayat_UNIQ_antibiotic_agents.pptx
@@ -2731,17 +2731,32 @@
           </a:p>
           <a:p>
             <a:r>
-              <a:t>On the cases where both can be scored, it is 91.1 against 90.6. Indistinguishable. The honest answer</a:t>
-            </a:r>
-          </a:p>
-          <a:p>
-            <a:r>
-              <a:t>to her question is that neither is better, and the interesting part is that a constant policy</a:t>
-            </a:r>
-          </a:p>
-          <a:p>
-            <a:r>
-              <a:t>achieves that.</a:t>
+              <a:t>Restricted to what each side can be scored on, it is 91.1 on 192 cases against 90.6 on 138. Within a</a:t>
+            </a:r>
+          </a:p>
+          <a:p>
+            <a:r>
+              <a:t>point. Say the next sentence before anyone else does: those are different sets of cases, so that is</a:t>
+            </a:r>
+          </a:p>
+          <a:p>
+            <a:r>
+              <a:t>two independent proportions and not a paired test. The paired version needs per-case outcomes on the</a:t>
+            </a:r>
+          </a:p>
+          <a:p>
+            <a:r>
+              <a:t>clinician side and the comparator artefact holds aggregates only, so it is further work and I say so.</a:t>
+            </a:r>
+          </a:p>
+          <a:p>
+            <a:r>
+              <a:t>The honest answer to her question is that on this evidence neither is better, and the interesting</a:t>
+            </a:r>
+          </a:p>
+          <a:p>
+            <a:r>
+              <a:t>part is that a constant policy achieves that.</a:t>
             </a:r>
           </a:p>
         </p:txBody>
@@ -24547,7 +24562,7 @@
                 </a:solidFill>
                 <a:latin typeface="IBM Plex Sans"/>
               </a:rPr>
-              <a:t>CASES WHERE BOTH CAN BE SCORED</a:t>
+              <a:t>CASES THAT SIDE CAN BE SCORED ON</a:t>
             </a:r>
           </a:p>
         </p:txBody>
@@ -24938,7 +24953,7 @@
                 </a:solidFill>
                 <a:latin typeface="IBM Plex Sans"/>
               </a:rPr>
-              <a:t>The clinician scores UNDETERMINED in 62 of 200 cases, largely because real prescriptions fall outside the closed 17-drug formulary or were never tested against the isolate, so that comparison penalises the clinician for prescribing outside the model's answer space. On the cases where both can be scored the two are indistinguishable, 91.1% against 90.6%. The answer to her question is that neither is better.</a:t>
+              <a:t>The clinician scores UNDETERMINED in 62 of 200 cases, largely because real prescriptions fall outside the closed 17-drug formulary or were never tested against the isolate, so that comparison penalises the clinician for prescribing outside the model's answer space. Restricted to what each side can be scored on, the two rates are within a point of each other, 91.1% on 192 cases against 90.6% on 138. Those are different sets of cases, so this is two independent proportions and not a paired test. The answer to her question is that on this evidence neither is better.</a:t>
             </a:r>
           </a:p>
         </p:txBody>

</xml_diff>

<commit_message>
Rank the further work by what each arm buys, and put the top item on the closing slide
PROJECT.md 8d lists eight next steps, each named with the claim it would strengthen and what it
would cost, split into the four runnable on this machine and the four that need credentialed access,
compute, a hosted endpoint or a clinician.

The speaker-stripped arm is first and is now on the closing slide. It is the one control the
pressure test has asked for since C6, it is what separates being contradicted by a peer from being
contradicted by any rival position, and it fixes the sharpest limitation of the control built
tonight.

Co-Authored-By: Claude Opus 5 (1M context) <noreply@anthropic.com>
</commit_message>
<xml_diff>
--- a/deck/Shomique_Hayat_UNIQ_antibiotic_agents.pptx
+++ b/deck/Shomique_Hayat_UNIQ_antibiotic_agents.pptx
@@ -13100,6 +13100,34 @@
             <a:spAutoFit/>
           </a:bodyPr>
           <a:lstStyle/>
+          <a:p>
+            <a:pPr algn="l">
+              <a:lnSpc>
+                <a:spcPct val="132000"/>
+              </a:lnSpc>
+              <a:spcAft>
+                <a:spcPts val="900"/>
+              </a:spcAft>
+            </a:pPr>
+            <a:r>
+              <a:rPr sz="1350" b="1" i="0">
+                <a:solidFill>
+                  <a:srgbClr val="FFFFFF"/>
+                </a:solidFill>
+                <a:latin typeface="IBM Plex Sans"/>
+              </a:rPr>
+              <a:t>Strip the speaker. </a:t>
+            </a:r>
+            <a:r>
+              <a:rPr sz="1350" b="0" i="0">
+                <a:solidFill>
+                  <a:srgbClr val="A8A8A8"/>
+                </a:solidFill>
+                <a:latin typeface="IBM Plex Sans"/>
+              </a:rPr>
+              <a:t>The control shows a counterpart moves it where being asked again does not. Keeping the counterpart's text and removing only the attribution is what separates a peer from any rival position, and it is the one control this design has always been missing.</a:t>
+            </a:r>
+          </a:p>
           <a:p>
             <a:pPr algn="l">
               <a:lnSpc>

</xml_diff>